<commit_message>
slides: add results slides 13-14 (verification + Taylor demo)
- slide 13: matched-constitutive verification with INL-styled scatter
  panels and stat callouts (forces 3.8e-4, displacements 7.8e-8 —
  recomputed from the exodus data, not copied from notes)
- slide 14: 3D Taylor anvil capability demo — plastic-strain sequence
  + full-hard vs annealed deformed profiles (51% / 58% shortening)
- deck_build/slide_figs.py: regenerates all three results figures in
  the deck's INL style (Arial, brand palette, CVD-validated pair)

Co-Authored-By: Claude Fable 5 <noreply@anthropic.com>
Claude-Session: https://claude.ai/code/session_01CCuKo2gP6Duy91irEj5f1y
</commit_message>
<xml_diff>
--- a/examples/impact/slide_assets/WCCM_NEML2_explicit_dynamics_v2.pptx
+++ b/examples/impact/slide_assets/WCCM_NEML2_explicit_dynamics_v2.pptx
@@ -20,6 +20,8 @@
     <p:sldId id="265" r:id="rId19"/>
     <p:sldId id="266" r:id="rId20"/>
     <p:sldId id="267" r:id="rId21"/>
+    <p:sldId id="268" r:id="rId22"/>
+    <p:sldId id="269" r:id="rId23"/>
   </p:sldIdLst>
   <p:sldSz cx="12192000" cy="6858000"/>
   <p:notesSz cx="6858000" cy="9144000"/>
@@ -6352,7 +6354,7 @@
                 <a:latin typeface="Arial"/>
                 <a:cs typeface="Arial"/>
               </a:rPr>
-              <a:t>10 / 12</a:t>
+              <a:t>10 / 14</a:t>
             </a:r>
           </a:p>
         </p:txBody>
@@ -7725,7 +7727,7 @@
                 <a:latin typeface="Arial"/>
                 <a:cs typeface="Arial"/>
               </a:rPr>
-              <a:t>11 / 12</a:t>
+              <a:t>11 / 14</a:t>
             </a:r>
           </a:p>
         </p:txBody>
@@ -8857,7 +8859,7 @@
                 <a:latin typeface="Arial"/>
                 <a:cs typeface="Arial"/>
               </a:rPr>
-              <a:t>12 / 12</a:t>
+              <a:t>12 / 14</a:t>
             </a:r>
           </a:p>
         </p:txBody>
@@ -9656,6 +9658,1161 @@
                 <a:cs typeface="Arial"/>
               </a:rPr>
               <a:t>verification against MOOSE’s native J2 update  ·  3-D Taylor anvil impact  ·  coupled thermo-mechanics</a:t>
+            </a:r>
+          </a:p>
+        </p:txBody>
+      </p:sp>
+    </p:spTree>
+  </p:cSld>
+  <p:clrMapOvr>
+    <a:masterClrMapping/>
+  </p:clrMapOvr>
+</p:sld>
+</file>
+
+<file path=ppt/slides/slide13.xml><?xml version="1.0" encoding="utf-8"?>
+<p:sld xmlns:a="http://schemas.openxmlformats.org/drawingml/2006/main" xmlns:p="http://schemas.openxmlformats.org/presentationml/2006/main" xmlns:r="http://schemas.openxmlformats.org/officeDocument/2006/relationships">
+  <p:cSld>
+    <p:spTree>
+      <p:nvGrpSpPr>
+        <p:cNvPr id="1" name=""/>
+        <p:cNvGrpSpPr/>
+        <p:nvPr/>
+      </p:nvGrpSpPr>
+      <p:grpSpPr/>
+      <p:sp>
+        <p:nvSpPr>
+          <p:cNvPr id="2" name="Title 1"/>
+          <p:cNvSpPr>
+            <a:spLocks noGrp="1"/>
+          </p:cNvSpPr>
+          <p:nvPr>
+            <p:ph type="title"/>
+          </p:nvPr>
+        </p:nvSpPr>
+        <p:spPr/>
+        <p:txBody>
+          <a:bodyPr/>
+          <a:lstStyle/>
+          <a:p>
+            <a:r>
+              <a:rPr sz="2600"/>
+              <a:t>The interface adds no error</a:t>
+            </a:r>
+          </a:p>
+        </p:txBody>
+      </p:sp>
+      <p:sp>
+        <p:nvSpPr>
+          <p:cNvPr id="3" name="TextBox 2"/>
+          <p:cNvSpPr txBox="1"/>
+          <p:nvPr/>
+        </p:nvSpPr>
+        <p:spPr>
+          <a:xfrm>
+            <a:off x="11231575" y="274320"/>
+            <a:ext cx="685800" cy="228600"/>
+          </a:xfrm>
+          <a:prstGeom prst="rect">
+            <a:avLst/>
+          </a:prstGeom>
+          <a:noFill/>
+        </p:spPr>
+        <p:txBody>
+          <a:bodyPr wrap="square" anchor="t" lIns="0" rIns="0" tIns="0" bIns="0">
+            <a:spAutoFit/>
+          </a:bodyPr>
+          <a:lstStyle/>
+          <a:p>
+            <a:pPr algn="r"/>
+            <a:r>
+              <a:rPr sz="900" b="0" i="0">
+                <a:solidFill>
+                  <a:srgbClr val="59595C"/>
+                </a:solidFill>
+                <a:latin typeface="Arial"/>
+                <a:cs typeface="Arial"/>
+              </a:rPr>
+              <a:t>13 / 14</a:t>
+            </a:r>
+          </a:p>
+        </p:txBody>
+      </p:sp>
+      <p:sp>
+        <p:nvSpPr>
+          <p:cNvPr id="4" name="TextBox 3"/>
+          <p:cNvSpPr txBox="1"/>
+          <p:nvPr/>
+        </p:nvSpPr>
+        <p:spPr>
+          <a:xfrm>
+            <a:off x="566928" y="1133856"/>
+            <a:ext cx="11057839" cy="320040"/>
+          </a:xfrm>
+          <a:prstGeom prst="rect">
+            <a:avLst/>
+          </a:prstGeom>
+          <a:noFill/>
+        </p:spPr>
+        <p:txBody>
+          <a:bodyPr wrap="square" anchor="t" lIns="0" rIns="0" tIns="0" bIns="0">
+            <a:spAutoFit/>
+          </a:bodyPr>
+          <a:lstStyle/>
+          <a:p>
+            <a:pPr algn="l"/>
+            <a:r>
+              <a:rPr sz="1450" b="0" i="0">
+                <a:solidFill>
+                  <a:srgbClr val="3A3F47"/>
+                </a:solidFill>
+                <a:latin typeface="Arial"/>
+                <a:cs typeface="Arial"/>
+              </a:rPr>
+              <a:t>Matched-constitutive comparison: </a:t>
+            </a:r>
+            <a:r>
+              <a:rPr sz="1450" b="1" i="0">
+                <a:solidFill>
+                  <a:srgbClr val="1E2430"/>
+                </a:solidFill>
+                <a:latin typeface="Arial"/>
+                <a:cs typeface="Arial"/>
+              </a:rPr>
+              <a:t>the same J2 model through both force paths</a:t>
+            </a:r>
+            <a:r>
+              <a:rPr sz="1450" b="0" i="0">
+                <a:solidFill>
+                  <a:srgbClr val="3A3F47"/>
+                </a:solidFill>
+                <a:latin typeface="Arial"/>
+                <a:cs typeface="Arial"/>
+              </a:rPr>
+              <a:t> — same mesh, same steps; only the assembly implementation differs</a:t>
+            </a:r>
+          </a:p>
+        </p:txBody>
+      </p:sp>
+      <p:pic>
+        <p:nvPicPr>
+          <p:cNvPr id="5" name="Picture 4" descr="fig_verification.png"/>
+          <p:cNvPicPr>
+            <a:picLocks noChangeAspect="1"/>
+          </p:cNvPicPr>
+          <p:nvPr/>
+        </p:nvPicPr>
+        <p:blipFill>
+          <a:blip r:embed="rId2"/>
+          <a:stretch>
+            <a:fillRect/>
+          </a:stretch>
+        </p:blipFill>
+        <p:spPr>
+          <a:xfrm>
+            <a:off x="566928" y="1709928"/>
+            <a:ext cx="6720840" cy="3237500"/>
+          </a:xfrm>
+          <a:prstGeom prst="rect">
+            <a:avLst/>
+          </a:prstGeom>
+        </p:spPr>
+      </p:pic>
+      <p:sp>
+        <p:nvSpPr>
+          <p:cNvPr id="6" name="Rounded Rectangle 5"/>
+          <p:cNvSpPr/>
+          <p:nvPr/>
+        </p:nvSpPr>
+        <p:spPr>
+          <a:xfrm>
+            <a:off x="7699248" y="1801368"/>
+            <a:ext cx="3925519" cy="1207008"/>
+          </a:xfrm>
+          <a:prstGeom prst="roundRect">
+            <a:avLst>
+              <a:gd name="adj" fmla="val 5500"/>
+            </a:avLst>
+          </a:prstGeom>
+          <a:solidFill>
+            <a:srgbClr val="FFFFFF"/>
+          </a:solidFill>
+          <a:ln w="12700">
+            <a:solidFill>
+              <a:srgbClr val="DADDE2"/>
+            </a:solidFill>
+          </a:ln>
+          <a:effectLst/>
+        </p:spPr>
+        <p:style>
+          <a:lnRef idx="1">
+            <a:schemeClr val="accent1"/>
+          </a:lnRef>
+          <a:fillRef idx="3">
+            <a:schemeClr val="accent1"/>
+          </a:fillRef>
+          <a:effectRef idx="2">
+            <a:schemeClr val="accent1"/>
+          </a:effectRef>
+          <a:fontRef idx="minor">
+            <a:schemeClr val="lt1"/>
+          </a:fontRef>
+        </p:style>
+        <p:txBody>
+          <a:bodyPr rtlCol="0" anchor="ctr"/>
+          <a:lstStyle/>
+          <a:p>
+            <a:pPr algn="ctr"/>
+          </a:p>
+        </p:txBody>
+      </p:sp>
+      <p:sp>
+        <p:nvSpPr>
+          <p:cNvPr id="7" name="Rectangle 6"/>
+          <p:cNvSpPr/>
+          <p:nvPr/>
+        </p:nvSpPr>
+        <p:spPr>
+          <a:xfrm>
+            <a:off x="7699248" y="1911096"/>
+            <a:ext cx="50292" cy="987552"/>
+          </a:xfrm>
+          <a:prstGeom prst="rect">
+            <a:avLst/>
+          </a:prstGeom>
+          <a:solidFill>
+            <a:srgbClr val="06509D"/>
+          </a:solidFill>
+          <a:ln>
+            <a:noFill/>
+          </a:ln>
+          <a:effectLst/>
+        </p:spPr>
+        <p:style>
+          <a:lnRef idx="1">
+            <a:schemeClr val="accent1"/>
+          </a:lnRef>
+          <a:fillRef idx="3">
+            <a:schemeClr val="accent1"/>
+          </a:fillRef>
+          <a:effectRef idx="2">
+            <a:schemeClr val="accent1"/>
+          </a:effectRef>
+          <a:fontRef idx="minor">
+            <a:schemeClr val="lt1"/>
+          </a:fontRef>
+        </p:style>
+        <p:txBody>
+          <a:bodyPr rtlCol="0" anchor="ctr"/>
+          <a:lstStyle/>
+          <a:p>
+            <a:pPr algn="ctr"/>
+          </a:p>
+        </p:txBody>
+      </p:sp>
+      <p:sp>
+        <p:nvSpPr>
+          <p:cNvPr id="8" name="TextBox 7"/>
+          <p:cNvSpPr txBox="1"/>
+          <p:nvPr/>
+        </p:nvSpPr>
+        <p:spPr>
+          <a:xfrm>
+            <a:off x="7955280" y="1929384"/>
+            <a:ext cx="3468319" cy="502920"/>
+          </a:xfrm>
+          <a:prstGeom prst="rect">
+            <a:avLst/>
+          </a:prstGeom>
+          <a:noFill/>
+        </p:spPr>
+        <p:txBody>
+          <a:bodyPr wrap="square" anchor="t" lIns="0" rIns="0" tIns="0" bIns="0">
+            <a:spAutoFit/>
+          </a:bodyPr>
+          <a:lstStyle/>
+          <a:p>
+            <a:pPr algn="l"/>
+            <a:r>
+              <a:rPr sz="3000" b="1" i="0">
+                <a:solidFill>
+                  <a:srgbClr val="06509D"/>
+                </a:solidFill>
+                <a:latin typeface="Arial"/>
+                <a:cs typeface="Arial"/>
+              </a:rPr>
+              <a:t>3.8 × 10</a:t>
+            </a:r>
+            <a:r>
+              <a:rPr sz="3000" b="1" i="0" baseline="30000">
+                <a:solidFill>
+                  <a:srgbClr val="06509D"/>
+                </a:solidFill>
+                <a:latin typeface="Arial"/>
+                <a:cs typeface="Arial"/>
+              </a:rPr>
+              <a:t>−4</a:t>
+            </a:r>
+          </a:p>
+        </p:txBody>
+      </p:sp>
+      <p:sp>
+        <p:nvSpPr>
+          <p:cNvPr id="9" name="TextBox 8"/>
+          <p:cNvSpPr txBox="1"/>
+          <p:nvPr/>
+        </p:nvSpPr>
+        <p:spPr>
+          <a:xfrm>
+            <a:off x="7955280" y="2478024"/>
+            <a:ext cx="3468319" cy="475488"/>
+          </a:xfrm>
+          <a:prstGeom prst="rect">
+            <a:avLst/>
+          </a:prstGeom>
+          <a:noFill/>
+        </p:spPr>
+        <p:txBody>
+          <a:bodyPr wrap="square" anchor="t" lIns="0" rIns="0" tIns="0" bIns="0">
+            <a:spAutoFit/>
+          </a:bodyPr>
+          <a:lstStyle/>
+          <a:p>
+            <a:pPr algn="l">
+              <a:lnSpc>
+                <a:spcPct val="105000"/>
+              </a:lnSpc>
+            </a:pPr>
+            <a:r>
+              <a:rPr sz="1150" b="0" i="0">
+                <a:solidFill>
+                  <a:srgbClr val="59595C"/>
+                </a:solidFill>
+                <a:latin typeface="Arial"/>
+                <a:cs typeface="Arial"/>
+              </a:rPr>
+              <a:t>max relative difference,</a:t>
+            </a:r>
+          </a:p>
+          <a:p>
+            <a:pPr algn="l">
+              <a:lnSpc>
+                <a:spcPct val="105000"/>
+              </a:lnSpc>
+            </a:pPr>
+            <a:r>
+              <a:rPr sz="1150" b="0" i="0">
+                <a:solidFill>
+                  <a:srgbClr val="59595C"/>
+                </a:solidFill>
+                <a:latin typeface="Arial"/>
+                <a:cs typeface="Arial"/>
+              </a:rPr>
+              <a:t>internal nodal forces</a:t>
+            </a:r>
+          </a:p>
+        </p:txBody>
+      </p:sp>
+      <p:sp>
+        <p:nvSpPr>
+          <p:cNvPr id="10" name="Rounded Rectangle 9"/>
+          <p:cNvSpPr/>
+          <p:nvPr/>
+        </p:nvSpPr>
+        <p:spPr>
+          <a:xfrm>
+            <a:off x="7699248" y="3227832"/>
+            <a:ext cx="3925519" cy="1207008"/>
+          </a:xfrm>
+          <a:prstGeom prst="roundRect">
+            <a:avLst>
+              <a:gd name="adj" fmla="val 5500"/>
+            </a:avLst>
+          </a:prstGeom>
+          <a:solidFill>
+            <a:srgbClr val="FFFFFF"/>
+          </a:solidFill>
+          <a:ln w="12700">
+            <a:solidFill>
+              <a:srgbClr val="DADDE2"/>
+            </a:solidFill>
+          </a:ln>
+          <a:effectLst/>
+        </p:spPr>
+        <p:style>
+          <a:lnRef idx="1">
+            <a:schemeClr val="accent1"/>
+          </a:lnRef>
+          <a:fillRef idx="3">
+            <a:schemeClr val="accent1"/>
+          </a:fillRef>
+          <a:effectRef idx="2">
+            <a:schemeClr val="accent1"/>
+          </a:effectRef>
+          <a:fontRef idx="minor">
+            <a:schemeClr val="lt1"/>
+          </a:fontRef>
+        </p:style>
+        <p:txBody>
+          <a:bodyPr rtlCol="0" anchor="ctr"/>
+          <a:lstStyle/>
+          <a:p>
+            <a:pPr algn="ctr"/>
+          </a:p>
+        </p:txBody>
+      </p:sp>
+      <p:sp>
+        <p:nvSpPr>
+          <p:cNvPr id="11" name="Rectangle 10"/>
+          <p:cNvSpPr/>
+          <p:nvPr/>
+        </p:nvSpPr>
+        <p:spPr>
+          <a:xfrm>
+            <a:off x="7699248" y="3337560"/>
+            <a:ext cx="50292" cy="987552"/>
+          </a:xfrm>
+          <a:prstGeom prst="rect">
+            <a:avLst/>
+          </a:prstGeom>
+          <a:solidFill>
+            <a:srgbClr val="5E8614"/>
+          </a:solidFill>
+          <a:ln>
+            <a:noFill/>
+          </a:ln>
+          <a:effectLst/>
+        </p:spPr>
+        <p:style>
+          <a:lnRef idx="1">
+            <a:schemeClr val="accent1"/>
+          </a:lnRef>
+          <a:fillRef idx="3">
+            <a:schemeClr val="accent1"/>
+          </a:fillRef>
+          <a:effectRef idx="2">
+            <a:schemeClr val="accent1"/>
+          </a:effectRef>
+          <a:fontRef idx="minor">
+            <a:schemeClr val="lt1"/>
+          </a:fontRef>
+        </p:style>
+        <p:txBody>
+          <a:bodyPr rtlCol="0" anchor="ctr"/>
+          <a:lstStyle/>
+          <a:p>
+            <a:pPr algn="ctr"/>
+          </a:p>
+        </p:txBody>
+      </p:sp>
+      <p:sp>
+        <p:nvSpPr>
+          <p:cNvPr id="12" name="TextBox 11"/>
+          <p:cNvSpPr txBox="1"/>
+          <p:nvPr/>
+        </p:nvSpPr>
+        <p:spPr>
+          <a:xfrm>
+            <a:off x="7955280" y="3355848"/>
+            <a:ext cx="3468319" cy="502920"/>
+          </a:xfrm>
+          <a:prstGeom prst="rect">
+            <a:avLst/>
+          </a:prstGeom>
+          <a:noFill/>
+        </p:spPr>
+        <p:txBody>
+          <a:bodyPr wrap="square" anchor="t" lIns="0" rIns="0" tIns="0" bIns="0">
+            <a:spAutoFit/>
+          </a:bodyPr>
+          <a:lstStyle/>
+          <a:p>
+            <a:pPr algn="l"/>
+            <a:r>
+              <a:rPr sz="3000" b="1" i="0">
+                <a:solidFill>
+                  <a:srgbClr val="5E8614"/>
+                </a:solidFill>
+                <a:latin typeface="Arial"/>
+                <a:cs typeface="Arial"/>
+              </a:rPr>
+              <a:t>7.8 × 10</a:t>
+            </a:r>
+            <a:r>
+              <a:rPr sz="3000" b="1" i="0" baseline="30000">
+                <a:solidFill>
+                  <a:srgbClr val="5E8614"/>
+                </a:solidFill>
+                <a:latin typeface="Arial"/>
+                <a:cs typeface="Arial"/>
+              </a:rPr>
+              <a:t>−8</a:t>
+            </a:r>
+          </a:p>
+        </p:txBody>
+      </p:sp>
+      <p:sp>
+        <p:nvSpPr>
+          <p:cNvPr id="13" name="TextBox 12"/>
+          <p:cNvSpPr txBox="1"/>
+          <p:nvPr/>
+        </p:nvSpPr>
+        <p:spPr>
+          <a:xfrm>
+            <a:off x="7955280" y="3904488"/>
+            <a:ext cx="3468319" cy="475488"/>
+          </a:xfrm>
+          <a:prstGeom prst="rect">
+            <a:avLst/>
+          </a:prstGeom>
+          <a:noFill/>
+        </p:spPr>
+        <p:txBody>
+          <a:bodyPr wrap="square" anchor="t" lIns="0" rIns="0" tIns="0" bIns="0">
+            <a:spAutoFit/>
+          </a:bodyPr>
+          <a:lstStyle/>
+          <a:p>
+            <a:pPr algn="l">
+              <a:lnSpc>
+                <a:spcPct val="105000"/>
+              </a:lnSpc>
+            </a:pPr>
+            <a:r>
+              <a:rPr sz="1150" b="0" i="0">
+                <a:solidFill>
+                  <a:srgbClr val="59595C"/>
+                </a:solidFill>
+                <a:latin typeface="Arial"/>
+                <a:cs typeface="Arial"/>
+              </a:rPr>
+              <a:t>max relative difference,</a:t>
+            </a:r>
+          </a:p>
+          <a:p>
+            <a:pPr algn="l">
+              <a:lnSpc>
+                <a:spcPct val="105000"/>
+              </a:lnSpc>
+            </a:pPr>
+            <a:r>
+              <a:rPr sz="1150" b="0" i="0">
+                <a:solidFill>
+                  <a:srgbClr val="59595C"/>
+                </a:solidFill>
+                <a:latin typeface="Arial"/>
+                <a:cs typeface="Arial"/>
+              </a:rPr>
+              <a:t>displacements</a:t>
+            </a:r>
+          </a:p>
+        </p:txBody>
+      </p:sp>
+      <p:sp>
+        <p:nvSpPr>
+          <p:cNvPr id="14" name="TextBox 13"/>
+          <p:cNvSpPr txBox="1"/>
+          <p:nvPr/>
+        </p:nvSpPr>
+        <p:spPr>
+          <a:xfrm>
+            <a:off x="7699248" y="4700016"/>
+            <a:ext cx="3925519" cy="731520"/>
+          </a:xfrm>
+          <a:prstGeom prst="rect">
+            <a:avLst/>
+          </a:prstGeom>
+          <a:noFill/>
+        </p:spPr>
+        <p:txBody>
+          <a:bodyPr wrap="square" anchor="t" lIns="0" rIns="0" tIns="0" bIns="0">
+            <a:spAutoFit/>
+          </a:bodyPr>
+          <a:lstStyle/>
+          <a:p>
+            <a:pPr algn="l">
+              <a:lnSpc>
+                <a:spcPct val="110000"/>
+              </a:lnSpc>
+            </a:pPr>
+            <a:r>
+              <a:rPr sz="1150" b="0" i="1">
+                <a:solidFill>
+                  <a:srgbClr val="59595C"/>
+                </a:solidFill>
+                <a:latin typeface="Arial"/>
+                <a:cs typeface="Arial"/>
+              </a:rPr>
+              <a:t>node-by-node scatter: every point on the identity line</a:t>
+            </a:r>
+          </a:p>
+        </p:txBody>
+      </p:sp>
+      <p:sp>
+        <p:nvSpPr>
+          <p:cNvPr id="15" name="Rounded Rectangle 14"/>
+          <p:cNvSpPr/>
+          <p:nvPr/>
+        </p:nvSpPr>
+        <p:spPr>
+          <a:xfrm>
+            <a:off x="566928" y="5394960"/>
+            <a:ext cx="11057839" cy="658368"/>
+          </a:xfrm>
+          <a:prstGeom prst="roundRect">
+            <a:avLst>
+              <a:gd name="adj" fmla="val 5500"/>
+            </a:avLst>
+          </a:prstGeom>
+          <a:solidFill>
+            <a:srgbClr val="FDF0DF"/>
+          </a:solidFill>
+          <a:ln w="12700">
+            <a:solidFill>
+              <a:srgbClr val="B4620B"/>
+            </a:solidFill>
+          </a:ln>
+          <a:effectLst/>
+        </p:spPr>
+        <p:style>
+          <a:lnRef idx="1">
+            <a:schemeClr val="accent1"/>
+          </a:lnRef>
+          <a:fillRef idx="3">
+            <a:schemeClr val="accent1"/>
+          </a:fillRef>
+          <a:effectRef idx="2">
+            <a:schemeClr val="accent1"/>
+          </a:effectRef>
+          <a:fontRef idx="minor">
+            <a:schemeClr val="lt1"/>
+          </a:fontRef>
+        </p:style>
+        <p:txBody>
+          <a:bodyPr rtlCol="0" anchor="ctr"/>
+          <a:lstStyle/>
+          <a:p>
+            <a:pPr algn="ctr"/>
+          </a:p>
+        </p:txBody>
+      </p:sp>
+      <p:sp>
+        <p:nvSpPr>
+          <p:cNvPr id="16" name="TextBox 15"/>
+          <p:cNvSpPr txBox="1"/>
+          <p:nvPr/>
+        </p:nvSpPr>
+        <p:spPr>
+          <a:xfrm>
+            <a:off x="841248" y="5394960"/>
+            <a:ext cx="10509199" cy="658368"/>
+          </a:xfrm>
+          <a:prstGeom prst="rect">
+            <a:avLst/>
+          </a:prstGeom>
+          <a:noFill/>
+        </p:spPr>
+        <p:txBody>
+          <a:bodyPr wrap="square" anchor="ctr" lIns="0" rIns="0" tIns="0" bIns="0">
+            <a:spAutoFit/>
+          </a:bodyPr>
+          <a:lstStyle/>
+          <a:p>
+            <a:pPr algn="l"/>
+            <a:r>
+              <a:rPr sz="1500" b="1" i="0">
+                <a:solidFill>
+                  <a:srgbClr val="1E2430"/>
+                </a:solidFill>
+                <a:latin typeface="Arial"/>
+                <a:cs typeface="Arial"/>
+              </a:rPr>
+              <a:t>Any error in the interface would appear here — it doesn't.</a:t>
+            </a:r>
+            <a:r>
+              <a:rPr sz="1500" b="0" i="0">
+                <a:solidFill>
+                  <a:srgbClr val="3A3F47"/>
+                </a:solidFill>
+                <a:latin typeface="Arial"/>
+                <a:cs typeface="Arial"/>
+              </a:rPr>
+              <a:t> The NEML2 force path reproduces MOOSE's native assembly to solver precision.</a:t>
+            </a:r>
+          </a:p>
+        </p:txBody>
+      </p:sp>
+    </p:spTree>
+  </p:cSld>
+  <p:clrMapOvr>
+    <a:masterClrMapping/>
+  </p:clrMapOvr>
+</p:sld>
+</file>
+
+<file path=ppt/slides/slide14.xml><?xml version="1.0" encoding="utf-8"?>
+<p:sld xmlns:a="http://schemas.openxmlformats.org/drawingml/2006/main" xmlns:p="http://schemas.openxmlformats.org/presentationml/2006/main" xmlns:r="http://schemas.openxmlformats.org/officeDocument/2006/relationships">
+  <p:cSld>
+    <p:spTree>
+      <p:nvGrpSpPr>
+        <p:cNvPr id="1" name=""/>
+        <p:cNvGrpSpPr/>
+        <p:nvPr/>
+      </p:nvGrpSpPr>
+      <p:grpSpPr/>
+      <p:sp>
+        <p:nvSpPr>
+          <p:cNvPr id="2" name="Title 1"/>
+          <p:cNvSpPr>
+            <a:spLocks noGrp="1"/>
+          </p:cNvSpPr>
+          <p:nvPr>
+            <p:ph type="title"/>
+          </p:nvPr>
+        </p:nvSpPr>
+        <p:spPr/>
+        <p:txBody>
+          <a:bodyPr/>
+          <a:lstStyle/>
+          <a:p>
+            <a:r>
+              <a:rPr sz="2600"/>
+              <a:t>3-D Taylor anvil impact, end to end</a:t>
+            </a:r>
+          </a:p>
+        </p:txBody>
+      </p:sp>
+      <p:sp>
+        <p:nvSpPr>
+          <p:cNvPr id="3" name="TextBox 2"/>
+          <p:cNvSpPr txBox="1"/>
+          <p:nvPr/>
+        </p:nvSpPr>
+        <p:spPr>
+          <a:xfrm>
+            <a:off x="11231575" y="274320"/>
+            <a:ext cx="685800" cy="228600"/>
+          </a:xfrm>
+          <a:prstGeom prst="rect">
+            <a:avLst/>
+          </a:prstGeom>
+          <a:noFill/>
+        </p:spPr>
+        <p:txBody>
+          <a:bodyPr wrap="square" anchor="t" lIns="0" rIns="0" tIns="0" bIns="0">
+            <a:spAutoFit/>
+          </a:bodyPr>
+          <a:lstStyle/>
+          <a:p>
+            <a:pPr algn="r"/>
+            <a:r>
+              <a:rPr sz="900" b="0" i="0">
+                <a:solidFill>
+                  <a:srgbClr val="59595C"/>
+                </a:solidFill>
+                <a:latin typeface="Arial"/>
+                <a:cs typeface="Arial"/>
+              </a:rPr>
+              <a:t>14 / 14</a:t>
+            </a:r>
+          </a:p>
+        </p:txBody>
+      </p:sp>
+      <p:sp>
+        <p:nvSpPr>
+          <p:cNvPr id="4" name="TextBox 3"/>
+          <p:cNvSpPr txBox="1"/>
+          <p:nvPr/>
+        </p:nvSpPr>
+        <p:spPr>
+          <a:xfrm>
+            <a:off x="566928" y="1133856"/>
+            <a:ext cx="11057839" cy="320040"/>
+          </a:xfrm>
+          <a:prstGeom prst="rect">
+            <a:avLst/>
+          </a:prstGeom>
+          <a:noFill/>
+        </p:spPr>
+        <p:txBody>
+          <a:bodyPr wrap="square" anchor="t" lIns="0" rIns="0" tIns="0" bIns="0">
+            <a:spAutoFit/>
+          </a:bodyPr>
+          <a:lstStyle/>
+          <a:p>
+            <a:pPr algn="l"/>
+            <a:r>
+              <a:rPr sz="1450" b="0" i="0">
+                <a:solidFill>
+                  <a:srgbClr val="3A3F47"/>
+                </a:solidFill>
+                <a:latin typeface="Arial"/>
+                <a:cs typeface="Arial"/>
+              </a:rPr>
+              <a:t>OFHC copper slug at </a:t>
+            </a:r>
+            <a:r>
+              <a:rPr sz="1450" b="1" i="0">
+                <a:solidFill>
+                  <a:srgbClr val="1E2430"/>
+                </a:solidFill>
+                <a:latin typeface="Arial"/>
+                <a:cs typeface="Arial"/>
+              </a:rPr>
+              <a:t>235.9 m/s</a:t>
+            </a:r>
+            <a:r>
+              <a:rPr sz="1450" b="0" i="0">
+                <a:solidFill>
+                  <a:srgbClr val="3A3F47"/>
+                </a:solidFill>
+                <a:latin typeface="Arial"/>
+                <a:cs typeface="Arial"/>
+              </a:rPr>
+              <a:t> — Johnson–Cook plasticity in NEML2,  Δt = 10 ns,  </a:t>
+            </a:r>
+            <a:r>
+              <a:rPr sz="1450" b="1" i="0">
+                <a:solidFill>
+                  <a:srgbClr val="1E2430"/>
+                </a:solidFill>
+                <a:latin typeface="Arial"/>
+                <a:cs typeface="Arial"/>
+              </a:rPr>
+              <a:t>~12,000 explicit steps</a:t>
+            </a:r>
+          </a:p>
+        </p:txBody>
+      </p:sp>
+      <p:pic>
+        <p:nvPicPr>
+          <p:cNvPr id="5" name="Picture 4" descr="fig_pstrain.png"/>
+          <p:cNvPicPr>
+            <a:picLocks noChangeAspect="1"/>
+          </p:cNvPicPr>
+          <p:nvPr/>
+        </p:nvPicPr>
+        <p:blipFill>
+          <a:blip r:embed="rId2"/>
+          <a:stretch>
+            <a:fillRect/>
+          </a:stretch>
+        </p:blipFill>
+        <p:spPr>
+          <a:xfrm>
+            <a:off x="566928" y="1664208"/>
+            <a:ext cx="8412480" cy="2217107"/>
+          </a:xfrm>
+          <a:prstGeom prst="rect">
+            <a:avLst/>
+          </a:prstGeom>
+        </p:spPr>
+      </p:pic>
+      <p:sp>
+        <p:nvSpPr>
+          <p:cNvPr id="6" name="Rounded Rectangle 5"/>
+          <p:cNvSpPr/>
+          <p:nvPr/>
+        </p:nvSpPr>
+        <p:spPr>
+          <a:xfrm>
+            <a:off x="9299448" y="1709928"/>
+            <a:ext cx="2325319" cy="2125667"/>
+          </a:xfrm>
+          <a:prstGeom prst="roundRect">
+            <a:avLst>
+              <a:gd name="adj" fmla="val 5500"/>
+            </a:avLst>
+          </a:prstGeom>
+          <a:solidFill>
+            <a:srgbClr val="F4F5F7"/>
+          </a:solidFill>
+          <a:ln w="9525">
+            <a:solidFill>
+              <a:srgbClr val="DADDE2"/>
+            </a:solidFill>
+          </a:ln>
+          <a:effectLst/>
+        </p:spPr>
+        <p:style>
+          <a:lnRef idx="1">
+            <a:schemeClr val="accent1"/>
+          </a:lnRef>
+          <a:fillRef idx="3">
+            <a:schemeClr val="accent1"/>
+          </a:fillRef>
+          <a:effectRef idx="2">
+            <a:schemeClr val="accent1"/>
+          </a:effectRef>
+          <a:fontRef idx="minor">
+            <a:schemeClr val="lt1"/>
+          </a:fontRef>
+        </p:style>
+        <p:txBody>
+          <a:bodyPr rtlCol="0" anchor="ctr"/>
+          <a:lstStyle/>
+          <a:p>
+            <a:pPr algn="ctr"/>
+          </a:p>
+        </p:txBody>
+      </p:sp>
+      <p:sp>
+        <p:nvSpPr>
+          <p:cNvPr id="7" name="TextBox 6"/>
+          <p:cNvSpPr txBox="1"/>
+          <p:nvPr/>
+        </p:nvSpPr>
+        <p:spPr>
+          <a:xfrm>
+            <a:off x="9500616" y="1865376"/>
+            <a:ext cx="1922983" cy="2194560"/>
+          </a:xfrm>
+          <a:prstGeom prst="rect">
+            <a:avLst/>
+          </a:prstGeom>
+          <a:noFill/>
+        </p:spPr>
+        <p:txBody>
+          <a:bodyPr wrap="square" anchor="t" lIns="0" rIns="0" tIns="0" bIns="0">
+            <a:spAutoFit/>
+          </a:bodyPr>
+          <a:lstStyle/>
+          <a:p>
+            <a:pPr algn="l">
+              <a:lnSpc>
+                <a:spcPct val="112000"/>
+              </a:lnSpc>
+            </a:pPr>
+            <a:r>
+              <a:rPr sz="1250" b="0" i="0">
+                <a:solidFill>
+                  <a:srgbClr val="3A3F47"/>
+                </a:solidFill>
+                <a:latin typeface="Arial"/>
+                <a:cs typeface="Arial"/>
+              </a:rPr>
+              <a:t>plastic strain localizes at the impact foot — peak </a:t>
+            </a:r>
+            <a:r>
+              <a:rPr sz="1250" b="0" i="1">
+                <a:solidFill>
+                  <a:srgbClr val="3A3F47"/>
+                </a:solidFill>
+                <a:latin typeface="Arial"/>
+                <a:cs typeface="Arial"/>
+              </a:rPr>
+              <a:t>ε</a:t>
+            </a:r>
+            <a:r>
+              <a:rPr sz="1250" b="0" i="0" baseline="-25000">
+                <a:solidFill>
+                  <a:srgbClr val="3A3F47"/>
+                </a:solidFill>
+                <a:latin typeface="Arial"/>
+                <a:cs typeface="Arial"/>
+              </a:rPr>
+              <a:t>p</a:t>
+            </a:r>
+            <a:r>
+              <a:rPr sz="1250" b="1" i="0">
+                <a:solidFill>
+                  <a:srgbClr val="1E2430"/>
+                </a:solidFill>
+                <a:latin typeface="Arial"/>
+                <a:cs typeface="Arial"/>
+              </a:rPr>
+              <a:t> ≈ 0.44</a:t>
+            </a:r>
+          </a:p>
+          <a:p>
+            <a:pPr algn="l">
+              <a:lnSpc>
+                <a:spcPct val="112000"/>
+              </a:lnSpc>
+            </a:pPr>
+            <a:r>
+              <a:rPr sz="1250" b="0" i="0">
+                <a:solidFill>
+                  <a:srgbClr val="3A3F47"/>
+                </a:solidFill>
+                <a:latin typeface="Arial"/>
+                <a:cs typeface="Arial"/>
+              </a:rPr>
+              <a:t/>
+            </a:r>
+          </a:p>
+          <a:p>
+            <a:pPr algn="l">
+              <a:lnSpc>
+                <a:spcPct val="112000"/>
+              </a:lnSpc>
+            </a:pPr>
+            <a:r>
+              <a:rPr sz="1250" b="0" i="0">
+                <a:solidFill>
+                  <a:srgbClr val="3A3F47"/>
+                </a:solidFill>
+                <a:latin typeface="Arial"/>
+                <a:cs typeface="Arial"/>
+              </a:rPr>
+              <a:t>mushrooming develops within the first </a:t>
+            </a:r>
+            <a:r>
+              <a:rPr sz="1250" b="1" i="0">
+                <a:solidFill>
+                  <a:srgbClr val="1E2430"/>
+                </a:solidFill>
+                <a:latin typeface="Arial"/>
+                <a:cs typeface="Arial"/>
+              </a:rPr>
+              <a:t>10 µs</a:t>
+            </a:r>
+          </a:p>
+        </p:txBody>
+      </p:sp>
+      <p:pic>
+        <p:nvPicPr>
+          <p:cNvPr id="8" name="Picture 7" descr="fig_profile.png"/>
+          <p:cNvPicPr>
+            <a:picLocks noChangeAspect="1"/>
+          </p:cNvPicPr>
+          <p:nvPr/>
+        </p:nvPicPr>
+        <p:blipFill>
+          <a:blip r:embed="rId3"/>
+          <a:stretch>
+            <a:fillRect/>
+          </a:stretch>
+        </p:blipFill>
+        <p:spPr>
+          <a:xfrm>
+            <a:off x="566928" y="4045907"/>
+            <a:ext cx="5486400" cy="1904674"/>
+          </a:xfrm>
+          <a:prstGeom prst="rect">
+            <a:avLst/>
+          </a:prstGeom>
+        </p:spPr>
+      </p:pic>
+      <p:sp>
+        <p:nvSpPr>
+          <p:cNvPr id="9" name="TextBox 8"/>
+          <p:cNvSpPr txBox="1"/>
+          <p:nvPr/>
+        </p:nvSpPr>
+        <p:spPr>
+          <a:xfrm>
+            <a:off x="6464808" y="4301939"/>
+            <a:ext cx="5159959" cy="1721794"/>
+          </a:xfrm>
+          <a:prstGeom prst="rect">
+            <a:avLst/>
+          </a:prstGeom>
+          <a:noFill/>
+        </p:spPr>
+        <p:txBody>
+          <a:bodyPr wrap="square" lIns="0" rIns="0" tIns="0" bIns="0">
+            <a:spAutoFit/>
+          </a:bodyPr>
+          <a:lstStyle/>
+          <a:p>
+            <a:pPr marL="219456" indent="-219456">
+              <a:lnSpc>
+                <a:spcPct val="106000"/>
+              </a:lnSpc>
+              <a:spcAft>
+                <a:spcPts val="1200"/>
+              </a:spcAft>
+              <a:buClr>
+                <a:srgbClr val="06509D"/>
+              </a:buClr>
+              <a:buFont typeface="Arial"/>
+              <a:buChar char="•"/>
+            </a:pPr>
+            <a:r>
+              <a:rPr sz="1350" b="0" i="0">
+                <a:solidFill>
+                  <a:srgbClr val="3A3F47"/>
+                </a:solidFill>
+                <a:latin typeface="Arial"/>
+                <a:cs typeface="Arial"/>
+              </a:rPr>
+              <a:t>Same everything — mesh, BCs, integrator. Copper temper swapped by </a:t>
+            </a:r>
+            <a:r>
+              <a:rPr sz="1350" b="1" i="0">
+                <a:solidFill>
+                  <a:srgbClr val="3A3F47"/>
+                </a:solidFill>
+                <a:latin typeface="Arial"/>
+                <a:cs typeface="Arial"/>
+              </a:rPr>
+              <a:t>changing only NEML2 material parameters</a:t>
+            </a:r>
+          </a:p>
+          <a:p>
+            <a:pPr marL="219456" indent="-219456">
+              <a:lnSpc>
+                <a:spcPct val="106000"/>
+              </a:lnSpc>
+              <a:spcAft>
+                <a:spcPts val="1200"/>
+              </a:spcAft>
+              <a:buClr>
+                <a:srgbClr val="06509D"/>
+              </a:buClr>
+              <a:buFont typeface="Arial"/>
+              <a:buChar char="•"/>
+            </a:pPr>
+            <a:r>
+              <a:rPr sz="1350" b="0" i="0">
+                <a:solidFill>
+                  <a:srgbClr val="3A3F47"/>
+                </a:solidFill>
+                <a:latin typeface="Arial"/>
+                <a:cs typeface="Arial"/>
+              </a:rPr>
+              <a:t>Final profiles: full-hard </a:t>
+            </a:r>
+            <a:r>
+              <a:rPr sz="1350" b="1" i="0">
+                <a:solidFill>
+                  <a:srgbClr val="CF1D4C"/>
+                </a:solidFill>
+                <a:latin typeface="Arial"/>
+                <a:cs typeface="Arial"/>
+              </a:rPr>
+              <a:t>51%</a:t>
+            </a:r>
+            <a:r>
+              <a:rPr sz="1350" b="0" i="0">
+                <a:solidFill>
+                  <a:srgbClr val="3A3F47"/>
+                </a:solidFill>
+                <a:latin typeface="Arial"/>
+                <a:cs typeface="Arial"/>
+              </a:rPr>
+              <a:t> vs annealed </a:t>
+            </a:r>
+            <a:r>
+              <a:rPr sz="1350" b="1" i="0">
+                <a:solidFill>
+                  <a:srgbClr val="06509D"/>
+                </a:solidFill>
+                <a:latin typeface="Arial"/>
+                <a:cs typeface="Arial"/>
+              </a:rPr>
+              <a:t>58%</a:t>
+            </a:r>
+            <a:r>
+              <a:rPr sz="1350" b="0" i="0">
+                <a:solidFill>
+                  <a:srgbClr val="3A3F47"/>
+                </a:solidFill>
+                <a:latin typeface="Arial"/>
+                <a:cs typeface="Arial"/>
+              </a:rPr>
+              <a:t> axial shortening — temper sensitivity captured</a:t>
             </a:r>
           </a:p>
         </p:txBody>
@@ -9731,7 +10888,7 @@
                 <a:latin typeface="Arial"/>
                 <a:cs typeface="Arial"/>
               </a:rPr>
-              <a:t>2 / 12</a:t>
+              <a:t>2 / 14</a:t>
             </a:r>
           </a:p>
         </p:txBody>
@@ -10688,7 +11845,7 @@
                 <a:latin typeface="Arial"/>
                 <a:cs typeface="Arial"/>
               </a:rPr>
-              <a:t>3 / 12</a:t>
+              <a:t>3 / 14</a:t>
             </a:r>
           </a:p>
         </p:txBody>
@@ -11365,7 +12522,7 @@
                 <a:latin typeface="Arial"/>
                 <a:cs typeface="Arial"/>
               </a:rPr>
-              <a:t>4 / 12</a:t>
+              <a:t>4 / 14</a:t>
             </a:r>
           </a:p>
         </p:txBody>
@@ -11795,7 +12952,7 @@
                 <a:latin typeface="Arial"/>
                 <a:cs typeface="Arial"/>
               </a:rPr>
-              <a:t>5 / 12</a:t>
+              <a:t>5 / 14</a:t>
             </a:r>
           </a:p>
         </p:txBody>
@@ -12520,7 +13677,7 @@
                 <a:latin typeface="Arial"/>
                 <a:cs typeface="Arial"/>
               </a:rPr>
-              <a:t>6 / 12</a:t>
+              <a:t>6 / 14</a:t>
             </a:r>
           </a:p>
         </p:txBody>
@@ -13390,7 +14547,7 @@
                 <a:latin typeface="Arial"/>
                 <a:cs typeface="Arial"/>
               </a:rPr>
-              <a:t>7 / 12</a:t>
+              <a:t>7 / 14</a:t>
             </a:r>
           </a:p>
         </p:txBody>
@@ -14624,7 +15781,7 @@
                 <a:latin typeface="Arial"/>
                 <a:cs typeface="Arial"/>
               </a:rPr>
-              <a:t>8 / 12</a:t>
+              <a:t>8 / 14</a:t>
             </a:r>
           </a:p>
         </p:txBody>
@@ -16812,7 +17969,7 @@
                 <a:latin typeface="Arial"/>
                 <a:cs typeface="Arial"/>
               </a:rPr>
-              <a:t>9 / 12</a:t>
+              <a:t>9 / 14</a:t>
             </a:r>
           </a:p>
         </p:txBody>

</xml_diff>

<commit_message>
slides: redesign results figures to show the physics directly
- verification: force FIELDS side by side + difference strip (needs a
  1e8 magnification) instead of identity scatter; error normalized by
  peak force (3e-8) rather than the floor-inflated per-node metric
- Taylor demo: meridional cross-section sequence (azimuthally
  projected, Blues ramp) replaces the 3D exterior render; temper
  profile redrawn as mirrored halves (full-hard top / annealed bottom)
- johnson_cook_neml2_thermal.i: production coupled input — adiabatic
  Taylor-Quinney heating inside NEML2, reformulated in temperature
  RISE (state/dT, zero-init exact; T* = dT/1038) with lagged coupling
  via state/dT~1; smoke-tested (dT matches hand estimate at 1 us)

Co-Authored-By: Claude Fable 5 <noreply@anthropic.com>
Claude-Session: https://claude.ai/code/session_01CCuKo2gP6Duy91irEj5f1y
</commit_message>
<xml_diff>
--- a/examples/impact/slide_assets/WCCM_NEML2_explicit_dynamics_v2.pptx
+++ b/examples/impact/slide_assets/WCCM_NEML2_explicit_dynamics_v2.pptx
@@ -9810,8 +9810,8 @@
         </p:blipFill>
         <p:spPr>
           <a:xfrm>
-            <a:off x="566928" y="1709928"/>
-            <a:ext cx="6720840" cy="3237500"/>
+            <a:off x="566928" y="1664208"/>
+            <a:ext cx="7040880" cy="3110107"/>
           </a:xfrm>
           <a:prstGeom prst="rect">
             <a:avLst/>
@@ -9820,14 +9820,50 @@
       </p:pic>
       <p:sp>
         <p:nvSpPr>
-          <p:cNvPr id="6" name="Rounded Rectangle 5"/>
+          <p:cNvPr id="6" name="TextBox 5"/>
+          <p:cNvSpPr txBox="1"/>
+          <p:nvPr/>
+        </p:nvSpPr>
+        <p:spPr>
+          <a:xfrm>
+            <a:off x="658368" y="4847467"/>
+            <a:ext cx="7040880" cy="274320"/>
+          </a:xfrm>
+          <a:prstGeom prst="rect">
+            <a:avLst/>
+          </a:prstGeom>
+          <a:noFill/>
+        </p:spPr>
+        <p:txBody>
+          <a:bodyPr wrap="square" anchor="t" lIns="0" rIns="0" tIns="0" bIns="0">
+            <a:spAutoFit/>
+          </a:bodyPr>
+          <a:lstStyle/>
+          <a:p>
+            <a:pPr algn="l"/>
+            <a:r>
+              <a:rPr sz="1100" b="0" i="1">
+                <a:solidFill>
+                  <a:srgbClr val="59595C"/>
+                </a:solidFill>
+                <a:latin typeface="Arial"/>
+                <a:cs typeface="Arial"/>
+              </a:rPr>
+              <a:t>2-D slug impact test problem — internal force field at the final step; impact face at left</a:t>
+            </a:r>
+          </a:p>
+        </p:txBody>
+      </p:sp>
+      <p:sp>
+        <p:nvSpPr>
+          <p:cNvPr id="7" name="Rounded Rectangle 6"/>
           <p:cNvSpPr/>
           <p:nvPr/>
         </p:nvSpPr>
         <p:spPr>
           <a:xfrm>
-            <a:off x="7699248" y="1801368"/>
-            <a:ext cx="3925519" cy="1207008"/>
+            <a:off x="8019288" y="1801368"/>
+            <a:ext cx="3605479" cy="1207008"/>
           </a:xfrm>
           <a:prstGeom prst="roundRect">
             <a:avLst>
@@ -9868,13 +9904,13 @@
       </p:sp>
       <p:sp>
         <p:nvSpPr>
-          <p:cNvPr id="7" name="Rectangle 6"/>
+          <p:cNvPr id="8" name="Rectangle 7"/>
           <p:cNvSpPr/>
           <p:nvPr/>
         </p:nvSpPr>
         <p:spPr>
           <a:xfrm>
-            <a:off x="7699248" y="1911096"/>
+            <a:off x="8019288" y="1911096"/>
             <a:ext cx="50292" cy="987552"/>
           </a:xfrm>
           <a:prstGeom prst="rect">
@@ -9912,14 +9948,14 @@
       </p:sp>
       <p:sp>
         <p:nvSpPr>
-          <p:cNvPr id="8" name="TextBox 7"/>
+          <p:cNvPr id="9" name="TextBox 8"/>
           <p:cNvSpPr txBox="1"/>
           <p:nvPr/>
         </p:nvSpPr>
         <p:spPr>
           <a:xfrm>
-            <a:off x="7955280" y="1929384"/>
-            <a:ext cx="3468319" cy="502920"/>
+            <a:off x="8275320" y="1929384"/>
+            <a:ext cx="3148279" cy="502920"/>
           </a:xfrm>
           <a:prstGeom prst="rect">
             <a:avLst/>
@@ -9941,7 +9977,7 @@
                 <a:latin typeface="Arial"/>
                 <a:cs typeface="Arial"/>
               </a:rPr>
-              <a:t>3.8 × 10</a:t>
+              <a:t>≤ 3 × 10</a:t>
             </a:r>
             <a:r>
               <a:rPr sz="3000" b="1" i="0" baseline="30000">
@@ -9951,21 +9987,21 @@
                 <a:latin typeface="Arial"/>
                 <a:cs typeface="Arial"/>
               </a:rPr>
-              <a:t>−4</a:t>
-            </a:r>
-          </a:p>
-        </p:txBody>
-      </p:sp>
-      <p:sp>
-        <p:nvSpPr>
-          <p:cNvPr id="9" name="TextBox 8"/>
+              <a:t>−8</a:t>
+            </a:r>
+          </a:p>
+        </p:txBody>
+      </p:sp>
+      <p:sp>
+        <p:nvSpPr>
+          <p:cNvPr id="10" name="TextBox 9"/>
           <p:cNvSpPr txBox="1"/>
           <p:nvPr/>
         </p:nvSpPr>
         <p:spPr>
           <a:xfrm>
-            <a:off x="7955280" y="2478024"/>
-            <a:ext cx="3468319" cy="475488"/>
+            <a:off x="8275320" y="2478024"/>
+            <a:ext cx="3148279" cy="475488"/>
           </a:xfrm>
           <a:prstGeom prst="rect">
             <a:avLst/>
@@ -9991,7 +10027,7 @@
                 <a:latin typeface="Arial"/>
                 <a:cs typeface="Arial"/>
               </a:rPr>
-              <a:t>max relative difference,</a:t>
+              <a:t>difference in nodal forces,</a:t>
             </a:r>
           </a:p>
           <a:p>
@@ -10008,21 +10044,21 @@
                 <a:latin typeface="Arial"/>
                 <a:cs typeface="Arial"/>
               </a:rPr>
-              <a:t>internal nodal forces</a:t>
-            </a:r>
-          </a:p>
-        </p:txBody>
-      </p:sp>
-      <p:sp>
-        <p:nvSpPr>
-          <p:cNvPr id="10" name="Rounded Rectangle 9"/>
+              <a:t>relative to the peak force</a:t>
+            </a:r>
+          </a:p>
+        </p:txBody>
+      </p:sp>
+      <p:sp>
+        <p:nvSpPr>
+          <p:cNvPr id="11" name="Rounded Rectangle 10"/>
           <p:cNvSpPr/>
           <p:nvPr/>
         </p:nvSpPr>
         <p:spPr>
           <a:xfrm>
-            <a:off x="7699248" y="3227832"/>
-            <a:ext cx="3925519" cy="1207008"/>
+            <a:off x="8019288" y="3227832"/>
+            <a:ext cx="3605479" cy="1207008"/>
           </a:xfrm>
           <a:prstGeom prst="roundRect">
             <a:avLst>
@@ -10063,13 +10099,13 @@
       </p:sp>
       <p:sp>
         <p:nvSpPr>
-          <p:cNvPr id="11" name="Rectangle 10"/>
+          <p:cNvPr id="12" name="Rectangle 11"/>
           <p:cNvSpPr/>
           <p:nvPr/>
         </p:nvSpPr>
         <p:spPr>
           <a:xfrm>
-            <a:off x="7699248" y="3337560"/>
+            <a:off x="8019288" y="3337560"/>
             <a:ext cx="50292" cy="987552"/>
           </a:xfrm>
           <a:prstGeom prst="rect">
@@ -10107,14 +10143,14 @@
       </p:sp>
       <p:sp>
         <p:nvSpPr>
-          <p:cNvPr id="12" name="TextBox 11"/>
+          <p:cNvPr id="13" name="TextBox 12"/>
           <p:cNvSpPr txBox="1"/>
           <p:nvPr/>
         </p:nvSpPr>
         <p:spPr>
           <a:xfrm>
-            <a:off x="7955280" y="3355848"/>
-            <a:ext cx="3468319" cy="502920"/>
+            <a:off x="8275320" y="3355848"/>
+            <a:ext cx="3148279" cy="502920"/>
           </a:xfrm>
           <a:prstGeom prst="rect">
             <a:avLst/>
@@ -10136,7 +10172,7 @@
                 <a:latin typeface="Arial"/>
                 <a:cs typeface="Arial"/>
               </a:rPr>
-              <a:t>7.8 × 10</a:t>
+              <a:t>≤ 8 × 10</a:t>
             </a:r>
             <a:r>
               <a:rPr sz="3000" b="1" i="0" baseline="30000">
@@ -10153,14 +10189,14 @@
       </p:sp>
       <p:sp>
         <p:nvSpPr>
-          <p:cNvPr id="13" name="TextBox 12"/>
+          <p:cNvPr id="14" name="TextBox 13"/>
           <p:cNvSpPr txBox="1"/>
           <p:nvPr/>
         </p:nvSpPr>
         <p:spPr>
           <a:xfrm>
-            <a:off x="7955280" y="3904488"/>
-            <a:ext cx="3468319" cy="475488"/>
+            <a:off x="8275320" y="3904488"/>
+            <a:ext cx="3148279" cy="475488"/>
           </a:xfrm>
           <a:prstGeom prst="rect">
             <a:avLst/>
@@ -10186,7 +10222,7 @@
                 <a:latin typeface="Arial"/>
                 <a:cs typeface="Arial"/>
               </a:rPr>
-              <a:t>max relative difference,</a:t>
+              <a:t>max relative difference</a:t>
             </a:r>
           </a:p>
           <a:p>
@@ -10203,21 +10239,21 @@
                 <a:latin typeface="Arial"/>
                 <a:cs typeface="Arial"/>
               </a:rPr>
-              <a:t>displacements</a:t>
-            </a:r>
-          </a:p>
-        </p:txBody>
-      </p:sp>
-      <p:sp>
-        <p:nvSpPr>
-          <p:cNvPr id="14" name="TextBox 13"/>
+              <a:t>in displacements</a:t>
+            </a:r>
+          </a:p>
+        </p:txBody>
+      </p:sp>
+      <p:sp>
+        <p:nvSpPr>
+          <p:cNvPr id="15" name="TextBox 14"/>
           <p:cNvSpPr txBox="1"/>
           <p:nvPr/>
         </p:nvSpPr>
         <p:spPr>
           <a:xfrm>
-            <a:off x="7699248" y="4700016"/>
-            <a:ext cx="3925519" cy="731520"/>
+            <a:off x="8019288" y="4700016"/>
+            <a:ext cx="3605479" cy="731520"/>
           </a:xfrm>
           <a:prstGeom prst="rect">
             <a:avLst/>
@@ -10243,14 +10279,14 @@
                 <a:latin typeface="Arial"/>
                 <a:cs typeface="Arial"/>
               </a:rPr>
-              <a:t>node-by-node scatter: every point on the identity line</a:t>
-            </a:r>
-          </a:p>
-        </p:txBody>
-      </p:sp>
-      <p:sp>
-        <p:nvSpPr>
-          <p:cNvPr id="15" name="Rounded Rectangle 14"/>
+              <a:t>the difference panel needs a 10⁸ magnification to show anything at all</a:t>
+            </a:r>
+          </a:p>
+        </p:txBody>
+      </p:sp>
+      <p:sp>
+        <p:nvSpPr>
+          <p:cNvPr id="16" name="Rounded Rectangle 15"/>
           <p:cNvSpPr/>
           <p:nvPr/>
         </p:nvSpPr>
@@ -10298,7 +10334,7 @@
       </p:sp>
       <p:sp>
         <p:nvSpPr>
-          <p:cNvPr id="16" name="TextBox 15"/>
+          <p:cNvPr id="17" name="TextBox 16"/>
           <p:cNvSpPr txBox="1"/>
           <p:nvPr/>
         </p:nvSpPr>
@@ -10337,7 +10373,27 @@
                 <a:latin typeface="Arial"/>
                 <a:cs typeface="Arial"/>
               </a:rPr>
-              <a:t> The NEML2 force path reproduces MOOSE's native assembly to solver precision.</a:t>
+              <a:t> The NEML2 force path reproduces MOOSE's native assembly to one part in 10</a:t>
+            </a:r>
+            <a:r>
+              <a:rPr sz="1500" b="0" i="0" baseline="30000">
+                <a:solidFill>
+                  <a:srgbClr val="3A3F47"/>
+                </a:solidFill>
+                <a:latin typeface="Arial"/>
+                <a:cs typeface="Arial"/>
+              </a:rPr>
+              <a:t>8</a:t>
+            </a:r>
+            <a:r>
+              <a:rPr sz="1500" b="0" i="0">
+                <a:solidFill>
+                  <a:srgbClr val="3A3F47"/>
+                </a:solidFill>
+                <a:latin typeface="Arial"/>
+                <a:cs typeface="Arial"/>
+              </a:rPr>
+              <a:t>.</a:t>
             </a:r>
           </a:p>
         </p:txBody>
@@ -10500,8 +10556,8 @@
         </p:blipFill>
         <p:spPr>
           <a:xfrm>
-            <a:off x="566928" y="1664208"/>
-            <a:ext cx="8412480" cy="2217107"/>
+            <a:off x="749808" y="1645920"/>
+            <a:ext cx="10424160" cy="2028611"/>
           </a:xfrm>
           <a:prstGeom prst="rect">
             <a:avLst/>
@@ -10510,62 +10566,14 @@
       </p:pic>
       <p:sp>
         <p:nvSpPr>
-          <p:cNvPr id="6" name="Rounded Rectangle 5"/>
-          <p:cNvSpPr/>
-          <p:nvPr/>
-        </p:nvSpPr>
-        <p:spPr>
-          <a:xfrm>
-            <a:off x="9299448" y="1709928"/>
-            <a:ext cx="2325319" cy="2125667"/>
-          </a:xfrm>
-          <a:prstGeom prst="roundRect">
-            <a:avLst>
-              <a:gd name="adj" fmla="val 5500"/>
-            </a:avLst>
-          </a:prstGeom>
-          <a:solidFill>
-            <a:srgbClr val="F4F5F7"/>
-          </a:solidFill>
-          <a:ln w="9525">
-            <a:solidFill>
-              <a:srgbClr val="DADDE2"/>
-            </a:solidFill>
-          </a:ln>
-          <a:effectLst/>
-        </p:spPr>
-        <p:style>
-          <a:lnRef idx="1">
-            <a:schemeClr val="accent1"/>
-          </a:lnRef>
-          <a:fillRef idx="3">
-            <a:schemeClr val="accent1"/>
-          </a:fillRef>
-          <a:effectRef idx="2">
-            <a:schemeClr val="accent1"/>
-          </a:effectRef>
-          <a:fontRef idx="minor">
-            <a:schemeClr val="lt1"/>
-          </a:fontRef>
-        </p:style>
-        <p:txBody>
-          <a:bodyPr rtlCol="0" anchor="ctr"/>
-          <a:lstStyle/>
-          <a:p>
-            <a:pPr algn="ctr"/>
-          </a:p>
-        </p:txBody>
-      </p:sp>
-      <p:sp>
-        <p:nvSpPr>
-          <p:cNvPr id="7" name="TextBox 6"/>
+          <p:cNvPr id="6" name="TextBox 5"/>
           <p:cNvSpPr txBox="1"/>
           <p:nvPr/>
         </p:nvSpPr>
         <p:spPr>
           <a:xfrm>
-            <a:off x="9500616" y="1865376"/>
-            <a:ext cx="1922983" cy="2194560"/>
+            <a:off x="841248" y="3720251"/>
+            <a:ext cx="10058400" cy="256032"/>
           </a:xfrm>
           <a:prstGeom prst="rect">
             <a:avLst/>
@@ -10578,101 +10586,23 @@
           </a:bodyPr>
           <a:lstStyle/>
           <a:p>
-            <a:pPr algn="l">
-              <a:lnSpc>
-                <a:spcPct val="112000"/>
-              </a:lnSpc>
-            </a:pPr>
-            <a:r>
-              <a:rPr sz="1250" b="0" i="0">
-                <a:solidFill>
-                  <a:srgbClr val="3A3F47"/>
-                </a:solidFill>
-                <a:latin typeface="Arial"/>
-                <a:cs typeface="Arial"/>
-              </a:rPr>
-              <a:t>plastic strain localizes at the impact foot — peak </a:t>
-            </a:r>
-            <a:r>
-              <a:rPr sz="1250" b="0" i="1">
-                <a:solidFill>
-                  <a:srgbClr val="3A3F47"/>
-                </a:solidFill>
-                <a:latin typeface="Arial"/>
-                <a:cs typeface="Arial"/>
-              </a:rPr>
-              <a:t>ε</a:t>
-            </a:r>
-            <a:r>
-              <a:rPr sz="1250" b="0" i="0" baseline="-25000">
-                <a:solidFill>
-                  <a:srgbClr val="3A3F47"/>
-                </a:solidFill>
-                <a:latin typeface="Arial"/>
-                <a:cs typeface="Arial"/>
-              </a:rPr>
-              <a:t>p</a:t>
-            </a:r>
-            <a:r>
-              <a:rPr sz="1250" b="1" i="0">
-                <a:solidFill>
-                  <a:srgbClr val="1E2430"/>
-                </a:solidFill>
-                <a:latin typeface="Arial"/>
-                <a:cs typeface="Arial"/>
-              </a:rPr>
-              <a:t> ≈ 0.44</a:t>
-            </a:r>
-          </a:p>
-          <a:p>
-            <a:pPr algn="l">
-              <a:lnSpc>
-                <a:spcPct val="112000"/>
-              </a:lnSpc>
-            </a:pPr>
-            <a:r>
-              <a:rPr sz="1250" b="0" i="0">
-                <a:solidFill>
-                  <a:srgbClr val="3A3F47"/>
-                </a:solidFill>
-                <a:latin typeface="Arial"/>
-                <a:cs typeface="Arial"/>
-              </a:rPr>
-              <a:t/>
-            </a:r>
-          </a:p>
-          <a:p>
-            <a:pPr algn="l">
-              <a:lnSpc>
-                <a:spcPct val="112000"/>
-              </a:lnSpc>
-            </a:pPr>
-            <a:r>
-              <a:rPr sz="1250" b="0" i="0">
-                <a:solidFill>
-                  <a:srgbClr val="3A3F47"/>
-                </a:solidFill>
-                <a:latin typeface="Arial"/>
-                <a:cs typeface="Arial"/>
-              </a:rPr>
-              <a:t>mushrooming develops within the first </a:t>
-            </a:r>
-            <a:r>
-              <a:rPr sz="1250" b="1" i="0">
-                <a:solidFill>
-                  <a:srgbClr val="1E2430"/>
-                </a:solidFill>
-                <a:latin typeface="Arial"/>
-                <a:cs typeface="Arial"/>
-              </a:rPr>
-              <a:t>10 µs</a:t>
+            <a:pPr algn="l"/>
+            <a:r>
+              <a:rPr sz="1100" b="0" i="1">
+                <a:solidFill>
+                  <a:srgbClr val="59595C"/>
+                </a:solidFill>
+                <a:latin typeface="Arial"/>
+                <a:cs typeface="Arial"/>
+              </a:rPr>
+              <a:t>meridional cross-sections (azimuthally projected) — plastic strain localizes at the impact foot</a:t>
             </a:r>
           </a:p>
         </p:txBody>
       </p:sp>
       <p:pic>
         <p:nvPicPr>
-          <p:cNvPr id="8" name="Picture 7" descr="fig_profile.png"/>
+          <p:cNvPr id="7" name="Picture 6" descr="fig_profile.png"/>
           <p:cNvPicPr>
             <a:picLocks noChangeAspect="1"/>
           </p:cNvPicPr>
@@ -10686,8 +10616,8 @@
         </p:blipFill>
         <p:spPr>
           <a:xfrm>
-            <a:off x="566928" y="4045907"/>
-            <a:ext cx="5486400" cy="1904674"/>
+            <a:off x="566928" y="3985427"/>
+            <a:ext cx="5394960" cy="2069343"/>
           </a:xfrm>
           <a:prstGeom prst="rect">
             <a:avLst/>
@@ -10696,14 +10626,14 @@
       </p:pic>
       <p:sp>
         <p:nvSpPr>
-          <p:cNvPr id="9" name="TextBox 8"/>
+          <p:cNvPr id="8" name="TextBox 7"/>
           <p:cNvSpPr txBox="1"/>
           <p:nvPr/>
         </p:nvSpPr>
         <p:spPr>
           <a:xfrm>
-            <a:off x="6464808" y="4301939"/>
-            <a:ext cx="5159959" cy="1721794"/>
+            <a:off x="6419088" y="4259747"/>
+            <a:ext cx="5205679" cy="1886463"/>
           </a:xfrm>
           <a:prstGeom prst="rect">
             <a:avLst/>
@@ -10737,7 +10667,7 @@
                 <a:latin typeface="Arial"/>
                 <a:cs typeface="Arial"/>
               </a:rPr>
-              <a:t>Same everything — mesh, BCs, integrator. Copper temper swapped by </a:t>
+              <a:t>Same mesh, BCs, integrator — the copper temper is swapped by </a:t>
             </a:r>
             <a:r>
               <a:rPr sz="1350" b="1" i="0">
@@ -10772,7 +10702,7 @@
                 <a:latin typeface="Arial"/>
                 <a:cs typeface="Arial"/>
               </a:rPr>
-              <a:t>Final profiles: full-hard </a:t>
+              <a:t>Full-hard </a:t>
             </a:r>
             <a:r>
               <a:rPr sz="1350" b="1" i="0">

</xml_diff>

<commit_message>
slides: ParaView-style 3D renders + thermal results slide 15
- render_3d.py: pyvista offscreen pipeline — cutaway 3D sequences of
  plastic strain (viridis) and temperature rise (inferno) with a fixed
  camera so the bar visibly shortens across frames, rigid-anvil plane,
  solid-shaded temper comparison (undeformed/full-hard/annealed), and
  crisp flat renders for the verification field strips
- slide 15: coupled thermo-mechanics — dT ~ 120 K at the foot; run to
  114 us (>99% of impact KE dissipated; identical failure step on the
  relaxed-Newton rerun points to endgame element distortion, not
  solver tolerance)
- deckkit: fix INL footer text clipping (template box was 0.107in tall;
  grown to 0.32in during base generation)
- thermal input: relaxed Newton settings documented

Co-Authored-By: Claude Fable 5 <noreply@anthropic.com>
Claude-Session: https://claude.ai/code/session_01CCuKo2gP6Duy91irEj5f1y
</commit_message>
<xml_diff>
--- a/examples/impact/slide_assets/WCCM_NEML2_explicit_dynamics_v2.pptx
+++ b/examples/impact/slide_assets/WCCM_NEML2_explicit_dynamics_v2.pptx
@@ -22,6 +22,7 @@
     <p:sldId id="267" r:id="rId21"/>
     <p:sldId id="268" r:id="rId22"/>
     <p:sldId id="269" r:id="rId23"/>
+    <p:sldId id="270" r:id="rId24"/>
   </p:sldIdLst>
   <p:sldSz cx="12192000" cy="6858000"/>
   <p:notesSz cx="6858000" cy="9144000"/>
@@ -1422,8 +1423,8 @@
         </p:nvSpPr>
         <p:spPr>
           <a:xfrm>
-            <a:off x="0" y="6237795"/>
-            <a:ext cx="12192000" cy="97917"/>
+            <a:off x="0" y="6043104"/>
+            <a:ext cx="12192000" cy="292608"/>
           </a:xfrm>
           <a:prstGeom prst="rect">
             <a:avLst/>
@@ -3390,8 +3391,8 @@
         </p:nvSpPr>
         <p:spPr>
           <a:xfrm>
-            <a:off x="0" y="6237795"/>
-            <a:ext cx="12192000" cy="97917"/>
+            <a:off x="0" y="6043104"/>
+            <a:ext cx="12192000" cy="292608"/>
           </a:xfrm>
           <a:prstGeom prst="rect">
             <a:avLst/>
@@ -3949,8 +3950,8 @@
         </p:nvSpPr>
         <p:spPr>
           <a:xfrm>
-            <a:off x="0" y="6237795"/>
-            <a:ext cx="12192000" cy="97917"/>
+            <a:off x="0" y="6043104"/>
+            <a:ext cx="12192000" cy="292608"/>
           </a:xfrm>
           <a:prstGeom prst="rect">
             <a:avLst/>
@@ -5421,8 +5422,8 @@
         </p:nvSpPr>
         <p:spPr>
           <a:xfrm>
-            <a:off x="8465769" y="6237795"/>
-            <a:ext cx="3726231" cy="97917"/>
+            <a:off x="8465769" y="6043104"/>
+            <a:ext cx="3726231" cy="292608"/>
           </a:xfrm>
           <a:prstGeom prst="rect">
             <a:avLst/>
@@ -6354,7 +6355,7 @@
                 <a:latin typeface="Arial"/>
                 <a:cs typeface="Arial"/>
               </a:rPr>
-              <a:t>10 / 14</a:t>
+              <a:t>10 / 15</a:t>
             </a:r>
           </a:p>
         </p:txBody>
@@ -7727,7 +7728,7 @@
                 <a:latin typeface="Arial"/>
                 <a:cs typeface="Arial"/>
               </a:rPr>
-              <a:t>11 / 14</a:t>
+              <a:t>11 / 15</a:t>
             </a:r>
           </a:p>
         </p:txBody>
@@ -8859,7 +8860,7 @@
                 <a:latin typeface="Arial"/>
                 <a:cs typeface="Arial"/>
               </a:rPr>
-              <a:t>12 / 14</a:t>
+              <a:t>12 / 15</a:t>
             </a:r>
           </a:p>
         </p:txBody>
@@ -9733,7 +9734,7 @@
                 <a:latin typeface="Arial"/>
                 <a:cs typeface="Arial"/>
               </a:rPr>
-              <a:t>13 / 14</a:t>
+              <a:t>13 / 15</a:t>
             </a:r>
           </a:p>
         </p:txBody>
@@ -9811,7 +9812,7 @@
         <p:spPr>
           <a:xfrm>
             <a:off x="566928" y="1664208"/>
-            <a:ext cx="7040880" cy="3110107"/>
+            <a:ext cx="6583680" cy="2609561"/>
           </a:xfrm>
           <a:prstGeom prst="rect">
             <a:avLst/>
@@ -9826,8 +9827,8 @@
         </p:nvSpPr>
         <p:spPr>
           <a:xfrm>
-            <a:off x="658368" y="4847467"/>
-            <a:ext cx="7040880" cy="274320"/>
+            <a:off x="658368" y="4346921"/>
+            <a:ext cx="6583680" cy="274320"/>
           </a:xfrm>
           <a:prstGeom prst="rect">
             <a:avLst/>
@@ -9862,8 +9863,8 @@
         </p:nvSpPr>
         <p:spPr>
           <a:xfrm>
-            <a:off x="8019288" y="1801368"/>
-            <a:ext cx="3605479" cy="1207008"/>
+            <a:off x="7562088" y="1801368"/>
+            <a:ext cx="4062679" cy="1207008"/>
           </a:xfrm>
           <a:prstGeom prst="roundRect">
             <a:avLst>
@@ -9910,7 +9911,7 @@
         </p:nvSpPr>
         <p:spPr>
           <a:xfrm>
-            <a:off x="8019288" y="1911096"/>
+            <a:off x="7562088" y="1911096"/>
             <a:ext cx="50292" cy="987552"/>
           </a:xfrm>
           <a:prstGeom prst="rect">
@@ -9954,8 +9955,8 @@
         </p:nvSpPr>
         <p:spPr>
           <a:xfrm>
-            <a:off x="8275320" y="1929384"/>
-            <a:ext cx="3148279" cy="502920"/>
+            <a:off x="7818120" y="1929384"/>
+            <a:ext cx="3605479" cy="502920"/>
           </a:xfrm>
           <a:prstGeom prst="rect">
             <a:avLst/>
@@ -10000,8 +10001,8 @@
         </p:nvSpPr>
         <p:spPr>
           <a:xfrm>
-            <a:off x="8275320" y="2478024"/>
-            <a:ext cx="3148279" cy="475488"/>
+            <a:off x="7818120" y="2478024"/>
+            <a:ext cx="3605479" cy="475488"/>
           </a:xfrm>
           <a:prstGeom prst="rect">
             <a:avLst/>
@@ -10057,8 +10058,8 @@
         </p:nvSpPr>
         <p:spPr>
           <a:xfrm>
-            <a:off x="8019288" y="3227832"/>
-            <a:ext cx="3605479" cy="1207008"/>
+            <a:off x="7562088" y="3227832"/>
+            <a:ext cx="4062679" cy="1207008"/>
           </a:xfrm>
           <a:prstGeom prst="roundRect">
             <a:avLst>
@@ -10105,7 +10106,7 @@
         </p:nvSpPr>
         <p:spPr>
           <a:xfrm>
-            <a:off x="8019288" y="3337560"/>
+            <a:off x="7562088" y="3337560"/>
             <a:ext cx="50292" cy="987552"/>
           </a:xfrm>
           <a:prstGeom prst="rect">
@@ -10149,8 +10150,8 @@
         </p:nvSpPr>
         <p:spPr>
           <a:xfrm>
-            <a:off x="8275320" y="3355848"/>
-            <a:ext cx="3148279" cy="502920"/>
+            <a:off x="7818120" y="3355848"/>
+            <a:ext cx="3605479" cy="502920"/>
           </a:xfrm>
           <a:prstGeom prst="rect">
             <a:avLst/>
@@ -10195,8 +10196,8 @@
         </p:nvSpPr>
         <p:spPr>
           <a:xfrm>
-            <a:off x="8275320" y="3904488"/>
-            <a:ext cx="3148279" cy="475488"/>
+            <a:off x="7818120" y="3904488"/>
+            <a:ext cx="3605479" cy="475488"/>
           </a:xfrm>
           <a:prstGeom prst="rect">
             <a:avLst/>
@@ -10252,8 +10253,8 @@
         </p:nvSpPr>
         <p:spPr>
           <a:xfrm>
-            <a:off x="8019288" y="4700016"/>
-            <a:ext cx="3605479" cy="731520"/>
+            <a:off x="7562088" y="4700016"/>
+            <a:ext cx="4062679" cy="731520"/>
           </a:xfrm>
           <a:prstGeom prst="rect">
             <a:avLst/>
@@ -10469,7 +10470,7 @@
                 <a:latin typeface="Arial"/>
                 <a:cs typeface="Arial"/>
               </a:rPr>
-              <a:t>14 / 14</a:t>
+              <a:t>14 / 15</a:t>
             </a:r>
           </a:p>
         </p:txBody>
@@ -10556,8 +10557,8 @@
         </p:blipFill>
         <p:spPr>
           <a:xfrm>
-            <a:off x="749808" y="1645920"/>
-            <a:ext cx="10424160" cy="2028611"/>
+            <a:off x="1115568" y="1627632"/>
+            <a:ext cx="8778240" cy="2424788"/>
           </a:xfrm>
           <a:prstGeom prst="rect">
             <a:avLst/>
@@ -10572,7 +10573,7 @@
         </p:nvSpPr>
         <p:spPr>
           <a:xfrm>
-            <a:off x="841248" y="3720251"/>
+            <a:off x="1207008" y="4079852"/>
             <a:ext cx="10058400" cy="256032"/>
           </a:xfrm>
           <a:prstGeom prst="rect">
@@ -10595,7 +10596,7 @@
                 <a:latin typeface="Arial"/>
                 <a:cs typeface="Arial"/>
               </a:rPr>
-              <a:t>meridional cross-sections (azimuthally projected) — plastic strain localizes at the impact foot</a:t>
+              <a:t>cutaway views (near half removed) — plastic strain localizes at the impact foot; gray plane = rigid anvil</a:t>
             </a:r>
           </a:p>
         </p:txBody>
@@ -10616,8 +10617,8 @@
         </p:blipFill>
         <p:spPr>
           <a:xfrm>
-            <a:off x="566928" y="3985427"/>
-            <a:ext cx="5394960" cy="2069343"/>
+            <a:off x="566928" y="4372460"/>
+            <a:ext cx="4114800" cy="1573222"/>
           </a:xfrm>
           <a:prstGeom prst="rect">
             <a:avLst/>
@@ -10632,8 +10633,8 @@
         </p:nvSpPr>
         <p:spPr>
           <a:xfrm>
-            <a:off x="6419088" y="4259747"/>
-            <a:ext cx="5205679" cy="1886463"/>
+            <a:off x="5138928" y="4601060"/>
+            <a:ext cx="6485839" cy="1390342"/>
           </a:xfrm>
           <a:prstGeom prst="rect">
             <a:avLst/>
@@ -10743,6 +10744,808 @@
                 <a:cs typeface="Arial"/>
               </a:rPr>
               <a:t> axial shortening — temper sensitivity captured</a:t>
+            </a:r>
+          </a:p>
+        </p:txBody>
+      </p:sp>
+    </p:spTree>
+  </p:cSld>
+  <p:clrMapOvr>
+    <a:masterClrMapping/>
+  </p:clrMapOvr>
+</p:sld>
+</file>
+
+<file path=ppt/slides/slide15.xml><?xml version="1.0" encoding="utf-8"?>
+<p:sld xmlns:a="http://schemas.openxmlformats.org/drawingml/2006/main" xmlns:p="http://schemas.openxmlformats.org/presentationml/2006/main" xmlns:r="http://schemas.openxmlformats.org/officeDocument/2006/relationships">
+  <p:cSld>
+    <p:spTree>
+      <p:nvGrpSpPr>
+        <p:cNvPr id="1" name=""/>
+        <p:cNvGrpSpPr/>
+        <p:nvPr/>
+      </p:nvGrpSpPr>
+      <p:grpSpPr/>
+      <p:sp>
+        <p:nvSpPr>
+          <p:cNvPr id="2" name="Title 1"/>
+          <p:cNvSpPr>
+            <a:spLocks noGrp="1"/>
+          </p:cNvSpPr>
+          <p:nvPr>
+            <p:ph type="title"/>
+          </p:nvPr>
+        </p:nvSpPr>
+        <p:spPr/>
+        <p:txBody>
+          <a:bodyPr/>
+          <a:lstStyle/>
+          <a:p>
+            <a:r>
+              <a:rPr sz="2600"/>
+              <a:t>Coupled thermo-mechanics: heating from plastic work</a:t>
+            </a:r>
+          </a:p>
+        </p:txBody>
+      </p:sp>
+      <p:sp>
+        <p:nvSpPr>
+          <p:cNvPr id="3" name="TextBox 2"/>
+          <p:cNvSpPr txBox="1"/>
+          <p:nvPr/>
+        </p:nvSpPr>
+        <p:spPr>
+          <a:xfrm>
+            <a:off x="11231575" y="274320"/>
+            <a:ext cx="685800" cy="228600"/>
+          </a:xfrm>
+          <a:prstGeom prst="rect">
+            <a:avLst/>
+          </a:prstGeom>
+          <a:noFill/>
+        </p:spPr>
+        <p:txBody>
+          <a:bodyPr wrap="square" anchor="t" lIns="0" rIns="0" tIns="0" bIns="0">
+            <a:spAutoFit/>
+          </a:bodyPr>
+          <a:lstStyle/>
+          <a:p>
+            <a:pPr algn="r"/>
+            <a:r>
+              <a:rPr sz="900" b="0" i="0">
+                <a:solidFill>
+                  <a:srgbClr val="59595C"/>
+                </a:solidFill>
+                <a:latin typeface="Arial"/>
+                <a:cs typeface="Arial"/>
+              </a:rPr>
+              <a:t>15 / 15</a:t>
+            </a:r>
+          </a:p>
+        </p:txBody>
+      </p:sp>
+      <p:sp>
+        <p:nvSpPr>
+          <p:cNvPr id="4" name="TextBox 3"/>
+          <p:cNvSpPr txBox="1"/>
+          <p:nvPr/>
+        </p:nvSpPr>
+        <p:spPr>
+          <a:xfrm>
+            <a:off x="566928" y="1133856"/>
+            <a:ext cx="11057839" cy="320040"/>
+          </a:xfrm>
+          <a:prstGeom prst="rect">
+            <a:avLst/>
+          </a:prstGeom>
+          <a:noFill/>
+        </p:spPr>
+        <p:txBody>
+          <a:bodyPr wrap="square" anchor="t" lIns="0" rIns="0" tIns="0" bIns="0">
+            <a:spAutoFit/>
+          </a:bodyPr>
+          <a:lstStyle/>
+          <a:p>
+            <a:pPr algn="l"/>
+            <a:r>
+              <a:rPr sz="1450" b="0" i="0">
+                <a:solidFill>
+                  <a:srgbClr val="3A3F47"/>
+                </a:solidFill>
+                <a:latin typeface="Arial"/>
+                <a:cs typeface="Arial"/>
+              </a:rPr>
+              <a:t>Same coupled run — temperature integrated </a:t>
+            </a:r>
+            <a:r>
+              <a:rPr sz="1450" b="1" i="0">
+                <a:solidFill>
+                  <a:srgbClr val="1E2430"/>
+                </a:solidFill>
+                <a:latin typeface="Arial"/>
+                <a:cs typeface="Arial"/>
+              </a:rPr>
+              <a:t>inside the NEML2 model</a:t>
+            </a:r>
+            <a:r>
+              <a:rPr sz="1450" b="0" i="0">
+                <a:solidFill>
+                  <a:srgbClr val="3A3F47"/>
+                </a:solidFill>
+                <a:latin typeface="Arial"/>
+                <a:cs typeface="Arial"/>
+              </a:rPr>
+              <a:t> (adiabatic Taylor–Quinney heating, β = 0.9), in the same batched update</a:t>
+            </a:r>
+          </a:p>
+        </p:txBody>
+      </p:sp>
+      <p:pic>
+        <p:nvPicPr>
+          <p:cNvPr id="5" name="Picture 4" descr="fig_thermal.png"/>
+          <p:cNvPicPr>
+            <a:picLocks noChangeAspect="1"/>
+          </p:cNvPicPr>
+          <p:nvPr/>
+        </p:nvPicPr>
+        <p:blipFill>
+          <a:blip r:embed="rId2"/>
+          <a:stretch>
+            <a:fillRect/>
+          </a:stretch>
+        </p:blipFill>
+        <p:spPr>
+          <a:xfrm>
+            <a:off x="1389888" y="1627632"/>
+            <a:ext cx="8229600" cy="2450098"/>
+          </a:xfrm>
+          <a:prstGeom prst="rect">
+            <a:avLst/>
+          </a:prstGeom>
+        </p:spPr>
+      </p:pic>
+      <p:sp>
+        <p:nvSpPr>
+          <p:cNvPr id="6" name="TextBox 5"/>
+          <p:cNvSpPr txBox="1"/>
+          <p:nvPr/>
+        </p:nvSpPr>
+        <p:spPr>
+          <a:xfrm>
+            <a:off x="1481328" y="4105162"/>
+            <a:ext cx="10058400" cy="256032"/>
+          </a:xfrm>
+          <a:prstGeom prst="rect">
+            <a:avLst/>
+          </a:prstGeom>
+          <a:noFill/>
+        </p:spPr>
+        <p:txBody>
+          <a:bodyPr wrap="square" anchor="t" lIns="0" rIns="0" tIns="0" bIns="0">
+            <a:spAutoFit/>
+          </a:bodyPr>
+          <a:lstStyle/>
+          <a:p>
+            <a:pPr algn="l"/>
+            <a:r>
+              <a:rPr sz="1100" b="0" i="1">
+                <a:solidFill>
+                  <a:srgbClr val="59595C"/>
+                </a:solidFill>
+                <a:latin typeface="Arial"/>
+                <a:cs typeface="Arial"/>
+              </a:rPr>
+              <a:t>temperature rise above 300 K, cutaway views — run to 114 µs, &gt;99% of the impact kinetic energy dissipated</a:t>
+            </a:r>
+          </a:p>
+        </p:txBody>
+      </p:sp>
+      <p:sp>
+        <p:nvSpPr>
+          <p:cNvPr id="7" name="Rounded Rectangle 6"/>
+          <p:cNvSpPr/>
+          <p:nvPr/>
+        </p:nvSpPr>
+        <p:spPr>
+          <a:xfrm>
+            <a:off x="566928" y="4443490"/>
+            <a:ext cx="3442106" cy="960120"/>
+          </a:xfrm>
+          <a:prstGeom prst="roundRect">
+            <a:avLst>
+              <a:gd name="adj" fmla="val 5500"/>
+            </a:avLst>
+          </a:prstGeom>
+          <a:solidFill>
+            <a:srgbClr val="F4F5F7"/>
+          </a:solidFill>
+          <a:ln w="9525">
+            <a:solidFill>
+              <a:srgbClr val="DADDE2"/>
+            </a:solidFill>
+          </a:ln>
+          <a:effectLst/>
+        </p:spPr>
+        <p:style>
+          <a:lnRef idx="1">
+            <a:schemeClr val="accent1"/>
+          </a:lnRef>
+          <a:fillRef idx="3">
+            <a:schemeClr val="accent1"/>
+          </a:fillRef>
+          <a:effectRef idx="2">
+            <a:schemeClr val="accent1"/>
+          </a:effectRef>
+          <a:fontRef idx="minor">
+            <a:schemeClr val="lt1"/>
+          </a:fontRef>
+        </p:style>
+        <p:txBody>
+          <a:bodyPr rtlCol="0" anchor="ctr"/>
+          <a:lstStyle/>
+          <a:p>
+            <a:pPr algn="ctr"/>
+          </a:p>
+        </p:txBody>
+      </p:sp>
+      <p:sp>
+        <p:nvSpPr>
+          <p:cNvPr id="8" name="Rectangle 7"/>
+          <p:cNvSpPr/>
+          <p:nvPr/>
+        </p:nvSpPr>
+        <p:spPr>
+          <a:xfrm>
+            <a:off x="566928" y="4525786"/>
+            <a:ext cx="50292" cy="795528"/>
+          </a:xfrm>
+          <a:prstGeom prst="rect">
+            <a:avLst/>
+          </a:prstGeom>
+          <a:solidFill>
+            <a:srgbClr val="CF1D4C"/>
+          </a:solidFill>
+          <a:ln>
+            <a:noFill/>
+          </a:ln>
+          <a:effectLst/>
+        </p:spPr>
+        <p:style>
+          <a:lnRef idx="1">
+            <a:schemeClr val="accent1"/>
+          </a:lnRef>
+          <a:fillRef idx="3">
+            <a:schemeClr val="accent1"/>
+          </a:fillRef>
+          <a:effectRef idx="2">
+            <a:schemeClr val="accent1"/>
+          </a:effectRef>
+          <a:fontRef idx="minor">
+            <a:schemeClr val="lt1"/>
+          </a:fontRef>
+        </p:style>
+        <p:txBody>
+          <a:bodyPr rtlCol="0" anchor="ctr"/>
+          <a:lstStyle/>
+          <a:p>
+            <a:pPr algn="ctr"/>
+          </a:p>
+        </p:txBody>
+      </p:sp>
+      <p:sp>
+        <p:nvSpPr>
+          <p:cNvPr id="9" name="TextBox 8"/>
+          <p:cNvSpPr txBox="1"/>
+          <p:nvPr/>
+        </p:nvSpPr>
+        <p:spPr>
+          <a:xfrm>
+            <a:off x="786384" y="4516642"/>
+            <a:ext cx="3039770" cy="274320"/>
+          </a:xfrm>
+          <a:prstGeom prst="rect">
+            <a:avLst/>
+          </a:prstGeom>
+          <a:noFill/>
+        </p:spPr>
+        <p:txBody>
+          <a:bodyPr wrap="square" anchor="t" lIns="0" rIns="0" tIns="0" bIns="0">
+            <a:spAutoFit/>
+          </a:bodyPr>
+          <a:lstStyle/>
+          <a:p>
+            <a:pPr algn="l">
+              <a:lnSpc>
+                <a:spcPct val="102000"/>
+              </a:lnSpc>
+            </a:pPr>
+            <a:r>
+              <a:rPr sz="1200" b="1" i="0">
+                <a:solidFill>
+                  <a:srgbClr val="1E2430"/>
+                </a:solidFill>
+                <a:latin typeface="Arial"/>
+                <a:cs typeface="Arial"/>
+              </a:rPr>
+              <a:t>Feeds back into the flow stress</a:t>
+            </a:r>
+          </a:p>
+        </p:txBody>
+      </p:sp>
+      <p:sp>
+        <p:nvSpPr>
+          <p:cNvPr id="10" name="TextBox 9"/>
+          <p:cNvSpPr txBox="1"/>
+          <p:nvPr/>
+        </p:nvSpPr>
+        <p:spPr>
+          <a:xfrm>
+            <a:off x="786384" y="4836682"/>
+            <a:ext cx="3039770" cy="548640"/>
+          </a:xfrm>
+          <a:prstGeom prst="rect">
+            <a:avLst/>
+          </a:prstGeom>
+          <a:noFill/>
+        </p:spPr>
+        <p:txBody>
+          <a:bodyPr wrap="square" anchor="t" lIns="0" rIns="0" tIns="0" bIns="0">
+            <a:spAutoFit/>
+          </a:bodyPr>
+          <a:lstStyle/>
+          <a:p>
+            <a:pPr algn="l">
+              <a:lnSpc>
+                <a:spcPct val="106000"/>
+              </a:lnSpc>
+            </a:pPr>
+            <a:r>
+              <a:rPr sz="1000" b="0" i="0">
+                <a:solidFill>
+                  <a:srgbClr val="3A3F47"/>
+                </a:solidFill>
+                <a:latin typeface="Arial"/>
+                <a:cs typeface="Arial"/>
+              </a:rPr>
+              <a:t>the hot foot softens (Johnson–Cook Θ = 1 − T*ᵐ) and flows more easily</a:t>
+            </a:r>
+          </a:p>
+        </p:txBody>
+      </p:sp>
+      <p:sp>
+        <p:nvSpPr>
+          <p:cNvPr id="11" name="Rounded Rectangle 10"/>
+          <p:cNvSpPr/>
+          <p:nvPr/>
+        </p:nvSpPr>
+        <p:spPr>
+          <a:xfrm>
+            <a:off x="4374794" y="4443490"/>
+            <a:ext cx="3442106" cy="960120"/>
+          </a:xfrm>
+          <a:prstGeom prst="roundRect">
+            <a:avLst>
+              <a:gd name="adj" fmla="val 5500"/>
+            </a:avLst>
+          </a:prstGeom>
+          <a:solidFill>
+            <a:srgbClr val="F4F5F7"/>
+          </a:solidFill>
+          <a:ln w="9525">
+            <a:solidFill>
+              <a:srgbClr val="DADDE2"/>
+            </a:solidFill>
+          </a:ln>
+          <a:effectLst/>
+        </p:spPr>
+        <p:style>
+          <a:lnRef idx="1">
+            <a:schemeClr val="accent1"/>
+          </a:lnRef>
+          <a:fillRef idx="3">
+            <a:schemeClr val="accent1"/>
+          </a:fillRef>
+          <a:effectRef idx="2">
+            <a:schemeClr val="accent1"/>
+          </a:effectRef>
+          <a:fontRef idx="minor">
+            <a:schemeClr val="lt1"/>
+          </a:fontRef>
+        </p:style>
+        <p:txBody>
+          <a:bodyPr rtlCol="0" anchor="ctr"/>
+          <a:lstStyle/>
+          <a:p>
+            <a:pPr algn="ctr"/>
+          </a:p>
+        </p:txBody>
+      </p:sp>
+      <p:sp>
+        <p:nvSpPr>
+          <p:cNvPr id="12" name="Rectangle 11"/>
+          <p:cNvSpPr/>
+          <p:nvPr/>
+        </p:nvSpPr>
+        <p:spPr>
+          <a:xfrm>
+            <a:off x="4374794" y="4525786"/>
+            <a:ext cx="50292" cy="795528"/>
+          </a:xfrm>
+          <a:prstGeom prst="rect">
+            <a:avLst/>
+          </a:prstGeom>
+          <a:solidFill>
+            <a:srgbClr val="06509D"/>
+          </a:solidFill>
+          <a:ln>
+            <a:noFill/>
+          </a:ln>
+          <a:effectLst/>
+        </p:spPr>
+        <p:style>
+          <a:lnRef idx="1">
+            <a:schemeClr val="accent1"/>
+          </a:lnRef>
+          <a:fillRef idx="3">
+            <a:schemeClr val="accent1"/>
+          </a:fillRef>
+          <a:effectRef idx="2">
+            <a:schemeClr val="accent1"/>
+          </a:effectRef>
+          <a:fontRef idx="minor">
+            <a:schemeClr val="lt1"/>
+          </a:fontRef>
+        </p:style>
+        <p:txBody>
+          <a:bodyPr rtlCol="0" anchor="ctr"/>
+          <a:lstStyle/>
+          <a:p>
+            <a:pPr algn="ctr"/>
+          </a:p>
+        </p:txBody>
+      </p:sp>
+      <p:sp>
+        <p:nvSpPr>
+          <p:cNvPr id="13" name="TextBox 12"/>
+          <p:cNvSpPr txBox="1"/>
+          <p:nvPr/>
+        </p:nvSpPr>
+        <p:spPr>
+          <a:xfrm>
+            <a:off x="4594250" y="4516642"/>
+            <a:ext cx="3039770" cy="274320"/>
+          </a:xfrm>
+          <a:prstGeom prst="rect">
+            <a:avLst/>
+          </a:prstGeom>
+          <a:noFill/>
+        </p:spPr>
+        <p:txBody>
+          <a:bodyPr wrap="square" anchor="t" lIns="0" rIns="0" tIns="0" bIns="0">
+            <a:spAutoFit/>
+          </a:bodyPr>
+          <a:lstStyle/>
+          <a:p>
+            <a:pPr algn="l">
+              <a:lnSpc>
+                <a:spcPct val="102000"/>
+              </a:lnSpc>
+            </a:pPr>
+            <a:r>
+              <a:rPr sz="1200" b="1" i="0">
+                <a:solidFill>
+                  <a:srgbClr val="1E2430"/>
+                </a:solidFill>
+                <a:latin typeface="Arial"/>
+                <a:cs typeface="Arial"/>
+              </a:rPr>
+              <a:t>Adiabatic by physics, not assumption</a:t>
+            </a:r>
+          </a:p>
+        </p:txBody>
+      </p:sp>
+      <p:sp>
+        <p:nvSpPr>
+          <p:cNvPr id="14" name="TextBox 13"/>
+          <p:cNvSpPr txBox="1"/>
+          <p:nvPr/>
+        </p:nvSpPr>
+        <p:spPr>
+          <a:xfrm>
+            <a:off x="4594250" y="4836682"/>
+            <a:ext cx="3039770" cy="548640"/>
+          </a:xfrm>
+          <a:prstGeom prst="rect">
+            <a:avLst/>
+          </a:prstGeom>
+          <a:noFill/>
+        </p:spPr>
+        <p:txBody>
+          <a:bodyPr wrap="square" anchor="t" lIns="0" rIns="0" tIns="0" bIns="0">
+            <a:spAutoFit/>
+          </a:bodyPr>
+          <a:lstStyle/>
+          <a:p>
+            <a:pPr algn="l">
+              <a:lnSpc>
+                <a:spcPct val="106000"/>
+              </a:lnSpc>
+            </a:pPr>
+            <a:r>
+              <a:rPr sz="1000" b="0" i="0">
+                <a:solidFill>
+                  <a:srgbClr val="3A3F47"/>
+                </a:solidFill>
+                <a:latin typeface="Arial"/>
+                <a:cs typeface="Arial"/>
+              </a:rPr>
+              <a:t>diffusion length √(αt) ≈ 0.1 mm ≪ element size over 120 µs — no heat-conduction PDE needed</a:t>
+            </a:r>
+          </a:p>
+        </p:txBody>
+      </p:sp>
+      <p:sp>
+        <p:nvSpPr>
+          <p:cNvPr id="15" name="Rounded Rectangle 14"/>
+          <p:cNvSpPr/>
+          <p:nvPr/>
+        </p:nvSpPr>
+        <p:spPr>
+          <a:xfrm>
+            <a:off x="8182660" y="4443490"/>
+            <a:ext cx="3442106" cy="960120"/>
+          </a:xfrm>
+          <a:prstGeom prst="roundRect">
+            <a:avLst>
+              <a:gd name="adj" fmla="val 5500"/>
+            </a:avLst>
+          </a:prstGeom>
+          <a:solidFill>
+            <a:srgbClr val="F4F5F7"/>
+          </a:solidFill>
+          <a:ln w="9525">
+            <a:solidFill>
+              <a:srgbClr val="DADDE2"/>
+            </a:solidFill>
+          </a:ln>
+          <a:effectLst/>
+        </p:spPr>
+        <p:style>
+          <a:lnRef idx="1">
+            <a:schemeClr val="accent1"/>
+          </a:lnRef>
+          <a:fillRef idx="3">
+            <a:schemeClr val="accent1"/>
+          </a:fillRef>
+          <a:effectRef idx="2">
+            <a:schemeClr val="accent1"/>
+          </a:effectRef>
+          <a:fontRef idx="minor">
+            <a:schemeClr val="lt1"/>
+          </a:fontRef>
+        </p:style>
+        <p:txBody>
+          <a:bodyPr rtlCol="0" anchor="ctr"/>
+          <a:lstStyle/>
+          <a:p>
+            <a:pPr algn="ctr"/>
+          </a:p>
+        </p:txBody>
+      </p:sp>
+      <p:sp>
+        <p:nvSpPr>
+          <p:cNvPr id="16" name="Rectangle 15"/>
+          <p:cNvSpPr/>
+          <p:nvPr/>
+        </p:nvSpPr>
+        <p:spPr>
+          <a:xfrm>
+            <a:off x="8182660" y="4525786"/>
+            <a:ext cx="50292" cy="795528"/>
+          </a:xfrm>
+          <a:prstGeom prst="rect">
+            <a:avLst/>
+          </a:prstGeom>
+          <a:solidFill>
+            <a:srgbClr val="5E8614"/>
+          </a:solidFill>
+          <a:ln>
+            <a:noFill/>
+          </a:ln>
+          <a:effectLst/>
+        </p:spPr>
+        <p:style>
+          <a:lnRef idx="1">
+            <a:schemeClr val="accent1"/>
+          </a:lnRef>
+          <a:fillRef idx="3">
+            <a:schemeClr val="accent1"/>
+          </a:fillRef>
+          <a:effectRef idx="2">
+            <a:schemeClr val="accent1"/>
+          </a:effectRef>
+          <a:fontRef idx="minor">
+            <a:schemeClr val="lt1"/>
+          </a:fontRef>
+        </p:style>
+        <p:txBody>
+          <a:bodyPr rtlCol="0" anchor="ctr"/>
+          <a:lstStyle/>
+          <a:p>
+            <a:pPr algn="ctr"/>
+          </a:p>
+        </p:txBody>
+      </p:sp>
+      <p:sp>
+        <p:nvSpPr>
+          <p:cNvPr id="17" name="TextBox 16"/>
+          <p:cNvSpPr txBox="1"/>
+          <p:nvPr/>
+        </p:nvSpPr>
+        <p:spPr>
+          <a:xfrm>
+            <a:off x="8402116" y="4516642"/>
+            <a:ext cx="3039770" cy="274320"/>
+          </a:xfrm>
+          <a:prstGeom prst="rect">
+            <a:avLst/>
+          </a:prstGeom>
+          <a:noFill/>
+        </p:spPr>
+        <p:txBody>
+          <a:bodyPr wrap="square" anchor="t" lIns="0" rIns="0" tIns="0" bIns="0">
+            <a:spAutoFit/>
+          </a:bodyPr>
+          <a:lstStyle/>
+          <a:p>
+            <a:pPr algn="l">
+              <a:lnSpc>
+                <a:spcPct val="102000"/>
+              </a:lnSpc>
+            </a:pPr>
+            <a:r>
+              <a:rPr sz="1200" b="1" i="0">
+                <a:solidFill>
+                  <a:srgbClr val="1E2430"/>
+                </a:solidFill>
+                <a:latin typeface="Arial"/>
+                <a:cs typeface="Arial"/>
+              </a:rPr>
+              <a:t>Three extra NEML2 model blocks</a:t>
+            </a:r>
+          </a:p>
+        </p:txBody>
+      </p:sp>
+      <p:sp>
+        <p:nvSpPr>
+          <p:cNvPr id="18" name="TextBox 17"/>
+          <p:cNvSpPr txBox="1"/>
+          <p:nvPr/>
+        </p:nvSpPr>
+        <p:spPr>
+          <a:xfrm>
+            <a:off x="8402116" y="4836682"/>
+            <a:ext cx="3039770" cy="548640"/>
+          </a:xfrm>
+          <a:prstGeom prst="rect">
+            <a:avLst/>
+          </a:prstGeom>
+          <a:noFill/>
+        </p:spPr>
+        <p:txBody>
+          <a:bodyPr wrap="square" anchor="t" lIns="0" rIns="0" tIns="0" bIns="0">
+            <a:spAutoFit/>
+          </a:bodyPr>
+          <a:lstStyle/>
+          <a:p>
+            <a:pPr algn="l">
+              <a:lnSpc>
+                <a:spcPct val="106000"/>
+              </a:lnSpc>
+            </a:pPr>
+            <a:r>
+              <a:rPr sz="1000" b="0" i="0">
+                <a:solidFill>
+                  <a:srgbClr val="3A3F47"/>
+                </a:solidFill>
+                <a:latin typeface="Arial"/>
+                <a:cs typeface="Arial"/>
+              </a:rPr>
+              <a:t>no new MOOSE modules, no new transfers — temperature state lives on the device like everything else</a:t>
+            </a:r>
+          </a:p>
+        </p:txBody>
+      </p:sp>
+      <p:sp>
+        <p:nvSpPr>
+          <p:cNvPr id="19" name="Rounded Rectangle 18"/>
+          <p:cNvSpPr/>
+          <p:nvPr/>
+        </p:nvSpPr>
+        <p:spPr>
+          <a:xfrm>
+            <a:off x="566928" y="5468112"/>
+            <a:ext cx="11057839" cy="658368"/>
+          </a:xfrm>
+          <a:prstGeom prst="roundRect">
+            <a:avLst>
+              <a:gd name="adj" fmla="val 5500"/>
+            </a:avLst>
+          </a:prstGeom>
+          <a:solidFill>
+            <a:srgbClr val="FDF0DF"/>
+          </a:solidFill>
+          <a:ln w="12700">
+            <a:solidFill>
+              <a:srgbClr val="B4620B"/>
+            </a:solidFill>
+          </a:ln>
+          <a:effectLst/>
+        </p:spPr>
+        <p:style>
+          <a:lnRef idx="1">
+            <a:schemeClr val="accent1"/>
+          </a:lnRef>
+          <a:fillRef idx="3">
+            <a:schemeClr val="accent1"/>
+          </a:fillRef>
+          <a:effectRef idx="2">
+            <a:schemeClr val="accent1"/>
+          </a:effectRef>
+          <a:fontRef idx="minor">
+            <a:schemeClr val="lt1"/>
+          </a:fontRef>
+        </p:style>
+        <p:txBody>
+          <a:bodyPr rtlCol="0" anchor="ctr"/>
+          <a:lstStyle/>
+          <a:p>
+            <a:pPr algn="ctr"/>
+          </a:p>
+        </p:txBody>
+      </p:sp>
+      <p:sp>
+        <p:nvSpPr>
+          <p:cNvPr id="20" name="TextBox 19"/>
+          <p:cNvSpPr txBox="1"/>
+          <p:nvPr/>
+        </p:nvSpPr>
+        <p:spPr>
+          <a:xfrm>
+            <a:off x="841248" y="5468112"/>
+            <a:ext cx="10509199" cy="658368"/>
+          </a:xfrm>
+          <a:prstGeom prst="rect">
+            <a:avLst/>
+          </a:prstGeom>
+          <a:noFill/>
+        </p:spPr>
+        <p:txBody>
+          <a:bodyPr wrap="square" anchor="ctr" lIns="0" rIns="0" tIns="0" bIns="0">
+            <a:spAutoFit/>
+          </a:bodyPr>
+          <a:lstStyle/>
+          <a:p>
+            <a:pPr algn="l"/>
+            <a:r>
+              <a:rPr sz="1500" b="1" i="0">
+                <a:solidFill>
+                  <a:srgbClr val="1E2430"/>
+                </a:solidFill>
+                <a:latin typeface="Arial"/>
+                <a:cs typeface="Arial"/>
+              </a:rPr>
+              <a:t>The abstract's thermo-mechanical claim, delivered:</a:t>
+            </a:r>
+            <a:r>
+              <a:rPr sz="1500" b="0" i="0">
+                <a:solidFill>
+                  <a:srgbClr val="3A3F47"/>
+                </a:solidFill>
+                <a:latin typeface="Arial"/>
+                <a:cs typeface="Arial"/>
+              </a:rPr>
+              <a:t> ΔT ≈ 120 K at the mushroom foot, captured end-to-end through the NEML2 force path.</a:t>
             </a:r>
           </a:p>
         </p:txBody>
@@ -10818,7 +11621,7 @@
                 <a:latin typeface="Arial"/>
                 <a:cs typeface="Arial"/>
               </a:rPr>
-              <a:t>2 / 14</a:t>
+              <a:t>2 / 15</a:t>
             </a:r>
           </a:p>
         </p:txBody>
@@ -11775,7 +12578,7 @@
                 <a:latin typeface="Arial"/>
                 <a:cs typeface="Arial"/>
               </a:rPr>
-              <a:t>3 / 14</a:t>
+              <a:t>3 / 15</a:t>
             </a:r>
           </a:p>
         </p:txBody>
@@ -12452,7 +13255,7 @@
                 <a:latin typeface="Arial"/>
                 <a:cs typeface="Arial"/>
               </a:rPr>
-              <a:t>4 / 14</a:t>
+              <a:t>4 / 15</a:t>
             </a:r>
           </a:p>
         </p:txBody>
@@ -12882,7 +13685,7 @@
                 <a:latin typeface="Arial"/>
                 <a:cs typeface="Arial"/>
               </a:rPr>
-              <a:t>5 / 14</a:t>
+              <a:t>5 / 15</a:t>
             </a:r>
           </a:p>
         </p:txBody>
@@ -13607,7 +14410,7 @@
                 <a:latin typeface="Arial"/>
                 <a:cs typeface="Arial"/>
               </a:rPr>
-              <a:t>6 / 14</a:t>
+              <a:t>6 / 15</a:t>
             </a:r>
           </a:p>
         </p:txBody>
@@ -14477,7 +15280,7 @@
                 <a:latin typeface="Arial"/>
                 <a:cs typeface="Arial"/>
               </a:rPr>
-              <a:t>7 / 14</a:t>
+              <a:t>7 / 15</a:t>
             </a:r>
           </a:p>
         </p:txBody>
@@ -15711,7 +16514,7 @@
                 <a:latin typeface="Arial"/>
                 <a:cs typeface="Arial"/>
               </a:rPr>
-              <a:t>8 / 14</a:t>
+              <a:t>8 / 15</a:t>
             </a:r>
           </a:p>
         </p:txBody>
@@ -17899,7 +18702,7 @@
                 <a:latin typeface="Arial"/>
                 <a:cs typeface="Arial"/>
               </a:rPr>
-              <a:t>9 / 14</a:t>
+              <a:t>9 / 15</a:t>
             </a:r>
           </a:p>
         </p:txBody>

</xml_diff>

<commit_message>
slides: final QA pass across all 15 slides
Fixes from the 16-agent visual + consistency audit:
- global: takeaway bands raised to clear the INL green stripe
  (verified programmatically: 0% non-white pixels in the 12px band
  above the stripe on every slide)
- consistency: dT 119 K (not ~120), 114 us run time everywhere,
  'a few parts in 1e8' verification claim, 11,000+ step count,
  slide 15 lead-in ties to slide 14's coupled run, uniform chip
  colors on slide 12, curly apostrophes
- wraps/orphans: slide 3/5/6/8/9/10/11 rewords; slide 8 op labels
  centered as two paragraphs; ExplicitMixedOrder no longer
  hyphenated on slide 10
- figures regenerated with projector-size labels (temper names,
  colorbar ticks, panel titles)
- slide 1 author placeholder box widened (names still pending)

Co-Authored-By: Claude Fable 5 <noreply@anthropic.com>
Claude-Session: https://claude.ai/code/session_01CCuKo2gP6Duy91irEj5f1y
</commit_message>
<xml_diff>
--- a/examples/impact/slide_assets/WCCM_NEML2_explicit_dynamics_v2.pptx
+++ b/examples/impact/slide_assets/WCCM_NEML2_explicit_dynamics_v2.pptx
@@ -6263,7 +6263,11 @@
             <p:ph type="body" idx="16" sz="quarter"/>
           </p:nvPr>
         </p:nvSpPr>
-        <p:spPr/>
+        <p:spPr>
+          <a:xfrm>
+            <a:ext cx="3840480" cy="0"/>
+          </a:xfrm>
+        </p:spPr>
         <p:txBody>
           <a:bodyPr/>
           <a:lstStyle/>
@@ -6631,7 +6635,7 @@
                 <a:latin typeface="Arial"/>
                 <a:cs typeface="Arial"/>
               </a:rPr>
-              <a:t>ExplicitMixed-</a:t>
+              <a:t>ExplicitMixed</a:t>
             </a:r>
           </a:p>
           <a:p>
@@ -7558,7 +7562,7 @@
                 <a:latin typeface="Arial"/>
                 <a:cs typeface="Arial"/>
               </a:rPr>
-              <a:t>shape functions φ, ∇φ,  DOF maps,  quadrature weights JxW  — rebuilt only on mesh change</a:t>
+              <a:t>shape functions φ, ∇φ,  DOF maps,  weights JxW — rebuilt only on mesh change</a:t>
             </a:r>
           </a:p>
         </p:txBody>
@@ -7571,7 +7575,7 @@
         </p:nvSpPr>
         <p:spPr>
           <a:xfrm>
-            <a:off x="566928" y="5394960"/>
+            <a:off x="566928" y="5266944"/>
             <a:ext cx="11057839" cy="658368"/>
           </a:xfrm>
           <a:prstGeom prst="roundRect">
@@ -7619,7 +7623,7 @@
         </p:nvSpPr>
         <p:spPr>
           <a:xfrm>
-            <a:off x="841248" y="5394960"/>
+            <a:off x="841248" y="5266944"/>
             <a:ext cx="10509199" cy="658368"/>
           </a:xfrm>
           <a:prstGeom prst="rect">
@@ -8145,8 +8149,8 @@
         </p:nvCxnSpPr>
         <p:spPr>
           <a:xfrm flipV="1">
-            <a:off x="6510528" y="2130552"/>
-            <a:ext cx="731520" cy="457200"/>
+            <a:off x="6784848" y="2130552"/>
+            <a:ext cx="457200" cy="219456"/>
           </a:xfrm>
           <a:prstGeom prst="line">
             <a:avLst/>
@@ -8182,8 +8186,8 @@
         </p:nvSpPr>
         <p:spPr>
           <a:xfrm>
-            <a:off x="8887968" y="1819656"/>
-            <a:ext cx="2377440" cy="1005840"/>
+            <a:off x="8842248" y="1819656"/>
+            <a:ext cx="2560320" cy="1005840"/>
           </a:xfrm>
           <a:prstGeom prst="rect">
             <a:avLst/>
@@ -8663,8 +8667,8 @@
         </p:nvSpPr>
         <p:spPr>
           <a:xfrm>
-            <a:off x="8887968" y="3886200"/>
-            <a:ext cx="2377440" cy="1005840"/>
+            <a:off x="8842248" y="3886200"/>
+            <a:ext cx="2560320" cy="1005840"/>
           </a:xfrm>
           <a:prstGeom prst="rect">
             <a:avLst/>
@@ -8703,7 +8707,7 @@
         </p:nvSpPr>
         <p:spPr>
           <a:xfrm>
-            <a:off x="566928" y="5394960"/>
+            <a:off x="566928" y="5266944"/>
             <a:ext cx="11057839" cy="658368"/>
           </a:xfrm>
           <a:prstGeom prst="roundRect">
@@ -8751,7 +8755,7 @@
         </p:nvSpPr>
         <p:spPr>
           <a:xfrm>
-            <a:off x="841248" y="5394960"/>
+            <a:off x="841248" y="5266944"/>
             <a:ext cx="10509199" cy="658368"/>
           </a:xfrm>
           <a:prstGeom prst="rect">
@@ -9282,7 +9286,7 @@
             </a:avLst>
           </a:prstGeom>
           <a:solidFill>
-            <a:srgbClr val="5E8614"/>
+            <a:srgbClr val="06509D"/>
           </a:solidFill>
           <a:ln>
             <a:noFill/>
@@ -9458,7 +9462,7 @@
             </a:avLst>
           </a:prstGeom>
           <a:solidFill>
-            <a:srgbClr val="5E8614"/>
+            <a:srgbClr val="06509D"/>
           </a:solidFill>
           <a:ln>
             <a:noFill/>
@@ -9790,7 +9794,7 @@
                 <a:latin typeface="Arial"/>
                 <a:cs typeface="Arial"/>
               </a:rPr>
-              <a:t> — same mesh, same steps; only the assembly implementation differs</a:t>
+              <a:t> — same mesh, same steps; only the assembly differs</a:t>
             </a:r>
           </a:p>
         </p:txBody>
@@ -9812,7 +9816,7 @@
         <p:spPr>
           <a:xfrm>
             <a:off x="566928" y="1664208"/>
-            <a:ext cx="6583680" cy="2609561"/>
+            <a:ext cx="6949440" cy="2751269"/>
           </a:xfrm>
           <a:prstGeom prst="rect">
             <a:avLst/>
@@ -9827,8 +9831,8 @@
         </p:nvSpPr>
         <p:spPr>
           <a:xfrm>
-            <a:off x="658368" y="4346921"/>
-            <a:ext cx="6583680" cy="274320"/>
+            <a:off x="658368" y="4488629"/>
+            <a:ext cx="6949440" cy="274320"/>
           </a:xfrm>
           <a:prstGeom prst="rect">
             <a:avLst/>
@@ -9863,8 +9867,8 @@
         </p:nvSpPr>
         <p:spPr>
           <a:xfrm>
-            <a:off x="7562088" y="1801368"/>
-            <a:ext cx="4062679" cy="1207008"/>
+            <a:off x="7927848" y="1801368"/>
+            <a:ext cx="3696919" cy="1207008"/>
           </a:xfrm>
           <a:prstGeom prst="roundRect">
             <a:avLst>
@@ -9911,7 +9915,7 @@
         </p:nvSpPr>
         <p:spPr>
           <a:xfrm>
-            <a:off x="7562088" y="1911096"/>
+            <a:off x="7927848" y="1911096"/>
             <a:ext cx="50292" cy="987552"/>
           </a:xfrm>
           <a:prstGeom prst="rect">
@@ -9955,8 +9959,8 @@
         </p:nvSpPr>
         <p:spPr>
           <a:xfrm>
-            <a:off x="7818120" y="1929384"/>
-            <a:ext cx="3605479" cy="502920"/>
+            <a:off x="8183880" y="1929384"/>
+            <a:ext cx="3239719" cy="502920"/>
           </a:xfrm>
           <a:prstGeom prst="rect">
             <a:avLst/>
@@ -10001,8 +10005,8 @@
         </p:nvSpPr>
         <p:spPr>
           <a:xfrm>
-            <a:off x="7818120" y="2478024"/>
-            <a:ext cx="3605479" cy="475488"/>
+            <a:off x="8183880" y="2478024"/>
+            <a:ext cx="3239719" cy="475488"/>
           </a:xfrm>
           <a:prstGeom prst="rect">
             <a:avLst/>
@@ -10058,8 +10062,8 @@
         </p:nvSpPr>
         <p:spPr>
           <a:xfrm>
-            <a:off x="7562088" y="3227832"/>
-            <a:ext cx="4062679" cy="1207008"/>
+            <a:off x="7927848" y="3227832"/>
+            <a:ext cx="3696919" cy="1207008"/>
           </a:xfrm>
           <a:prstGeom prst="roundRect">
             <a:avLst>
@@ -10106,7 +10110,7 @@
         </p:nvSpPr>
         <p:spPr>
           <a:xfrm>
-            <a:off x="7562088" y="3337560"/>
+            <a:off x="7927848" y="3337560"/>
             <a:ext cx="50292" cy="987552"/>
           </a:xfrm>
           <a:prstGeom prst="rect">
@@ -10150,8 +10154,8 @@
         </p:nvSpPr>
         <p:spPr>
           <a:xfrm>
-            <a:off x="7818120" y="3355848"/>
-            <a:ext cx="3605479" cy="502920"/>
+            <a:off x="8183880" y="3355848"/>
+            <a:ext cx="3239719" cy="502920"/>
           </a:xfrm>
           <a:prstGeom prst="rect">
             <a:avLst/>
@@ -10196,8 +10200,8 @@
         </p:nvSpPr>
         <p:spPr>
           <a:xfrm>
-            <a:off x="7818120" y="3904488"/>
-            <a:ext cx="3605479" cy="475488"/>
+            <a:off x="8183880" y="3904488"/>
+            <a:ext cx="3239719" cy="475488"/>
           </a:xfrm>
           <a:prstGeom prst="rect">
             <a:avLst/>
@@ -10253,8 +10257,8 @@
         </p:nvSpPr>
         <p:spPr>
           <a:xfrm>
-            <a:off x="7562088" y="4700016"/>
-            <a:ext cx="4062679" cy="731520"/>
+            <a:off x="7927848" y="4700016"/>
+            <a:ext cx="3696919" cy="731520"/>
           </a:xfrm>
           <a:prstGeom prst="rect">
             <a:avLst/>
@@ -10293,7 +10297,7 @@
         </p:nvSpPr>
         <p:spPr>
           <a:xfrm>
-            <a:off x="566928" y="5394960"/>
+            <a:off x="566928" y="5266944"/>
             <a:ext cx="11057839" cy="658368"/>
           </a:xfrm>
           <a:prstGeom prst="roundRect">
@@ -10341,7 +10345,7 @@
         </p:nvSpPr>
         <p:spPr>
           <a:xfrm>
-            <a:off x="841248" y="5394960"/>
+            <a:off x="841248" y="5266944"/>
             <a:ext cx="10509199" cy="658368"/>
           </a:xfrm>
           <a:prstGeom prst="rect">
@@ -10364,7 +10368,7 @@
                 <a:latin typeface="Arial"/>
                 <a:cs typeface="Arial"/>
               </a:rPr>
-              <a:t>Any error in the interface would appear here — it doesn't.</a:t>
+              <a:t>Any error in the interface would appear here — it doesn’t.</a:t>
             </a:r>
             <a:r>
               <a:rPr sz="1500" b="0" i="0">
@@ -10374,7 +10378,7 @@
                 <a:latin typeface="Arial"/>
                 <a:cs typeface="Arial"/>
               </a:rPr>
-              <a:t> The NEML2 force path reproduces MOOSE's native assembly to one part in 10</a:t>
+              <a:t> The NEML2 force path matches MOOSE’s native assembly to a few parts in 10</a:t>
             </a:r>
             <a:r>
               <a:rPr sz="1500" b="0" i="0" baseline="30000">
@@ -10526,7 +10530,7 @@
                 <a:latin typeface="Arial"/>
                 <a:cs typeface="Arial"/>
               </a:rPr>
-              <a:t> — Johnson–Cook plasticity in NEML2,  Δt = 10 ns,  </a:t>
+              <a:t> — Johnson–Cook plasticity in NEML2 · Δt = 10 ns · </a:t>
             </a:r>
             <a:r>
               <a:rPr sz="1450" b="1" i="0">
@@ -10536,7 +10540,7 @@
                 <a:latin typeface="Arial"/>
                 <a:cs typeface="Arial"/>
               </a:rPr>
-              <a:t>~12,000 explicit steps</a:t>
+              <a:t>11,000+ explicit steps</a:t>
             </a:r>
           </a:p>
         </p:txBody>
@@ -10558,7 +10562,7 @@
         <p:spPr>
           <a:xfrm>
             <a:off x="1115568" y="1627632"/>
-            <a:ext cx="8778240" cy="2424788"/>
+            <a:ext cx="8778240" cy="2436529"/>
           </a:xfrm>
           <a:prstGeom prst="rect">
             <a:avLst/>
@@ -10573,7 +10577,7 @@
         </p:nvSpPr>
         <p:spPr>
           <a:xfrm>
-            <a:off x="1207008" y="4079852"/>
+            <a:off x="1207008" y="4091593"/>
             <a:ext cx="10058400" cy="256032"/>
           </a:xfrm>
           <a:prstGeom prst="rect">
@@ -10617,8 +10621,8 @@
         </p:blipFill>
         <p:spPr>
           <a:xfrm>
-            <a:off x="566928" y="4372460"/>
-            <a:ext cx="4114800" cy="1573222"/>
+            <a:off x="566928" y="4356769"/>
+            <a:ext cx="3931920" cy="1522296"/>
           </a:xfrm>
           <a:prstGeom prst="rect">
             <a:avLst/>
@@ -10633,8 +10637,8 @@
         </p:nvSpPr>
         <p:spPr>
           <a:xfrm>
-            <a:off x="5138928" y="4601060"/>
-            <a:ext cx="6485839" cy="1390342"/>
+            <a:off x="4956048" y="4585369"/>
+            <a:ext cx="6668719" cy="1339416"/>
           </a:xfrm>
           <a:prstGeom prst="rect">
             <a:avLst/>
@@ -10855,7 +10859,7 @@
                 <a:latin typeface="Arial"/>
                 <a:cs typeface="Arial"/>
               </a:rPr>
-              <a:t>Same coupled run — temperature integrated </a:t>
+              <a:t>The run you just saw is coupled — temperature integrated </a:t>
             </a:r>
             <a:r>
               <a:rPr sz="1450" b="1" i="0">
@@ -10875,7 +10879,7 @@
                 <a:latin typeface="Arial"/>
                 <a:cs typeface="Arial"/>
               </a:rPr>
-              <a:t> (adiabatic Taylor–Quinney heating, β = 0.9), in the same batched update</a:t>
+              <a:t> (adiabatic Taylor–Quinney heating, β = 0.9)</a:t>
             </a:r>
           </a:p>
         </p:txBody>
@@ -10896,8 +10900,8 @@
         </p:blipFill>
         <p:spPr>
           <a:xfrm>
-            <a:off x="1389888" y="1627632"/>
-            <a:ext cx="8229600" cy="2450098"/>
+            <a:off x="1755648" y="1609344"/>
+            <a:ext cx="7498079" cy="2072261"/>
           </a:xfrm>
           <a:prstGeom prst="rect">
             <a:avLst/>
@@ -10912,7 +10916,7 @@
         </p:nvSpPr>
         <p:spPr>
           <a:xfrm>
-            <a:off x="1481328" y="4105162"/>
+            <a:off x="1847088" y="3709037"/>
             <a:ext cx="10058400" cy="256032"/>
           </a:xfrm>
           <a:prstGeom prst="rect">
@@ -10948,7 +10952,7 @@
         </p:nvSpPr>
         <p:spPr>
           <a:xfrm>
-            <a:off x="566928" y="4443490"/>
+            <a:off x="566928" y="4029077"/>
             <a:ext cx="3442106" cy="960120"/>
           </a:xfrm>
           <a:prstGeom prst="roundRect">
@@ -10996,7 +11000,7 @@
         </p:nvSpPr>
         <p:spPr>
           <a:xfrm>
-            <a:off x="566928" y="4525786"/>
+            <a:off x="566928" y="4111373"/>
             <a:ext cx="50292" cy="795528"/>
           </a:xfrm>
           <a:prstGeom prst="rect">
@@ -11040,7 +11044,7 @@
         </p:nvSpPr>
         <p:spPr>
           <a:xfrm>
-            <a:off x="786384" y="4516642"/>
+            <a:off x="786384" y="4102229"/>
             <a:ext cx="3039770" cy="274320"/>
           </a:xfrm>
           <a:prstGeom prst="rect">
@@ -11080,7 +11084,7 @@
         </p:nvSpPr>
         <p:spPr>
           <a:xfrm>
-            <a:off x="786384" y="4836682"/>
+            <a:off x="786384" y="4422269"/>
             <a:ext cx="3039770" cy="548640"/>
           </a:xfrm>
           <a:prstGeom prst="rect">
@@ -11120,7 +11124,7 @@
         </p:nvSpPr>
         <p:spPr>
           <a:xfrm>
-            <a:off x="4374794" y="4443490"/>
+            <a:off x="4374794" y="4029077"/>
             <a:ext cx="3442106" cy="960120"/>
           </a:xfrm>
           <a:prstGeom prst="roundRect">
@@ -11168,7 +11172,7 @@
         </p:nvSpPr>
         <p:spPr>
           <a:xfrm>
-            <a:off x="4374794" y="4525786"/>
+            <a:off x="4374794" y="4111373"/>
             <a:ext cx="50292" cy="795528"/>
           </a:xfrm>
           <a:prstGeom prst="rect">
@@ -11212,7 +11216,7 @@
         </p:nvSpPr>
         <p:spPr>
           <a:xfrm>
-            <a:off x="4594250" y="4516642"/>
+            <a:off x="4594250" y="4102229"/>
             <a:ext cx="3039770" cy="274320"/>
           </a:xfrm>
           <a:prstGeom prst="rect">
@@ -11252,7 +11256,7 @@
         </p:nvSpPr>
         <p:spPr>
           <a:xfrm>
-            <a:off x="4594250" y="4836682"/>
+            <a:off x="4594250" y="4422269"/>
             <a:ext cx="3039770" cy="548640"/>
           </a:xfrm>
           <a:prstGeom prst="rect">
@@ -11279,7 +11283,7 @@
                 <a:latin typeface="Arial"/>
                 <a:cs typeface="Arial"/>
               </a:rPr>
-              <a:t>diffusion length √(αt) ≈ 0.1 mm ≪ element size over 120 µs — no heat-conduction PDE needed</a:t>
+              <a:t>diffusion length √(αt) ≈ 0.1 mm ≪ element size over the 114 µs run — no heat-conduction PDE needed</a:t>
             </a:r>
           </a:p>
         </p:txBody>
@@ -11292,7 +11296,7 @@
         </p:nvSpPr>
         <p:spPr>
           <a:xfrm>
-            <a:off x="8182660" y="4443490"/>
+            <a:off x="8182660" y="4029077"/>
             <a:ext cx="3442106" cy="960120"/>
           </a:xfrm>
           <a:prstGeom prst="roundRect">
@@ -11340,7 +11344,7 @@
         </p:nvSpPr>
         <p:spPr>
           <a:xfrm>
-            <a:off x="8182660" y="4525786"/>
+            <a:off x="8182660" y="4111373"/>
             <a:ext cx="50292" cy="795528"/>
           </a:xfrm>
           <a:prstGeom prst="rect">
@@ -11384,7 +11388,7 @@
         </p:nvSpPr>
         <p:spPr>
           <a:xfrm>
-            <a:off x="8402116" y="4516642"/>
+            <a:off x="8402116" y="4102229"/>
             <a:ext cx="3039770" cy="274320"/>
           </a:xfrm>
           <a:prstGeom prst="rect">
@@ -11424,7 +11428,7 @@
         </p:nvSpPr>
         <p:spPr>
           <a:xfrm>
-            <a:off x="8402116" y="4836682"/>
+            <a:off x="8402116" y="4422269"/>
             <a:ext cx="3039770" cy="548640"/>
           </a:xfrm>
           <a:prstGeom prst="rect">
@@ -11464,7 +11468,7 @@
         </p:nvSpPr>
         <p:spPr>
           <a:xfrm>
-            <a:off x="566928" y="5468112"/>
+            <a:off x="566928" y="5266944"/>
             <a:ext cx="11057839" cy="658368"/>
           </a:xfrm>
           <a:prstGeom prst="roundRect">
@@ -11512,7 +11516,7 @@
         </p:nvSpPr>
         <p:spPr>
           <a:xfrm>
-            <a:off x="841248" y="5468112"/>
+            <a:off x="841248" y="5266944"/>
             <a:ext cx="10509199" cy="658368"/>
           </a:xfrm>
           <a:prstGeom prst="rect">
@@ -11535,7 +11539,7 @@
                 <a:latin typeface="Arial"/>
                 <a:cs typeface="Arial"/>
               </a:rPr>
-              <a:t>The abstract's thermo-mechanical claim, delivered:</a:t>
+              <a:t>The abstract’s thermo-mechanical claim, delivered:</a:t>
             </a:r>
             <a:r>
               <a:rPr sz="1500" b="0" i="0">
@@ -11545,7 +11549,7 @@
                 <a:latin typeface="Arial"/>
                 <a:cs typeface="Arial"/>
               </a:rPr>
-              <a:t> ΔT ≈ 120 K at the mushroom foot, captured end-to-end through the NEML2 force path.</a:t>
+              <a:t> a peak ΔT of 119 K at the mushroom foot, captured through the NEML2 force path.</a:t>
             </a:r>
           </a:p>
         </p:txBody>
@@ -12421,7 +12425,7 @@
         </p:nvSpPr>
         <p:spPr>
           <a:xfrm>
-            <a:off x="566928" y="5394960"/>
+            <a:off x="566928" y="5266944"/>
             <a:ext cx="11057839" cy="658368"/>
           </a:xfrm>
           <a:prstGeom prst="roundRect">
@@ -12469,7 +12473,7 @@
         </p:nvSpPr>
         <p:spPr>
           <a:xfrm>
-            <a:off x="841248" y="5394960"/>
+            <a:off x="841248" y="5266944"/>
             <a:ext cx="10509199" cy="658368"/>
           </a:xfrm>
           <a:prstGeom prst="rect">
@@ -12735,7 +12739,7 @@
                 <a:latin typeface="Arial"/>
                 <a:cs typeface="Arial"/>
               </a:rPr>
-              <a:t>Coupled-physics machinery, meshing, restart, in-situ output</a:t>
+              <a:t>Coupled-physics machinery, in-situ output, meshing, restart</a:t>
             </a:r>
           </a:p>
           <a:p>
@@ -13041,8 +13045,8 @@
         </p:nvSpPr>
         <p:spPr>
           <a:xfrm>
-            <a:off x="5464911" y="2596896"/>
-            <a:ext cx="1261872" cy="914400"/>
+            <a:off x="5428335" y="2596896"/>
+            <a:ext cx="1335024" cy="914400"/>
           </a:xfrm>
           <a:prstGeom prst="rect">
             <a:avLst/>
@@ -13061,7 +13065,7 @@
               </a:lnSpc>
             </a:pPr>
             <a:r>
-              <a:rPr sz="1050" b="0" i="1">
+              <a:rPr sz="1250" b="0" i="1">
                 <a:solidFill>
                   <a:srgbClr val="CF1D4C"/>
                 </a:solidFill>
@@ -13078,7 +13082,7 @@
               </a:lnSpc>
             </a:pPr>
             <a:r>
-              <a:rPr sz="1050" b="0" i="1">
+              <a:rPr sz="1250" b="0" i="1">
                 <a:solidFill>
                   <a:srgbClr val="CF1D4C"/>
                 </a:solidFill>
@@ -13098,7 +13102,7 @@
         </p:nvSpPr>
         <p:spPr>
           <a:xfrm>
-            <a:off x="566928" y="4334256"/>
+            <a:off x="566928" y="4453128"/>
             <a:ext cx="11057839" cy="914400"/>
           </a:xfrm>
           <a:prstGeom prst="roundRect">
@@ -13146,7 +13150,7 @@
         </p:nvSpPr>
         <p:spPr>
           <a:xfrm>
-            <a:off x="841248" y="4334256"/>
+            <a:off x="841248" y="4453128"/>
             <a:ext cx="10509199" cy="914400"/>
           </a:xfrm>
           <a:prstGeom prst="rect">
@@ -13508,7 +13512,7 @@
         </p:nvSpPr>
         <p:spPr>
           <a:xfrm>
-            <a:off x="566928" y="5394960"/>
+            <a:off x="566928" y="5266944"/>
             <a:ext cx="11057839" cy="658368"/>
           </a:xfrm>
           <a:prstGeom prst="roundRect">
@@ -13556,7 +13560,7 @@
         </p:nvSpPr>
         <p:spPr>
           <a:xfrm>
-            <a:off x="841248" y="5394960"/>
+            <a:off x="841248" y="5266944"/>
             <a:ext cx="10509199" cy="658368"/>
           </a:xfrm>
           <a:prstGeom prst="rect">
@@ -13801,7 +13805,7 @@
                 <a:latin typeface="Arial"/>
                 <a:cs typeface="Arial"/>
               </a:rPr>
-              <a:t>lumped mass: pointwise divide, no solver</a:t>
+              <a:t>pointwise divide — no solver</a:t>
             </a:r>
           </a:p>
         </p:txBody>
@@ -13861,7 +13865,7 @@
                 <a:latin typeface="Arial"/>
                 <a:cs typeface="Arial"/>
               </a:rPr>
-              <a:t>midpoint velocity update (variable Δt)</a:t>
+              <a:t>variable-Δt midpoint velocity update</a:t>
             </a:r>
           </a:p>
         </p:txBody>
@@ -14253,7 +14257,7 @@
         </p:nvSpPr>
         <p:spPr>
           <a:xfrm>
-            <a:off x="566928" y="5394960"/>
+            <a:off x="566928" y="5266944"/>
             <a:ext cx="11057839" cy="658368"/>
           </a:xfrm>
           <a:prstGeom prst="roundRect">
@@ -14301,7 +14305,7 @@
         </p:nvSpPr>
         <p:spPr>
           <a:xfrm>
-            <a:off x="841248" y="5394960"/>
+            <a:off x="841248" y="5266944"/>
             <a:ext cx="10509199" cy="658368"/>
           </a:xfrm>
           <a:prstGeom prst="rect">
@@ -15123,7 +15127,7 @@
         </p:nvSpPr>
         <p:spPr>
           <a:xfrm>
-            <a:off x="566928" y="5394960"/>
+            <a:off x="566928" y="5266944"/>
             <a:ext cx="11057839" cy="658368"/>
           </a:xfrm>
           <a:prstGeom prst="roundRect">
@@ -15171,7 +15175,7 @@
         </p:nvSpPr>
         <p:spPr>
           <a:xfrm>
-            <a:off x="841248" y="5394960"/>
+            <a:off x="841248" y="5266944"/>
             <a:ext cx="10509199" cy="658368"/>
           </a:xfrm>
           <a:prstGeom prst="rect">
@@ -15204,7 +15208,7 @@
                 <a:latin typeface="Arial"/>
                 <a:cs typeface="Arial"/>
               </a:rPr>
-              <a:t> The step count is physics. The material cost is engineering — and it is the target.</a:t>
+              <a:t> The step count is physics; the material cost is the target.</a:t>
             </a:r>
           </a:p>
         </p:txBody>
@@ -16166,7 +16170,7 @@
                 <a:latin typeface="Arial"/>
                 <a:cs typeface="Arial"/>
               </a:rPr>
-              <a:t>mesh generators, adaptivity, Exodus/CSV in-situ output</a:t>
+              <a:t>mesh generators, adaptivity, in-situ Exodus/CSV output</a:t>
             </a:r>
           </a:p>
         </p:txBody>
@@ -16347,7 +16351,7 @@
         </p:nvSpPr>
         <p:spPr>
           <a:xfrm>
-            <a:off x="566928" y="5394960"/>
+            <a:off x="566928" y="5266944"/>
             <a:ext cx="11057839" cy="658368"/>
           </a:xfrm>
           <a:prstGeom prst="roundRect">
@@ -16395,7 +16399,7 @@
         </p:nvSpPr>
         <p:spPr>
           <a:xfrm>
-            <a:off x="841248" y="5394960"/>
+            <a:off x="841248" y="5266944"/>
             <a:ext cx="10509199" cy="658368"/>
           </a:xfrm>
           <a:prstGeom prst="rect">
@@ -16693,7 +16697,11 @@
           <a:bodyPr rtlCol="0" anchor="ctr" wrap="square" lIns="54864" rIns="54864" tIns="27432" bIns="27432"/>
           <a:lstStyle/>
           <a:p>
-            <a:pPr algn="ctr"/>
+            <a:pPr algn="ctr">
+              <a:lnSpc>
+                <a:spcPct val="105000"/>
+              </a:lnSpc>
+            </a:pPr>
             <a:r>
               <a:rPr sz="1050" b="0" i="0">
                 <a:solidFill>
@@ -16788,7 +16796,11 @@
           <a:bodyPr rtlCol="0" anchor="ctr" wrap="square" lIns="54864" rIns="54864" tIns="27432" bIns="27432"/>
           <a:lstStyle/>
           <a:p>
-            <a:pPr algn="ctr"/>
+            <a:pPr algn="ctr">
+              <a:lnSpc>
+                <a:spcPct val="105000"/>
+              </a:lnSpc>
+            </a:pPr>
             <a:r>
               <a:rPr sz="1050" b="0" i="0">
                 <a:solidFill>
@@ -16883,7 +16895,11 @@
           <a:bodyPr rtlCol="0" anchor="ctr" wrap="square" lIns="54864" rIns="54864" tIns="27432" bIns="27432"/>
           <a:lstStyle/>
           <a:p>
-            <a:pPr algn="ctr"/>
+            <a:pPr algn="ctr">
+              <a:lnSpc>
+                <a:spcPct val="105000"/>
+              </a:lnSpc>
+            </a:pPr>
             <a:r>
               <a:rPr sz="1050" b="0" i="0">
                 <a:solidFill>
@@ -16978,7 +16994,11 @@
           <a:bodyPr rtlCol="0" anchor="ctr" wrap="square" lIns="54864" rIns="54864" tIns="27432" bIns="27432"/>
           <a:lstStyle/>
           <a:p>
-            <a:pPr algn="ctr"/>
+            <a:pPr algn="ctr">
+              <a:lnSpc>
+                <a:spcPct val="105000"/>
+              </a:lnSpc>
+            </a:pPr>
             <a:r>
               <a:rPr sz="1050" b="0" i="0">
                 <a:solidFill>
@@ -16987,8 +17007,24 @@
                 <a:latin typeface="Arial"/>
                 <a:cs typeface="Arial"/>
               </a:rPr>
-              <a:t>rate
-sensitivity</a:t>
+              <a:t>rate</a:t>
+            </a:r>
+          </a:p>
+          <a:p>
+            <a:pPr algn="ctr">
+              <a:lnSpc>
+                <a:spcPct val="105000"/>
+              </a:lnSpc>
+            </a:pPr>
+            <a:r>
+              <a:rPr sz="1050" b="0" i="0">
+                <a:solidFill>
+                  <a:srgbClr val="1E2430"/>
+                </a:solidFill>
+                <a:latin typeface="Arial"/>
+                <a:cs typeface="Arial"/>
+              </a:rPr>
+              <a:t>sensitivity</a:t>
             </a:r>
           </a:p>
         </p:txBody>
@@ -17074,7 +17110,11 @@
           <a:bodyPr rtlCol="0" anchor="ctr" wrap="square" lIns="54864" rIns="54864" tIns="27432" bIns="27432"/>
           <a:lstStyle/>
           <a:p>
-            <a:pPr algn="ctr"/>
+            <a:pPr algn="ctr">
+              <a:lnSpc>
+                <a:spcPct val="105000"/>
+              </a:lnSpc>
+            </a:pPr>
             <a:r>
               <a:rPr sz="1050" b="0" i="0">
                 <a:solidFill>
@@ -17083,8 +17123,24 @@
                 <a:latin typeface="Arial"/>
                 <a:cs typeface="Arial"/>
               </a:rPr>
-              <a:t>state
-update</a:t>
+              <a:t>state</a:t>
+            </a:r>
+          </a:p>
+          <a:p>
+            <a:pPr algn="ctr">
+              <a:lnSpc>
+                <a:spcPct val="105000"/>
+              </a:lnSpc>
+            </a:pPr>
+            <a:r>
+              <a:rPr sz="1050" b="0" i="0">
+                <a:solidFill>
+                  <a:srgbClr val="1E2430"/>
+                </a:solidFill>
+                <a:latin typeface="Arial"/>
+                <a:cs typeface="Arial"/>
+              </a:rPr>
+              <a:t>update</a:t>
             </a:r>
           </a:p>
         </p:txBody>
@@ -17248,7 +17304,7 @@
                 <a:latin typeface="Arial"/>
                 <a:cs typeface="Arial"/>
               </a:rPr>
-              <a:t>NEML2 library benchmark</a:t>
+              <a:t>NEML2 library benchmark:</a:t>
             </a:r>
             <a:r>
               <a:rPr sz="1400" b="0" i="0">
@@ -17258,7 +17314,7 @@
                 <a:latin typeface="Arial"/>
                 <a:cs typeface="Arial"/>
               </a:rPr>
-              <a:t> (crystal plasticity): 42,500 s (NEML, CPU) → 68 s on one GPU</a:t>
+              <a:t> 42,500 s (NEML, CPU) → 68 s on one GPU</a:t>
             </a:r>
           </a:p>
         </p:txBody>
@@ -18545,7 +18601,7 @@
         </p:nvSpPr>
         <p:spPr>
           <a:xfrm>
-            <a:off x="566928" y="5394960"/>
+            <a:off x="566928" y="5266944"/>
             <a:ext cx="11057839" cy="658368"/>
           </a:xfrm>
           <a:prstGeom prst="roundRect">
@@ -18593,7 +18649,7 @@
         </p:nvSpPr>
         <p:spPr>
           <a:xfrm>
-            <a:off x="841248" y="5394960"/>
+            <a:off x="841248" y="5266944"/>
             <a:ext cx="10509199" cy="658368"/>
           </a:xfrm>
           <a:prstGeom prst="rect">
@@ -19377,7 +19433,7 @@
                 <a:latin typeface="Arial"/>
                 <a:cs typeface="Arial"/>
               </a:rPr>
-              <a:t>MOOSE boundary conditions  ·  parallel domain decomposition  ·  meshing &amp; output  ·  contact-compatible architecture</a:t>
+              <a:t>MOOSE boundary conditions  ·  parallel domain decomposition  ·  meshing &amp; output  ·  contact (architecture-compatible)</a:t>
             </a:r>
           </a:p>
         </p:txBody>
@@ -19390,7 +19446,7 @@
         </p:nvSpPr>
         <p:spPr>
           <a:xfrm>
-            <a:off x="566928" y="5394960"/>
+            <a:off x="566928" y="5266944"/>
             <a:ext cx="11057839" cy="658368"/>
           </a:xfrm>
           <a:prstGeom prst="roundRect">
@@ -19438,7 +19494,7 @@
         </p:nvSpPr>
         <p:spPr>
           <a:xfrm>
-            <a:off x="841248" y="5394960"/>
+            <a:off x="841248" y="5266944"/>
             <a:ext cx="10509199" cy="658368"/>
           </a:xfrm>
           <a:prstGeom prst="rect">

</xml_diff>

<commit_message>
slides: fix the INL footer properly
Root cause found: 'IDAHO NATIONAL LABORATORY' in the footer band is an
EMF picture, not text. The earlier 'fix' had resized the shape before
it — the green brand stripe — making it 3x too tall. Reverted.

Real fix: the EMF's glyph bottoms clip in several renderers, so base
generation now swaps the wordmark rels to a padded high-res PNG
(white letterspaced caps, 28% vertical padding — cannot clip anywhere)
injected as ppt/media/inl_wordmark.png. Verified at 300dpi: full
glyphs, thin stripe restored at its true 6.82in on every slide.

Co-Authored-By: Claude Fable 5 <noreply@anthropic.com>
Claude-Session: https://claude.ai/code/session_01CCuKo2gP6Duy91irEj5f1y
</commit_message>
<xml_diff>
--- a/examples/impact/slide_assets/WCCM_NEML2_explicit_dynamics_v2.pptx
+++ b/examples/impact/slide_assets/WCCM_NEML2_explicit_dynamics_v2.pptx
@@ -1423,8 +1423,8 @@
         </p:nvSpPr>
         <p:spPr>
           <a:xfrm>
-            <a:off x="0" y="6043104"/>
-            <a:ext cx="12192000" cy="292608"/>
+            <a:off x="0" y="6237795"/>
+            <a:ext cx="12192000" cy="97917"/>
           </a:xfrm>
           <a:prstGeom prst="rect">
             <a:avLst/>
@@ -3391,8 +3391,8 @@
         </p:nvSpPr>
         <p:spPr>
           <a:xfrm>
-            <a:off x="0" y="6043104"/>
-            <a:ext cx="12192000" cy="292608"/>
+            <a:off x="0" y="6237795"/>
+            <a:ext cx="12192000" cy="97917"/>
           </a:xfrm>
           <a:prstGeom prst="rect">
             <a:avLst/>
@@ -3950,8 +3950,8 @@
         </p:nvSpPr>
         <p:spPr>
           <a:xfrm>
-            <a:off x="0" y="6043104"/>
-            <a:ext cx="12192000" cy="292608"/>
+            <a:off x="0" y="6237795"/>
+            <a:ext cx="12192000" cy="97917"/>
           </a:xfrm>
           <a:prstGeom prst="rect">
             <a:avLst/>
@@ -5422,8 +5422,8 @@
         </p:nvSpPr>
         <p:spPr>
           <a:xfrm>
-            <a:off x="8465769" y="6043104"/>
-            <a:ext cx="3726231" cy="292608"/>
+            <a:off x="8465769" y="6237795"/>
+            <a:ext cx="3726231" cy="97917"/>
           </a:xfrm>
           <a:prstGeom prst="rect">
             <a:avLst/>
@@ -7575,7 +7575,7 @@
         </p:nvSpPr>
         <p:spPr>
           <a:xfrm>
-            <a:off x="566928" y="5266944"/>
+            <a:off x="566928" y="5376672"/>
             <a:ext cx="11057839" cy="658368"/>
           </a:xfrm>
           <a:prstGeom prst="roundRect">
@@ -7623,7 +7623,7 @@
         </p:nvSpPr>
         <p:spPr>
           <a:xfrm>
-            <a:off x="841248" y="5266944"/>
+            <a:off x="841248" y="5376672"/>
             <a:ext cx="10509199" cy="658368"/>
           </a:xfrm>
           <a:prstGeom prst="rect">
@@ -8707,7 +8707,7 @@
         </p:nvSpPr>
         <p:spPr>
           <a:xfrm>
-            <a:off x="566928" y="5266944"/>
+            <a:off x="566928" y="5376672"/>
             <a:ext cx="11057839" cy="658368"/>
           </a:xfrm>
           <a:prstGeom prst="roundRect">
@@ -8755,7 +8755,7 @@
         </p:nvSpPr>
         <p:spPr>
           <a:xfrm>
-            <a:off x="841248" y="5266944"/>
+            <a:off x="841248" y="5376672"/>
             <a:ext cx="10509199" cy="658368"/>
           </a:xfrm>
           <a:prstGeom prst="rect">
@@ -10297,7 +10297,7 @@
         </p:nvSpPr>
         <p:spPr>
           <a:xfrm>
-            <a:off x="566928" y="5266944"/>
+            <a:off x="566928" y="5376672"/>
             <a:ext cx="11057839" cy="658368"/>
           </a:xfrm>
           <a:prstGeom prst="roundRect">
@@ -10345,7 +10345,7 @@
         </p:nvSpPr>
         <p:spPr>
           <a:xfrm>
-            <a:off x="841248" y="5266944"/>
+            <a:off x="841248" y="5376672"/>
             <a:ext cx="10509199" cy="658368"/>
           </a:xfrm>
           <a:prstGeom prst="rect">
@@ -11468,7 +11468,7 @@
         </p:nvSpPr>
         <p:spPr>
           <a:xfrm>
-            <a:off x="566928" y="5266944"/>
+            <a:off x="566928" y="5376672"/>
             <a:ext cx="11057839" cy="658368"/>
           </a:xfrm>
           <a:prstGeom prst="roundRect">
@@ -11516,7 +11516,7 @@
         </p:nvSpPr>
         <p:spPr>
           <a:xfrm>
-            <a:off x="841248" y="5266944"/>
+            <a:off x="841248" y="5376672"/>
             <a:ext cx="10509199" cy="658368"/>
           </a:xfrm>
           <a:prstGeom prst="rect">
@@ -12425,7 +12425,7 @@
         </p:nvSpPr>
         <p:spPr>
           <a:xfrm>
-            <a:off x="566928" y="5266944"/>
+            <a:off x="566928" y="5376672"/>
             <a:ext cx="11057839" cy="658368"/>
           </a:xfrm>
           <a:prstGeom prst="roundRect">
@@ -12473,7 +12473,7 @@
         </p:nvSpPr>
         <p:spPr>
           <a:xfrm>
-            <a:off x="841248" y="5266944"/>
+            <a:off x="841248" y="5376672"/>
             <a:ext cx="10509199" cy="658368"/>
           </a:xfrm>
           <a:prstGeom prst="rect">
@@ -13512,7 +13512,7 @@
         </p:nvSpPr>
         <p:spPr>
           <a:xfrm>
-            <a:off x="566928" y="5266944"/>
+            <a:off x="566928" y="5376672"/>
             <a:ext cx="11057839" cy="658368"/>
           </a:xfrm>
           <a:prstGeom prst="roundRect">
@@ -13560,7 +13560,7 @@
         </p:nvSpPr>
         <p:spPr>
           <a:xfrm>
-            <a:off x="841248" y="5266944"/>
+            <a:off x="841248" y="5376672"/>
             <a:ext cx="10509199" cy="658368"/>
           </a:xfrm>
           <a:prstGeom prst="rect">
@@ -14257,7 +14257,7 @@
         </p:nvSpPr>
         <p:spPr>
           <a:xfrm>
-            <a:off x="566928" y="5266944"/>
+            <a:off x="566928" y="5376672"/>
             <a:ext cx="11057839" cy="658368"/>
           </a:xfrm>
           <a:prstGeom prst="roundRect">
@@ -14305,7 +14305,7 @@
         </p:nvSpPr>
         <p:spPr>
           <a:xfrm>
-            <a:off x="841248" y="5266944"/>
+            <a:off x="841248" y="5376672"/>
             <a:ext cx="10509199" cy="658368"/>
           </a:xfrm>
           <a:prstGeom prst="rect">
@@ -15127,7 +15127,7 @@
         </p:nvSpPr>
         <p:spPr>
           <a:xfrm>
-            <a:off x="566928" y="5266944"/>
+            <a:off x="566928" y="5376672"/>
             <a:ext cx="11057839" cy="658368"/>
           </a:xfrm>
           <a:prstGeom prst="roundRect">
@@ -15175,7 +15175,7 @@
         </p:nvSpPr>
         <p:spPr>
           <a:xfrm>
-            <a:off x="841248" y="5266944"/>
+            <a:off x="841248" y="5376672"/>
             <a:ext cx="10509199" cy="658368"/>
           </a:xfrm>
           <a:prstGeom prst="rect">
@@ -16351,7 +16351,7 @@
         </p:nvSpPr>
         <p:spPr>
           <a:xfrm>
-            <a:off x="566928" y="5266944"/>
+            <a:off x="566928" y="5376672"/>
             <a:ext cx="11057839" cy="658368"/>
           </a:xfrm>
           <a:prstGeom prst="roundRect">
@@ -16399,7 +16399,7 @@
         </p:nvSpPr>
         <p:spPr>
           <a:xfrm>
-            <a:off x="841248" y="5266944"/>
+            <a:off x="841248" y="5376672"/>
             <a:ext cx="10509199" cy="658368"/>
           </a:xfrm>
           <a:prstGeom prst="rect">
@@ -18601,7 +18601,7 @@
         </p:nvSpPr>
         <p:spPr>
           <a:xfrm>
-            <a:off x="566928" y="5266944"/>
+            <a:off x="566928" y="5376672"/>
             <a:ext cx="11057839" cy="658368"/>
           </a:xfrm>
           <a:prstGeom prst="roundRect">
@@ -18649,7 +18649,7 @@
         </p:nvSpPr>
         <p:spPr>
           <a:xfrm>
-            <a:off x="841248" y="5266944"/>
+            <a:off x="841248" y="5376672"/>
             <a:ext cx="10509199" cy="658368"/>
           </a:xfrm>
           <a:prstGeom prst="rect">
@@ -19446,7 +19446,7 @@
         </p:nvSpPr>
         <p:spPr>
           <a:xfrm>
-            <a:off x="566928" y="5266944"/>
+            <a:off x="566928" y="5376672"/>
             <a:ext cx="11057839" cy="658368"/>
           </a:xfrm>
           <a:prstGeom prst="roundRect">
@@ -19494,7 +19494,7 @@
         </p:nvSpPr>
         <p:spPr>
           <a:xfrm>
-            <a:off x="841248" y="5266944"/>
+            <a:off x="841248" y="5376672"/>
             <a:ext cx="10509199" cy="658368"/>
           </a:xfrm>
           <a:prstGeom prst="rect">

</xml_diff>

<commit_message>
slides: replace verification graphic with a log-scale error ladder
Slide 13 graphic no longer shows fields or the coarse test mesh.
New figure: relative error on a log axis with context markers —
1% engineering agreement, exodiff tolerance 5e-4, and our two
measured differences (forces 3e-8, displacements 8e-8) sitting in a
shaded floating-point-noise zone, with a '6,000x tighter than the
test suite requires' margin arrow.

Co-Authored-By: Claude Fable 5 <noreply@anthropic.com>
Claude-Session: https://claude.ai/code/session_01CCuKo2gP6Duy91irEj5f1y
</commit_message>
<xml_diff>
--- a/examples/impact/slide_assets/WCCM_NEML2_explicit_dynamics_v2.pptx
+++ b/examples/impact/slide_assets/WCCM_NEML2_explicit_dynamics_v2.pptx
@@ -9815,8 +9815,8 @@
         </p:blipFill>
         <p:spPr>
           <a:xfrm>
-            <a:off x="566928" y="1664208"/>
-            <a:ext cx="6949440" cy="2751269"/>
+            <a:off x="566928" y="1892808"/>
+            <a:ext cx="6949440" cy="2655808"/>
           </a:xfrm>
           <a:prstGeom prst="rect">
             <a:avLst/>
@@ -9831,7 +9831,7 @@
         </p:nvSpPr>
         <p:spPr>
           <a:xfrm>
-            <a:off x="658368" y="4488629"/>
+            <a:off x="658368" y="4685776"/>
             <a:ext cx="6949440" cy="274320"/>
           </a:xfrm>
           <a:prstGeom prst="rect">
@@ -9854,7 +9854,7 @@
                 <a:latin typeface="Arial"/>
                 <a:cs typeface="Arial"/>
               </a:rPr>
-              <a:t>2-D slug impact test problem — internal force field at the final step; impact face at left</a:t>
+              <a:t>measured on the 2-D slug impact test problem, final step, over every node</a:t>
             </a:r>
           </a:p>
         </p:txBody>
@@ -9867,7 +9867,7 @@
         </p:nvSpPr>
         <p:spPr>
           <a:xfrm>
-            <a:off x="7927848" y="1801368"/>
+            <a:off x="7927848" y="2029968"/>
             <a:ext cx="3696919" cy="1207008"/>
           </a:xfrm>
           <a:prstGeom prst="roundRect">
@@ -9915,7 +9915,7 @@
         </p:nvSpPr>
         <p:spPr>
           <a:xfrm>
-            <a:off x="7927848" y="1911096"/>
+            <a:off x="7927848" y="2139696"/>
             <a:ext cx="50292" cy="987552"/>
           </a:xfrm>
           <a:prstGeom prst="rect">
@@ -9959,7 +9959,7 @@
         </p:nvSpPr>
         <p:spPr>
           <a:xfrm>
-            <a:off x="8183880" y="1929384"/>
+            <a:off x="8183880" y="2157984"/>
             <a:ext cx="3239719" cy="502920"/>
           </a:xfrm>
           <a:prstGeom prst="rect">
@@ -10005,7 +10005,7 @@
         </p:nvSpPr>
         <p:spPr>
           <a:xfrm>
-            <a:off x="8183880" y="2478024"/>
+            <a:off x="8183880" y="2706624"/>
             <a:ext cx="3239719" cy="475488"/>
           </a:xfrm>
           <a:prstGeom prst="rect">
@@ -10062,7 +10062,7 @@
         </p:nvSpPr>
         <p:spPr>
           <a:xfrm>
-            <a:off x="7927848" y="3227832"/>
+            <a:off x="7927848" y="3456432"/>
             <a:ext cx="3696919" cy="1207008"/>
           </a:xfrm>
           <a:prstGeom prst="roundRect">
@@ -10110,7 +10110,7 @@
         </p:nvSpPr>
         <p:spPr>
           <a:xfrm>
-            <a:off x="7927848" y="3337560"/>
+            <a:off x="7927848" y="3566160"/>
             <a:ext cx="50292" cy="987552"/>
           </a:xfrm>
           <a:prstGeom prst="rect">
@@ -10154,7 +10154,7 @@
         </p:nvSpPr>
         <p:spPr>
           <a:xfrm>
-            <a:off x="8183880" y="3355848"/>
+            <a:off x="8183880" y="3584448"/>
             <a:ext cx="3239719" cy="502920"/>
           </a:xfrm>
           <a:prstGeom prst="rect">
@@ -10200,7 +10200,7 @@
         </p:nvSpPr>
         <p:spPr>
           <a:xfrm>
-            <a:off x="8183880" y="3904488"/>
+            <a:off x="8183880" y="4133088"/>
             <a:ext cx="3239719" cy="475488"/>
           </a:xfrm>
           <a:prstGeom prst="rect">
@@ -10257,7 +10257,7 @@
         </p:nvSpPr>
         <p:spPr>
           <a:xfrm>
-            <a:off x="7927848" y="4700016"/>
+            <a:off x="7927848" y="4928616"/>
             <a:ext cx="3696919" cy="731520"/>
           </a:xfrm>
           <a:prstGeom prst="rect">
@@ -10284,7 +10284,7 @@
                 <a:latin typeface="Arial"/>
                 <a:cs typeface="Arial"/>
               </a:rPr>
-              <a:t>the difference panel needs a 10⁸ magnification to show anything at all</a:t>
+              <a:t>both differences sit at the floating-point noise floor of an explicit step</a:t>
             </a:r>
           </a:p>
         </p:txBody>

</xml_diff>

<commit_message>
slides: verification slide as words and numbers only
Slide 13 drops the graphic entirely: two large stat cards
(forces <= 3e-8 of peak, displacements <= 8e-8) with a one-line
context statement (6,000x tighter than the exodiff tolerance,
floating-point noise territory) and the measurement caption.

Co-Authored-By: Claude Fable 5 <noreply@anthropic.com>
Claude-Session: https://claude.ai/code/session_01CCuKo2gP6Duy91irEj5f1y
</commit_message>
<xml_diff>
--- a/examples/impact/slide_assets/WCCM_NEML2_explicit_dynamics_v2.pptx
+++ b/examples/impact/slide_assets/WCCM_NEML2_explicit_dynamics_v2.pptx
@@ -9799,76 +9799,16 @@
           </a:p>
         </p:txBody>
       </p:sp>
-      <p:pic>
-        <p:nvPicPr>
-          <p:cNvPr id="5" name="Picture 4" descr="fig_verification.png"/>
-          <p:cNvPicPr>
-            <a:picLocks noChangeAspect="1"/>
-          </p:cNvPicPr>
-          <p:nvPr/>
-        </p:nvPicPr>
-        <p:blipFill>
-          <a:blip r:embed="rId2"/>
-          <a:stretch>
-            <a:fillRect/>
-          </a:stretch>
-        </p:blipFill>
+      <p:sp>
+        <p:nvSpPr>
+          <p:cNvPr id="5" name="Rounded Rectangle 4"/>
+          <p:cNvSpPr/>
+          <p:nvPr/>
+        </p:nvSpPr>
         <p:spPr>
           <a:xfrm>
             <a:off x="566928" y="1892808"/>
-            <a:ext cx="6949440" cy="2655808"/>
-          </a:xfrm>
-          <a:prstGeom prst="rect">
-            <a:avLst/>
-          </a:prstGeom>
-        </p:spPr>
-      </p:pic>
-      <p:sp>
-        <p:nvSpPr>
-          <p:cNvPr id="6" name="TextBox 5"/>
-          <p:cNvSpPr txBox="1"/>
-          <p:nvPr/>
-        </p:nvSpPr>
-        <p:spPr>
-          <a:xfrm>
-            <a:off x="658368" y="4685776"/>
-            <a:ext cx="6949440" cy="274320"/>
-          </a:xfrm>
-          <a:prstGeom prst="rect">
-            <a:avLst/>
-          </a:prstGeom>
-          <a:noFill/>
-        </p:spPr>
-        <p:txBody>
-          <a:bodyPr wrap="square" anchor="t" lIns="0" rIns="0" tIns="0" bIns="0">
-            <a:spAutoFit/>
-          </a:bodyPr>
-          <a:lstStyle/>
-          <a:p>
-            <a:pPr algn="l"/>
-            <a:r>
-              <a:rPr sz="1100" b="0" i="1">
-                <a:solidFill>
-                  <a:srgbClr val="59595C"/>
-                </a:solidFill>
-                <a:latin typeface="Arial"/>
-                <a:cs typeface="Arial"/>
-              </a:rPr>
-              <a:t>measured on the 2-D slug impact test problem, final step, over every node</a:t>
-            </a:r>
-          </a:p>
-        </p:txBody>
-      </p:sp>
-      <p:sp>
-        <p:nvSpPr>
-          <p:cNvPr id="7" name="Rounded Rectangle 6"/>
-          <p:cNvSpPr/>
-          <p:nvPr/>
-        </p:nvSpPr>
-        <p:spPr>
-          <a:xfrm>
-            <a:off x="7927848" y="2029968"/>
-            <a:ext cx="3696919" cy="1207008"/>
+            <a:ext cx="5300319" cy="1965960"/>
           </a:xfrm>
           <a:prstGeom prst="roundRect">
             <a:avLst>
@@ -9909,14 +9849,14 @@
       </p:sp>
       <p:sp>
         <p:nvSpPr>
-          <p:cNvPr id="8" name="Rectangle 7"/>
+          <p:cNvPr id="6" name="Rectangle 5"/>
           <p:cNvSpPr/>
           <p:nvPr/>
         </p:nvSpPr>
         <p:spPr>
           <a:xfrm>
-            <a:off x="7927848" y="2139696"/>
-            <a:ext cx="50292" cy="987552"/>
+            <a:off x="566928" y="2057400"/>
+            <a:ext cx="64008" cy="1636776"/>
           </a:xfrm>
           <a:prstGeom prst="rect">
             <a:avLst/>
@@ -9953,14 +9893,14 @@
       </p:sp>
       <p:sp>
         <p:nvSpPr>
-          <p:cNvPr id="9" name="TextBox 8"/>
+          <p:cNvPr id="7" name="TextBox 6"/>
           <p:cNvSpPr txBox="1"/>
           <p:nvPr/>
         </p:nvSpPr>
         <p:spPr>
           <a:xfrm>
-            <a:off x="8183880" y="2157984"/>
-            <a:ext cx="3239719" cy="502920"/>
+            <a:off x="978408" y="2167128"/>
+            <a:ext cx="4660239" cy="960120"/>
           </a:xfrm>
           <a:prstGeom prst="rect">
             <a:avLst/>
@@ -9975,7 +9915,7 @@
           <a:p>
             <a:pPr algn="l"/>
             <a:r>
-              <a:rPr sz="3000" b="1" i="0">
+              <a:rPr sz="5400" b="1" i="0">
                 <a:solidFill>
                   <a:srgbClr val="06509D"/>
                 </a:solidFill>
@@ -9985,7 +9925,7 @@
               <a:t>≤ 3 × 10</a:t>
             </a:r>
             <a:r>
-              <a:rPr sz="3000" b="1" i="0" baseline="30000">
+              <a:rPr sz="3400" b="1" i="0" baseline="30000">
                 <a:solidFill>
                   <a:srgbClr val="06509D"/>
                 </a:solidFill>
@@ -9999,14 +9939,14 @@
       </p:sp>
       <p:sp>
         <p:nvSpPr>
-          <p:cNvPr id="10" name="TextBox 9"/>
+          <p:cNvPr id="8" name="TextBox 7"/>
           <p:cNvSpPr txBox="1"/>
           <p:nvPr/>
         </p:nvSpPr>
         <p:spPr>
           <a:xfrm>
-            <a:off x="8183880" y="2706624"/>
-            <a:ext cx="3239719" cy="475488"/>
+            <a:off x="996696" y="3191256"/>
+            <a:ext cx="4614519" cy="548640"/>
           </a:xfrm>
           <a:prstGeom prst="rect">
             <a:avLst/>
@@ -10021,30 +9961,30 @@
           <a:p>
             <a:pPr algn="l">
               <a:lnSpc>
-                <a:spcPct val="105000"/>
+                <a:spcPct val="115000"/>
               </a:lnSpc>
             </a:pPr>
             <a:r>
-              <a:rPr sz="1150" b="0" i="0">
-                <a:solidFill>
-                  <a:srgbClr val="59595C"/>
-                </a:solidFill>
-                <a:latin typeface="Arial"/>
-                <a:cs typeface="Arial"/>
-              </a:rPr>
-              <a:t>difference in nodal forces,</a:t>
+              <a:rPr sz="1450" b="0" i="0">
+                <a:solidFill>
+                  <a:srgbClr val="3A3F47"/>
+                </a:solidFill>
+                <a:latin typeface="Arial"/>
+                <a:cs typeface="Arial"/>
+              </a:rPr>
+              <a:t>maximum difference in nodal forces</a:t>
             </a:r>
           </a:p>
           <a:p>
             <a:pPr algn="l">
               <a:lnSpc>
-                <a:spcPct val="105000"/>
+                <a:spcPct val="115000"/>
               </a:lnSpc>
             </a:pPr>
             <a:r>
-              <a:rPr sz="1150" b="0" i="0">
-                <a:solidFill>
-                  <a:srgbClr val="59595C"/>
+              <a:rPr sz="1450" b="0" i="0">
+                <a:solidFill>
+                  <a:srgbClr val="3A3F47"/>
                 </a:solidFill>
                 <a:latin typeface="Arial"/>
                 <a:cs typeface="Arial"/>
@@ -10056,14 +9996,14 @@
       </p:sp>
       <p:sp>
         <p:nvSpPr>
-          <p:cNvPr id="11" name="Rounded Rectangle 10"/>
+          <p:cNvPr id="9" name="Rounded Rectangle 8"/>
           <p:cNvSpPr/>
           <p:nvPr/>
         </p:nvSpPr>
         <p:spPr>
           <a:xfrm>
-            <a:off x="7927848" y="3456432"/>
-            <a:ext cx="3696919" cy="1207008"/>
+            <a:off x="6324447" y="1892808"/>
+            <a:ext cx="5300319" cy="1965960"/>
           </a:xfrm>
           <a:prstGeom prst="roundRect">
             <a:avLst>
@@ -10104,14 +10044,14 @@
       </p:sp>
       <p:sp>
         <p:nvSpPr>
-          <p:cNvPr id="12" name="Rectangle 11"/>
+          <p:cNvPr id="10" name="Rectangle 9"/>
           <p:cNvSpPr/>
           <p:nvPr/>
         </p:nvSpPr>
         <p:spPr>
           <a:xfrm>
-            <a:off x="7927848" y="3566160"/>
-            <a:ext cx="50292" cy="987552"/>
+            <a:off x="6324447" y="2057400"/>
+            <a:ext cx="64008" cy="1636776"/>
           </a:xfrm>
           <a:prstGeom prst="rect">
             <a:avLst/>
@@ -10148,14 +10088,14 @@
       </p:sp>
       <p:sp>
         <p:nvSpPr>
-          <p:cNvPr id="13" name="TextBox 12"/>
+          <p:cNvPr id="11" name="TextBox 10"/>
           <p:cNvSpPr txBox="1"/>
           <p:nvPr/>
         </p:nvSpPr>
         <p:spPr>
           <a:xfrm>
-            <a:off x="8183880" y="3584448"/>
-            <a:ext cx="3239719" cy="502920"/>
+            <a:off x="6735927" y="2167128"/>
+            <a:ext cx="4660239" cy="960120"/>
           </a:xfrm>
           <a:prstGeom prst="rect">
             <a:avLst/>
@@ -10170,7 +10110,7 @@
           <a:p>
             <a:pPr algn="l"/>
             <a:r>
-              <a:rPr sz="3000" b="1" i="0">
+              <a:rPr sz="5400" b="1" i="0">
                 <a:solidFill>
                   <a:srgbClr val="5E8614"/>
                 </a:solidFill>
@@ -10180,7 +10120,7 @@
               <a:t>≤ 8 × 10</a:t>
             </a:r>
             <a:r>
-              <a:rPr sz="3000" b="1" i="0" baseline="30000">
+              <a:rPr sz="3400" b="1" i="0" baseline="30000">
                 <a:solidFill>
                   <a:srgbClr val="5E8614"/>
                 </a:solidFill>
@@ -10194,14 +10134,14 @@
       </p:sp>
       <p:sp>
         <p:nvSpPr>
-          <p:cNvPr id="14" name="TextBox 13"/>
+          <p:cNvPr id="12" name="TextBox 11"/>
           <p:cNvSpPr txBox="1"/>
           <p:nvPr/>
         </p:nvSpPr>
         <p:spPr>
           <a:xfrm>
-            <a:off x="8183880" y="4133088"/>
-            <a:ext cx="3239719" cy="475488"/>
+            <a:off x="6754215" y="3191256"/>
+            <a:ext cx="4614519" cy="548640"/>
           </a:xfrm>
           <a:prstGeom prst="rect">
             <a:avLst/>
@@ -10216,49 +10156,49 @@
           <a:p>
             <a:pPr algn="l">
               <a:lnSpc>
-                <a:spcPct val="105000"/>
+                <a:spcPct val="115000"/>
               </a:lnSpc>
             </a:pPr>
             <a:r>
-              <a:rPr sz="1150" b="0" i="0">
-                <a:solidFill>
-                  <a:srgbClr val="59595C"/>
-                </a:solidFill>
-                <a:latin typeface="Arial"/>
-                <a:cs typeface="Arial"/>
-              </a:rPr>
-              <a:t>max relative difference</a:t>
+              <a:rPr sz="1450" b="0" i="0">
+                <a:solidFill>
+                  <a:srgbClr val="3A3F47"/>
+                </a:solidFill>
+                <a:latin typeface="Arial"/>
+                <a:cs typeface="Arial"/>
+              </a:rPr>
+              <a:t>maximum relative difference</a:t>
             </a:r>
           </a:p>
           <a:p>
             <a:pPr algn="l">
               <a:lnSpc>
-                <a:spcPct val="105000"/>
+                <a:spcPct val="115000"/>
               </a:lnSpc>
             </a:pPr>
             <a:r>
-              <a:rPr sz="1150" b="0" i="0">
-                <a:solidFill>
-                  <a:srgbClr val="59595C"/>
-                </a:solidFill>
-                <a:latin typeface="Arial"/>
-                <a:cs typeface="Arial"/>
-              </a:rPr>
-              <a:t>in displacements</a:t>
-            </a:r>
-          </a:p>
-        </p:txBody>
-      </p:sp>
-      <p:sp>
-        <p:nvSpPr>
-          <p:cNvPr id="15" name="TextBox 14"/>
+              <a:rPr sz="1450" b="0" i="0">
+                <a:solidFill>
+                  <a:srgbClr val="3A3F47"/>
+                </a:solidFill>
+                <a:latin typeface="Arial"/>
+                <a:cs typeface="Arial"/>
+              </a:rPr>
+              <a:t>in nodal displacements</a:t>
+            </a:r>
+          </a:p>
+        </p:txBody>
+      </p:sp>
+      <p:sp>
+        <p:nvSpPr>
+          <p:cNvPr id="13" name="TextBox 12"/>
           <p:cNvSpPr txBox="1"/>
           <p:nvPr/>
         </p:nvSpPr>
         <p:spPr>
           <a:xfrm>
-            <a:off x="7927848" y="4928616"/>
-            <a:ext cx="3696919" cy="731520"/>
+            <a:off x="566928" y="4315968"/>
+            <a:ext cx="11057839" cy="365760"/>
           </a:xfrm>
           <a:prstGeom prst="rect">
             <a:avLst/>
@@ -10271,11 +10211,83 @@
           </a:bodyPr>
           <a:lstStyle/>
           <a:p>
-            <a:pPr algn="l">
-              <a:lnSpc>
-                <a:spcPct val="110000"/>
-              </a:lnSpc>
-            </a:pPr>
+            <a:pPr algn="ctr"/>
+            <a:r>
+              <a:rPr sz="1650" b="0" i="0">
+                <a:solidFill>
+                  <a:srgbClr val="3A3F47"/>
+                </a:solidFill>
+                <a:latin typeface="Arial"/>
+                <a:cs typeface="Arial"/>
+              </a:rPr>
+              <a:t>That is </a:t>
+            </a:r>
+            <a:r>
+              <a:rPr sz="1650" b="1" i="0">
+                <a:solidFill>
+                  <a:srgbClr val="1E2430"/>
+                </a:solidFill>
+                <a:latin typeface="Arial"/>
+                <a:cs typeface="Arial"/>
+              </a:rPr>
+              <a:t>6,000× tighter</a:t>
+            </a:r>
+            <a:r>
+              <a:rPr sz="1650" b="0" i="0">
+                <a:solidFill>
+                  <a:srgbClr val="3A3F47"/>
+                </a:solidFill>
+                <a:latin typeface="Arial"/>
+                <a:cs typeface="Arial"/>
+              </a:rPr>
+              <a:t> than the exodiff regression tolerance of 5 × 10</a:t>
+            </a:r>
+            <a:r>
+              <a:rPr sz="1200" b="0" i="0" baseline="30000">
+                <a:solidFill>
+                  <a:srgbClr val="3A3F47"/>
+                </a:solidFill>
+                <a:latin typeface="Arial"/>
+                <a:cs typeface="Arial"/>
+              </a:rPr>
+              <a:t>−4</a:t>
+            </a:r>
+            <a:r>
+              <a:rPr sz="1650" b="0" i="0">
+                <a:solidFill>
+                  <a:srgbClr val="3A3F47"/>
+                </a:solidFill>
+                <a:latin typeface="Arial"/>
+                <a:cs typeface="Arial"/>
+              </a:rPr>
+              <a:t> — floating-point noise territory.</a:t>
+            </a:r>
+          </a:p>
+        </p:txBody>
+      </p:sp>
+      <p:sp>
+        <p:nvSpPr>
+          <p:cNvPr id="14" name="TextBox 13"/>
+          <p:cNvSpPr txBox="1"/>
+          <p:nvPr/>
+        </p:nvSpPr>
+        <p:spPr>
+          <a:xfrm>
+            <a:off x="566928" y="4791456"/>
+            <a:ext cx="11057839" cy="274320"/>
+          </a:xfrm>
+          <a:prstGeom prst="rect">
+            <a:avLst/>
+          </a:prstGeom>
+          <a:noFill/>
+        </p:spPr>
+        <p:txBody>
+          <a:bodyPr wrap="square" anchor="t" lIns="0" rIns="0" tIns="0" bIns="0">
+            <a:spAutoFit/>
+          </a:bodyPr>
+          <a:lstStyle/>
+          <a:p>
+            <a:pPr algn="ctr"/>
             <a:r>
               <a:rPr sz="1150" b="0" i="1">
                 <a:solidFill>
@@ -10284,14 +10296,14 @@
                 <a:latin typeface="Arial"/>
                 <a:cs typeface="Arial"/>
               </a:rPr>
-              <a:t>both differences sit at the floating-point noise floor of an explicit step</a:t>
-            </a:r>
-          </a:p>
-        </p:txBody>
-      </p:sp>
-      <p:sp>
-        <p:nvSpPr>
-          <p:cNvPr id="16" name="Rounded Rectangle 15"/>
+              <a:t>measured node-by-node on the 2-D slug impact test problem, final step</a:t>
+            </a:r>
+          </a:p>
+        </p:txBody>
+      </p:sp>
+      <p:sp>
+        <p:nvSpPr>
+          <p:cNvPr id="15" name="Rounded Rectangle 14"/>
           <p:cNvSpPr/>
           <p:nvPr/>
         </p:nvSpPr>
@@ -10339,7 +10351,7 @@
       </p:sp>
       <p:sp>
         <p:nvSpPr>
-          <p:cNvPr id="17" name="TextBox 16"/>
+          <p:cNvPr id="16" name="TextBox 15"/>
           <p:cNvSpPr txBox="1"/>
           <p:nvPr/>
         </p:nvSpPr>

</xml_diff>

<commit_message>
slides: calibration slide - scan vs calibrated run only
</commit_message>
<xml_diff>
--- a/examples/impact/slide_assets/WCCM_NEML2_explicit_dynamics_v2.pptx
+++ b/examples/impact/slide_assets/WCCM_NEML2_explicit_dynamics_v2.pptx
@@ -14150,8 +14150,8 @@
         </p:blipFill>
         <p:spPr>
           <a:xfrm>
-            <a:off x="1572768" y="1591056"/>
-            <a:ext cx="7863840" cy="2703195"/>
+            <a:off x="658368" y="1709928"/>
+            <a:ext cx="6949440" cy="2918764"/>
           </a:xfrm>
           <a:prstGeom prst="rect">
             <a:avLst/>
@@ -14166,8 +14166,8 @@
         </p:nvSpPr>
         <p:spPr>
           <a:xfrm>
-            <a:off x="1664208" y="4294251"/>
-            <a:ext cx="10058400" cy="219456"/>
+            <a:off x="749808" y="4683556"/>
+            <a:ext cx="6949440" cy="219456"/>
           </a:xfrm>
           <a:prstGeom prst="rect">
             <a:avLst/>
@@ -14182,14 +14182,14 @@
           <a:p>
             <a:pPr algn="l"/>
             <a:r>
-              <a:rPr sz="1000" b="0" i="1">
+              <a:rPr sz="1050" b="0" i="1">
                 <a:solidFill>
                   <a:srgbClr val="59595C"/>
                 </a:solidFill>
                 <a:latin typeface="Arial"/>
                 <a:cs typeface="Arial"/>
               </a:rPr>
-              <a:t>scan silhouette vs simulated final profiles (left); residuals vs scan noise band (right) — RZ production model</a:t>
+              <a:t>final deformed profile, RZ production model at the calibrated posterior median</a:t>
             </a:r>
           </a:p>
         </p:txBody>
@@ -14202,8 +14202,8 @@
         </p:nvSpPr>
         <p:spPr>
           <a:xfrm>
-            <a:off x="566928" y="4550283"/>
-            <a:ext cx="3015386" cy="713232"/>
+            <a:off x="8065008" y="1755648"/>
+            <a:ext cx="3559759" cy="786384"/>
           </a:xfrm>
           <a:prstGeom prst="roundRect">
             <a:avLst>
@@ -14244,14 +14244,58 @@
       </p:sp>
       <p:sp>
         <p:nvSpPr>
-          <p:cNvPr id="8" name="TextBox 7"/>
+          <p:cNvPr id="8" name="Rectangle 7"/>
+          <p:cNvSpPr/>
+          <p:nvPr/>
+        </p:nvSpPr>
+        <p:spPr>
+          <a:xfrm>
+            <a:off x="8065008" y="1847088"/>
+            <a:ext cx="50292" cy="603504"/>
+          </a:xfrm>
+          <a:prstGeom prst="rect">
+            <a:avLst/>
+          </a:prstGeom>
+          <a:solidFill>
+            <a:srgbClr val="59595C"/>
+          </a:solidFill>
+          <a:ln>
+            <a:noFill/>
+          </a:ln>
+          <a:effectLst/>
+        </p:spPr>
+        <p:style>
+          <a:lnRef idx="1">
+            <a:schemeClr val="accent1"/>
+          </a:lnRef>
+          <a:fillRef idx="3">
+            <a:schemeClr val="accent1"/>
+          </a:fillRef>
+          <a:effectRef idx="2">
+            <a:schemeClr val="accent1"/>
+          </a:effectRef>
+          <a:fontRef idx="minor">
+            <a:schemeClr val="lt1"/>
+          </a:fontRef>
+        </p:style>
+        <p:txBody>
+          <a:bodyPr rtlCol="0" anchor="ctr"/>
+          <a:lstStyle/>
+          <a:p>
+            <a:pPr algn="ctr"/>
+          </a:p>
+        </p:txBody>
+      </p:sp>
+      <p:sp>
+        <p:nvSpPr>
+          <p:cNvPr id="9" name="TextBox 8"/>
           <p:cNvSpPr txBox="1"/>
           <p:nvPr/>
         </p:nvSpPr>
         <p:spPr>
           <a:xfrm>
-            <a:off x="749808" y="4605147"/>
-            <a:ext cx="2649626" cy="365760"/>
+            <a:off x="8302752" y="1828800"/>
+            <a:ext cx="3102559" cy="384048"/>
           </a:xfrm>
           <a:prstGeom prst="rect">
             <a:avLst/>
@@ -14266,7 +14310,7 @@
           <a:p>
             <a:pPr algn="l"/>
             <a:r>
-              <a:rPr sz="2100" b="1" i="0">
+              <a:rPr sz="2200" b="1" i="0">
                 <a:solidFill>
                   <a:srgbClr val="59595C"/>
                 </a:solidFill>
@@ -14290,14 +14334,14 @@
       </p:sp>
       <p:sp>
         <p:nvSpPr>
-          <p:cNvPr id="9" name="TextBox 8"/>
+          <p:cNvPr id="10" name="TextBox 9"/>
           <p:cNvSpPr txBox="1"/>
           <p:nvPr/>
         </p:nvSpPr>
         <p:spPr>
           <a:xfrm>
-            <a:off x="749808" y="4980051"/>
-            <a:ext cx="2649626" cy="237744"/>
+            <a:off x="8302752" y="2231136"/>
+            <a:ext cx="3102559" cy="237744"/>
           </a:xfrm>
           <a:prstGeom prst="rect">
             <a:avLst/>
@@ -14326,14 +14370,14 @@
       </p:sp>
       <p:cxnSp>
         <p:nvCxnSpPr>
-          <p:cNvPr id="10" name="Connector 9"/>
+          <p:cNvPr id="11" name="Connector 10"/>
           <p:cNvCxnSpPr/>
           <p:nvPr/>
         </p:nvCxnSpPr>
         <p:spPr>
           <a:xfrm>
-            <a:off x="3692042.3333333335" y="4906899"/>
-            <a:ext cx="786384.0000000005" cy="0"/>
+            <a:off x="9844887.5" y="2560320"/>
+            <a:ext cx="0.0" cy="256032"/>
           </a:xfrm>
           <a:prstGeom prst="line">
             <a:avLst/>
@@ -14363,14 +14407,14 @@
       </p:cxnSp>
       <p:sp>
         <p:nvSpPr>
-          <p:cNvPr id="11" name="Rounded Rectangle 10"/>
+          <p:cNvPr id="12" name="Rounded Rectangle 11"/>
           <p:cNvSpPr/>
           <p:nvPr/>
         </p:nvSpPr>
         <p:spPr>
           <a:xfrm>
-            <a:off x="4588154" y="4550283"/>
-            <a:ext cx="3015386" cy="713232"/>
+            <a:off x="8065008" y="2871216"/>
+            <a:ext cx="3559759" cy="786384"/>
           </a:xfrm>
           <a:prstGeom prst="roundRect">
             <a:avLst>
@@ -14411,14 +14455,58 @@
       </p:sp>
       <p:sp>
         <p:nvSpPr>
-          <p:cNvPr id="12" name="TextBox 11"/>
+          <p:cNvPr id="13" name="Rectangle 12"/>
+          <p:cNvSpPr/>
+          <p:nvPr/>
+        </p:nvSpPr>
+        <p:spPr>
+          <a:xfrm>
+            <a:off x="8065008" y="2962656"/>
+            <a:ext cx="50292" cy="603504"/>
+          </a:xfrm>
+          <a:prstGeom prst="rect">
+            <a:avLst/>
+          </a:prstGeom>
+          <a:solidFill>
+            <a:srgbClr val="06509D"/>
+          </a:solidFill>
+          <a:ln>
+            <a:noFill/>
+          </a:ln>
+          <a:effectLst/>
+        </p:spPr>
+        <p:style>
+          <a:lnRef idx="1">
+            <a:schemeClr val="accent1"/>
+          </a:lnRef>
+          <a:fillRef idx="3">
+            <a:schemeClr val="accent1"/>
+          </a:fillRef>
+          <a:effectRef idx="2">
+            <a:schemeClr val="accent1"/>
+          </a:effectRef>
+          <a:fontRef idx="minor">
+            <a:schemeClr val="lt1"/>
+          </a:fontRef>
+        </p:style>
+        <p:txBody>
+          <a:bodyPr rtlCol="0" anchor="ctr"/>
+          <a:lstStyle/>
+          <a:p>
+            <a:pPr algn="ctr"/>
+          </a:p>
+        </p:txBody>
+      </p:sp>
+      <p:sp>
+        <p:nvSpPr>
+          <p:cNvPr id="14" name="TextBox 13"/>
           <p:cNvSpPr txBox="1"/>
           <p:nvPr/>
         </p:nvSpPr>
         <p:spPr>
           <a:xfrm>
-            <a:off x="4771034" y="4605147"/>
-            <a:ext cx="2649626" cy="365760"/>
+            <a:off x="8302752" y="2944368"/>
+            <a:ext cx="3102559" cy="384048"/>
           </a:xfrm>
           <a:prstGeom prst="rect">
             <a:avLst/>
@@ -14433,7 +14521,7 @@
           <a:p>
             <a:pPr algn="l"/>
             <a:r>
-              <a:rPr sz="2100" b="1" i="0">
+              <a:rPr sz="2200" b="1" i="0">
                 <a:solidFill>
                   <a:srgbClr val="06509D"/>
                 </a:solidFill>
@@ -14457,14 +14545,14 @@
       </p:sp>
       <p:sp>
         <p:nvSpPr>
-          <p:cNvPr id="13" name="TextBox 12"/>
+          <p:cNvPr id="15" name="TextBox 14"/>
           <p:cNvSpPr txBox="1"/>
           <p:nvPr/>
         </p:nvSpPr>
         <p:spPr>
           <a:xfrm>
-            <a:off x="4771034" y="4980051"/>
-            <a:ext cx="2649626" cy="237744"/>
+            <a:off x="8302752" y="3346704"/>
+            <a:ext cx="3102559" cy="237744"/>
           </a:xfrm>
           <a:prstGeom prst="rect">
             <a:avLst/>
@@ -14493,14 +14581,14 @@
       </p:sp>
       <p:cxnSp>
         <p:nvCxnSpPr>
-          <p:cNvPr id="14" name="Connector 13"/>
+          <p:cNvPr id="16" name="Connector 15"/>
           <p:cNvCxnSpPr/>
           <p:nvPr/>
         </p:nvCxnSpPr>
         <p:spPr>
           <a:xfrm>
-            <a:off x="7713268.666666668" y="4906899"/>
-            <a:ext cx="786384.0" cy="0"/>
+            <a:off x="9844887.5" y="3675888"/>
+            <a:ext cx="0.0" cy="256032"/>
           </a:xfrm>
           <a:prstGeom prst="line">
             <a:avLst/>
@@ -14530,14 +14618,14 @@
       </p:cxnSp>
       <p:sp>
         <p:nvSpPr>
-          <p:cNvPr id="15" name="Rounded Rectangle 14"/>
+          <p:cNvPr id="17" name="Rounded Rectangle 16"/>
           <p:cNvSpPr/>
           <p:nvPr/>
         </p:nvSpPr>
         <p:spPr>
           <a:xfrm>
-            <a:off x="8609380" y="4550283"/>
-            <a:ext cx="3015386" cy="713232"/>
+            <a:off x="8065008" y="3986784"/>
+            <a:ext cx="3559759" cy="786384"/>
           </a:xfrm>
           <a:prstGeom prst="roundRect">
             <a:avLst>
@@ -14578,14 +14666,58 @@
       </p:sp>
       <p:sp>
         <p:nvSpPr>
-          <p:cNvPr id="16" name="TextBox 15"/>
+          <p:cNvPr id="18" name="Rectangle 17"/>
+          <p:cNvSpPr/>
+          <p:nvPr/>
+        </p:nvSpPr>
+        <p:spPr>
+          <a:xfrm>
+            <a:off x="8065008" y="4078224"/>
+            <a:ext cx="50292" cy="603504"/>
+          </a:xfrm>
+          <a:prstGeom prst="rect">
+            <a:avLst/>
+          </a:prstGeom>
+          <a:solidFill>
+            <a:srgbClr val="5E8614"/>
+          </a:solidFill>
+          <a:ln>
+            <a:noFill/>
+          </a:ln>
+          <a:effectLst/>
+        </p:spPr>
+        <p:style>
+          <a:lnRef idx="1">
+            <a:schemeClr val="accent1"/>
+          </a:lnRef>
+          <a:fillRef idx="3">
+            <a:schemeClr val="accent1"/>
+          </a:fillRef>
+          <a:effectRef idx="2">
+            <a:schemeClr val="accent1"/>
+          </a:effectRef>
+          <a:fontRef idx="minor">
+            <a:schemeClr val="lt1"/>
+          </a:fontRef>
+        </p:style>
+        <p:txBody>
+          <a:bodyPr rtlCol="0" anchor="ctr"/>
+          <a:lstStyle/>
+          <a:p>
+            <a:pPr algn="ctr"/>
+          </a:p>
+        </p:txBody>
+      </p:sp>
+      <p:sp>
+        <p:nvSpPr>
+          <p:cNvPr id="19" name="TextBox 18"/>
           <p:cNvSpPr txBox="1"/>
           <p:nvPr/>
         </p:nvSpPr>
         <p:spPr>
           <a:xfrm>
-            <a:off x="8792260" y="4605147"/>
-            <a:ext cx="2649626" cy="365760"/>
+            <a:off x="8302752" y="4059936"/>
+            <a:ext cx="3102559" cy="384048"/>
           </a:xfrm>
           <a:prstGeom prst="rect">
             <a:avLst/>
@@ -14600,7 +14732,7 @@
           <a:p>
             <a:pPr algn="l"/>
             <a:r>
-              <a:rPr sz="2100" b="1" i="0">
+              <a:rPr sz="2200" b="1" i="0">
                 <a:solidFill>
                   <a:srgbClr val="5E8614"/>
                 </a:solidFill>
@@ -14624,14 +14756,14 @@
       </p:sp>
       <p:sp>
         <p:nvSpPr>
-          <p:cNvPr id="17" name="TextBox 16"/>
+          <p:cNvPr id="20" name="TextBox 19"/>
           <p:cNvSpPr txBox="1"/>
           <p:nvPr/>
         </p:nvSpPr>
         <p:spPr>
           <a:xfrm>
-            <a:off x="8792260" y="4980051"/>
-            <a:ext cx="2649626" cy="237744"/>
+            <a:off x="8302752" y="4462272"/>
+            <a:ext cx="3102559" cy="237744"/>
           </a:xfrm>
           <a:prstGeom prst="rect">
             <a:avLst/>
@@ -14660,7 +14792,7 @@
       </p:sp>
       <p:sp>
         <p:nvSpPr>
-          <p:cNvPr id="18" name="Rounded Rectangle 17"/>
+          <p:cNvPr id="21" name="Rounded Rectangle 20"/>
           <p:cNvSpPr/>
           <p:nvPr/>
         </p:nvSpPr>
@@ -14708,7 +14840,7 @@
       </p:sp>
       <p:sp>
         <p:nvSpPr>
-          <p:cNvPr id="19" name="TextBox 18"/>
+          <p:cNvPr id="22" name="TextBox 21"/>
           <p:cNvSpPr txBox="1"/>
           <p:nvPr/>
         </p:nvSpPr>

</xml_diff>

<commit_message>
slides: rerun 3-D Taylor demos on the production stack
New 3d_slug_thermal_mult_ri.i: calibrated multiplicative thermal JC
(campaign_r1_nofric posterior median), reduced integration + HEX8 hourglass,
frictionless boundary-restricted nodal contact. Full-hard and annealed
(ipe -> 0) tempers rerun to rebound; slides 16-17 updated with the new
figures and measured numbers (39/43% shortening, peak dT 422 K, 9.6k steps).
</commit_message>
<xml_diff>
--- a/examples/impact/slide_assets/WCCM_NEML2_explicit_dynamics_v2.pptx
+++ b/examples/impact/slide_assets/WCCM_NEML2_explicit_dynamics_v2.pptx
@@ -12988,7 +12988,7 @@
                 <a:latin typeface="Arial"/>
                 <a:cs typeface="Arial"/>
               </a:rPr>
-              <a:t> — Johnson–Cook plasticity in NEML2 · Δt = 10 ns · </a:t>
+              <a:t> — calibrated multiplicative Johnson–Cook · reduced integration · Δt = 10 ns · </a:t>
             </a:r>
             <a:r>
               <a:rPr sz="1450" b="1" i="0">
@@ -12998,7 +12998,7 @@
                 <a:latin typeface="Arial"/>
                 <a:cs typeface="Arial"/>
               </a:rPr>
-              <a:t>11,000+ explicit steps</a:t>
+              <a:t>9,600+ explicit steps</a:t>
             </a:r>
           </a:p>
         </p:txBody>
@@ -13020,7 +13020,7 @@
         <p:spPr>
           <a:xfrm>
             <a:off x="1115568" y="1627632"/>
-            <a:ext cx="8778240" cy="2436529"/>
+            <a:ext cx="8778240" cy="2259290"/>
           </a:xfrm>
           <a:prstGeom prst="rect">
             <a:avLst/>
@@ -13035,7 +13035,7 @@
         </p:nvSpPr>
         <p:spPr>
           <a:xfrm>
-            <a:off x="1207008" y="4091593"/>
+            <a:off x="1207008" y="3914354"/>
             <a:ext cx="10058400" cy="256032"/>
           </a:xfrm>
           <a:prstGeom prst="rect">
@@ -13079,8 +13079,8 @@
         </p:blipFill>
         <p:spPr>
           <a:xfrm>
-            <a:off x="566928" y="4356769"/>
-            <a:ext cx="3931920" cy="1522296"/>
+            <a:off x="566928" y="4179530"/>
+            <a:ext cx="3931920" cy="1438444"/>
           </a:xfrm>
           <a:prstGeom prst="rect">
             <a:avLst/>
@@ -13095,8 +13095,8 @@
         </p:nvSpPr>
         <p:spPr>
           <a:xfrm>
-            <a:off x="4956048" y="4585369"/>
-            <a:ext cx="6668719" cy="1339416"/>
+            <a:off x="4956048" y="4270970"/>
+            <a:ext cx="6668719" cy="1529884"/>
           </a:xfrm>
           <a:prstGeom prst="rect">
             <a:avLst/>
@@ -13114,7 +13114,7 @@
                 <a:spcPct val="106000"/>
               </a:lnSpc>
               <a:spcAft>
-                <a:spcPts val="1200"/>
+                <a:spcPts val="1000"/>
               </a:spcAft>
               <a:buClr>
                 <a:srgbClr val="06509D"/>
@@ -13130,7 +13130,7 @@
                 <a:latin typeface="Arial"/>
                 <a:cs typeface="Arial"/>
               </a:rPr>
-              <a:t>Same mesh, BCs, integrator — the copper temper is swapped by </a:t>
+              <a:t>Same mesh, BCs, integrator — the temper is swapped by </a:t>
             </a:r>
             <a:r>
               <a:rPr sz="1350" b="1" i="0">
@@ -13140,7 +13140,17 @@
                 <a:latin typeface="Arial"/>
                 <a:cs typeface="Arial"/>
               </a:rPr>
-              <a:t>changing only NEML2 material parameters</a:t>
+              <a:t>one NEML2 parameter</a:t>
+            </a:r>
+            <a:r>
+              <a:rPr sz="1350" b="0" i="0">
+                <a:solidFill>
+                  <a:srgbClr val="3A3F47"/>
+                </a:solidFill>
+                <a:latin typeface="Arial"/>
+                <a:cs typeface="Arial"/>
+              </a:rPr>
+              <a:t>: the prior cold work (initial plastic strain)</a:t>
             </a:r>
           </a:p>
           <a:p>
@@ -13149,7 +13159,7 @@
                 <a:spcPct val="106000"/>
               </a:lnSpc>
               <a:spcAft>
-                <a:spcPts val="1200"/>
+                <a:spcPts val="1000"/>
               </a:spcAft>
               <a:buClr>
                 <a:srgbClr val="06509D"/>
@@ -13175,7 +13185,7 @@
                 <a:latin typeface="Arial"/>
                 <a:cs typeface="Arial"/>
               </a:rPr>
-              <a:t>51%</a:t>
+              <a:t>39%</a:t>
             </a:r>
             <a:r>
               <a:rPr sz="1350" b="0" i="0">
@@ -13195,7 +13205,7 @@
                 <a:latin typeface="Arial"/>
                 <a:cs typeface="Arial"/>
               </a:rPr>
-              <a:t>58%</a:t>
+              <a:t>43%</a:t>
             </a:r>
             <a:r>
               <a:rPr sz="1350" b="0" i="0">
@@ -13206,6 +13216,51 @@
                 <a:cs typeface="Arial"/>
               </a:rPr>
               <a:t> axial shortening — temper sensitivity captured</a:t>
+            </a:r>
+          </a:p>
+          <a:p>
+            <a:pPr marL="219456" indent="-219456">
+              <a:lnSpc>
+                <a:spcPct val="106000"/>
+              </a:lnSpc>
+              <a:spcAft>
+                <a:spcPts val="1000"/>
+              </a:spcAft>
+              <a:buClr>
+                <a:srgbClr val="06509D"/>
+              </a:buClr>
+              <a:buFont typeface="Arial"/>
+              <a:buChar char="•"/>
+            </a:pPr>
+            <a:r>
+              <a:rPr sz="1350" b="0" i="0">
+                <a:solidFill>
+                  <a:srgbClr val="3A3F47"/>
+                </a:solidFill>
+                <a:latin typeface="Arial"/>
+                <a:cs typeface="Arial"/>
+              </a:rPr>
+              <a:t>3-D full-hard shortening matches the calibrated axisymmetric model (</a:t>
+            </a:r>
+            <a:r>
+              <a:rPr sz="1350" b="1" i="0">
+                <a:solidFill>
+                  <a:srgbClr val="1E2430"/>
+                </a:solidFill>
+                <a:latin typeface="Arial"/>
+                <a:cs typeface="Arial"/>
+              </a:rPr>
+              <a:t>39.5%</a:t>
+            </a:r>
+            <a:r>
+              <a:rPr sz="1350" b="0" i="0">
+                <a:solidFill>
+                  <a:srgbClr val="3A3F47"/>
+                </a:solidFill>
+                <a:latin typeface="Arial"/>
+                <a:cs typeface="Arial"/>
+              </a:rPr>
+              <a:t>) — cross-dimensional consistency</a:t>
             </a:r>
           </a:p>
         </p:txBody>
@@ -13359,7 +13414,7 @@
         <p:spPr>
           <a:xfrm>
             <a:off x="1755648" y="1609344"/>
-            <a:ext cx="7498079" cy="2072261"/>
+            <a:ext cx="7498079" cy="1921582"/>
           </a:xfrm>
           <a:prstGeom prst="rect">
             <a:avLst/>
@@ -13374,7 +13429,7 @@
         </p:nvSpPr>
         <p:spPr>
           <a:xfrm>
-            <a:off x="1847088" y="3709037"/>
+            <a:off x="1847088" y="3558358"/>
             <a:ext cx="10058400" cy="256032"/>
           </a:xfrm>
           <a:prstGeom prst="rect">
@@ -13397,7 +13452,7 @@
                 <a:latin typeface="Arial"/>
                 <a:cs typeface="Arial"/>
               </a:rPr>
-              <a:t>temperature rise above 300 K, cutaway views — run to 114 µs, &gt;99% of the impact kinetic energy dissipated</a:t>
+              <a:t>temperature rise above 300 K, cutaway views — run to rebound at 96 µs, &gt;99% of the impact kinetic energy dissipated</a:t>
             </a:r>
           </a:p>
         </p:txBody>
@@ -13410,7 +13465,7 @@
         </p:nvSpPr>
         <p:spPr>
           <a:xfrm>
-            <a:off x="566928" y="4029077"/>
+            <a:off x="566928" y="3878398"/>
             <a:ext cx="3442106" cy="960120"/>
           </a:xfrm>
           <a:prstGeom prst="roundRect">
@@ -13458,7 +13513,7 @@
         </p:nvSpPr>
         <p:spPr>
           <a:xfrm>
-            <a:off x="566928" y="4111373"/>
+            <a:off x="566928" y="3960694"/>
             <a:ext cx="50292" cy="795528"/>
           </a:xfrm>
           <a:prstGeom prst="rect">
@@ -13502,7 +13557,7 @@
         </p:nvSpPr>
         <p:spPr>
           <a:xfrm>
-            <a:off x="786384" y="4102229"/>
+            <a:off x="786384" y="3951550"/>
             <a:ext cx="3039770" cy="274320"/>
           </a:xfrm>
           <a:prstGeom prst="rect">
@@ -13542,7 +13597,7 @@
         </p:nvSpPr>
         <p:spPr>
           <a:xfrm>
-            <a:off x="786384" y="4422269"/>
+            <a:off x="786384" y="4271590"/>
             <a:ext cx="3039770" cy="548640"/>
           </a:xfrm>
           <a:prstGeom prst="rect">
@@ -13582,7 +13637,7 @@
         </p:nvSpPr>
         <p:spPr>
           <a:xfrm>
-            <a:off x="4374794" y="4029077"/>
+            <a:off x="4374794" y="3878398"/>
             <a:ext cx="3442106" cy="960120"/>
           </a:xfrm>
           <a:prstGeom prst="roundRect">
@@ -13630,7 +13685,7 @@
         </p:nvSpPr>
         <p:spPr>
           <a:xfrm>
-            <a:off x="4374794" y="4111373"/>
+            <a:off x="4374794" y="3960694"/>
             <a:ext cx="50292" cy="795528"/>
           </a:xfrm>
           <a:prstGeom prst="rect">
@@ -13674,7 +13729,7 @@
         </p:nvSpPr>
         <p:spPr>
           <a:xfrm>
-            <a:off x="4594250" y="4102229"/>
+            <a:off x="4594250" y="3951550"/>
             <a:ext cx="3039770" cy="274320"/>
           </a:xfrm>
           <a:prstGeom prst="rect">
@@ -13714,7 +13769,7 @@
         </p:nvSpPr>
         <p:spPr>
           <a:xfrm>
-            <a:off x="4594250" y="4422269"/>
+            <a:off x="4594250" y="4271590"/>
             <a:ext cx="3039770" cy="548640"/>
           </a:xfrm>
           <a:prstGeom prst="rect">
@@ -13741,7 +13796,7 @@
                 <a:latin typeface="Arial"/>
                 <a:cs typeface="Arial"/>
               </a:rPr>
-              <a:t>diffusion length √(αt) ≈ 0.1 mm ≪ element size over the 114 µs run — no heat-conduction PDE needed</a:t>
+              <a:t>diffusion length √(αt) ≈ 0.1 mm ≪ element size over the ~100 µs run — no heat-conduction PDE needed</a:t>
             </a:r>
           </a:p>
         </p:txBody>
@@ -13754,7 +13809,7 @@
         </p:nvSpPr>
         <p:spPr>
           <a:xfrm>
-            <a:off x="8182660" y="4029077"/>
+            <a:off x="8182660" y="3878398"/>
             <a:ext cx="3442106" cy="960120"/>
           </a:xfrm>
           <a:prstGeom prst="roundRect">
@@ -13802,7 +13857,7 @@
         </p:nvSpPr>
         <p:spPr>
           <a:xfrm>
-            <a:off x="8182660" y="4111373"/>
+            <a:off x="8182660" y="3960694"/>
             <a:ext cx="50292" cy="795528"/>
           </a:xfrm>
           <a:prstGeom prst="rect">
@@ -13846,7 +13901,7 @@
         </p:nvSpPr>
         <p:spPr>
           <a:xfrm>
-            <a:off x="8402116" y="4102229"/>
+            <a:off x="8402116" y="3951550"/>
             <a:ext cx="3039770" cy="274320"/>
           </a:xfrm>
           <a:prstGeom prst="rect">
@@ -13886,7 +13941,7 @@
         </p:nvSpPr>
         <p:spPr>
           <a:xfrm>
-            <a:off x="8402116" y="4422269"/>
+            <a:off x="8402116" y="4271590"/>
             <a:ext cx="3039770" cy="548640"/>
           </a:xfrm>
           <a:prstGeom prst="rect">
@@ -14007,7 +14062,7 @@
                 <a:latin typeface="Arial"/>
                 <a:cs typeface="Arial"/>
               </a:rPr>
-              <a:t> a peak ΔT of 119 K at the mushroom foot, captured through the NEML2 force path.</a:t>
+              <a:t> a peak ΔT of 422 K in the localized foot, captured through the NEML2 force path.</a:t>
             </a:r>
           </a:p>
         </p:txBody>

</xml_diff>

<commit_message>
slides: drop thermal takeaway strip
</commit_message>
<xml_diff>
--- a/examples/impact/slide_assets/WCCM_NEML2_explicit_dynamics_v2.pptx
+++ b/examples/impact/slide_assets/WCCM_NEML2_explicit_dynamics_v2.pptx
@@ -13969,100 +13969,6 @@
                 <a:cs typeface="Arial"/>
               </a:rPr>
               <a:t>no new MOOSE modules, no new transfers — temperature state lives on the device like everything else</a:t>
-            </a:r>
-          </a:p>
-        </p:txBody>
-      </p:sp>
-      <p:sp>
-        <p:nvSpPr>
-          <p:cNvPr id="19" name="Rounded Rectangle 18"/>
-          <p:cNvSpPr/>
-          <p:nvPr/>
-        </p:nvSpPr>
-        <p:spPr>
-          <a:xfrm>
-            <a:off x="566928" y="5376672"/>
-            <a:ext cx="11057839" cy="658368"/>
-          </a:xfrm>
-          <a:prstGeom prst="roundRect">
-            <a:avLst>
-              <a:gd name="adj" fmla="val 5500"/>
-            </a:avLst>
-          </a:prstGeom>
-          <a:solidFill>
-            <a:srgbClr val="FDF0DF"/>
-          </a:solidFill>
-          <a:ln w="12700">
-            <a:solidFill>
-              <a:srgbClr val="B4620B"/>
-            </a:solidFill>
-          </a:ln>
-          <a:effectLst/>
-        </p:spPr>
-        <p:style>
-          <a:lnRef idx="1">
-            <a:schemeClr val="accent1"/>
-          </a:lnRef>
-          <a:fillRef idx="3">
-            <a:schemeClr val="accent1"/>
-          </a:fillRef>
-          <a:effectRef idx="2">
-            <a:schemeClr val="accent1"/>
-          </a:effectRef>
-          <a:fontRef idx="minor">
-            <a:schemeClr val="lt1"/>
-          </a:fontRef>
-        </p:style>
-        <p:txBody>
-          <a:bodyPr rtlCol="0" anchor="ctr"/>
-          <a:lstStyle/>
-          <a:p>
-            <a:pPr algn="ctr"/>
-          </a:p>
-        </p:txBody>
-      </p:sp>
-      <p:sp>
-        <p:nvSpPr>
-          <p:cNvPr id="20" name="TextBox 19"/>
-          <p:cNvSpPr txBox="1"/>
-          <p:nvPr/>
-        </p:nvSpPr>
-        <p:spPr>
-          <a:xfrm>
-            <a:off x="841248" y="5376672"/>
-            <a:ext cx="10509199" cy="658368"/>
-          </a:xfrm>
-          <a:prstGeom prst="rect">
-            <a:avLst/>
-          </a:prstGeom>
-          <a:noFill/>
-        </p:spPr>
-        <p:txBody>
-          <a:bodyPr wrap="square" anchor="ctr" lIns="0" rIns="0" tIns="0" bIns="0">
-            <a:spAutoFit/>
-          </a:bodyPr>
-          <a:lstStyle/>
-          <a:p>
-            <a:pPr algn="l"/>
-            <a:r>
-              <a:rPr sz="1500" b="1" i="0">
-                <a:solidFill>
-                  <a:srgbClr val="1E2430"/>
-                </a:solidFill>
-                <a:latin typeface="Arial"/>
-                <a:cs typeface="Arial"/>
-              </a:rPr>
-              <a:t>The abstract’s thermo-mechanical claim, delivered:</a:t>
-            </a:r>
-            <a:r>
-              <a:rPr sz="1500" b="0" i="0">
-                <a:solidFill>
-                  <a:srgbClr val="3A3F47"/>
-                </a:solidFill>
-                <a:latin typeface="Arial"/>
-                <a:cs typeface="Arial"/>
-              </a:rPr>
-              <a:t> a peak ΔT of 422 K in the localized foot, captured through the NEML2 force path.</a:t>
             </a:r>
           </a:p>
         </p:txBody>

</xml_diff>

<commit_message>
slides: tone pass, no em dashes, plain takeaways, simpler mixed-order card, unified eq scale
</commit_message>
<xml_diff>
--- a/examples/impact/slide_assets/WCCM_NEML2_explicit_dynamics_v2.pptx
+++ b/examples/impact/slide_assets/WCCM_NEML2_explicit_dynamics_v2.pptx
@@ -6400,7 +6400,7 @@
                 <a:latin typeface="Arial"/>
                 <a:cs typeface="Arial"/>
               </a:rPr>
-              <a:t>New Engineering Material model Library v2 (ANL, open source) — constitutive models as </a:t>
+              <a:t>New Engineering Material model Library v2 (ANL, open source): constitutive models as </a:t>
             </a:r>
             <a:r>
               <a:rPr sz="1550" b="1" i="0">
@@ -8666,7 +8666,7 @@
                 <a:latin typeface="Arial"/>
                 <a:cs typeface="Arial"/>
               </a:rPr>
-              <a:t>NEML2 evaluates sophisticated material models the way accelerators want them evaluated.</a:t>
+              <a:t>NEML2 evaluates material models as batched tensor programs.</a:t>
             </a:r>
             <a:r>
               <a:rPr sz="1500" b="0" i="0">
@@ -8676,7 +8676,7 @@
                 <a:latin typeface="Arial"/>
                 <a:cs typeface="Arial"/>
               </a:rPr>
-              <a:t> What it lacks — mesh, BCs, assembly — is exactly what MOOSE has.</a:t>
+              <a:t> It has no mesh, boundary conditions, or assembly; MOOSE does.</a:t>
             </a:r>
           </a:p>
         </p:txBody>
@@ -8985,7 +8985,7 @@
                 <a:latin typeface="Arial"/>
                 <a:cs typeface="Arial"/>
               </a:rPr>
-              <a:t>Lumped mass via matrix tag — </a:t>
+              <a:t>Lumped mass via matrix tag: </a:t>
             </a:r>
             <a:r>
               <a:rPr sz="1300" b="1" i="0">
@@ -9263,7 +9263,7 @@
                 <a:latin typeface="Arial"/>
                 <a:cs typeface="Arial"/>
               </a:rPr>
-              <a:t> itself — not just stress — for the whole mesh in batched tensor ops</a:t>
+              <a:t> itself, not just stress, for the whole mesh in batched tensor ops</a:t>
             </a:r>
           </a:p>
           <a:p>
@@ -9333,7 +9333,7 @@
                 <a:latin typeface="Arial"/>
                 <a:cs typeface="Arial"/>
               </a:rPr>
-              <a:t>Plugs into the explicit solve as a residual contribution — MOOSE BCs, outputs, MPI unchanged</a:t>
+              <a:t>Plugs into the explicit solve as a residual contribution; MOOSE BCs, outputs, MPI unchanged</a:t>
             </a:r>
           </a:p>
         </p:txBody>
@@ -9681,7 +9681,7 @@
                 <a:latin typeface="Arial"/>
                 <a:cs typeface="Arial"/>
               </a:rPr>
-              <a:t>DEVICE (libTorch)  —  same code on CPU / CUDA</a:t>
+              <a:t>DEVICE (libTorch): same code on CPU / CUDA</a:t>
             </a:r>
           </a:p>
         </p:txBody>
@@ -11022,7 +11022,7 @@
                 <a:latin typeface="Arial"/>
                 <a:cs typeface="Arial"/>
               </a:rPr>
-              <a:t>shape functions φ, ∇φ,  DOF maps,  weights JxW — rebuilt only on mesh change</a:t>
+              <a:t>shape functions φ, ∇φ,  DOF maps,  weights JxW; rebuilt only on mesh change</a:t>
             </a:r>
           </a:p>
         </p:txBody>
@@ -11276,7 +11276,7 @@
                 <a:latin typeface="Arial"/>
                 <a:cs typeface="Arial"/>
               </a:rPr>
-              <a:t>CONVENTIONAL COUPLING — state round-trips through MOOSE every step</a:t>
+              <a:t>CONVENTIONAL COUPLING: state round-trips through MOOSE every step</a:t>
             </a:r>
           </a:p>
         </p:txBody>
@@ -11747,7 +11747,7 @@
                 <a:latin typeface="Arial"/>
                 <a:cs typeface="Arial"/>
               </a:rPr>
-              <a:t>state copied down and back up every step — scales with model complexity</a:t>
+              <a:t>state copied down and back up every step; scales with model complexity</a:t>
             </a:r>
           </a:p>
         </p:txBody>
@@ -11831,7 +11831,7 @@
                 <a:latin typeface="Arial"/>
                 <a:cs typeface="Arial"/>
               </a:rPr>
-              <a:t>THIS WORK — state advances in place on the device  (manage_state_advance)</a:t>
+              <a:t>THIS WORK: state advances in place on the device  (manage_state_advance)</a:t>
             </a:r>
           </a:p>
         </p:txBody>
@@ -12302,7 +12302,7 @@
                 <a:latin typeface="Arial"/>
                 <a:cs typeface="Arial"/>
               </a:rPr>
-              <a:t>per step: one solution upload, one force download — independent of model complexity</a:t>
+              <a:t>per step: one solution upload, one force download; independent of model complexity</a:t>
             </a:r>
           </a:p>
         </p:txBody>
@@ -12386,7 +12386,7 @@
                 <a:latin typeface="Arial"/>
                 <a:cs typeface="Arial"/>
               </a:rPr>
-              <a:t>The richer the model, the more this matters</a:t>
+              <a:t>State stays where it is computed;</a:t>
             </a:r>
             <a:r>
               <a:rPr sz="1500" b="0" i="0">
@@ -12396,7 +12396,7 @@
                 <a:latin typeface="Arial"/>
                 <a:cs typeface="Arial"/>
               </a:rPr>
-              <a:t> — state stays where it is computed; traffic does not grow with it.</a:t>
+              <a:t> transfer volume does not grow with model complexity.</a:t>
             </a:r>
           </a:p>
         </p:txBody>
@@ -13140,7 +13140,7 @@
                 <a:latin typeface="Arial"/>
                 <a:cs typeface="Arial"/>
               </a:rPr>
-              <a:t>MOOSE keeps BCs, parallelism, outputs — unchanged</a:t>
+              <a:t>MOOSE keeps BCs, parallelism, outputs unchanged</a:t>
             </a:r>
           </a:p>
         </p:txBody>
@@ -13414,7 +13414,7 @@
                 <a:latin typeface="Arial"/>
                 <a:cs typeface="Arial"/>
               </a:rPr>
-              <a:t> under large plastic flow — the batched </a:t>
+              <a:t> under large plastic flow; the batched </a:t>
             </a:r>
             <a:r>
               <a:rPr sz="1500" b="1" i="0">
@@ -13479,7 +13479,7 @@
                 <a:latin typeface="Arial"/>
                 <a:cs typeface="Arial"/>
               </a:rPr>
-              <a:t> — locking-free by construction and much cheaper per step</a:t>
+              <a:t>, locking-free by construction and much cheaper per step</a:t>
             </a:r>
           </a:p>
           <a:p>
@@ -13569,7 +13569,7 @@
                 <a:latin typeface="Arial"/>
                 <a:cs typeface="Arial"/>
               </a:rPr>
-              <a:t> — the classic coefficient, not a tunable</a:t>
+              <a:t>, the classic coefficient, not a tunable</a:t>
             </a:r>
           </a:p>
         </p:txBody>
@@ -13881,7 +13881,7 @@
                 <a:latin typeface="Arial"/>
                 <a:cs typeface="Arial"/>
               </a:rPr>
-              <a:t> — the physics does not hide in the stabilization.</a:t>
+              <a:t>. The physics does not hide in the stabilization.</a:t>
             </a:r>
           </a:p>
         </p:txBody>
@@ -14285,7 +14285,7 @@
                 <a:latin typeface="Arial"/>
                 <a:cs typeface="Arial"/>
               </a:rPr>
-              <a:t>   — for the rest of the run</a:t>
+              <a:t>   for the rest of the run</a:t>
             </a:r>
           </a:p>
         </p:txBody>
@@ -14353,7 +14353,7 @@
                 <a:latin typeface="Arial"/>
                 <a:cs typeface="Arial"/>
               </a:rPr>
-              <a:t>: only elements adjacent to integrated BCs — none, with node-wise contact</a:t>
+              <a:t>: only elements adjacent to integrated BCs (none, with node-wise contact)</a:t>
             </a:r>
           </a:p>
           <a:p>
@@ -14892,7 +14892,7 @@
                 <a:latin typeface="Arial"/>
                 <a:cs typeface="Arial"/>
               </a:rPr>
-              <a:t> That call is exactly the work that moves to the GPU — everything around it is already negligible.</a:t>
+              <a:t> Everything around it is negligible.</a:t>
             </a:r>
           </a:p>
         </p:txBody>
@@ -15024,7 +15024,7 @@
                 <a:latin typeface="Arial"/>
                 <a:cs typeface="Arial"/>
               </a:rPr>
-              <a:t> — calibrated multiplicative Johnson–Cook · reduced integration · Δt = 10 ns · </a:t>
+              <a:t> · calibrated multiplicative Johnson–Cook · reduced integration · Δt = 10 ns · </a:t>
             </a:r>
             <a:r>
               <a:rPr sz="1450" b="1" i="0">
@@ -15094,7 +15094,7 @@
                 <a:latin typeface="Arial"/>
                 <a:cs typeface="Arial"/>
               </a:rPr>
-              <a:t>cutaway views (near half removed) — plastic strain localizes at the impact foot; gray plane = rigid anvil</a:t>
+              <a:t>cutaway views (near half removed); plastic strain localizes at the impact foot; gray plane = rigid anvil</a:t>
             </a:r>
           </a:p>
         </p:txBody>
@@ -15166,7 +15166,7 @@
                 <a:latin typeface="Arial"/>
                 <a:cs typeface="Arial"/>
               </a:rPr>
-              <a:t>Same mesh, BCs, integrator — the temper is swapped by </a:t>
+              <a:t>Same mesh, BCs, integrator; the temper is swapped by </a:t>
             </a:r>
             <a:r>
               <a:rPr sz="1350" b="1" i="0">
@@ -15251,7 +15251,7 @@
                 <a:latin typeface="Arial"/>
                 <a:cs typeface="Arial"/>
               </a:rPr>
-              <a:t> axial shortening — temper sensitivity captured</a:t>
+              <a:t> axial shortening</a:t>
             </a:r>
           </a:p>
           <a:p>
@@ -15296,7 +15296,7 @@
                 <a:latin typeface="Arial"/>
                 <a:cs typeface="Arial"/>
               </a:rPr>
-              <a:t>) — cross-dimensional consistency</a:t>
+              <a:t>)</a:t>
             </a:r>
           </a:p>
         </p:txBody>
@@ -15408,7 +15408,7 @@
                 <a:latin typeface="Arial"/>
                 <a:cs typeface="Arial"/>
               </a:rPr>
-              <a:t>The run you just saw is coupled — temperature integrated </a:t>
+              <a:t>The run you just saw is coupled: temperature integrated </a:t>
             </a:r>
             <a:r>
               <a:rPr sz="1450" b="1" i="0">
@@ -15488,7 +15488,7 @@
                 <a:latin typeface="Arial"/>
                 <a:cs typeface="Arial"/>
               </a:rPr>
-              <a:t>temperature rise above 300 K, cutaway views — run to rebound at 96 µs, &gt;99% of the impact kinetic energy dissipated</a:t>
+              <a:t>temperature rise above 300 K, cutaway views; run to rebound at 96 µs; &gt;99% of the impact kinetic energy dissipated</a:t>
             </a:r>
           </a:p>
         </p:txBody>
@@ -15832,7 +15832,7 @@
                 <a:latin typeface="Arial"/>
                 <a:cs typeface="Arial"/>
               </a:rPr>
-              <a:t>diffusion length √(αt) ≈ 0.1 mm ≪ element size over the ~100 µs run — no heat-conduction PDE needed</a:t>
+              <a:t>diffusion length √(αt) ≈ 0.1 mm ≪ element size over the ~100 µs run; no heat-conduction PDE needed</a:t>
             </a:r>
           </a:p>
         </p:txBody>
@@ -16004,7 +16004,7 @@
                 <a:latin typeface="Arial"/>
                 <a:cs typeface="Arial"/>
               </a:rPr>
-              <a:t>no new MOOSE modules, no new transfers — temperature state lives on the device like everything else</a:t>
+              <a:t>no new MOOSE modules, no new transfers; temperature state lives on the device like everything else</a:t>
             </a:r>
           </a:p>
         </p:txBody>
@@ -16950,7 +16950,7 @@
                 <a:latin typeface="Arial"/>
                 <a:cs typeface="Arial"/>
               </a:rPr>
-              <a:t> The data rejects anvil friction, and one shot cannot separate A–B–n–C — multi-velocity shots are next.</a:t>
+              <a:t> The data rejects anvil friction, and one shot cannot separate A–B–n–C; multi-velocity shots are next.</a:t>
             </a:r>
           </a:p>
         </p:txBody>
@@ -17129,7 +17129,7 @@
                 <a:latin typeface="Arial"/>
                 <a:cs typeface="Arial"/>
               </a:rPr>
-              <a:t> — stress waves traverse the part in microseconds, with severe, localized plasticity</a:t>
+              <a:t>: stress waves traverse the part in microseconds, with severe, localized plasticity</a:t>
             </a:r>
           </a:p>
           <a:p>
@@ -17174,7 +17174,7 @@
                 <a:latin typeface="Arial"/>
                 <a:cs typeface="Arial"/>
               </a:rPr>
-              <a:t> — rate- and temperature-dependent plasticity, evolving internal state</a:t>
+              <a:t>: rate- and temperature-dependent plasticity, evolving internal state</a:t>
             </a:r>
           </a:p>
           <a:p>
@@ -18821,7 +18821,7 @@
           <a:p>
             <a:r>
               <a:rPr sz="2600"/>
-              <a:t>Two mature ecosystems — and a gap between them</a:t>
+              <a:t>Two mature ecosystems and a gap between them</a:t>
             </a:r>
           </a:p>
         </p:txBody>
@@ -19261,7 +19261,7 @@
                 <a:latin typeface="Arial"/>
                 <a:cs typeface="Arial"/>
               </a:rPr>
-              <a:t>But: no mesh, no boundary conditions, no solver — </a:t>
+              <a:t>But: no mesh, no boundary conditions, no solver; </a:t>
             </a:r>
             <a:r>
               <a:rPr sz="1400" b="1" i="0">
@@ -19458,7 +19458,7 @@
                 <a:latin typeface="Arial"/>
                 <a:cs typeface="Arial"/>
               </a:rPr>
-              <a:t>an interface that lets NEML2 assemble the nodal internal forces itself — batched, device-resident — while MOOSE keeps doing everything else it is good at.</a:t>
+              <a:t>an interface where NEML2 assembles the nodal internal forces itself, batched and device-resident, while MOOSE keeps doing everything else.</a:t>
             </a:r>
           </a:p>
         </p:txBody>
@@ -19556,7 +19556,7 @@
         <p:spPr>
           <a:xfrm>
             <a:off x="658368" y="1389888"/>
-            <a:ext cx="2962198" cy="277977"/>
+            <a:ext cx="2884246" cy="270662"/>
           </a:xfrm>
           <a:prstGeom prst="rect">
             <a:avLst/>
@@ -19616,7 +19616,7 @@
         <p:spPr>
           <a:xfrm>
             <a:off x="658368" y="2377440"/>
-            <a:ext cx="7175296" cy="385114"/>
+            <a:ext cx="6986473" cy="374980"/>
           </a:xfrm>
           <a:prstGeom prst="rect">
             <a:avLst/>
@@ -19654,7 +19654,7 @@
                 <a:latin typeface="Arial"/>
                 <a:cs typeface="Arial"/>
               </a:rPr>
-              <a:t>total-Lagrangian weak form — every integral on the reference configuration</a:t>
+              <a:t>total-Lagrangian weak form: every integral on the reference configuration</a:t>
             </a:r>
           </a:p>
         </p:txBody>
@@ -19676,7 +19676,7 @@
         <p:spPr>
           <a:xfrm>
             <a:off x="658368" y="3364992"/>
-            <a:ext cx="2478633" cy="330098"/>
+            <a:ext cx="2413406" cy="321411"/>
           </a:xfrm>
           <a:prstGeom prst="rect">
             <a:avLst/>
@@ -19736,7 +19736,7 @@
         <p:spPr>
           <a:xfrm>
             <a:off x="658368" y="4352544"/>
-            <a:ext cx="6517995" cy="390906"/>
+            <a:ext cx="6346469" cy="380619"/>
           </a:xfrm>
           <a:prstGeom prst="rect">
             <a:avLst/>
@@ -19868,7 +19868,7 @@
                 <a:latin typeface="Arial"/>
                 <a:cs typeface="Arial"/>
               </a:rPr>
-              <a:t>shape functions, weights, and dof maps never change during the run — and the material physics lives in one place, the stress </a:t>
+              <a:t>shape functions, weights, and dof maps never change during the run. All material physics enters through the stress </a:t>
             </a:r>
             <a:r>
               <a:rPr sz="1500" b="1" i="0">
@@ -19888,7 +19888,7 @@
                 <a:latin typeface="Arial"/>
                 <a:cs typeface="Arial"/>
               </a:rPr>
-              <a:t> at each quadrature point. That is where NEML2 plugs in.</a:t>
+              <a:t> at the quadrature points.</a:t>
             </a:r>
           </a:p>
         </p:txBody>
@@ -19986,7 +19986,7 @@
         <p:spPr>
           <a:xfrm>
             <a:off x="658368" y="1280160"/>
-            <a:ext cx="1128141" cy="221361"/>
+            <a:ext cx="1192606" cy="234010"/>
           </a:xfrm>
           <a:prstGeom prst="rect">
             <a:avLst/>
@@ -20046,7 +20046,7 @@
         <p:spPr>
           <a:xfrm>
             <a:off x="658368" y="2084832"/>
-            <a:ext cx="3896487" cy="333375"/>
+            <a:ext cx="4119143" cy="352425"/>
           </a:xfrm>
           <a:prstGeom prst="rect">
             <a:avLst/>
@@ -20106,7 +20106,7 @@
         <p:spPr>
           <a:xfrm>
             <a:off x="658368" y="2889504"/>
-            <a:ext cx="4712589" cy="333375"/>
+            <a:ext cx="4981879" cy="352425"/>
           </a:xfrm>
           <a:prstGeom prst="rect">
             <a:avLst/>
@@ -20144,7 +20144,7 @@
                 <a:latin typeface="Arial"/>
                 <a:cs typeface="Arial"/>
               </a:rPr>
-              <a:t>radial return on the trial elastic strain — one scalar unknown</a:t>
+              <a:t>radial return on the trial elastic strain, one scalar unknown</a:t>
             </a:r>
           </a:p>
         </p:txBody>
@@ -20166,7 +20166,7 @@
         <p:spPr>
           <a:xfrm>
             <a:off x="658368" y="3694176"/>
-            <a:ext cx="2330958" cy="333375"/>
+            <a:ext cx="2464155" cy="352425"/>
           </a:xfrm>
           <a:prstGeom prst="rect">
             <a:avLst/>
@@ -20226,7 +20226,7 @@
         <p:spPr>
           <a:xfrm>
             <a:off x="658368" y="4498848"/>
-            <a:ext cx="2192274" cy="333375"/>
+            <a:ext cx="2317546" cy="352425"/>
           </a:xfrm>
           <a:prstGeom prst="rect">
             <a:avLst/>
@@ -20264,7 +20264,7 @@
                 <a:latin typeface="Arial"/>
                 <a:cs typeface="Arial"/>
               </a:rPr>
-              <a:t>pull-back to the reference configuration — the PK1 the weak form needs</a:t>
+              <a:t>pull-back to the reference configuration: the PK1 stress of the weak form</a:t>
             </a:r>
           </a:p>
         </p:txBody>
@@ -20358,7 +20358,7 @@
                 <a:latin typeface="Arial"/>
                 <a:cs typeface="Arial"/>
               </a:rPr>
-              <a:t> S on the relaxed intermediate configuration, P on the reference — matching the Ω</a:t>
+              <a:t> S on the relaxed intermediate configuration, P on the reference, matching the Ω</a:t>
             </a:r>
             <a:r>
               <a:rPr sz="1500" b="0" i="0" baseline="-25000">
@@ -21454,17 +21454,7 @@
                 <a:latin typeface="Arial"/>
                 <a:cs typeface="Arial"/>
               </a:rPr>
-              <a:t>Rate-, hardening-, and temperature-coupled with three internal states (εᵖ, Fᵖ, T)</a:t>
-            </a:r>
-            <a:r>
-              <a:rPr sz="1500" b="0" i="0">
-                <a:solidFill>
-                  <a:srgbClr val="3A3F47"/>
-                </a:solidFill>
-                <a:latin typeface="Arial"/>
-                <a:cs typeface="Arial"/>
-              </a:rPr>
-              <a:t> — exactly the model class that makes conventional per-point CPU updates expensive.</a:t>
+              <a:t>Internal state (εᵖ, Fᵖ, T) advances inside the model every step.</a:t>
             </a:r>
           </a:p>
         </p:txBody>
@@ -21656,7 +21646,7 @@
                 <a:latin typeface="Arial"/>
                 <a:cs typeface="Arial"/>
               </a:rPr>
-              <a:t>pointwise divide — no solver</a:t>
+              <a:t>pointwise divide, no solver</a:t>
             </a:r>
           </a:p>
         </p:txBody>
@@ -21812,7 +21802,7 @@
                 <a:latin typeface="Arial"/>
                 <a:cs typeface="Arial"/>
               </a:rPr>
-              <a:t>No Newton iterations, no global linear solve, no Jacobian — </a:t>
+              <a:t>No Newton iterations, no global linear solve, no Jacobian. </a:t>
             </a:r>
             <a:r>
               <a:rPr sz="1400" b="1" i="0">
@@ -21822,7 +21812,7 @@
                 <a:latin typeface="Arial"/>
                 <a:cs typeface="Arial"/>
               </a:rPr>
-              <a:t>each step is one residual evaluation plus vector updates.</a:t>
+              <a:t>Each step is one residual evaluation plus vector updates.</a:t>
             </a:r>
           </a:p>
         </p:txBody>
@@ -21906,7 +21896,7 @@
                 <a:latin typeface="Arial"/>
                 <a:cs typeface="Arial"/>
               </a:rPr>
-              <a:t>WHY “MIXED ORDER”</a:t>
+              <a:t>MIXED ORDER</a:t>
             </a:r>
           </a:p>
         </p:txBody>
@@ -21954,7 +21944,7 @@
                 <a:latin typeface="Arial"/>
                 <a:cs typeface="Arial"/>
               </a:rPr>
-              <a:t>Second-order fields</a:t>
+              <a:t>Displacements: </a:t>
             </a:r>
             <a:r>
               <a:rPr sz="1300" b="0" i="0">
@@ -21964,7 +21954,7 @@
                 <a:latin typeface="Arial"/>
                 <a:cs typeface="Arial"/>
               </a:rPr>
-              <a:t> (displacement): central difference, as at left</a:t>
+              <a:t>central difference</a:t>
             </a:r>
           </a:p>
           <a:p>
@@ -21989,7 +21979,7 @@
                 <a:latin typeface="Arial"/>
                 <a:cs typeface="Arial"/>
               </a:rPr>
-              <a:t>First-order fields</a:t>
+              <a:t>First-order fields (temperature): </a:t>
             </a:r>
             <a:r>
               <a:rPr sz="1300" b="0" i="0">
@@ -21999,7 +21989,7 @@
                 <a:latin typeface="Arial"/>
                 <a:cs typeface="Arial"/>
               </a:rPr>
-              <a:t> (e.g. temperature): forward Euler on the rate — same update loop</a:t>
+              <a:t>forward Euler on the rate</a:t>
             </a:r>
           </a:p>
         </p:txBody>
@@ -22075,27 +22065,7 @@
                 <a:latin typeface="Arial"/>
                 <a:cs typeface="Arial"/>
               </a:rPr>
-              <a:t>One integrator advances a </a:t>
-            </a:r>
-            <a:r>
-              <a:rPr sz="1300" b="1" i="0">
-                <a:solidFill>
-                  <a:srgbClr val="1E2430"/>
-                </a:solidFill>
-                <a:latin typeface="Arial"/>
-                <a:cs typeface="Arial"/>
-              </a:rPr>
-              <a:t>coupled thermo-mechanical system</a:t>
-            </a:r>
-            <a:r>
-              <a:rPr sz="1300" b="0" i="0">
-                <a:solidFill>
-                  <a:srgbClr val="3A3F47"/>
-                </a:solidFill>
-                <a:latin typeface="Arial"/>
-                <a:cs typeface="Arial"/>
-              </a:rPr>
-              <a:t> explicitly — the multiphysics lever used later in this talk.</a:t>
+              <a:t>Both advance in the same update loop.</a:t>
             </a:r>
           </a:p>
         </p:txBody>
@@ -22189,7 +22159,7 @@
                 <a:latin typeface="Arial"/>
                 <a:cs typeface="Arial"/>
               </a:rPr>
-              <a:t> part of MOOSE solid mechanics today, available to every MOOSE application.</a:t>
+              <a:t> part of MOOSE solid mechanics today.</a:t>
             </a:r>
           </a:p>
         </p:txBody>
@@ -22504,7 +22474,7 @@
                 <a:latin typeface="Arial"/>
                 <a:cs typeface="Arial"/>
               </a:rPr>
-              <a:t>Each step: no solve — the runtime </a:t>
+              <a:t>Each step: no solve; the runtime </a:t>
             </a:r>
             <a:r>
               <a:rPr sz="1500" b="0" i="1">
@@ -23171,7 +23141,7 @@
                 <a:latin typeface="Arial"/>
                 <a:cs typeface="Arial"/>
               </a:rPr>
-              <a:t>Open-source multiphysics FE framework (Idaho National Laboratory) — </a:t>
+              <a:t>Open-source multiphysics FE framework (Idaho National Laboratory): </a:t>
             </a:r>
             <a:r>
               <a:rPr sz="1550" b="1" i="0">
@@ -23517,7 +23487,7 @@
                 <a:latin typeface="Arial"/>
                 <a:cs typeface="Arial"/>
               </a:rPr>
-              <a:t>mortar and node-face algorithms — architecture-compatible with this interface</a:t>
+              <a:t>mortar and node-face algorithms, architecture-compatible with this interface</a:t>
             </a:r>
           </a:p>
         </p:txBody>
@@ -24293,7 +24263,7 @@
                 <a:latin typeface="Arial"/>
                 <a:cs typeface="Arial"/>
               </a:rPr>
-              <a:t> the material update already exists here — parallel and production-tested.</a:t>
+              <a:t> the material update already exists here, parallel and production-tested.</a:t>
             </a:r>
           </a:p>
         </p:txBody>

</xml_diff>

<commit_message>
slides: full sentences instead of splice colons/semicolons
</commit_message>
<xml_diff>
--- a/examples/impact/slide_assets/WCCM_NEML2_explicit_dynamics_v2.pptx
+++ b/examples/impact/slide_assets/WCCM_NEML2_explicit_dynamics_v2.pptx
@@ -6400,7 +6400,7 @@
                 <a:latin typeface="Arial"/>
                 <a:cs typeface="Arial"/>
               </a:rPr>
-              <a:t>New Engineering Material model Library v2 (ANL, open source): constitutive models as </a:t>
+              <a:t>New Engineering Material model Library v2 (ANL, open source). Constitutive models as </a:t>
             </a:r>
             <a:r>
               <a:rPr sz="1550" b="1" i="0">
@@ -8676,7 +8676,7 @@
                 <a:latin typeface="Arial"/>
                 <a:cs typeface="Arial"/>
               </a:rPr>
-              <a:t> It has no mesh, boundary conditions, or assembly; MOOSE does.</a:t>
+              <a:t> It has no mesh, boundary conditions, or assembly. MOOSE does.</a:t>
             </a:r>
           </a:p>
         </p:txBody>
@@ -8985,7 +8985,7 @@
                 <a:latin typeface="Arial"/>
                 <a:cs typeface="Arial"/>
               </a:rPr>
-              <a:t>Lumped mass via matrix tag: </a:t>
+              <a:t>Lumped mass via matrix tag. </a:t>
             </a:r>
             <a:r>
               <a:rPr sz="1300" b="1" i="0">
@@ -8995,7 +8995,7 @@
                 <a:latin typeface="Arial"/>
                 <a:cs typeface="Arial"/>
               </a:rPr>
-              <a:t>zero linear iterations per step</a:t>
+              <a:t>Zero linear iterations per step</a:t>
             </a:r>
           </a:p>
           <a:p>
@@ -9333,7 +9333,7 @@
                 <a:latin typeface="Arial"/>
                 <a:cs typeface="Arial"/>
               </a:rPr>
-              <a:t>Plugs into the explicit solve as a residual contribution; MOOSE BCs, outputs, MPI unchanged</a:t>
+              <a:t>Plugs into the explicit solve as a residual contribution. MOOSE BCs, outputs, and MPI are unchanged</a:t>
             </a:r>
           </a:p>
         </p:txBody>
@@ -9681,7 +9681,7 @@
                 <a:latin typeface="Arial"/>
                 <a:cs typeface="Arial"/>
               </a:rPr>
-              <a:t>DEVICE (libTorch): same code on CPU / CUDA</a:t>
+              <a:t>DEVICE (libTorch) · same code on CPU / CUDA</a:t>
             </a:r>
           </a:p>
         </p:txBody>
@@ -11022,7 +11022,7 @@
                 <a:latin typeface="Arial"/>
                 <a:cs typeface="Arial"/>
               </a:rPr>
-              <a:t>shape functions φ, ∇φ,  DOF maps,  weights JxW; rebuilt only on mesh change</a:t>
+              <a:t>shape functions φ, ∇φ,  DOF maps,  weights JxW. Rebuilt only on mesh change</a:t>
             </a:r>
           </a:p>
         </p:txBody>
@@ -11276,7 +11276,7 @@
                 <a:latin typeface="Arial"/>
                 <a:cs typeface="Arial"/>
               </a:rPr>
-              <a:t>CONVENTIONAL COUPLING: state round-trips through MOOSE every step</a:t>
+              <a:t>CONVENTIONAL COUPLING · state round-trips through MOOSE every step</a:t>
             </a:r>
           </a:p>
         </p:txBody>
@@ -11747,7 +11747,7 @@
                 <a:latin typeface="Arial"/>
                 <a:cs typeface="Arial"/>
               </a:rPr>
-              <a:t>state copied down and back up every step; scales with model complexity</a:t>
+              <a:t>state copied down and back up every step. Traffic scales with model complexity</a:t>
             </a:r>
           </a:p>
         </p:txBody>
@@ -11831,7 +11831,7 @@
                 <a:latin typeface="Arial"/>
                 <a:cs typeface="Arial"/>
               </a:rPr>
-              <a:t>THIS WORK: state advances in place on the device  (manage_state_advance)</a:t>
+              <a:t>THIS WORK · state advances in place on the device  (manage_state_advance)</a:t>
             </a:r>
           </a:p>
         </p:txBody>
@@ -12302,7 +12302,7 @@
                 <a:latin typeface="Arial"/>
                 <a:cs typeface="Arial"/>
               </a:rPr>
-              <a:t>per step: one solution upload, one force download; independent of model complexity</a:t>
+              <a:t>per step: one solution upload, one force download. Independent of model complexity</a:t>
             </a:r>
           </a:p>
         </p:txBody>
@@ -12386,7 +12386,7 @@
                 <a:latin typeface="Arial"/>
                 <a:cs typeface="Arial"/>
               </a:rPr>
-              <a:t>State stays where it is computed;</a:t>
+              <a:t>State stays where it is computed.</a:t>
             </a:r>
             <a:r>
               <a:rPr sz="1500" b="0" i="0">
@@ -12396,7 +12396,7 @@
                 <a:latin typeface="Arial"/>
                 <a:cs typeface="Arial"/>
               </a:rPr>
-              <a:t> transfer volume does not grow with model complexity.</a:t>
+              <a:t> Transfer volume does not grow with model complexity.</a:t>
             </a:r>
           </a:p>
         </p:txBody>
@@ -13414,7 +13414,7 @@
                 <a:latin typeface="Arial"/>
                 <a:cs typeface="Arial"/>
               </a:rPr>
-              <a:t> under large plastic flow; the batched </a:t>
+              <a:t> under large plastic flow. The batched </a:t>
             </a:r>
             <a:r>
               <a:rPr sz="1500" b="1" i="0">
@@ -15094,7 +15094,7 @@
                 <a:latin typeface="Arial"/>
                 <a:cs typeface="Arial"/>
               </a:rPr>
-              <a:t>cutaway views (near half removed); plastic strain localizes at the impact foot; gray plane = rigid anvil</a:t>
+              <a:t>cutaway views (near half removed). Plastic strain localizes at the impact foot. The gray plane is the rigid anvil</a:t>
             </a:r>
           </a:p>
         </p:txBody>
@@ -15166,7 +15166,7 @@
                 <a:latin typeface="Arial"/>
                 <a:cs typeface="Arial"/>
               </a:rPr>
-              <a:t>Same mesh, BCs, integrator; the temper is swapped by </a:t>
+              <a:t>Same mesh, BCs, integrator. The temper is swapped by </a:t>
             </a:r>
             <a:r>
               <a:rPr sz="1350" b="1" i="0">
@@ -15408,7 +15408,7 @@
                 <a:latin typeface="Arial"/>
                 <a:cs typeface="Arial"/>
               </a:rPr>
-              <a:t>The run you just saw is coupled: temperature integrated </a:t>
+              <a:t>The run you just saw is coupled. Temperature is integrated </a:t>
             </a:r>
             <a:r>
               <a:rPr sz="1450" b="1" i="0">
@@ -15488,7 +15488,7 @@
                 <a:latin typeface="Arial"/>
                 <a:cs typeface="Arial"/>
               </a:rPr>
-              <a:t>temperature rise above 300 K, cutaway views; run to rebound at 96 µs; &gt;99% of the impact kinetic energy dissipated</a:t>
+              <a:t>temperature rise above 300 K, cutaway views. Run to rebound at 96 µs with &gt;99% of the impact kinetic energy dissipated</a:t>
             </a:r>
           </a:p>
         </p:txBody>
@@ -15832,7 +15832,7 @@
                 <a:latin typeface="Arial"/>
                 <a:cs typeface="Arial"/>
               </a:rPr>
-              <a:t>diffusion length √(αt) ≈ 0.1 mm ≪ element size over the ~100 µs run; no heat-conduction PDE needed</a:t>
+              <a:t>diffusion length √(αt) ≈ 0.1 mm ≪ element size over the ~100 µs run. No heat-conduction PDE needed</a:t>
             </a:r>
           </a:p>
         </p:txBody>
@@ -16004,7 +16004,7 @@
                 <a:latin typeface="Arial"/>
                 <a:cs typeface="Arial"/>
               </a:rPr>
-              <a:t>no new MOOSE modules, no new transfers; temperature state lives on the device like everything else</a:t>
+              <a:t>no new MOOSE modules, no new transfers. Temperature state lives on the device like everything else</a:t>
             </a:r>
           </a:p>
         </p:txBody>
@@ -16950,7 +16950,7 @@
                 <a:latin typeface="Arial"/>
                 <a:cs typeface="Arial"/>
               </a:rPr>
-              <a:t> The data rejects anvil friction, and one shot cannot separate A–B–n–C; multi-velocity shots are next.</a:t>
+              <a:t> The data rejects anvil friction, and one shot cannot separate A–B–n–C. Multi-velocity shots are next.</a:t>
             </a:r>
           </a:p>
         </p:txBody>
@@ -17129,7 +17129,7 @@
                 <a:latin typeface="Arial"/>
                 <a:cs typeface="Arial"/>
               </a:rPr>
-              <a:t>: stress waves traverse the part in microseconds, with severe, localized plasticity</a:t>
+              <a:t>. Stress waves traverse the part in microseconds, with severe, localized plasticity</a:t>
             </a:r>
           </a:p>
           <a:p>
@@ -17174,7 +17174,7 @@
                 <a:latin typeface="Arial"/>
                 <a:cs typeface="Arial"/>
               </a:rPr>
-              <a:t>: rate- and temperature-dependent plasticity, evolving internal state</a:t>
+              <a:t>. Rate- and temperature-dependent, with evolving internal state</a:t>
             </a:r>
           </a:p>
           <a:p>
@@ -19261,7 +19261,7 @@
                 <a:latin typeface="Arial"/>
                 <a:cs typeface="Arial"/>
               </a:rPr>
-              <a:t>But: no mesh, no boundary conditions, no solver; </a:t>
+              <a:t>But: no mesh, no boundary conditions, no solver. </a:t>
             </a:r>
             <a:r>
               <a:rPr sz="1400" b="1" i="0">
@@ -19271,7 +19271,7 @@
                 <a:latin typeface="Arial"/>
                 <a:cs typeface="Arial"/>
               </a:rPr>
-              <a:t>not a simulation code</a:t>
+              <a:t>Not a simulation code</a:t>
             </a:r>
           </a:p>
         </p:txBody>
@@ -19654,7 +19654,7 @@
                 <a:latin typeface="Arial"/>
                 <a:cs typeface="Arial"/>
               </a:rPr>
-              <a:t>total-Lagrangian weak form: every integral on the reference configuration</a:t>
+              <a:t>total-Lagrangian weak form. Every integral is on the reference configuration</a:t>
             </a:r>
           </a:p>
         </p:txBody>
@@ -20264,7 +20264,7 @@
                 <a:latin typeface="Arial"/>
                 <a:cs typeface="Arial"/>
               </a:rPr>
-              <a:t>pull-back to the reference configuration: the PK1 stress of the weak form</a:t>
+              <a:t>pull-back to the reference configuration, giving the PK1 stress of the weak form</a:t>
             </a:r>
           </a:p>
         </p:txBody>
@@ -22474,7 +22474,7 @@
                 <a:latin typeface="Arial"/>
                 <a:cs typeface="Arial"/>
               </a:rPr>
-              <a:t>Each step: no solve; the runtime </a:t>
+              <a:t>Each step needs no solve. The runtime </a:t>
             </a:r>
             <a:r>
               <a:rPr sz="1500" b="0" i="1">
@@ -23141,7 +23141,7 @@
                 <a:latin typeface="Arial"/>
                 <a:cs typeface="Arial"/>
               </a:rPr>
-              <a:t>Open-source multiphysics FE framework (Idaho National Laboratory): </a:t>
+              <a:t>Open-source multiphysics FE framework (Idaho National Laboratory). </a:t>
             </a:r>
             <a:r>
               <a:rPr sz="1550" b="1" i="0">
@@ -23151,7 +23151,7 @@
                 <a:latin typeface="Arial"/>
                 <a:cs typeface="Arial"/>
               </a:rPr>
-              <a:t>we keep all of this for free</a:t>
+              <a:t>We keep all of this for free</a:t>
             </a:r>
           </a:p>
         </p:txBody>

</xml_diff>

<commit_message>
slides: drop takeaways slide, remove dimensionality mentions
</commit_message>
<xml_diff>
--- a/examples/impact/slide_assets/WCCM_NEML2_explicit_dynamics_v2.pptx
+++ b/examples/impact/slide_assets/WCCM_NEML2_explicit_dynamics_v2.pptx
@@ -26,7 +26,6 @@
     <p:sldId id="271" r:id="rId25"/>
     <p:sldId id="272" r:id="rId26"/>
     <p:sldId id="273" r:id="rId27"/>
-    <p:sldId id="274" r:id="rId28"/>
   </p:sldIdLst>
   <p:sldSz cx="12192000" cy="6858000"/>
   <p:notesSz cx="6858000" cy="9144000"/>
@@ -6363,7 +6362,7 @@
                 <a:latin typeface="Arial"/>
                 <a:cs typeface="Arial"/>
               </a:rPr>
-              <a:t>10 / 19</a:t>
+              <a:t>10 / 18</a:t>
             </a:r>
           </a:p>
         </p:txBody>
@@ -8751,7 +8750,7 @@
                 <a:latin typeface="Arial"/>
                 <a:cs typeface="Arial"/>
               </a:rPr>
-              <a:t>11 / 19</a:t>
+              <a:t>11 / 18</a:t>
             </a:r>
           </a:p>
         </p:txBody>
@@ -9596,7 +9595,7 @@
                 <a:latin typeface="Arial"/>
                 <a:cs typeface="Arial"/>
               </a:rPr>
-              <a:t>12 / 19</a:t>
+              <a:t>12 / 18</a:t>
             </a:r>
           </a:p>
         </p:txBody>
@@ -11191,7 +11190,7 @@
                 <a:latin typeface="Arial"/>
                 <a:cs typeface="Arial"/>
               </a:rPr>
-              <a:t>13 / 19</a:t>
+              <a:t>13 / 18</a:t>
             </a:r>
           </a:p>
         </p:txBody>
@@ -12471,7 +12470,7 @@
                 <a:latin typeface="Arial"/>
                 <a:cs typeface="Arial"/>
               </a:rPr>
-              <a:t>14 / 19</a:t>
+              <a:t>14 / 18</a:t>
             </a:r>
           </a:p>
         </p:txBody>
@@ -13309,7 +13308,7 @@
           <a:p>
             <a:r>
               <a:rPr sz="2600"/>
-              <a:t>3-D Taylor anvil impact, end to end</a:t>
+              <a:t>Taylor anvil impact, end to end</a:t>
             </a:r>
           </a:p>
         </p:txBody>
@@ -13345,7 +13344,7 @@
                 <a:latin typeface="Arial"/>
                 <a:cs typeface="Arial"/>
               </a:rPr>
-              <a:t>15 / 19</a:t>
+              <a:t>15 / 18</a:t>
             </a:r>
           </a:p>
         </p:txBody>
@@ -13629,51 +13628,6 @@
                 <a:cs typeface="Arial"/>
               </a:rPr>
               <a:t> axial shortening</a:t>
-            </a:r>
-          </a:p>
-          <a:p>
-            <a:pPr marL="219456" indent="-219456">
-              <a:lnSpc>
-                <a:spcPct val="106000"/>
-              </a:lnSpc>
-              <a:spcAft>
-                <a:spcPts val="1000"/>
-              </a:spcAft>
-              <a:buClr>
-                <a:srgbClr val="06509D"/>
-              </a:buClr>
-              <a:buFont typeface="Arial"/>
-              <a:buChar char="•"/>
-            </a:pPr>
-            <a:r>
-              <a:rPr sz="1350" b="0" i="0">
-                <a:solidFill>
-                  <a:srgbClr val="3A3F47"/>
-                </a:solidFill>
-                <a:latin typeface="Arial"/>
-                <a:cs typeface="Arial"/>
-              </a:rPr>
-              <a:t>3-D full-hard shortening matches the calibrated axisymmetric model (</a:t>
-            </a:r>
-            <a:r>
-              <a:rPr sz="1350" b="1" i="0">
-                <a:solidFill>
-                  <a:srgbClr val="1E2430"/>
-                </a:solidFill>
-                <a:latin typeface="Arial"/>
-                <a:cs typeface="Arial"/>
-              </a:rPr>
-              <a:t>39.5%</a:t>
-            </a:r>
-            <a:r>
-              <a:rPr sz="1350" b="0" i="0">
-                <a:solidFill>
-                  <a:srgbClr val="3A3F47"/>
-                </a:solidFill>
-                <a:latin typeface="Arial"/>
-                <a:cs typeface="Arial"/>
-              </a:rPr>
-              <a:t>)</a:t>
             </a:r>
           </a:p>
         </p:txBody>
@@ -13749,7 +13703,7 @@
                 <a:latin typeface="Arial"/>
                 <a:cs typeface="Arial"/>
               </a:rPr>
-              <a:t>16 / 19</a:t>
+              <a:t>16 / 18</a:t>
             </a:r>
           </a:p>
         </p:txBody>
@@ -14457,7 +14411,7 @@
                 <a:latin typeface="Arial"/>
                 <a:cs typeface="Arial"/>
               </a:rPr>
-              <a:t>17 / 19</a:t>
+              <a:t>17 / 18</a:t>
             </a:r>
           </a:p>
         </p:txBody>
@@ -14951,7 +14905,7 @@
                 <a:latin typeface="Arial"/>
                 <a:cs typeface="Arial"/>
               </a:rPr>
-              <a:t>one production RZ simulation per point (~21 min each)</a:t>
+              <a:t>one production simulation per point (~21 min each)</a:t>
             </a:r>
           </a:p>
         </p:txBody>
@@ -15639,7 +15593,7 @@
                 <a:latin typeface="Arial"/>
                 <a:cs typeface="Arial"/>
               </a:rPr>
-              <a:t>18 / 19</a:t>
+              <a:t>18 / 18</a:t>
             </a:r>
           </a:p>
         </p:txBody>
@@ -15745,7 +15699,7 @@
                 <a:latin typeface="Arial"/>
                 <a:cs typeface="Arial"/>
               </a:rPr>
-              <a:t>final deformed profile, RZ production model at the calibrated posterior median</a:t>
+              <a:t>final deformed profile, production model at the calibrated posterior median</a:t>
             </a:r>
           </a:p>
         </p:txBody>
@@ -16180,880 +16134,6 @@
 </p:sld>
 </file>
 
-<file path=ppt/slides/slide19.xml><?xml version="1.0" encoding="utf-8"?>
-<p:sld xmlns:a="http://schemas.openxmlformats.org/drawingml/2006/main" xmlns:p="http://schemas.openxmlformats.org/presentationml/2006/main" xmlns:r="http://schemas.openxmlformats.org/officeDocument/2006/relationships">
-  <p:cSld>
-    <p:spTree>
-      <p:nvGrpSpPr>
-        <p:cNvPr id="1" name=""/>
-        <p:cNvGrpSpPr/>
-        <p:nvPr/>
-      </p:nvGrpSpPr>
-      <p:grpSpPr/>
-      <p:sp>
-        <p:nvSpPr>
-          <p:cNvPr id="2" name="Title 1"/>
-          <p:cNvSpPr>
-            <a:spLocks noGrp="1"/>
-          </p:cNvSpPr>
-          <p:nvPr>
-            <p:ph type="title"/>
-          </p:nvPr>
-        </p:nvSpPr>
-        <p:spPr/>
-        <p:txBody>
-          <a:bodyPr/>
-          <a:lstStyle/>
-          <a:p>
-            <a:r>
-              <a:rPr sz="2600"/>
-              <a:t>Takeaways</a:t>
-            </a:r>
-          </a:p>
-        </p:txBody>
-      </p:sp>
-      <p:sp>
-        <p:nvSpPr>
-          <p:cNvPr id="3" name="TextBox 2"/>
-          <p:cNvSpPr txBox="1"/>
-          <p:nvPr/>
-        </p:nvSpPr>
-        <p:spPr>
-          <a:xfrm>
-            <a:off x="11231575" y="274320"/>
-            <a:ext cx="685800" cy="228600"/>
-          </a:xfrm>
-          <a:prstGeom prst="rect">
-            <a:avLst/>
-          </a:prstGeom>
-          <a:noFill/>
-        </p:spPr>
-        <p:txBody>
-          <a:bodyPr wrap="square" anchor="t" lIns="0" rIns="0" tIns="0" bIns="0">
-            <a:spAutoFit/>
-          </a:bodyPr>
-          <a:lstStyle/>
-          <a:p>
-            <a:pPr algn="r"/>
-            <a:r>
-              <a:rPr sz="900" b="0" i="0">
-                <a:solidFill>
-                  <a:srgbClr val="59595C"/>
-                </a:solidFill>
-                <a:latin typeface="Arial"/>
-                <a:cs typeface="Arial"/>
-              </a:rPr>
-              <a:t>19 / 19</a:t>
-            </a:r>
-          </a:p>
-        </p:txBody>
-      </p:sp>
-      <p:sp>
-        <p:nvSpPr>
-          <p:cNvPr id="4" name="Rounded Rectangle 3"/>
-          <p:cNvSpPr/>
-          <p:nvPr/>
-        </p:nvSpPr>
-        <p:spPr>
-          <a:xfrm>
-            <a:off x="566928" y="1298448"/>
-            <a:ext cx="11057839" cy="841248"/>
-          </a:xfrm>
-          <a:prstGeom prst="roundRect">
-            <a:avLst>
-              <a:gd name="adj" fmla="val 5500"/>
-            </a:avLst>
-          </a:prstGeom>
-          <a:solidFill>
-            <a:srgbClr val="FFFFFF"/>
-          </a:solidFill>
-          <a:ln w="9525">
-            <a:solidFill>
-              <a:srgbClr val="DADDE2"/>
-            </a:solidFill>
-          </a:ln>
-          <a:effectLst/>
-        </p:spPr>
-        <p:style>
-          <a:lnRef idx="1">
-            <a:schemeClr val="accent1"/>
-          </a:lnRef>
-          <a:fillRef idx="3">
-            <a:schemeClr val="accent1"/>
-          </a:fillRef>
-          <a:effectRef idx="2">
-            <a:schemeClr val="accent1"/>
-          </a:effectRef>
-          <a:fontRef idx="minor">
-            <a:schemeClr val="lt1"/>
-          </a:fontRef>
-        </p:style>
-        <p:txBody>
-          <a:bodyPr rtlCol="0" anchor="ctr"/>
-          <a:lstStyle/>
-          <a:p>
-            <a:pPr algn="ctr"/>
-          </a:p>
-        </p:txBody>
-      </p:sp>
-      <p:sp>
-        <p:nvSpPr>
-          <p:cNvPr id="5" name="Rounded Rectangle 4"/>
-          <p:cNvSpPr/>
-          <p:nvPr/>
-        </p:nvSpPr>
-        <p:spPr>
-          <a:xfrm>
-            <a:off x="768096" y="1508760"/>
-            <a:ext cx="420624" cy="420624"/>
-          </a:xfrm>
-          <a:prstGeom prst="roundRect">
-            <a:avLst>
-              <a:gd name="adj" fmla="val 5500"/>
-            </a:avLst>
-          </a:prstGeom>
-          <a:solidFill>
-            <a:srgbClr val="06509D"/>
-          </a:solidFill>
-          <a:ln>
-            <a:noFill/>
-          </a:ln>
-          <a:effectLst/>
-        </p:spPr>
-        <p:style>
-          <a:lnRef idx="1">
-            <a:schemeClr val="accent1"/>
-          </a:lnRef>
-          <a:fillRef idx="3">
-            <a:schemeClr val="accent1"/>
-          </a:fillRef>
-          <a:effectRef idx="2">
-            <a:schemeClr val="accent1"/>
-          </a:effectRef>
-          <a:fontRef idx="minor">
-            <a:schemeClr val="lt1"/>
-          </a:fontRef>
-        </p:style>
-        <p:txBody>
-          <a:bodyPr rtlCol="0" anchor="ctr" wrap="square" lIns="54864" rIns="54864" tIns="27432" bIns="27432"/>
-          <a:lstStyle/>
-          <a:p>
-            <a:pPr algn="ctr"/>
-            <a:r>
-              <a:rPr sz="1600" b="1" i="0">
-                <a:solidFill>
-                  <a:srgbClr val="FFFFFF"/>
-                </a:solidFill>
-                <a:latin typeface="Arial"/>
-                <a:cs typeface="Arial"/>
-              </a:rPr>
-              <a:t>1</a:t>
-            </a:r>
-          </a:p>
-        </p:txBody>
-      </p:sp>
-      <p:sp>
-        <p:nvSpPr>
-          <p:cNvPr id="6" name="TextBox 5"/>
-          <p:cNvSpPr txBox="1"/>
-          <p:nvPr/>
-        </p:nvSpPr>
-        <p:spPr>
-          <a:xfrm>
-            <a:off x="1435608" y="1417320"/>
-            <a:ext cx="9869119" cy="320040"/>
-          </a:xfrm>
-          <a:prstGeom prst="rect">
-            <a:avLst/>
-          </a:prstGeom>
-          <a:noFill/>
-        </p:spPr>
-        <p:txBody>
-          <a:bodyPr wrap="square" anchor="t" lIns="0" rIns="0" tIns="0" bIns="0">
-            <a:spAutoFit/>
-          </a:bodyPr>
-          <a:lstStyle/>
-          <a:p>
-            <a:pPr algn="l"/>
-            <a:r>
-              <a:rPr sz="1550" b="1" i="0">
-                <a:solidFill>
-                  <a:srgbClr val="1E2430"/>
-                </a:solidFill>
-                <a:latin typeface="Arial"/>
-                <a:cs typeface="Arial"/>
-              </a:rPr>
-              <a:t>NEML2 assembles the internal nodal forces inside MOOSE explicit dynamics</a:t>
-            </a:r>
-          </a:p>
-        </p:txBody>
-      </p:sp>
-      <p:sp>
-        <p:nvSpPr>
-          <p:cNvPr id="7" name="TextBox 6"/>
-          <p:cNvSpPr txBox="1"/>
-          <p:nvPr/>
-        </p:nvSpPr>
-        <p:spPr>
-          <a:xfrm>
-            <a:off x="1435608" y="1773936"/>
-            <a:ext cx="9869119" cy="292608"/>
-          </a:xfrm>
-          <a:prstGeom prst="rect">
-            <a:avLst/>
-          </a:prstGeom>
-          <a:noFill/>
-        </p:spPr>
-        <p:txBody>
-          <a:bodyPr wrap="square" anchor="t" lIns="0" rIns="0" tIns="0" bIns="0">
-            <a:spAutoFit/>
-          </a:bodyPr>
-          <a:lstStyle/>
-          <a:p>
-            <a:pPr algn="l"/>
-            <a:r>
-              <a:rPr sz="1200" b="0" i="0">
-                <a:solidFill>
-                  <a:srgbClr val="59595C"/>
-                </a:solidFill>
-                <a:latin typeface="Arial"/>
-                <a:cs typeface="Arial"/>
-              </a:rPr>
-              <a:t>batched, device-resident; state advances in place; one upload + one download per step</a:t>
-            </a:r>
-          </a:p>
-        </p:txBody>
-      </p:sp>
-      <p:sp>
-        <p:nvSpPr>
-          <p:cNvPr id="8" name="Rounded Rectangle 7"/>
-          <p:cNvSpPr/>
-          <p:nvPr/>
-        </p:nvSpPr>
-        <p:spPr>
-          <a:xfrm>
-            <a:off x="566928" y="2267712"/>
-            <a:ext cx="11057839" cy="841248"/>
-          </a:xfrm>
-          <a:prstGeom prst="roundRect">
-            <a:avLst>
-              <a:gd name="adj" fmla="val 5500"/>
-            </a:avLst>
-          </a:prstGeom>
-          <a:solidFill>
-            <a:srgbClr val="FFFFFF"/>
-          </a:solidFill>
-          <a:ln w="9525">
-            <a:solidFill>
-              <a:srgbClr val="DADDE2"/>
-            </a:solidFill>
-          </a:ln>
-          <a:effectLst/>
-        </p:spPr>
-        <p:style>
-          <a:lnRef idx="1">
-            <a:schemeClr val="accent1"/>
-          </a:lnRef>
-          <a:fillRef idx="3">
-            <a:schemeClr val="accent1"/>
-          </a:fillRef>
-          <a:effectRef idx="2">
-            <a:schemeClr val="accent1"/>
-          </a:effectRef>
-          <a:fontRef idx="minor">
-            <a:schemeClr val="lt1"/>
-          </a:fontRef>
-        </p:style>
-        <p:txBody>
-          <a:bodyPr rtlCol="0" anchor="ctr"/>
-          <a:lstStyle/>
-          <a:p>
-            <a:pPr algn="ctr"/>
-          </a:p>
-        </p:txBody>
-      </p:sp>
-      <p:sp>
-        <p:nvSpPr>
-          <p:cNvPr id="9" name="Rounded Rectangle 8"/>
-          <p:cNvSpPr/>
-          <p:nvPr/>
-        </p:nvSpPr>
-        <p:spPr>
-          <a:xfrm>
-            <a:off x="768096" y="2478024"/>
-            <a:ext cx="420624" cy="420624"/>
-          </a:xfrm>
-          <a:prstGeom prst="roundRect">
-            <a:avLst>
-              <a:gd name="adj" fmla="val 5500"/>
-            </a:avLst>
-          </a:prstGeom>
-          <a:solidFill>
-            <a:srgbClr val="5E8614"/>
-          </a:solidFill>
-          <a:ln>
-            <a:noFill/>
-          </a:ln>
-          <a:effectLst/>
-        </p:spPr>
-        <p:style>
-          <a:lnRef idx="1">
-            <a:schemeClr val="accent1"/>
-          </a:lnRef>
-          <a:fillRef idx="3">
-            <a:schemeClr val="accent1"/>
-          </a:fillRef>
-          <a:effectRef idx="2">
-            <a:schemeClr val="accent1"/>
-          </a:effectRef>
-          <a:fontRef idx="minor">
-            <a:schemeClr val="lt1"/>
-          </a:fontRef>
-        </p:style>
-        <p:txBody>
-          <a:bodyPr rtlCol="0" anchor="ctr" wrap="square" lIns="54864" rIns="54864" tIns="27432" bIns="27432"/>
-          <a:lstStyle/>
-          <a:p>
-            <a:pPr algn="ctr"/>
-            <a:r>
-              <a:rPr sz="1600" b="1" i="0">
-                <a:solidFill>
-                  <a:srgbClr val="FFFFFF"/>
-                </a:solidFill>
-                <a:latin typeface="Arial"/>
-                <a:cs typeface="Arial"/>
-              </a:rPr>
-              <a:t>2</a:t>
-            </a:r>
-          </a:p>
-        </p:txBody>
-      </p:sp>
-      <p:sp>
-        <p:nvSpPr>
-          <p:cNvPr id="10" name="TextBox 9"/>
-          <p:cNvSpPr txBox="1"/>
-          <p:nvPr/>
-        </p:nvSpPr>
-        <p:spPr>
-          <a:xfrm>
-            <a:off x="1435608" y="2386584"/>
-            <a:ext cx="9869119" cy="320040"/>
-          </a:xfrm>
-          <a:prstGeom prst="rect">
-            <a:avLst/>
-          </a:prstGeom>
-          <a:noFill/>
-        </p:spPr>
-        <p:txBody>
-          <a:bodyPr wrap="square" anchor="t" lIns="0" rIns="0" tIns="0" bIns="0">
-            <a:spAutoFit/>
-          </a:bodyPr>
-          <a:lstStyle/>
-          <a:p>
-            <a:pPr algn="l"/>
-            <a:r>
-              <a:rPr sz="1550" b="1" i="0">
-                <a:solidFill>
-                  <a:srgbClr val="1E2430"/>
-                </a:solidFill>
-                <a:latin typeface="Arial"/>
-                <a:cs typeface="Arial"/>
-              </a:rPr>
-              <a:t>Verified to machine precision across formulations</a:t>
-            </a:r>
-          </a:p>
-        </p:txBody>
-      </p:sp>
-      <p:sp>
-        <p:nvSpPr>
-          <p:cNvPr id="11" name="TextBox 10"/>
-          <p:cNvSpPr txBox="1"/>
-          <p:nvPr/>
-        </p:nvSpPr>
-        <p:spPr>
-          <a:xfrm>
-            <a:off x="1435608" y="2743200"/>
-            <a:ext cx="9869119" cy="292608"/>
-          </a:xfrm>
-          <a:prstGeom prst="rect">
-            <a:avLst/>
-          </a:prstGeom>
-          <a:noFill/>
-        </p:spPr>
-        <p:txBody>
-          <a:bodyPr wrap="square" anchor="t" lIns="0" rIns="0" tIns="0" bIns="0">
-            <a:spAutoFit/>
-          </a:bodyPr>
-          <a:lstStyle/>
-          <a:p>
-            <a:pPr algn="l"/>
-            <a:r>
-              <a:rPr sz="1200" b="0" i="0">
-                <a:solidFill>
-                  <a:srgbClr val="59595C"/>
-                </a:solidFill>
-                <a:latin typeface="Arial"/>
-                <a:cs typeface="Arial"/>
-              </a:rPr>
-              <a:t>small strain → total-Lagrangian → multiplicative plasticity, Cartesian and axisymmetric, incl. F-bar</a:t>
-            </a:r>
-          </a:p>
-        </p:txBody>
-      </p:sp>
-      <p:sp>
-        <p:nvSpPr>
-          <p:cNvPr id="12" name="Rounded Rectangle 11"/>
-          <p:cNvSpPr/>
-          <p:nvPr/>
-        </p:nvSpPr>
-        <p:spPr>
-          <a:xfrm>
-            <a:off x="566928" y="3236976"/>
-            <a:ext cx="11057839" cy="841248"/>
-          </a:xfrm>
-          <a:prstGeom prst="roundRect">
-            <a:avLst>
-              <a:gd name="adj" fmla="val 5500"/>
-            </a:avLst>
-          </a:prstGeom>
-          <a:solidFill>
-            <a:srgbClr val="FFFFFF"/>
-          </a:solidFill>
-          <a:ln w="9525">
-            <a:solidFill>
-              <a:srgbClr val="DADDE2"/>
-            </a:solidFill>
-          </a:ln>
-          <a:effectLst/>
-        </p:spPr>
-        <p:style>
-          <a:lnRef idx="1">
-            <a:schemeClr val="accent1"/>
-          </a:lnRef>
-          <a:fillRef idx="3">
-            <a:schemeClr val="accent1"/>
-          </a:fillRef>
-          <a:effectRef idx="2">
-            <a:schemeClr val="accent1"/>
-          </a:effectRef>
-          <a:fontRef idx="minor">
-            <a:schemeClr val="lt1"/>
-          </a:fontRef>
-        </p:style>
-        <p:txBody>
-          <a:bodyPr rtlCol="0" anchor="ctr"/>
-          <a:lstStyle/>
-          <a:p>
-            <a:pPr algn="ctr"/>
-          </a:p>
-        </p:txBody>
-      </p:sp>
-      <p:sp>
-        <p:nvSpPr>
-          <p:cNvPr id="13" name="Rounded Rectangle 12"/>
-          <p:cNvSpPr/>
-          <p:nvPr/>
-        </p:nvSpPr>
-        <p:spPr>
-          <a:xfrm>
-            <a:off x="768096" y="3447288"/>
-            <a:ext cx="420624" cy="420624"/>
-          </a:xfrm>
-          <a:prstGeom prst="roundRect">
-            <a:avLst>
-              <a:gd name="adj" fmla="val 5500"/>
-            </a:avLst>
-          </a:prstGeom>
-          <a:solidFill>
-            <a:srgbClr val="CF1D4C"/>
-          </a:solidFill>
-          <a:ln>
-            <a:noFill/>
-          </a:ln>
-          <a:effectLst/>
-        </p:spPr>
-        <p:style>
-          <a:lnRef idx="1">
-            <a:schemeClr val="accent1"/>
-          </a:lnRef>
-          <a:fillRef idx="3">
-            <a:schemeClr val="accent1"/>
-          </a:fillRef>
-          <a:effectRef idx="2">
-            <a:schemeClr val="accent1"/>
-          </a:effectRef>
-          <a:fontRef idx="minor">
-            <a:schemeClr val="lt1"/>
-          </a:fontRef>
-        </p:style>
-        <p:txBody>
-          <a:bodyPr rtlCol="0" anchor="ctr" wrap="square" lIns="54864" rIns="54864" tIns="27432" bIns="27432"/>
-          <a:lstStyle/>
-          <a:p>
-            <a:pPr algn="ctr"/>
-            <a:r>
-              <a:rPr sz="1600" b="1" i="0">
-                <a:solidFill>
-                  <a:srgbClr val="FFFFFF"/>
-                </a:solidFill>
-                <a:latin typeface="Arial"/>
-                <a:cs typeface="Arial"/>
-              </a:rPr>
-              <a:t>3</a:t>
-            </a:r>
-          </a:p>
-        </p:txBody>
-      </p:sp>
-      <p:sp>
-        <p:nvSpPr>
-          <p:cNvPr id="14" name="TextBox 13"/>
-          <p:cNvSpPr txBox="1"/>
-          <p:nvPr/>
-        </p:nvSpPr>
-        <p:spPr>
-          <a:xfrm>
-            <a:off x="1435608" y="3355848"/>
-            <a:ext cx="9869119" cy="320040"/>
-          </a:xfrm>
-          <a:prstGeom prst="rect">
-            <a:avLst/>
-          </a:prstGeom>
-          <a:noFill/>
-        </p:spPr>
-        <p:txBody>
-          <a:bodyPr wrap="square" anchor="t" lIns="0" rIns="0" tIns="0" bIns="0">
-            <a:spAutoFit/>
-          </a:bodyPr>
-          <a:lstStyle/>
-          <a:p>
-            <a:pPr algn="l"/>
-            <a:r>
-              <a:rPr sz="1550" b="1" i="0">
-                <a:solidFill>
-                  <a:srgbClr val="1E2430"/>
-                </a:solidFill>
-                <a:latin typeface="Arial"/>
-                <a:cs typeface="Arial"/>
-              </a:rPr>
-              <a:t>Per-step cost is one batched constitutive call</a:t>
-            </a:r>
-          </a:p>
-        </p:txBody>
-      </p:sp>
-      <p:sp>
-        <p:nvSpPr>
-          <p:cNvPr id="15" name="TextBox 14"/>
-          <p:cNvSpPr txBox="1"/>
-          <p:nvPr/>
-        </p:nvSpPr>
-        <p:spPr>
-          <a:xfrm>
-            <a:off x="1435608" y="3712464"/>
-            <a:ext cx="9869119" cy="292608"/>
-          </a:xfrm>
-          <a:prstGeom prst="rect">
-            <a:avLst/>
-          </a:prstGeom>
-          <a:noFill/>
-        </p:spPr>
-        <p:txBody>
-          <a:bodyPr wrap="square" anchor="t" lIns="0" rIns="0" tIns="0" bIns="0">
-            <a:spAutoFit/>
-          </a:bodyPr>
-          <a:lstStyle/>
-          <a:p>
-            <a:pPr algn="l"/>
-            <a:r>
-              <a:rPr sz="1200" b="0" i="0">
-                <a:solidFill>
-                  <a:srgbClr val="59595C"/>
-                </a:solidFill>
-                <a:latin typeface="Arial"/>
-                <a:cs typeface="Arial"/>
-              </a:rPr>
-              <a:t>the element loop is provably empty after setup; reduced integration + knob-free hourglass control, 2.6× faster</a:t>
-            </a:r>
-          </a:p>
-        </p:txBody>
-      </p:sp>
-      <p:sp>
-        <p:nvSpPr>
-          <p:cNvPr id="16" name="Rounded Rectangle 15"/>
-          <p:cNvSpPr/>
-          <p:nvPr/>
-        </p:nvSpPr>
-        <p:spPr>
-          <a:xfrm>
-            <a:off x="566928" y="4206240"/>
-            <a:ext cx="11057839" cy="841248"/>
-          </a:xfrm>
-          <a:prstGeom prst="roundRect">
-            <a:avLst>
-              <a:gd name="adj" fmla="val 5500"/>
-            </a:avLst>
-          </a:prstGeom>
-          <a:solidFill>
-            <a:srgbClr val="FFFFFF"/>
-          </a:solidFill>
-          <a:ln w="9525">
-            <a:solidFill>
-              <a:srgbClr val="DADDE2"/>
-            </a:solidFill>
-          </a:ln>
-          <a:effectLst/>
-        </p:spPr>
-        <p:style>
-          <a:lnRef idx="1">
-            <a:schemeClr val="accent1"/>
-          </a:lnRef>
-          <a:fillRef idx="3">
-            <a:schemeClr val="accent1"/>
-          </a:fillRef>
-          <a:effectRef idx="2">
-            <a:schemeClr val="accent1"/>
-          </a:effectRef>
-          <a:fontRef idx="minor">
-            <a:schemeClr val="lt1"/>
-          </a:fontRef>
-        </p:style>
-        <p:txBody>
-          <a:bodyPr rtlCol="0" anchor="ctr"/>
-          <a:lstStyle/>
-          <a:p>
-            <a:pPr algn="ctr"/>
-          </a:p>
-        </p:txBody>
-      </p:sp>
-      <p:sp>
-        <p:nvSpPr>
-          <p:cNvPr id="17" name="Rounded Rectangle 16"/>
-          <p:cNvSpPr/>
-          <p:nvPr/>
-        </p:nvSpPr>
-        <p:spPr>
-          <a:xfrm>
-            <a:off x="768096" y="4416552"/>
-            <a:ext cx="420624" cy="420624"/>
-          </a:xfrm>
-          <a:prstGeom prst="roundRect">
-            <a:avLst>
-              <a:gd name="adj" fmla="val 5500"/>
-            </a:avLst>
-          </a:prstGeom>
-          <a:solidFill>
-            <a:srgbClr val="B4620B"/>
-          </a:solidFill>
-          <a:ln>
-            <a:noFill/>
-          </a:ln>
-          <a:effectLst/>
-        </p:spPr>
-        <p:style>
-          <a:lnRef idx="1">
-            <a:schemeClr val="accent1"/>
-          </a:lnRef>
-          <a:fillRef idx="3">
-            <a:schemeClr val="accent1"/>
-          </a:fillRef>
-          <a:effectRef idx="2">
-            <a:schemeClr val="accent1"/>
-          </a:effectRef>
-          <a:fontRef idx="minor">
-            <a:schemeClr val="lt1"/>
-          </a:fontRef>
-        </p:style>
-        <p:txBody>
-          <a:bodyPr rtlCol="0" anchor="ctr" wrap="square" lIns="54864" rIns="54864" tIns="27432" bIns="27432"/>
-          <a:lstStyle/>
-          <a:p>
-            <a:pPr algn="ctr"/>
-            <a:r>
-              <a:rPr sz="1600" b="1" i="0">
-                <a:solidFill>
-                  <a:srgbClr val="FFFFFF"/>
-                </a:solidFill>
-                <a:latin typeface="Arial"/>
-                <a:cs typeface="Arial"/>
-              </a:rPr>
-              <a:t>4</a:t>
-            </a:r>
-          </a:p>
-        </p:txBody>
-      </p:sp>
-      <p:sp>
-        <p:nvSpPr>
-          <p:cNvPr id="18" name="TextBox 17"/>
-          <p:cNvSpPr txBox="1"/>
-          <p:nvPr/>
-        </p:nvSpPr>
-        <p:spPr>
-          <a:xfrm>
-            <a:off x="1435608" y="4325112"/>
-            <a:ext cx="9869119" cy="320040"/>
-          </a:xfrm>
-          <a:prstGeom prst="rect">
-            <a:avLst/>
-          </a:prstGeom>
-          <a:noFill/>
-        </p:spPr>
-        <p:txBody>
-          <a:bodyPr wrap="square" anchor="t" lIns="0" rIns="0" tIns="0" bIns="0">
-            <a:spAutoFit/>
-          </a:bodyPr>
-          <a:lstStyle/>
-          <a:p>
-            <a:pPr algn="l"/>
-            <a:r>
-              <a:rPr sz="1550" b="1" i="0">
-                <a:solidFill>
-                  <a:srgbClr val="1E2430"/>
-                </a:solidFill>
-                <a:latin typeface="Arial"/>
-                <a:cs typeface="Arial"/>
-              </a:rPr>
-              <a:t>End-to-end on a real experiment</a:t>
-            </a:r>
-          </a:p>
-        </p:txBody>
-      </p:sp>
-      <p:sp>
-        <p:nvSpPr>
-          <p:cNvPr id="19" name="TextBox 18"/>
-          <p:cNvSpPr txBox="1"/>
-          <p:nvPr/>
-        </p:nvSpPr>
-        <p:spPr>
-          <a:xfrm>
-            <a:off x="1435608" y="4681728"/>
-            <a:ext cx="9869119" cy="292608"/>
-          </a:xfrm>
-          <a:prstGeom prst="rect">
-            <a:avLst/>
-          </a:prstGeom>
-          <a:noFill/>
-        </p:spPr>
-        <p:txBody>
-          <a:bodyPr wrap="square" anchor="t" lIns="0" rIns="0" tIns="0" bIns="0">
-            <a:spAutoFit/>
-          </a:bodyPr>
-          <a:lstStyle/>
-          <a:p>
-            <a:pPr algn="l"/>
-            <a:r>
-              <a:rPr sz="1200" b="0" i="0">
-                <a:solidFill>
-                  <a:srgbClr val="59595C"/>
-                </a:solidFill>
-                <a:latin typeface="Arial"/>
-                <a:cs typeface="Arial"/>
-              </a:rPr>
-              <a:t>3-D and RZ Taylor impact with in-model adiabatic heating; Bayesian-calibrated to 69 µm profile RMS against a scanned specimen</a:t>
-            </a:r>
-          </a:p>
-        </p:txBody>
-      </p:sp>
-      <p:sp>
-        <p:nvSpPr>
-          <p:cNvPr id="20" name="Rounded Rectangle 19"/>
-          <p:cNvSpPr/>
-          <p:nvPr/>
-        </p:nvSpPr>
-        <p:spPr>
-          <a:xfrm>
-            <a:off x="566928" y="5266944"/>
-            <a:ext cx="11057839" cy="731520"/>
-          </a:xfrm>
-          <a:prstGeom prst="roundRect">
-            <a:avLst>
-              <a:gd name="adj" fmla="val 5500"/>
-            </a:avLst>
-          </a:prstGeom>
-          <a:solidFill>
-            <a:srgbClr val="E6EEF7"/>
-          </a:solidFill>
-          <a:ln w="12700">
-            <a:solidFill>
-              <a:srgbClr val="06509D"/>
-            </a:solidFill>
-          </a:ln>
-          <a:effectLst/>
-        </p:spPr>
-        <p:style>
-          <a:lnRef idx="1">
-            <a:schemeClr val="accent1"/>
-          </a:lnRef>
-          <a:fillRef idx="3">
-            <a:schemeClr val="accent1"/>
-          </a:fillRef>
-          <a:effectRef idx="2">
-            <a:schemeClr val="accent1"/>
-          </a:effectRef>
-          <a:fontRef idx="minor">
-            <a:schemeClr val="lt1"/>
-          </a:fontRef>
-        </p:style>
-        <p:txBody>
-          <a:bodyPr rtlCol="0" anchor="ctr"/>
-          <a:lstStyle/>
-          <a:p>
-            <a:pPr algn="ctr"/>
-          </a:p>
-        </p:txBody>
-      </p:sp>
-      <p:sp>
-        <p:nvSpPr>
-          <p:cNvPr id="21" name="TextBox 20"/>
-          <p:cNvSpPr txBox="1"/>
-          <p:nvPr/>
-        </p:nvSpPr>
-        <p:spPr>
-          <a:xfrm>
-            <a:off x="841248" y="5266944"/>
-            <a:ext cx="10509199" cy="731520"/>
-          </a:xfrm>
-          <a:prstGeom prst="rect">
-            <a:avLst/>
-          </a:prstGeom>
-          <a:noFill/>
-        </p:spPr>
-        <p:txBody>
-          <a:bodyPr wrap="square" anchor="ctr" lIns="0" rIns="0" tIns="0" bIns="0">
-            <a:spAutoFit/>
-          </a:bodyPr>
-          <a:lstStyle/>
-          <a:p>
-            <a:pPr algn="l"/>
-            <a:r>
-              <a:rPr sz="1450" b="1" i="0">
-                <a:solidFill>
-                  <a:srgbClr val="06509D"/>
-                </a:solidFill>
-                <a:latin typeface="Arial"/>
-                <a:cs typeface="Arial"/>
-              </a:rPr>
-              <a:t>Open source, in MOOSE today.   Next:  </a:t>
-            </a:r>
-            <a:r>
-              <a:rPr sz="1450" b="0" i="0">
-                <a:solidFill>
-                  <a:srgbClr val="1E2430"/>
-                </a:solidFill>
-                <a:latin typeface="Arial"/>
-                <a:cs typeface="Arial"/>
-              </a:rPr>
-              <a:t>GPU scaling studies  ·  multi-velocity calibration  ·  3-D reduced-integration production runs</a:t>
-            </a:r>
-          </a:p>
-        </p:txBody>
-      </p:sp>
-    </p:spTree>
-  </p:cSld>
-  <p:clrMapOvr>
-    <a:masterClrMapping/>
-  </p:clrMapOvr>
-</p:sld>
-</file>
-
 <file path=ppt/slides/slide2.xml><?xml version="1.0" encoding="utf-8"?>
 <p:sld xmlns:a="http://schemas.openxmlformats.org/drawingml/2006/main" xmlns:p="http://schemas.openxmlformats.org/presentationml/2006/main" xmlns:r="http://schemas.openxmlformats.org/officeDocument/2006/relationships">
   <p:cSld>
@@ -17117,7 +16197,7 @@
                 <a:latin typeface="Arial"/>
                 <a:cs typeface="Arial"/>
               </a:rPr>
-              <a:t>2 / 19</a:t>
+              <a:t>2 / 18</a:t>
             </a:r>
           </a:p>
         </p:txBody>
@@ -18074,7 +17154,7 @@
                 <a:latin typeface="Arial"/>
                 <a:cs typeface="Arial"/>
               </a:rPr>
-              <a:t>3 / 19</a:t>
+              <a:t>3 / 18</a:t>
             </a:r>
           </a:p>
         </p:txBody>
@@ -18751,7 +17831,7 @@
                 <a:latin typeface="Arial"/>
                 <a:cs typeface="Arial"/>
               </a:rPr>
-              <a:t>4 / 19</a:t>
+              <a:t>4 / 18</a:t>
             </a:r>
           </a:p>
         </p:txBody>
@@ -19181,7 +18261,7 @@
                 <a:latin typeface="Arial"/>
                 <a:cs typeface="Arial"/>
               </a:rPr>
-              <a:t>5 / 19</a:t>
+              <a:t>5 / 18</a:t>
             </a:r>
           </a:p>
         </p:txBody>
@@ -19557,7 +18637,7 @@
                 <a:latin typeface="Arial"/>
                 <a:cs typeface="Arial"/>
               </a:rPr>
-              <a:t>6 / 19</a:t>
+              <a:t>6 / 18</a:t>
             </a:r>
           </a:p>
         </p:txBody>
@@ -20633,7 +19713,7 @@
                 <a:latin typeface="Arial"/>
                 <a:cs typeface="Arial"/>
               </a:rPr>
-              <a:t>7 / 19</a:t>
+              <a:t>7 / 18</a:t>
             </a:r>
           </a:p>
         </p:txBody>
@@ -21338,7 +20418,7 @@
                 <a:latin typeface="Arial"/>
                 <a:cs typeface="Arial"/>
               </a:rPr>
-              <a:t>8 / 19</a:t>
+              <a:t>8 / 18</a:t>
             </a:r>
           </a:p>
         </p:txBody>
@@ -21434,7 +20514,7 @@
                 <a:latin typeface="Arial"/>
                 <a:cs typeface="Arial"/>
               </a:rPr>
-              <a:t>element length over elastic wave speed (dilatational speed in 3-D)</a:t>
+              <a:t>element length over elastic wave speed</a:t>
             </a:r>
           </a:p>
         </p:txBody>
@@ -22198,7 +21278,7 @@
                 <a:latin typeface="Arial"/>
                 <a:cs typeface="Arial"/>
               </a:rPr>
-              <a:t>9 / 19</a:t>
+              <a:t>9 / 18</a:t>
             </a:r>
           </a:p>
         </p:txBody>

</xml_diff>

<commit_message>
slides: drop divider line in parameter card
</commit_message>
<xml_diff>
--- a/examples/impact/slide_assets/WCCM_NEML2_explicit_dynamics_v2.pptx
+++ b/examples/impact/slide_assets/WCCM_NEML2_explicit_dynamics_v2.pptx
@@ -19482,45 +19482,9 @@
           </a:p>
         </p:txBody>
       </p:sp>
-      <p:cxnSp>
-        <p:nvCxnSpPr>
-          <p:cNvPr id="28" name="Connector 27"/>
-          <p:cNvCxnSpPr/>
-          <p:nvPr/>
-        </p:nvCxnSpPr>
-        <p:spPr>
-          <a:xfrm>
-            <a:off x="8513064" y="2834640"/>
-            <a:ext cx="2892247" cy="0"/>
-          </a:xfrm>
-          <a:prstGeom prst="line">
-            <a:avLst/>
-          </a:prstGeom>
-          <a:ln w="9525">
-            <a:solidFill>
-              <a:srgbClr val="DADDE2"/>
-            </a:solidFill>
-          </a:ln>
-          <a:effectLst/>
-        </p:spPr>
-        <p:style>
-          <a:lnRef idx="2">
-            <a:schemeClr val="accent1"/>
-          </a:lnRef>
-          <a:fillRef idx="0">
-            <a:schemeClr val="accent1"/>
-          </a:fillRef>
-          <a:effectRef idx="1">
-            <a:schemeClr val="accent1"/>
-          </a:effectRef>
-          <a:fontRef idx="minor">
-            <a:schemeClr val="tx1"/>
-          </a:fontRef>
-        </p:style>
-      </p:cxnSp>
-      <p:sp>
-        <p:nvSpPr>
-          <p:cNvPr id="29" name="TextBox 28"/>
+      <p:sp>
+        <p:nvSpPr>
+          <p:cNvPr id="28" name="TextBox 27"/>
           <p:cNvSpPr txBox="1"/>
           <p:nvPr/>
         </p:nvSpPr>
@@ -19560,7 +19524,7 @@
       </p:sp>
       <p:sp>
         <p:nvSpPr>
-          <p:cNvPr id="30" name="Rounded Rectangle 29"/>
+          <p:cNvPr id="29" name="Rounded Rectangle 28"/>
           <p:cNvSpPr/>
           <p:nvPr/>
         </p:nvSpPr>
@@ -19608,7 +19572,7 @@
       </p:sp>
       <p:sp>
         <p:nvSpPr>
-          <p:cNvPr id="31" name="TextBox 30"/>
+          <p:cNvPr id="30" name="TextBox 29"/>
           <p:cNvSpPr txBox="1"/>
           <p:nvPr/>
         </p:nvSpPr>

</xml_diff>

<commit_message>
slides: experiment/video slide, prior-posterior strips, large-deformation force path
</commit_message>
<xml_diff>
--- a/examples/impact/slide_assets/WCCM_NEML2_explicit_dynamics_v2.pptx
+++ b/examples/impact/slide_assets/WCCM_NEML2_explicit_dynamics_v2.pptx
@@ -26,6 +26,7 @@
     <p:sldId id="271" r:id="rId25"/>
     <p:sldId id="272" r:id="rId26"/>
     <p:sldId id="273" r:id="rId27"/>
+    <p:sldId id="274" r:id="rId28"/>
   </p:sldIdLst>
   <p:sldSz cx="12192000" cy="6858000"/>
   <p:notesSz cx="6858000" cy="9144000"/>
@@ -6362,7 +6363,7 @@
                 <a:latin typeface="Arial"/>
                 <a:cs typeface="Arial"/>
               </a:rPr>
-              <a:t>10 / 18</a:t>
+              <a:t>10 / 19</a:t>
             </a:r>
           </a:p>
         </p:txBody>
@@ -8750,7 +8751,7 @@
                 <a:latin typeface="Arial"/>
                 <a:cs typeface="Arial"/>
               </a:rPr>
-              <a:t>11 / 18</a:t>
+              <a:t>11 / 19</a:t>
             </a:r>
           </a:p>
         </p:txBody>
@@ -9595,7 +9596,7 @@
                 <a:latin typeface="Arial"/>
                 <a:cs typeface="Arial"/>
               </a:rPr>
-              <a:t>12 / 18</a:t>
+              <a:t>12 / 19</a:t>
             </a:r>
           </a:p>
         </p:txBody>
@@ -10171,7 +10172,7 @@
                 <a:latin typeface="Consolas"/>
                 <a:cs typeface="Consolas"/>
               </a:rPr>
-              <a:t>NEML2</a:t>
+              <a:t>NEML2Def</a:t>
             </a:r>
           </a:p>
           <a:p>
@@ -10188,7 +10189,7 @@
                 <a:latin typeface="Consolas"/>
                 <a:cs typeface="Consolas"/>
               </a:rPr>
-              <a:t>SmallStrain</a:t>
+              <a:t>Gradient</a:t>
             </a:r>
           </a:p>
           <a:p>
@@ -10205,7 +10206,7 @@
                 <a:latin typeface="Arial"/>
                 <a:cs typeface="Arial"/>
               </a:rPr>
-              <a:t>ε = sym ∇u</a:t>
+              <a:t>F = I + ∂u/∂X</a:t>
             </a:r>
           </a:p>
           <a:p>
@@ -10392,7 +10393,7 @@
                 <a:latin typeface="Arial"/>
                 <a:cs typeface="Arial"/>
               </a:rPr>
-              <a:t>σ = model(ε, state)</a:t>
+              <a:t>P = model(F, state)</a:t>
             </a:r>
           </a:p>
           <a:p>
@@ -10579,7 +10580,7 @@
                 <a:latin typeface="Arial"/>
                 <a:cs typeface="Arial"/>
               </a:rPr>
-              <a:t>Rᵉ = Σ ∇φ·σ JxW</a:t>
+              <a:t>Rᵉ = Σ ∇φ·P JxW</a:t>
             </a:r>
           </a:p>
           <a:p>
@@ -11190,7 +11191,7 @@
                 <a:latin typeface="Arial"/>
                 <a:cs typeface="Arial"/>
               </a:rPr>
-              <a:t>13 / 18</a:t>
+              <a:t>13 / 19</a:t>
             </a:r>
           </a:p>
         </p:txBody>
@@ -12470,7 +12471,7 @@
                 <a:latin typeface="Arial"/>
                 <a:cs typeface="Arial"/>
               </a:rPr>
-              <a:t>14 / 18</a:t>
+              <a:t>14 / 19</a:t>
             </a:r>
           </a:p>
         </p:txBody>
@@ -13268,7 +13269,7 @@
                 <a:latin typeface="Arial"/>
                 <a:cs typeface="Arial"/>
               </a:rPr>
-              <a:t>Taylor impact and coupled thermo-mechanics  ·  calibration against a scanned specimen</a:t>
+              <a:t>the experiment  ·  Taylor impact simulation  ·  calibration against the scanned specimen</a:t>
             </a:r>
           </a:p>
         </p:txBody>
@@ -13308,7 +13309,7 @@
           <a:p>
             <a:r>
               <a:rPr sz="2600"/>
-              <a:t>Taylor anvil impact, end to end</a:t>
+              <a:t>The experiment</a:t>
             </a:r>
           </a:p>
         </p:txBody>
@@ -13344,21 +13345,67 @@
                 <a:latin typeface="Arial"/>
                 <a:cs typeface="Arial"/>
               </a:rPr>
-              <a:t>15 / 18</a:t>
-            </a:r>
-          </a:p>
-        </p:txBody>
-      </p:sp>
-      <p:sp>
-        <p:nvSpPr>
-          <p:cNvPr id="4" name="TextBox 3"/>
+              <a:t>15 / 19</a:t>
+            </a:r>
+          </a:p>
+        </p:txBody>
+      </p:sp>
+      <p:sp>
+        <p:nvSpPr>
+          <p:cNvPr id="4" name="Rounded Rectangle 3"/>
+          <p:cNvSpPr/>
+          <p:nvPr/>
+        </p:nvSpPr>
+        <p:spPr>
+          <a:xfrm>
+            <a:off x="566928" y="1371600"/>
+            <a:ext cx="7223760" cy="4063365"/>
+          </a:xfrm>
+          <a:prstGeom prst="roundRect">
+            <a:avLst>
+              <a:gd name="adj" fmla="val 5500"/>
+            </a:avLst>
+          </a:prstGeom>
+          <a:solidFill>
+            <a:srgbClr val="1E2430"/>
+          </a:solidFill>
+          <a:ln>
+            <a:noFill/>
+          </a:ln>
+          <a:effectLst/>
+        </p:spPr>
+        <p:style>
+          <a:lnRef idx="1">
+            <a:schemeClr val="accent1"/>
+          </a:lnRef>
+          <a:fillRef idx="3">
+            <a:schemeClr val="accent1"/>
+          </a:fillRef>
+          <a:effectRef idx="2">
+            <a:schemeClr val="accent1"/>
+          </a:effectRef>
+          <a:fontRef idx="minor">
+            <a:schemeClr val="lt1"/>
+          </a:fontRef>
+        </p:style>
+        <p:txBody>
+          <a:bodyPr rtlCol="0" anchor="ctr"/>
+          <a:lstStyle/>
+          <a:p>
+            <a:pPr algn="ctr"/>
+          </a:p>
+        </p:txBody>
+      </p:sp>
+      <p:sp>
+        <p:nvSpPr>
+          <p:cNvPr id="5" name="TextBox 4"/>
           <p:cNvSpPr txBox="1"/>
           <p:nvPr/>
         </p:nvSpPr>
         <p:spPr>
           <a:xfrm>
-            <a:off x="566928" y="1133856"/>
-            <a:ext cx="11057839" cy="320040"/>
+            <a:off x="566928" y="2900362"/>
+            <a:ext cx="7223760" cy="640080"/>
           </a:xfrm>
           <a:prstGeom prst="rect">
             <a:avLst/>
@@ -13371,74 +13418,20 @@
           </a:bodyPr>
           <a:lstStyle/>
           <a:p>
-            <a:pPr algn="l"/>
-            <a:r>
-              <a:rPr sz="1450" b="0" i="0">
-                <a:solidFill>
-                  <a:srgbClr val="3A3F47"/>
-                </a:solidFill>
-                <a:latin typeface="Arial"/>
-                <a:cs typeface="Arial"/>
-              </a:rPr>
-              <a:t>OFHC copper slug at </a:t>
-            </a:r>
-            <a:r>
-              <a:rPr sz="1450" b="1" i="0">
-                <a:solidFill>
-                  <a:srgbClr val="1E2430"/>
-                </a:solidFill>
-                <a:latin typeface="Arial"/>
-                <a:cs typeface="Arial"/>
-              </a:rPr>
-              <a:t>235.9 m/s</a:t>
-            </a:r>
-            <a:r>
-              <a:rPr sz="1450" b="0" i="0">
-                <a:solidFill>
-                  <a:srgbClr val="3A3F47"/>
-                </a:solidFill>
-                <a:latin typeface="Arial"/>
-                <a:cs typeface="Arial"/>
-              </a:rPr>
-              <a:t> · calibrated multiplicative Johnson–Cook · reduced integration · Δt = 10 ns · </a:t>
-            </a:r>
-            <a:r>
-              <a:rPr sz="1450" b="1" i="0">
-                <a:solidFill>
-                  <a:srgbClr val="1E2430"/>
-                </a:solidFill>
-                <a:latin typeface="Arial"/>
-                <a:cs typeface="Arial"/>
-              </a:rPr>
-              <a:t>9,600+ explicit steps</a:t>
-            </a:r>
-          </a:p>
-        </p:txBody>
-      </p:sp>
-      <p:pic>
-        <p:nvPicPr>
-          <p:cNvPr id="5" name="Picture 4" descr="fig_pstrain.png"/>
-          <p:cNvPicPr>
-            <a:picLocks noChangeAspect="1"/>
-          </p:cNvPicPr>
-          <p:nvPr/>
-        </p:nvPicPr>
-        <p:blipFill>
-          <a:blip r:embed="rId2"/>
-          <a:stretch>
-            <a:fillRect/>
-          </a:stretch>
-        </p:blipFill>
-        <p:spPr>
-          <a:xfrm>
-            <a:off x="1115568" y="1627632"/>
-            <a:ext cx="8778240" cy="2259290"/>
-          </a:xfrm>
-          <a:prstGeom prst="rect">
-            <a:avLst/>
-          </a:prstGeom>
-        </p:spPr>
-      </p:pic>
+            <a:pPr algn="ctr"/>
+            <a:r>
+              <a:rPr sz="4000" b="0" i="0">
+                <a:solidFill>
+                  <a:srgbClr val="FFFFFF"/>
+                </a:solidFill>
+                <a:latin typeface="Arial"/>
+                <a:cs typeface="Arial"/>
+              </a:rPr>
+              <a:t>▶</a:t>
+            </a:r>
+          </a:p>
+        </p:txBody>
+      </p:sp>
       <p:sp>
         <p:nvSpPr>
           <p:cNvPr id="6" name="TextBox 5"/>
@@ -13447,8 +13440,8 @@
         </p:nvSpPr>
         <p:spPr>
           <a:xfrm>
-            <a:off x="1207008" y="3914354"/>
-            <a:ext cx="10058400" cy="256032"/>
+            <a:off x="566928" y="3540442"/>
+            <a:ext cx="7223760" cy="320040"/>
           </a:xfrm>
           <a:prstGeom prst="rect">
             <a:avLst/>
@@ -13461,54 +13454,30 @@
           </a:bodyPr>
           <a:lstStyle/>
           <a:p>
-            <a:pPr algn="l"/>
-            <a:r>
-              <a:rPr sz="1100" b="0" i="1">
-                <a:solidFill>
-                  <a:srgbClr val="59595C"/>
-                </a:solidFill>
-                <a:latin typeface="Arial"/>
-                <a:cs typeface="Arial"/>
-              </a:rPr>
-              <a:t>cutaway views (near half removed). Plastic strain localizes at the impact foot. The gray plane is the rigid anvil</a:t>
-            </a:r>
-          </a:p>
-        </p:txBody>
-      </p:sp>
-      <p:pic>
-        <p:nvPicPr>
-          <p:cNvPr id="7" name="Picture 6" descr="fig_profile.png"/>
-          <p:cNvPicPr>
-            <a:picLocks noChangeAspect="1"/>
-          </p:cNvPicPr>
-          <p:nvPr/>
-        </p:nvPicPr>
-        <p:blipFill>
-          <a:blip r:embed="rId3"/>
-          <a:stretch>
-            <a:fillRect/>
-          </a:stretch>
-        </p:blipFill>
-        <p:spPr>
-          <a:xfrm>
-            <a:off x="566928" y="4179530"/>
-            <a:ext cx="3931920" cy="1438444"/>
-          </a:xfrm>
-          <a:prstGeom prst="rect">
-            <a:avLst/>
-          </a:prstGeom>
-        </p:spPr>
-      </p:pic>
-      <p:sp>
-        <p:nvSpPr>
-          <p:cNvPr id="8" name="TextBox 7"/>
+            <a:pPr algn="ctr"/>
+            <a:r>
+              <a:rPr sz="1200" b="0" i="1">
+                <a:solidFill>
+                  <a:srgbClr val="B6BABF"/>
+                </a:solidFill>
+                <a:latin typeface="Arial"/>
+                <a:cs typeface="Arial"/>
+              </a:rPr>
+              <a:t>high-speed video placeholder</a:t>
+            </a:r>
+          </a:p>
+        </p:txBody>
+      </p:sp>
+      <p:sp>
+        <p:nvSpPr>
+          <p:cNvPr id="7" name="TextBox 6"/>
           <p:cNvSpPr txBox="1"/>
           <p:nvPr/>
         </p:nvSpPr>
         <p:spPr>
           <a:xfrm>
-            <a:off x="4956048" y="4270970"/>
-            <a:ext cx="6668719" cy="1529884"/>
+            <a:off x="658368" y="5508117"/>
+            <a:ext cx="7223760" cy="256032"/>
           </a:xfrm>
           <a:prstGeom prst="rect">
             <a:avLst/>
@@ -13516,118 +13485,693 @@
           <a:noFill/>
         </p:spPr>
         <p:txBody>
-          <a:bodyPr wrap="square" lIns="0" rIns="0" tIns="0" bIns="0">
+          <a:bodyPr wrap="square" anchor="t" lIns="0" rIns="0" tIns="0" bIns="0">
             <a:spAutoFit/>
           </a:bodyPr>
           <a:lstStyle/>
           <a:p>
-            <a:pPr marL="219456" indent="-219456">
+            <a:pPr algn="l"/>
+            <a:r>
+              <a:rPr sz="1050" b="0" i="1">
+                <a:solidFill>
+                  <a:srgbClr val="59595C"/>
+                </a:solidFill>
+                <a:latin typeface="Arial"/>
+                <a:cs typeface="Arial"/>
+              </a:rPr>
+              <a:t>impact and rebound of shot CuH04, high-speed camera</a:t>
+            </a:r>
+          </a:p>
+        </p:txBody>
+      </p:sp>
+      <p:sp>
+        <p:nvSpPr>
+          <p:cNvPr id="8" name="Rounded Rectangle 7"/>
+          <p:cNvSpPr/>
+          <p:nvPr/>
+        </p:nvSpPr>
+        <p:spPr>
+          <a:xfrm>
+            <a:off x="8247888" y="1371600"/>
+            <a:ext cx="3376879" cy="914400"/>
+          </a:xfrm>
+          <a:prstGeom prst="roundRect">
+            <a:avLst>
+              <a:gd name="adj" fmla="val 5500"/>
+            </a:avLst>
+          </a:prstGeom>
+          <a:solidFill>
+            <a:srgbClr val="FFFFFF"/>
+          </a:solidFill>
+          <a:ln w="9525">
+            <a:solidFill>
+              <a:srgbClr val="DADDE2"/>
+            </a:solidFill>
+          </a:ln>
+          <a:effectLst/>
+        </p:spPr>
+        <p:style>
+          <a:lnRef idx="1">
+            <a:schemeClr val="accent1"/>
+          </a:lnRef>
+          <a:fillRef idx="3">
+            <a:schemeClr val="accent1"/>
+          </a:fillRef>
+          <a:effectRef idx="2">
+            <a:schemeClr val="accent1"/>
+          </a:effectRef>
+          <a:fontRef idx="minor">
+            <a:schemeClr val="lt1"/>
+          </a:fontRef>
+        </p:style>
+        <p:txBody>
+          <a:bodyPr rtlCol="0" anchor="ctr"/>
+          <a:lstStyle/>
+          <a:p>
+            <a:pPr algn="ctr"/>
+          </a:p>
+        </p:txBody>
+      </p:sp>
+      <p:sp>
+        <p:nvSpPr>
+          <p:cNvPr id="9" name="Rectangle 8"/>
+          <p:cNvSpPr/>
+          <p:nvPr/>
+        </p:nvSpPr>
+        <p:spPr>
+          <a:xfrm>
+            <a:off x="8247888" y="1463040"/>
+            <a:ext cx="50292" cy="731520"/>
+          </a:xfrm>
+          <a:prstGeom prst="rect">
+            <a:avLst/>
+          </a:prstGeom>
+          <a:solidFill>
+            <a:srgbClr val="06509D"/>
+          </a:solidFill>
+          <a:ln>
+            <a:noFill/>
+          </a:ln>
+          <a:effectLst/>
+        </p:spPr>
+        <p:style>
+          <a:lnRef idx="1">
+            <a:schemeClr val="accent1"/>
+          </a:lnRef>
+          <a:fillRef idx="3">
+            <a:schemeClr val="accent1"/>
+          </a:fillRef>
+          <a:effectRef idx="2">
+            <a:schemeClr val="accent1"/>
+          </a:effectRef>
+          <a:fontRef idx="minor">
+            <a:schemeClr val="lt1"/>
+          </a:fontRef>
+        </p:style>
+        <p:txBody>
+          <a:bodyPr rtlCol="0" anchor="ctr"/>
+          <a:lstStyle/>
+          <a:p>
+            <a:pPr algn="ctr"/>
+          </a:p>
+        </p:txBody>
+      </p:sp>
+      <p:sp>
+        <p:nvSpPr>
+          <p:cNvPr id="10" name="TextBox 9"/>
+          <p:cNvSpPr txBox="1"/>
+          <p:nvPr/>
+        </p:nvSpPr>
+        <p:spPr>
+          <a:xfrm>
+            <a:off x="8467344" y="1463040"/>
+            <a:ext cx="2965399" cy="274320"/>
+          </a:xfrm>
+          <a:prstGeom prst="rect">
+            <a:avLst/>
+          </a:prstGeom>
+          <a:noFill/>
+        </p:spPr>
+        <p:txBody>
+          <a:bodyPr wrap="square" anchor="t" lIns="0" rIns="0" tIns="0" bIns="0">
+            <a:spAutoFit/>
+          </a:bodyPr>
+          <a:lstStyle/>
+          <a:p>
+            <a:pPr algn="l"/>
+            <a:r>
+              <a:rPr sz="1250" b="1" i="0">
+                <a:solidFill>
+                  <a:srgbClr val="1E2430"/>
+                </a:solidFill>
+                <a:latin typeface="Arial"/>
+                <a:cs typeface="Arial"/>
+              </a:rPr>
+              <a:t>Specimen</a:t>
+            </a:r>
+          </a:p>
+        </p:txBody>
+      </p:sp>
+      <p:sp>
+        <p:nvSpPr>
+          <p:cNvPr id="11" name="TextBox 10"/>
+          <p:cNvSpPr txBox="1"/>
+          <p:nvPr/>
+        </p:nvSpPr>
+        <p:spPr>
+          <a:xfrm>
+            <a:off x="8467344" y="1755648"/>
+            <a:ext cx="2965399" cy="502920"/>
+          </a:xfrm>
+          <a:prstGeom prst="rect">
+            <a:avLst/>
+          </a:prstGeom>
+          <a:noFill/>
+        </p:spPr>
+        <p:txBody>
+          <a:bodyPr wrap="square" anchor="t" lIns="0" rIns="0" tIns="0" bIns="0">
+            <a:spAutoFit/>
+          </a:bodyPr>
+          <a:lstStyle/>
+          <a:p>
+            <a:pPr algn="l">
               <a:lnSpc>
-                <a:spcPct val="106000"/>
+                <a:spcPct val="110000"/>
               </a:lnSpc>
-              <a:spcAft>
-                <a:spcPts val="1000"/>
-              </a:spcAft>
-              <a:buClr>
-                <a:srgbClr val="06509D"/>
-              </a:buClr>
-              <a:buFont typeface="Arial"/>
-              <a:buChar char="•"/>
             </a:pPr>
             <a:r>
-              <a:rPr sz="1350" b="0" i="0">
+              <a:rPr sz="1100" b="0" i="0">
                 <a:solidFill>
                   <a:srgbClr val="3A3F47"/>
                 </a:solidFill>
                 <a:latin typeface="Arial"/>
                 <a:cs typeface="Arial"/>
               </a:rPr>
-              <a:t>Same mesh, BCs, integrator. The temper is swapped by </a:t>
-            </a:r>
-            <a:r>
-              <a:rPr sz="1350" b="1" i="0">
+              <a:t>OFHC copper slug, Ø 7.62 mm × 38.1 mm, H04 full-hard temper</a:t>
+            </a:r>
+          </a:p>
+        </p:txBody>
+      </p:sp>
+      <p:sp>
+        <p:nvSpPr>
+          <p:cNvPr id="12" name="Rounded Rectangle 11"/>
+          <p:cNvSpPr/>
+          <p:nvPr/>
+        </p:nvSpPr>
+        <p:spPr>
+          <a:xfrm>
+            <a:off x="8247888" y="2414015"/>
+            <a:ext cx="3376879" cy="914400"/>
+          </a:xfrm>
+          <a:prstGeom prst="roundRect">
+            <a:avLst>
+              <a:gd name="adj" fmla="val 5500"/>
+            </a:avLst>
+          </a:prstGeom>
+          <a:solidFill>
+            <a:srgbClr val="FFFFFF"/>
+          </a:solidFill>
+          <a:ln w="9525">
+            <a:solidFill>
+              <a:srgbClr val="DADDE2"/>
+            </a:solidFill>
+          </a:ln>
+          <a:effectLst/>
+        </p:spPr>
+        <p:style>
+          <a:lnRef idx="1">
+            <a:schemeClr val="accent1"/>
+          </a:lnRef>
+          <a:fillRef idx="3">
+            <a:schemeClr val="accent1"/>
+          </a:fillRef>
+          <a:effectRef idx="2">
+            <a:schemeClr val="accent1"/>
+          </a:effectRef>
+          <a:fontRef idx="minor">
+            <a:schemeClr val="lt1"/>
+          </a:fontRef>
+        </p:style>
+        <p:txBody>
+          <a:bodyPr rtlCol="0" anchor="ctr"/>
+          <a:lstStyle/>
+          <a:p>
+            <a:pPr algn="ctr"/>
+          </a:p>
+        </p:txBody>
+      </p:sp>
+      <p:sp>
+        <p:nvSpPr>
+          <p:cNvPr id="13" name="Rectangle 12"/>
+          <p:cNvSpPr/>
+          <p:nvPr/>
+        </p:nvSpPr>
+        <p:spPr>
+          <a:xfrm>
+            <a:off x="8247888" y="2505455"/>
+            <a:ext cx="50292" cy="731520"/>
+          </a:xfrm>
+          <a:prstGeom prst="rect">
+            <a:avLst/>
+          </a:prstGeom>
+          <a:solidFill>
+            <a:srgbClr val="06509D"/>
+          </a:solidFill>
+          <a:ln>
+            <a:noFill/>
+          </a:ln>
+          <a:effectLst/>
+        </p:spPr>
+        <p:style>
+          <a:lnRef idx="1">
+            <a:schemeClr val="accent1"/>
+          </a:lnRef>
+          <a:fillRef idx="3">
+            <a:schemeClr val="accent1"/>
+          </a:fillRef>
+          <a:effectRef idx="2">
+            <a:schemeClr val="accent1"/>
+          </a:effectRef>
+          <a:fontRef idx="minor">
+            <a:schemeClr val="lt1"/>
+          </a:fontRef>
+        </p:style>
+        <p:txBody>
+          <a:bodyPr rtlCol="0" anchor="ctr"/>
+          <a:lstStyle/>
+          <a:p>
+            <a:pPr algn="ctr"/>
+          </a:p>
+        </p:txBody>
+      </p:sp>
+      <p:sp>
+        <p:nvSpPr>
+          <p:cNvPr id="14" name="TextBox 13"/>
+          <p:cNvSpPr txBox="1"/>
+          <p:nvPr/>
+        </p:nvSpPr>
+        <p:spPr>
+          <a:xfrm>
+            <a:off x="8467344" y="2505455"/>
+            <a:ext cx="2965399" cy="274320"/>
+          </a:xfrm>
+          <a:prstGeom prst="rect">
+            <a:avLst/>
+          </a:prstGeom>
+          <a:noFill/>
+        </p:spPr>
+        <p:txBody>
+          <a:bodyPr wrap="square" anchor="t" lIns="0" rIns="0" tIns="0" bIns="0">
+            <a:spAutoFit/>
+          </a:bodyPr>
+          <a:lstStyle/>
+          <a:p>
+            <a:pPr algn="l"/>
+            <a:r>
+              <a:rPr sz="1250" b="1" i="0">
+                <a:solidFill>
+                  <a:srgbClr val="1E2430"/>
+                </a:solidFill>
+                <a:latin typeface="Arial"/>
+                <a:cs typeface="Arial"/>
+              </a:rPr>
+              <a:t>Shot</a:t>
+            </a:r>
+          </a:p>
+        </p:txBody>
+      </p:sp>
+      <p:sp>
+        <p:nvSpPr>
+          <p:cNvPr id="15" name="TextBox 14"/>
+          <p:cNvSpPr txBox="1"/>
+          <p:nvPr/>
+        </p:nvSpPr>
+        <p:spPr>
+          <a:xfrm>
+            <a:off x="8467344" y="2798063"/>
+            <a:ext cx="2965399" cy="502920"/>
+          </a:xfrm>
+          <a:prstGeom prst="rect">
+            <a:avLst/>
+          </a:prstGeom>
+          <a:noFill/>
+        </p:spPr>
+        <p:txBody>
+          <a:bodyPr wrap="square" anchor="t" lIns="0" rIns="0" tIns="0" bIns="0">
+            <a:spAutoFit/>
+          </a:bodyPr>
+          <a:lstStyle/>
+          <a:p>
+            <a:pPr algn="l">
+              <a:lnSpc>
+                <a:spcPct val="110000"/>
+              </a:lnSpc>
+            </a:pPr>
+            <a:r>
+              <a:rPr sz="1100" b="0" i="0">
                 <a:solidFill>
                   <a:srgbClr val="3A3F47"/>
                 </a:solidFill>
                 <a:latin typeface="Arial"/>
                 <a:cs typeface="Arial"/>
               </a:rPr>
-              <a:t>one NEML2 parameter</a:t>
-            </a:r>
-            <a:r>
-              <a:rPr sz="1350" b="0" i="0">
+              <a:t>235.9 m/s impact against a rigid anvil</a:t>
+            </a:r>
+          </a:p>
+        </p:txBody>
+      </p:sp>
+      <p:sp>
+        <p:nvSpPr>
+          <p:cNvPr id="16" name="Rounded Rectangle 15"/>
+          <p:cNvSpPr/>
+          <p:nvPr/>
+        </p:nvSpPr>
+        <p:spPr>
+          <a:xfrm>
+            <a:off x="8247888" y="3456430"/>
+            <a:ext cx="3376879" cy="914400"/>
+          </a:xfrm>
+          <a:prstGeom prst="roundRect">
+            <a:avLst>
+              <a:gd name="adj" fmla="val 5500"/>
+            </a:avLst>
+          </a:prstGeom>
+          <a:solidFill>
+            <a:srgbClr val="FFFFFF"/>
+          </a:solidFill>
+          <a:ln w="9525">
+            <a:solidFill>
+              <a:srgbClr val="DADDE2"/>
+            </a:solidFill>
+          </a:ln>
+          <a:effectLst/>
+        </p:spPr>
+        <p:style>
+          <a:lnRef idx="1">
+            <a:schemeClr val="accent1"/>
+          </a:lnRef>
+          <a:fillRef idx="3">
+            <a:schemeClr val="accent1"/>
+          </a:fillRef>
+          <a:effectRef idx="2">
+            <a:schemeClr val="accent1"/>
+          </a:effectRef>
+          <a:fontRef idx="minor">
+            <a:schemeClr val="lt1"/>
+          </a:fontRef>
+        </p:style>
+        <p:txBody>
+          <a:bodyPr rtlCol="0" anchor="ctr"/>
+          <a:lstStyle/>
+          <a:p>
+            <a:pPr algn="ctr"/>
+          </a:p>
+        </p:txBody>
+      </p:sp>
+      <p:sp>
+        <p:nvSpPr>
+          <p:cNvPr id="17" name="Rectangle 16"/>
+          <p:cNvSpPr/>
+          <p:nvPr/>
+        </p:nvSpPr>
+        <p:spPr>
+          <a:xfrm>
+            <a:off x="8247888" y="3547870"/>
+            <a:ext cx="50292" cy="731520"/>
+          </a:xfrm>
+          <a:prstGeom prst="rect">
+            <a:avLst/>
+          </a:prstGeom>
+          <a:solidFill>
+            <a:srgbClr val="06509D"/>
+          </a:solidFill>
+          <a:ln>
+            <a:noFill/>
+          </a:ln>
+          <a:effectLst/>
+        </p:spPr>
+        <p:style>
+          <a:lnRef idx="1">
+            <a:schemeClr val="accent1"/>
+          </a:lnRef>
+          <a:fillRef idx="3">
+            <a:schemeClr val="accent1"/>
+          </a:fillRef>
+          <a:effectRef idx="2">
+            <a:schemeClr val="accent1"/>
+          </a:effectRef>
+          <a:fontRef idx="minor">
+            <a:schemeClr val="lt1"/>
+          </a:fontRef>
+        </p:style>
+        <p:txBody>
+          <a:bodyPr rtlCol="0" anchor="ctr"/>
+          <a:lstStyle/>
+          <a:p>
+            <a:pPr algn="ctr"/>
+          </a:p>
+        </p:txBody>
+      </p:sp>
+      <p:sp>
+        <p:nvSpPr>
+          <p:cNvPr id="18" name="TextBox 17"/>
+          <p:cNvSpPr txBox="1"/>
+          <p:nvPr/>
+        </p:nvSpPr>
+        <p:spPr>
+          <a:xfrm>
+            <a:off x="8467344" y="3547870"/>
+            <a:ext cx="2965399" cy="274320"/>
+          </a:xfrm>
+          <a:prstGeom prst="rect">
+            <a:avLst/>
+          </a:prstGeom>
+          <a:noFill/>
+        </p:spPr>
+        <p:txBody>
+          <a:bodyPr wrap="square" anchor="t" lIns="0" rIns="0" tIns="0" bIns="0">
+            <a:spAutoFit/>
+          </a:bodyPr>
+          <a:lstStyle/>
+          <a:p>
+            <a:pPr algn="l"/>
+            <a:r>
+              <a:rPr sz="1250" b="1" i="0">
+                <a:solidFill>
+                  <a:srgbClr val="1E2430"/>
+                </a:solidFill>
+                <a:latin typeface="Arial"/>
+                <a:cs typeface="Arial"/>
+              </a:rPr>
+              <a:t>Recovered geometry</a:t>
+            </a:r>
+          </a:p>
+        </p:txBody>
+      </p:sp>
+      <p:sp>
+        <p:nvSpPr>
+          <p:cNvPr id="19" name="TextBox 18"/>
+          <p:cNvSpPr txBox="1"/>
+          <p:nvPr/>
+        </p:nvSpPr>
+        <p:spPr>
+          <a:xfrm>
+            <a:off x="8467344" y="3840478"/>
+            <a:ext cx="2965399" cy="502920"/>
+          </a:xfrm>
+          <a:prstGeom prst="rect">
+            <a:avLst/>
+          </a:prstGeom>
+          <a:noFill/>
+        </p:spPr>
+        <p:txBody>
+          <a:bodyPr wrap="square" anchor="t" lIns="0" rIns="0" tIns="0" bIns="0">
+            <a:spAutoFit/>
+          </a:bodyPr>
+          <a:lstStyle/>
+          <a:p>
+            <a:pPr algn="l">
+              <a:lnSpc>
+                <a:spcPct val="110000"/>
+              </a:lnSpc>
+            </a:pPr>
+            <a:r>
+              <a:rPr sz="1100" b="0" i="0">
                 <a:solidFill>
                   <a:srgbClr val="3A3F47"/>
                 </a:solidFill>
                 <a:latin typeface="Arial"/>
                 <a:cs typeface="Arial"/>
               </a:rPr>
-              <a:t>: the prior cold work (initial plastic strain)</a:t>
-            </a:r>
-          </a:p>
-          <a:p>
-            <a:pPr marL="219456" indent="-219456">
+              <a:t>laser-scanned to a 46k-triangle surface mesh</a:t>
+            </a:r>
+          </a:p>
+        </p:txBody>
+      </p:sp>
+      <p:sp>
+        <p:nvSpPr>
+          <p:cNvPr id="20" name="Rounded Rectangle 19"/>
+          <p:cNvSpPr/>
+          <p:nvPr/>
+        </p:nvSpPr>
+        <p:spPr>
+          <a:xfrm>
+            <a:off x="8247888" y="4498845"/>
+            <a:ext cx="3376879" cy="914400"/>
+          </a:xfrm>
+          <a:prstGeom prst="roundRect">
+            <a:avLst>
+              <a:gd name="adj" fmla="val 5500"/>
+            </a:avLst>
+          </a:prstGeom>
+          <a:solidFill>
+            <a:srgbClr val="FFFFFF"/>
+          </a:solidFill>
+          <a:ln w="9525">
+            <a:solidFill>
+              <a:srgbClr val="DADDE2"/>
+            </a:solidFill>
+          </a:ln>
+          <a:effectLst/>
+        </p:spPr>
+        <p:style>
+          <a:lnRef idx="1">
+            <a:schemeClr val="accent1"/>
+          </a:lnRef>
+          <a:fillRef idx="3">
+            <a:schemeClr val="accent1"/>
+          </a:fillRef>
+          <a:effectRef idx="2">
+            <a:schemeClr val="accent1"/>
+          </a:effectRef>
+          <a:fontRef idx="minor">
+            <a:schemeClr val="lt1"/>
+          </a:fontRef>
+        </p:style>
+        <p:txBody>
+          <a:bodyPr rtlCol="0" anchor="ctr"/>
+          <a:lstStyle/>
+          <a:p>
+            <a:pPr algn="ctr"/>
+          </a:p>
+        </p:txBody>
+      </p:sp>
+      <p:sp>
+        <p:nvSpPr>
+          <p:cNvPr id="21" name="Rectangle 20"/>
+          <p:cNvSpPr/>
+          <p:nvPr/>
+        </p:nvSpPr>
+        <p:spPr>
+          <a:xfrm>
+            <a:off x="8247888" y="4590285"/>
+            <a:ext cx="50292" cy="731520"/>
+          </a:xfrm>
+          <a:prstGeom prst="rect">
+            <a:avLst/>
+          </a:prstGeom>
+          <a:solidFill>
+            <a:srgbClr val="06509D"/>
+          </a:solidFill>
+          <a:ln>
+            <a:noFill/>
+          </a:ln>
+          <a:effectLst/>
+        </p:spPr>
+        <p:style>
+          <a:lnRef idx="1">
+            <a:schemeClr val="accent1"/>
+          </a:lnRef>
+          <a:fillRef idx="3">
+            <a:schemeClr val="accent1"/>
+          </a:fillRef>
+          <a:effectRef idx="2">
+            <a:schemeClr val="accent1"/>
+          </a:effectRef>
+          <a:fontRef idx="minor">
+            <a:schemeClr val="lt1"/>
+          </a:fontRef>
+        </p:style>
+        <p:txBody>
+          <a:bodyPr rtlCol="0" anchor="ctr"/>
+          <a:lstStyle/>
+          <a:p>
+            <a:pPr algn="ctr"/>
+          </a:p>
+        </p:txBody>
+      </p:sp>
+      <p:sp>
+        <p:nvSpPr>
+          <p:cNvPr id="22" name="TextBox 21"/>
+          <p:cNvSpPr txBox="1"/>
+          <p:nvPr/>
+        </p:nvSpPr>
+        <p:spPr>
+          <a:xfrm>
+            <a:off x="8467344" y="4590285"/>
+            <a:ext cx="2965399" cy="274320"/>
+          </a:xfrm>
+          <a:prstGeom prst="rect">
+            <a:avLst/>
+          </a:prstGeom>
+          <a:noFill/>
+        </p:spPr>
+        <p:txBody>
+          <a:bodyPr wrap="square" anchor="t" lIns="0" rIns="0" tIns="0" bIns="0">
+            <a:spAutoFit/>
+          </a:bodyPr>
+          <a:lstStyle/>
+          <a:p>
+            <a:pPr algn="l"/>
+            <a:r>
+              <a:rPr sz="1250" b="1" i="0">
+                <a:solidFill>
+                  <a:srgbClr val="1E2430"/>
+                </a:solidFill>
+                <a:latin typeface="Arial"/>
+                <a:cs typeface="Arial"/>
+              </a:rPr>
+              <a:t>Role in this talk</a:t>
+            </a:r>
+          </a:p>
+        </p:txBody>
+      </p:sp>
+      <p:sp>
+        <p:nvSpPr>
+          <p:cNvPr id="23" name="TextBox 22"/>
+          <p:cNvSpPr txBox="1"/>
+          <p:nvPr/>
+        </p:nvSpPr>
+        <p:spPr>
+          <a:xfrm>
+            <a:off x="8467344" y="4882893"/>
+            <a:ext cx="2965399" cy="502920"/>
+          </a:xfrm>
+          <a:prstGeom prst="rect">
+            <a:avLst/>
+          </a:prstGeom>
+          <a:noFill/>
+        </p:spPr>
+        <p:txBody>
+          <a:bodyPr wrap="square" anchor="t" lIns="0" rIns="0" tIns="0" bIns="0">
+            <a:spAutoFit/>
+          </a:bodyPr>
+          <a:lstStyle/>
+          <a:p>
+            <a:pPr algn="l">
               <a:lnSpc>
-                <a:spcPct val="106000"/>
+                <a:spcPct val="110000"/>
               </a:lnSpc>
-              <a:spcAft>
-                <a:spcPts val="1000"/>
-              </a:spcAft>
-              <a:buClr>
-                <a:srgbClr val="06509D"/>
-              </a:buClr>
-              <a:buFont typeface="Arial"/>
-              <a:buChar char="•"/>
             </a:pPr>
             <a:r>
-              <a:rPr sz="1350" b="0" i="0">
+              <a:rPr sz="1100" b="0" i="0">
                 <a:solidFill>
                   <a:srgbClr val="3A3F47"/>
                 </a:solidFill>
                 <a:latin typeface="Arial"/>
                 <a:cs typeface="Arial"/>
               </a:rPr>
-              <a:t>Full-hard </a:t>
-            </a:r>
-            <a:r>
-              <a:rPr sz="1350" b="1" i="0">
-                <a:solidFill>
-                  <a:srgbClr val="CF1D4C"/>
-                </a:solidFill>
-                <a:latin typeface="Arial"/>
-                <a:cs typeface="Arial"/>
-              </a:rPr>
-              <a:t>39%</a:t>
-            </a:r>
-            <a:r>
-              <a:rPr sz="1350" b="0" i="0">
-                <a:solidFill>
-                  <a:srgbClr val="3A3F47"/>
-                </a:solidFill>
-                <a:latin typeface="Arial"/>
-                <a:cs typeface="Arial"/>
-              </a:rPr>
-              <a:t> vs annealed </a:t>
-            </a:r>
-            <a:r>
-              <a:rPr sz="1350" b="1" i="0">
-                <a:solidFill>
-                  <a:srgbClr val="06509D"/>
-                </a:solidFill>
-                <a:latin typeface="Arial"/>
-                <a:cs typeface="Arial"/>
-              </a:rPr>
-              <a:t>43%</a:t>
-            </a:r>
-            <a:r>
-              <a:rPr sz="1350" b="0" i="0">
-                <a:solidFill>
-                  <a:srgbClr val="3A3F47"/>
-                </a:solidFill>
-                <a:latin typeface="Arial"/>
-                <a:cs typeface="Arial"/>
-              </a:rPr>
-              <a:t> axial shortening</a:t>
+              <a:t>the scan is the calibration and validation target</a:t>
             </a:r>
           </a:p>
         </p:txBody>
@@ -13667,7 +14211,7 @@
           <a:p>
             <a:r>
               <a:rPr sz="2600"/>
-              <a:t>Coupled thermo-mechanics: heating from plastic work</a:t>
+              <a:t>Taylor anvil impact, end to end</a:t>
             </a:r>
           </a:p>
         </p:txBody>
@@ -13703,7 +14247,7 @@
                 <a:latin typeface="Arial"/>
                 <a:cs typeface="Arial"/>
               </a:rPr>
-              <a:t>16 / 18</a:t>
+              <a:t>16 / 19</a:t>
             </a:r>
           </a:p>
         </p:txBody>
@@ -13739,7 +14283,7 @@
                 <a:latin typeface="Arial"/>
                 <a:cs typeface="Arial"/>
               </a:rPr>
-              <a:t>The run you just saw is coupled. Temperature is integrated </a:t>
+              <a:t>OFHC copper slug at </a:t>
             </a:r>
             <a:r>
               <a:rPr sz="1450" b="1" i="0">
@@ -13749,7 +14293,7 @@
                 <a:latin typeface="Arial"/>
                 <a:cs typeface="Arial"/>
               </a:rPr>
-              <a:t>inside the NEML2 model</a:t>
+              <a:t>235.9 m/s</a:t>
             </a:r>
             <a:r>
               <a:rPr sz="1450" b="0" i="0">
@@ -13759,14 +14303,24 @@
                 <a:latin typeface="Arial"/>
                 <a:cs typeface="Arial"/>
               </a:rPr>
-              <a:t> (adiabatic Taylor–Quinney heating, β = 0.9)</a:t>
+              <a:t> · calibrated multiplicative Johnson–Cook · reduced integration · Δt = 10 ns · </a:t>
+            </a:r>
+            <a:r>
+              <a:rPr sz="1450" b="1" i="0">
+                <a:solidFill>
+                  <a:srgbClr val="1E2430"/>
+                </a:solidFill>
+                <a:latin typeface="Arial"/>
+                <a:cs typeface="Arial"/>
+              </a:rPr>
+              <a:t>9,600+ explicit steps</a:t>
             </a:r>
           </a:p>
         </p:txBody>
       </p:sp>
       <p:pic>
         <p:nvPicPr>
-          <p:cNvPr id="5" name="Picture 4" descr="fig_thermal.png"/>
+          <p:cNvPr id="5" name="Picture 4" descr="fig_pstrain.png"/>
           <p:cNvPicPr>
             <a:picLocks noChangeAspect="1"/>
           </p:cNvPicPr>
@@ -13780,8 +14334,8 @@
         </p:blipFill>
         <p:spPr>
           <a:xfrm>
-            <a:off x="1755648" y="1609344"/>
-            <a:ext cx="7498079" cy="1921582"/>
+            <a:off x="1115568" y="1627632"/>
+            <a:ext cx="8778240" cy="2259290"/>
           </a:xfrm>
           <a:prstGeom prst="rect">
             <a:avLst/>
@@ -13796,7 +14350,7 @@
         </p:nvSpPr>
         <p:spPr>
           <a:xfrm>
-            <a:off x="1847088" y="3558358"/>
+            <a:off x="1207008" y="3914354"/>
             <a:ext cx="10058400" cy="256032"/>
           </a:xfrm>
           <a:prstGeom prst="rect">
@@ -13819,113 +14373,45 @@
                 <a:latin typeface="Arial"/>
                 <a:cs typeface="Arial"/>
               </a:rPr>
-              <a:t>temperature rise above 300 K, cutaway views. Run to rebound at 96 µs with &gt;99% of the impact kinetic energy dissipated</a:t>
-            </a:r>
-          </a:p>
-        </p:txBody>
-      </p:sp>
-      <p:sp>
-        <p:nvSpPr>
-          <p:cNvPr id="7" name="Rounded Rectangle 6"/>
-          <p:cNvSpPr/>
-          <p:nvPr/>
-        </p:nvSpPr>
-        <p:spPr>
-          <a:xfrm>
-            <a:off x="566928" y="3878398"/>
-            <a:ext cx="3442106" cy="960120"/>
-          </a:xfrm>
-          <a:prstGeom prst="roundRect">
-            <a:avLst>
-              <a:gd name="adj" fmla="val 5500"/>
-            </a:avLst>
-          </a:prstGeom>
-          <a:solidFill>
-            <a:srgbClr val="F4F5F7"/>
-          </a:solidFill>
-          <a:ln w="9525">
-            <a:solidFill>
-              <a:srgbClr val="DADDE2"/>
-            </a:solidFill>
-          </a:ln>
-          <a:effectLst/>
-        </p:spPr>
-        <p:style>
-          <a:lnRef idx="1">
-            <a:schemeClr val="accent1"/>
-          </a:lnRef>
-          <a:fillRef idx="3">
-            <a:schemeClr val="accent1"/>
-          </a:fillRef>
-          <a:effectRef idx="2">
-            <a:schemeClr val="accent1"/>
-          </a:effectRef>
-          <a:fontRef idx="minor">
-            <a:schemeClr val="lt1"/>
-          </a:fontRef>
-        </p:style>
-        <p:txBody>
-          <a:bodyPr rtlCol="0" anchor="ctr"/>
-          <a:lstStyle/>
-          <a:p>
-            <a:pPr algn="ctr"/>
-          </a:p>
-        </p:txBody>
-      </p:sp>
-      <p:sp>
-        <p:nvSpPr>
-          <p:cNvPr id="8" name="Rectangle 7"/>
-          <p:cNvSpPr/>
-          <p:nvPr/>
-        </p:nvSpPr>
-        <p:spPr>
-          <a:xfrm>
-            <a:off x="566928" y="3960694"/>
-            <a:ext cx="50292" cy="795528"/>
-          </a:xfrm>
-          <a:prstGeom prst="rect">
-            <a:avLst/>
-          </a:prstGeom>
-          <a:solidFill>
-            <a:srgbClr val="CF1D4C"/>
-          </a:solidFill>
-          <a:ln>
-            <a:noFill/>
-          </a:ln>
-          <a:effectLst/>
-        </p:spPr>
-        <p:style>
-          <a:lnRef idx="1">
-            <a:schemeClr val="accent1"/>
-          </a:lnRef>
-          <a:fillRef idx="3">
-            <a:schemeClr val="accent1"/>
-          </a:fillRef>
-          <a:effectRef idx="2">
-            <a:schemeClr val="accent1"/>
-          </a:effectRef>
-          <a:fontRef idx="minor">
-            <a:schemeClr val="lt1"/>
-          </a:fontRef>
-        </p:style>
-        <p:txBody>
-          <a:bodyPr rtlCol="0" anchor="ctr"/>
-          <a:lstStyle/>
-          <a:p>
-            <a:pPr algn="ctr"/>
-          </a:p>
-        </p:txBody>
-      </p:sp>
-      <p:sp>
-        <p:nvSpPr>
-          <p:cNvPr id="9" name="TextBox 8"/>
+              <a:t>cutaway views (near half removed). Plastic strain localizes at the impact foot. The gray plane is the rigid anvil</a:t>
+            </a:r>
+          </a:p>
+        </p:txBody>
+      </p:sp>
+      <p:pic>
+        <p:nvPicPr>
+          <p:cNvPr id="7" name="Picture 6" descr="fig_profile.png"/>
+          <p:cNvPicPr>
+            <a:picLocks noChangeAspect="1"/>
+          </p:cNvPicPr>
+          <p:nvPr/>
+        </p:nvPicPr>
+        <p:blipFill>
+          <a:blip r:embed="rId3"/>
+          <a:stretch>
+            <a:fillRect/>
+          </a:stretch>
+        </p:blipFill>
+        <p:spPr>
+          <a:xfrm>
+            <a:off x="566928" y="4179530"/>
+            <a:ext cx="3931920" cy="1438444"/>
+          </a:xfrm>
+          <a:prstGeom prst="rect">
+            <a:avLst/>
+          </a:prstGeom>
+        </p:spPr>
+      </p:pic>
+      <p:sp>
+        <p:nvSpPr>
+          <p:cNvPr id="8" name="TextBox 7"/>
           <p:cNvSpPr txBox="1"/>
           <p:nvPr/>
         </p:nvSpPr>
         <p:spPr>
           <a:xfrm>
-            <a:off x="786384" y="3951550"/>
-            <a:ext cx="3039770" cy="274320"/>
+            <a:off x="4956048" y="4270970"/>
+            <a:ext cx="6668719" cy="1529884"/>
           </a:xfrm>
           <a:prstGeom prst="rect">
             <a:avLst/>
@@ -13933,409 +14419,118 @@
           <a:noFill/>
         </p:spPr>
         <p:txBody>
-          <a:bodyPr wrap="square" anchor="t" lIns="0" rIns="0" tIns="0" bIns="0">
+          <a:bodyPr wrap="square" lIns="0" rIns="0" tIns="0" bIns="0">
             <a:spAutoFit/>
           </a:bodyPr>
           <a:lstStyle/>
           <a:p>
-            <a:pPr algn="l">
-              <a:lnSpc>
-                <a:spcPct val="102000"/>
-              </a:lnSpc>
-            </a:pPr>
-            <a:r>
-              <a:rPr sz="1200" b="1" i="0">
-                <a:solidFill>
-                  <a:srgbClr val="1E2430"/>
-                </a:solidFill>
-                <a:latin typeface="Arial"/>
-                <a:cs typeface="Arial"/>
-              </a:rPr>
-              <a:t>Feeds back into the flow stress</a:t>
-            </a:r>
-          </a:p>
-        </p:txBody>
-      </p:sp>
-      <p:sp>
-        <p:nvSpPr>
-          <p:cNvPr id="10" name="TextBox 9"/>
-          <p:cNvSpPr txBox="1"/>
-          <p:nvPr/>
-        </p:nvSpPr>
-        <p:spPr>
-          <a:xfrm>
-            <a:off x="786384" y="4271590"/>
-            <a:ext cx="3039770" cy="548640"/>
-          </a:xfrm>
-          <a:prstGeom prst="rect">
-            <a:avLst/>
-          </a:prstGeom>
-          <a:noFill/>
-        </p:spPr>
-        <p:txBody>
-          <a:bodyPr wrap="square" anchor="t" lIns="0" rIns="0" tIns="0" bIns="0">
-            <a:spAutoFit/>
-          </a:bodyPr>
-          <a:lstStyle/>
-          <a:p>
-            <a:pPr algn="l">
+            <a:pPr marL="219456" indent="-219456">
               <a:lnSpc>
                 <a:spcPct val="106000"/>
               </a:lnSpc>
+              <a:spcAft>
+                <a:spcPts val="1000"/>
+              </a:spcAft>
+              <a:buClr>
+                <a:srgbClr val="06509D"/>
+              </a:buClr>
+              <a:buFont typeface="Arial"/>
+              <a:buChar char="•"/>
             </a:pPr>
             <a:r>
-              <a:rPr sz="1000" b="0" i="0">
+              <a:rPr sz="1350" b="0" i="0">
                 <a:solidFill>
                   <a:srgbClr val="3A3F47"/>
                 </a:solidFill>
                 <a:latin typeface="Arial"/>
                 <a:cs typeface="Arial"/>
               </a:rPr>
-              <a:t>the hot foot softens (Johnson–Cook Θ = 1 − T*ᵐ) and flows more easily</a:t>
-            </a:r>
-          </a:p>
-        </p:txBody>
-      </p:sp>
-      <p:sp>
-        <p:nvSpPr>
-          <p:cNvPr id="11" name="Rounded Rectangle 10"/>
-          <p:cNvSpPr/>
-          <p:nvPr/>
-        </p:nvSpPr>
-        <p:spPr>
-          <a:xfrm>
-            <a:off x="4374794" y="3878398"/>
-            <a:ext cx="3442106" cy="960120"/>
-          </a:xfrm>
-          <a:prstGeom prst="roundRect">
-            <a:avLst>
-              <a:gd name="adj" fmla="val 5500"/>
-            </a:avLst>
-          </a:prstGeom>
-          <a:solidFill>
-            <a:srgbClr val="F4F5F7"/>
-          </a:solidFill>
-          <a:ln w="9525">
-            <a:solidFill>
-              <a:srgbClr val="DADDE2"/>
-            </a:solidFill>
-          </a:ln>
-          <a:effectLst/>
-        </p:spPr>
-        <p:style>
-          <a:lnRef idx="1">
-            <a:schemeClr val="accent1"/>
-          </a:lnRef>
-          <a:fillRef idx="3">
-            <a:schemeClr val="accent1"/>
-          </a:fillRef>
-          <a:effectRef idx="2">
-            <a:schemeClr val="accent1"/>
-          </a:effectRef>
-          <a:fontRef idx="minor">
-            <a:schemeClr val="lt1"/>
-          </a:fontRef>
-        </p:style>
-        <p:txBody>
-          <a:bodyPr rtlCol="0" anchor="ctr"/>
-          <a:lstStyle/>
-          <a:p>
-            <a:pPr algn="ctr"/>
-          </a:p>
-        </p:txBody>
-      </p:sp>
-      <p:sp>
-        <p:nvSpPr>
-          <p:cNvPr id="12" name="Rectangle 11"/>
-          <p:cNvSpPr/>
-          <p:nvPr/>
-        </p:nvSpPr>
-        <p:spPr>
-          <a:xfrm>
-            <a:off x="4374794" y="3960694"/>
-            <a:ext cx="50292" cy="795528"/>
-          </a:xfrm>
-          <a:prstGeom prst="rect">
-            <a:avLst/>
-          </a:prstGeom>
-          <a:solidFill>
-            <a:srgbClr val="06509D"/>
-          </a:solidFill>
-          <a:ln>
-            <a:noFill/>
-          </a:ln>
-          <a:effectLst/>
-        </p:spPr>
-        <p:style>
-          <a:lnRef idx="1">
-            <a:schemeClr val="accent1"/>
-          </a:lnRef>
-          <a:fillRef idx="3">
-            <a:schemeClr val="accent1"/>
-          </a:fillRef>
-          <a:effectRef idx="2">
-            <a:schemeClr val="accent1"/>
-          </a:effectRef>
-          <a:fontRef idx="minor">
-            <a:schemeClr val="lt1"/>
-          </a:fontRef>
-        </p:style>
-        <p:txBody>
-          <a:bodyPr rtlCol="0" anchor="ctr"/>
-          <a:lstStyle/>
-          <a:p>
-            <a:pPr algn="ctr"/>
-          </a:p>
-        </p:txBody>
-      </p:sp>
-      <p:sp>
-        <p:nvSpPr>
-          <p:cNvPr id="13" name="TextBox 12"/>
-          <p:cNvSpPr txBox="1"/>
-          <p:nvPr/>
-        </p:nvSpPr>
-        <p:spPr>
-          <a:xfrm>
-            <a:off x="4594250" y="3951550"/>
-            <a:ext cx="3039770" cy="274320"/>
-          </a:xfrm>
-          <a:prstGeom prst="rect">
-            <a:avLst/>
-          </a:prstGeom>
-          <a:noFill/>
-        </p:spPr>
-        <p:txBody>
-          <a:bodyPr wrap="square" anchor="t" lIns="0" rIns="0" tIns="0" bIns="0">
-            <a:spAutoFit/>
-          </a:bodyPr>
-          <a:lstStyle/>
-          <a:p>
-            <a:pPr algn="l">
-              <a:lnSpc>
-                <a:spcPct val="102000"/>
-              </a:lnSpc>
-            </a:pPr>
-            <a:r>
-              <a:rPr sz="1200" b="1" i="0">
-                <a:solidFill>
-                  <a:srgbClr val="1E2430"/>
-                </a:solidFill>
-                <a:latin typeface="Arial"/>
-                <a:cs typeface="Arial"/>
-              </a:rPr>
-              <a:t>Adiabatic by physics, not assumption</a:t>
-            </a:r>
-          </a:p>
-        </p:txBody>
-      </p:sp>
-      <p:sp>
-        <p:nvSpPr>
-          <p:cNvPr id="14" name="TextBox 13"/>
-          <p:cNvSpPr txBox="1"/>
-          <p:nvPr/>
-        </p:nvSpPr>
-        <p:spPr>
-          <a:xfrm>
-            <a:off x="4594250" y="4271590"/>
-            <a:ext cx="3039770" cy="548640"/>
-          </a:xfrm>
-          <a:prstGeom prst="rect">
-            <a:avLst/>
-          </a:prstGeom>
-          <a:noFill/>
-        </p:spPr>
-        <p:txBody>
-          <a:bodyPr wrap="square" anchor="t" lIns="0" rIns="0" tIns="0" bIns="0">
-            <a:spAutoFit/>
-          </a:bodyPr>
-          <a:lstStyle/>
-          <a:p>
-            <a:pPr algn="l">
+              <a:t>Same mesh, BCs, integrator. The temper is swapped by </a:t>
+            </a:r>
+            <a:r>
+              <a:rPr sz="1350" b="1" i="0">
+                <a:solidFill>
+                  <a:srgbClr val="3A3F47"/>
+                </a:solidFill>
+                <a:latin typeface="Arial"/>
+                <a:cs typeface="Arial"/>
+              </a:rPr>
+              <a:t>one NEML2 parameter</a:t>
+            </a:r>
+            <a:r>
+              <a:rPr sz="1350" b="0" i="0">
+                <a:solidFill>
+                  <a:srgbClr val="3A3F47"/>
+                </a:solidFill>
+                <a:latin typeface="Arial"/>
+                <a:cs typeface="Arial"/>
+              </a:rPr>
+              <a:t>: the prior cold work (initial plastic strain)</a:t>
+            </a:r>
+          </a:p>
+          <a:p>
+            <a:pPr marL="219456" indent="-219456">
               <a:lnSpc>
                 <a:spcPct val="106000"/>
               </a:lnSpc>
+              <a:spcAft>
+                <a:spcPts val="1000"/>
+              </a:spcAft>
+              <a:buClr>
+                <a:srgbClr val="06509D"/>
+              </a:buClr>
+              <a:buFont typeface="Arial"/>
+              <a:buChar char="•"/>
             </a:pPr>
             <a:r>
-              <a:rPr sz="1000" b="0" i="0">
+              <a:rPr sz="1350" b="0" i="0">
                 <a:solidFill>
                   <a:srgbClr val="3A3F47"/>
                 </a:solidFill>
                 <a:latin typeface="Arial"/>
                 <a:cs typeface="Arial"/>
               </a:rPr>
-              <a:t>diffusion length √(αt) ≈ 0.1 mm ≪ element size over the ~100 µs run. No heat-conduction PDE needed</a:t>
-            </a:r>
-          </a:p>
-        </p:txBody>
-      </p:sp>
-      <p:sp>
-        <p:nvSpPr>
-          <p:cNvPr id="15" name="Rounded Rectangle 14"/>
-          <p:cNvSpPr/>
-          <p:nvPr/>
-        </p:nvSpPr>
-        <p:spPr>
-          <a:xfrm>
-            <a:off x="8182660" y="3878398"/>
-            <a:ext cx="3442106" cy="960120"/>
-          </a:xfrm>
-          <a:prstGeom prst="roundRect">
-            <a:avLst>
-              <a:gd name="adj" fmla="val 5500"/>
-            </a:avLst>
-          </a:prstGeom>
-          <a:solidFill>
-            <a:srgbClr val="F4F5F7"/>
-          </a:solidFill>
-          <a:ln w="9525">
-            <a:solidFill>
-              <a:srgbClr val="DADDE2"/>
-            </a:solidFill>
-          </a:ln>
-          <a:effectLst/>
-        </p:spPr>
-        <p:style>
-          <a:lnRef idx="1">
-            <a:schemeClr val="accent1"/>
-          </a:lnRef>
-          <a:fillRef idx="3">
-            <a:schemeClr val="accent1"/>
-          </a:fillRef>
-          <a:effectRef idx="2">
-            <a:schemeClr val="accent1"/>
-          </a:effectRef>
-          <a:fontRef idx="minor">
-            <a:schemeClr val="lt1"/>
-          </a:fontRef>
-        </p:style>
-        <p:txBody>
-          <a:bodyPr rtlCol="0" anchor="ctr"/>
-          <a:lstStyle/>
-          <a:p>
-            <a:pPr algn="ctr"/>
-          </a:p>
-        </p:txBody>
-      </p:sp>
-      <p:sp>
-        <p:nvSpPr>
-          <p:cNvPr id="16" name="Rectangle 15"/>
-          <p:cNvSpPr/>
-          <p:nvPr/>
-        </p:nvSpPr>
-        <p:spPr>
-          <a:xfrm>
-            <a:off x="8182660" y="3960694"/>
-            <a:ext cx="50292" cy="795528"/>
-          </a:xfrm>
-          <a:prstGeom prst="rect">
-            <a:avLst/>
-          </a:prstGeom>
-          <a:solidFill>
-            <a:srgbClr val="5E8614"/>
-          </a:solidFill>
-          <a:ln>
-            <a:noFill/>
-          </a:ln>
-          <a:effectLst/>
-        </p:spPr>
-        <p:style>
-          <a:lnRef idx="1">
-            <a:schemeClr val="accent1"/>
-          </a:lnRef>
-          <a:fillRef idx="3">
-            <a:schemeClr val="accent1"/>
-          </a:fillRef>
-          <a:effectRef idx="2">
-            <a:schemeClr val="accent1"/>
-          </a:effectRef>
-          <a:fontRef idx="minor">
-            <a:schemeClr val="lt1"/>
-          </a:fontRef>
-        </p:style>
-        <p:txBody>
-          <a:bodyPr rtlCol="0" anchor="ctr"/>
-          <a:lstStyle/>
-          <a:p>
-            <a:pPr algn="ctr"/>
-          </a:p>
-        </p:txBody>
-      </p:sp>
-      <p:sp>
-        <p:nvSpPr>
-          <p:cNvPr id="17" name="TextBox 16"/>
-          <p:cNvSpPr txBox="1"/>
-          <p:nvPr/>
-        </p:nvSpPr>
-        <p:spPr>
-          <a:xfrm>
-            <a:off x="8402116" y="3951550"/>
-            <a:ext cx="3039770" cy="274320"/>
-          </a:xfrm>
-          <a:prstGeom prst="rect">
-            <a:avLst/>
-          </a:prstGeom>
-          <a:noFill/>
-        </p:spPr>
-        <p:txBody>
-          <a:bodyPr wrap="square" anchor="t" lIns="0" rIns="0" tIns="0" bIns="0">
-            <a:spAutoFit/>
-          </a:bodyPr>
-          <a:lstStyle/>
-          <a:p>
-            <a:pPr algn="l">
-              <a:lnSpc>
-                <a:spcPct val="102000"/>
-              </a:lnSpc>
-            </a:pPr>
-            <a:r>
-              <a:rPr sz="1200" b="1" i="0">
-                <a:solidFill>
-                  <a:srgbClr val="1E2430"/>
-                </a:solidFill>
-                <a:latin typeface="Arial"/>
-                <a:cs typeface="Arial"/>
-              </a:rPr>
-              <a:t>Three extra NEML2 model blocks</a:t>
-            </a:r>
-          </a:p>
-        </p:txBody>
-      </p:sp>
-      <p:sp>
-        <p:nvSpPr>
-          <p:cNvPr id="18" name="TextBox 17"/>
-          <p:cNvSpPr txBox="1"/>
-          <p:nvPr/>
-        </p:nvSpPr>
-        <p:spPr>
-          <a:xfrm>
-            <a:off x="8402116" y="4271590"/>
-            <a:ext cx="3039770" cy="548640"/>
-          </a:xfrm>
-          <a:prstGeom prst="rect">
-            <a:avLst/>
-          </a:prstGeom>
-          <a:noFill/>
-        </p:spPr>
-        <p:txBody>
-          <a:bodyPr wrap="square" anchor="t" lIns="0" rIns="0" tIns="0" bIns="0">
-            <a:spAutoFit/>
-          </a:bodyPr>
-          <a:lstStyle/>
-          <a:p>
-            <a:pPr algn="l">
-              <a:lnSpc>
-                <a:spcPct val="106000"/>
-              </a:lnSpc>
-            </a:pPr>
-            <a:r>
-              <a:rPr sz="1000" b="0" i="0">
+              <a:t>Full-hard </a:t>
+            </a:r>
+            <a:r>
+              <a:rPr sz="1350" b="1" i="0">
+                <a:solidFill>
+                  <a:srgbClr val="CF1D4C"/>
+                </a:solidFill>
+                <a:latin typeface="Arial"/>
+                <a:cs typeface="Arial"/>
+              </a:rPr>
+              <a:t>39%</a:t>
+            </a:r>
+            <a:r>
+              <a:rPr sz="1350" b="0" i="0">
                 <a:solidFill>
                   <a:srgbClr val="3A3F47"/>
                 </a:solidFill>
                 <a:latin typeface="Arial"/>
                 <a:cs typeface="Arial"/>
               </a:rPr>
-              <a:t>no new MOOSE modules, no new transfers. Temperature state lives on the device like everything else</a:t>
+              <a:t> vs annealed </a:t>
+            </a:r>
+            <a:r>
+              <a:rPr sz="1350" b="1" i="0">
+                <a:solidFill>
+                  <a:srgbClr val="06509D"/>
+                </a:solidFill>
+                <a:latin typeface="Arial"/>
+                <a:cs typeface="Arial"/>
+              </a:rPr>
+              <a:t>43%</a:t>
+            </a:r>
+            <a:r>
+              <a:rPr sz="1350" b="0" i="0">
+                <a:solidFill>
+                  <a:srgbClr val="3A3F47"/>
+                </a:solidFill>
+                <a:latin typeface="Arial"/>
+                <a:cs typeface="Arial"/>
+              </a:rPr>
+              <a:t> axial shortening</a:t>
             </a:r>
           </a:p>
         </p:txBody>
@@ -14375,7 +14570,7 @@
           <a:p>
             <a:r>
               <a:rPr sz="2600"/>
-              <a:t>Bayesian calibration of the material parameters</a:t>
+              <a:t>Coupled thermo-mechanics: heating from plastic work</a:t>
             </a:r>
           </a:p>
         </p:txBody>
@@ -14411,7 +14606,715 @@
                 <a:latin typeface="Arial"/>
                 <a:cs typeface="Arial"/>
               </a:rPr>
-              <a:t>17 / 18</a:t>
+              <a:t>17 / 19</a:t>
+            </a:r>
+          </a:p>
+        </p:txBody>
+      </p:sp>
+      <p:sp>
+        <p:nvSpPr>
+          <p:cNvPr id="4" name="TextBox 3"/>
+          <p:cNvSpPr txBox="1"/>
+          <p:nvPr/>
+        </p:nvSpPr>
+        <p:spPr>
+          <a:xfrm>
+            <a:off x="566928" y="1133856"/>
+            <a:ext cx="11057839" cy="320040"/>
+          </a:xfrm>
+          <a:prstGeom prst="rect">
+            <a:avLst/>
+          </a:prstGeom>
+          <a:noFill/>
+        </p:spPr>
+        <p:txBody>
+          <a:bodyPr wrap="square" anchor="t" lIns="0" rIns="0" tIns="0" bIns="0">
+            <a:spAutoFit/>
+          </a:bodyPr>
+          <a:lstStyle/>
+          <a:p>
+            <a:pPr algn="l"/>
+            <a:r>
+              <a:rPr sz="1450" b="0" i="0">
+                <a:solidFill>
+                  <a:srgbClr val="3A3F47"/>
+                </a:solidFill>
+                <a:latin typeface="Arial"/>
+                <a:cs typeface="Arial"/>
+              </a:rPr>
+              <a:t>The run you just saw is coupled. Temperature is integrated </a:t>
+            </a:r>
+            <a:r>
+              <a:rPr sz="1450" b="1" i="0">
+                <a:solidFill>
+                  <a:srgbClr val="1E2430"/>
+                </a:solidFill>
+                <a:latin typeface="Arial"/>
+                <a:cs typeface="Arial"/>
+              </a:rPr>
+              <a:t>inside the NEML2 model</a:t>
+            </a:r>
+            <a:r>
+              <a:rPr sz="1450" b="0" i="0">
+                <a:solidFill>
+                  <a:srgbClr val="3A3F47"/>
+                </a:solidFill>
+                <a:latin typeface="Arial"/>
+                <a:cs typeface="Arial"/>
+              </a:rPr>
+              <a:t> (adiabatic Taylor–Quinney heating, β = 0.9)</a:t>
+            </a:r>
+          </a:p>
+        </p:txBody>
+      </p:sp>
+      <p:pic>
+        <p:nvPicPr>
+          <p:cNvPr id="5" name="Picture 4" descr="fig_thermal.png"/>
+          <p:cNvPicPr>
+            <a:picLocks noChangeAspect="1"/>
+          </p:cNvPicPr>
+          <p:nvPr/>
+        </p:nvPicPr>
+        <p:blipFill>
+          <a:blip r:embed="rId2"/>
+          <a:stretch>
+            <a:fillRect/>
+          </a:stretch>
+        </p:blipFill>
+        <p:spPr>
+          <a:xfrm>
+            <a:off x="1755648" y="1609344"/>
+            <a:ext cx="7498079" cy="1921582"/>
+          </a:xfrm>
+          <a:prstGeom prst="rect">
+            <a:avLst/>
+          </a:prstGeom>
+        </p:spPr>
+      </p:pic>
+      <p:sp>
+        <p:nvSpPr>
+          <p:cNvPr id="6" name="TextBox 5"/>
+          <p:cNvSpPr txBox="1"/>
+          <p:nvPr/>
+        </p:nvSpPr>
+        <p:spPr>
+          <a:xfrm>
+            <a:off x="1847088" y="3558358"/>
+            <a:ext cx="10058400" cy="256032"/>
+          </a:xfrm>
+          <a:prstGeom prst="rect">
+            <a:avLst/>
+          </a:prstGeom>
+          <a:noFill/>
+        </p:spPr>
+        <p:txBody>
+          <a:bodyPr wrap="square" anchor="t" lIns="0" rIns="0" tIns="0" bIns="0">
+            <a:spAutoFit/>
+          </a:bodyPr>
+          <a:lstStyle/>
+          <a:p>
+            <a:pPr algn="l"/>
+            <a:r>
+              <a:rPr sz="1100" b="0" i="1">
+                <a:solidFill>
+                  <a:srgbClr val="59595C"/>
+                </a:solidFill>
+                <a:latin typeface="Arial"/>
+                <a:cs typeface="Arial"/>
+              </a:rPr>
+              <a:t>temperature rise above 300 K, cutaway views. Run to rebound at 96 µs with &gt;99% of the impact kinetic energy dissipated</a:t>
+            </a:r>
+          </a:p>
+        </p:txBody>
+      </p:sp>
+      <p:sp>
+        <p:nvSpPr>
+          <p:cNvPr id="7" name="Rounded Rectangle 6"/>
+          <p:cNvSpPr/>
+          <p:nvPr/>
+        </p:nvSpPr>
+        <p:spPr>
+          <a:xfrm>
+            <a:off x="566928" y="3878398"/>
+            <a:ext cx="3442106" cy="960120"/>
+          </a:xfrm>
+          <a:prstGeom prst="roundRect">
+            <a:avLst>
+              <a:gd name="adj" fmla="val 5500"/>
+            </a:avLst>
+          </a:prstGeom>
+          <a:solidFill>
+            <a:srgbClr val="F4F5F7"/>
+          </a:solidFill>
+          <a:ln w="9525">
+            <a:solidFill>
+              <a:srgbClr val="DADDE2"/>
+            </a:solidFill>
+          </a:ln>
+          <a:effectLst/>
+        </p:spPr>
+        <p:style>
+          <a:lnRef idx="1">
+            <a:schemeClr val="accent1"/>
+          </a:lnRef>
+          <a:fillRef idx="3">
+            <a:schemeClr val="accent1"/>
+          </a:fillRef>
+          <a:effectRef idx="2">
+            <a:schemeClr val="accent1"/>
+          </a:effectRef>
+          <a:fontRef idx="minor">
+            <a:schemeClr val="lt1"/>
+          </a:fontRef>
+        </p:style>
+        <p:txBody>
+          <a:bodyPr rtlCol="0" anchor="ctr"/>
+          <a:lstStyle/>
+          <a:p>
+            <a:pPr algn="ctr"/>
+          </a:p>
+        </p:txBody>
+      </p:sp>
+      <p:sp>
+        <p:nvSpPr>
+          <p:cNvPr id="8" name="Rectangle 7"/>
+          <p:cNvSpPr/>
+          <p:nvPr/>
+        </p:nvSpPr>
+        <p:spPr>
+          <a:xfrm>
+            <a:off x="566928" y="3960694"/>
+            <a:ext cx="50292" cy="795528"/>
+          </a:xfrm>
+          <a:prstGeom prst="rect">
+            <a:avLst/>
+          </a:prstGeom>
+          <a:solidFill>
+            <a:srgbClr val="CF1D4C"/>
+          </a:solidFill>
+          <a:ln>
+            <a:noFill/>
+          </a:ln>
+          <a:effectLst/>
+        </p:spPr>
+        <p:style>
+          <a:lnRef idx="1">
+            <a:schemeClr val="accent1"/>
+          </a:lnRef>
+          <a:fillRef idx="3">
+            <a:schemeClr val="accent1"/>
+          </a:fillRef>
+          <a:effectRef idx="2">
+            <a:schemeClr val="accent1"/>
+          </a:effectRef>
+          <a:fontRef idx="minor">
+            <a:schemeClr val="lt1"/>
+          </a:fontRef>
+        </p:style>
+        <p:txBody>
+          <a:bodyPr rtlCol="0" anchor="ctr"/>
+          <a:lstStyle/>
+          <a:p>
+            <a:pPr algn="ctr"/>
+          </a:p>
+        </p:txBody>
+      </p:sp>
+      <p:sp>
+        <p:nvSpPr>
+          <p:cNvPr id="9" name="TextBox 8"/>
+          <p:cNvSpPr txBox="1"/>
+          <p:nvPr/>
+        </p:nvSpPr>
+        <p:spPr>
+          <a:xfrm>
+            <a:off x="786384" y="3951550"/>
+            <a:ext cx="3039770" cy="274320"/>
+          </a:xfrm>
+          <a:prstGeom prst="rect">
+            <a:avLst/>
+          </a:prstGeom>
+          <a:noFill/>
+        </p:spPr>
+        <p:txBody>
+          <a:bodyPr wrap="square" anchor="t" lIns="0" rIns="0" tIns="0" bIns="0">
+            <a:spAutoFit/>
+          </a:bodyPr>
+          <a:lstStyle/>
+          <a:p>
+            <a:pPr algn="l">
+              <a:lnSpc>
+                <a:spcPct val="102000"/>
+              </a:lnSpc>
+            </a:pPr>
+            <a:r>
+              <a:rPr sz="1200" b="1" i="0">
+                <a:solidFill>
+                  <a:srgbClr val="1E2430"/>
+                </a:solidFill>
+                <a:latin typeface="Arial"/>
+                <a:cs typeface="Arial"/>
+              </a:rPr>
+              <a:t>Feeds back into the flow stress</a:t>
+            </a:r>
+          </a:p>
+        </p:txBody>
+      </p:sp>
+      <p:sp>
+        <p:nvSpPr>
+          <p:cNvPr id="10" name="TextBox 9"/>
+          <p:cNvSpPr txBox="1"/>
+          <p:nvPr/>
+        </p:nvSpPr>
+        <p:spPr>
+          <a:xfrm>
+            <a:off x="786384" y="4271590"/>
+            <a:ext cx="3039770" cy="548640"/>
+          </a:xfrm>
+          <a:prstGeom prst="rect">
+            <a:avLst/>
+          </a:prstGeom>
+          <a:noFill/>
+        </p:spPr>
+        <p:txBody>
+          <a:bodyPr wrap="square" anchor="t" lIns="0" rIns="0" tIns="0" bIns="0">
+            <a:spAutoFit/>
+          </a:bodyPr>
+          <a:lstStyle/>
+          <a:p>
+            <a:pPr algn="l">
+              <a:lnSpc>
+                <a:spcPct val="106000"/>
+              </a:lnSpc>
+            </a:pPr>
+            <a:r>
+              <a:rPr sz="1000" b="0" i="0">
+                <a:solidFill>
+                  <a:srgbClr val="3A3F47"/>
+                </a:solidFill>
+                <a:latin typeface="Arial"/>
+                <a:cs typeface="Arial"/>
+              </a:rPr>
+              <a:t>the hot foot softens (Johnson–Cook Θ = 1 − T*ᵐ) and flows more easily</a:t>
+            </a:r>
+          </a:p>
+        </p:txBody>
+      </p:sp>
+      <p:sp>
+        <p:nvSpPr>
+          <p:cNvPr id="11" name="Rounded Rectangle 10"/>
+          <p:cNvSpPr/>
+          <p:nvPr/>
+        </p:nvSpPr>
+        <p:spPr>
+          <a:xfrm>
+            <a:off x="4374794" y="3878398"/>
+            <a:ext cx="3442106" cy="960120"/>
+          </a:xfrm>
+          <a:prstGeom prst="roundRect">
+            <a:avLst>
+              <a:gd name="adj" fmla="val 5500"/>
+            </a:avLst>
+          </a:prstGeom>
+          <a:solidFill>
+            <a:srgbClr val="F4F5F7"/>
+          </a:solidFill>
+          <a:ln w="9525">
+            <a:solidFill>
+              <a:srgbClr val="DADDE2"/>
+            </a:solidFill>
+          </a:ln>
+          <a:effectLst/>
+        </p:spPr>
+        <p:style>
+          <a:lnRef idx="1">
+            <a:schemeClr val="accent1"/>
+          </a:lnRef>
+          <a:fillRef idx="3">
+            <a:schemeClr val="accent1"/>
+          </a:fillRef>
+          <a:effectRef idx="2">
+            <a:schemeClr val="accent1"/>
+          </a:effectRef>
+          <a:fontRef idx="minor">
+            <a:schemeClr val="lt1"/>
+          </a:fontRef>
+        </p:style>
+        <p:txBody>
+          <a:bodyPr rtlCol="0" anchor="ctr"/>
+          <a:lstStyle/>
+          <a:p>
+            <a:pPr algn="ctr"/>
+          </a:p>
+        </p:txBody>
+      </p:sp>
+      <p:sp>
+        <p:nvSpPr>
+          <p:cNvPr id="12" name="Rectangle 11"/>
+          <p:cNvSpPr/>
+          <p:nvPr/>
+        </p:nvSpPr>
+        <p:spPr>
+          <a:xfrm>
+            <a:off x="4374794" y="3960694"/>
+            <a:ext cx="50292" cy="795528"/>
+          </a:xfrm>
+          <a:prstGeom prst="rect">
+            <a:avLst/>
+          </a:prstGeom>
+          <a:solidFill>
+            <a:srgbClr val="06509D"/>
+          </a:solidFill>
+          <a:ln>
+            <a:noFill/>
+          </a:ln>
+          <a:effectLst/>
+        </p:spPr>
+        <p:style>
+          <a:lnRef idx="1">
+            <a:schemeClr val="accent1"/>
+          </a:lnRef>
+          <a:fillRef idx="3">
+            <a:schemeClr val="accent1"/>
+          </a:fillRef>
+          <a:effectRef idx="2">
+            <a:schemeClr val="accent1"/>
+          </a:effectRef>
+          <a:fontRef idx="minor">
+            <a:schemeClr val="lt1"/>
+          </a:fontRef>
+        </p:style>
+        <p:txBody>
+          <a:bodyPr rtlCol="0" anchor="ctr"/>
+          <a:lstStyle/>
+          <a:p>
+            <a:pPr algn="ctr"/>
+          </a:p>
+        </p:txBody>
+      </p:sp>
+      <p:sp>
+        <p:nvSpPr>
+          <p:cNvPr id="13" name="TextBox 12"/>
+          <p:cNvSpPr txBox="1"/>
+          <p:nvPr/>
+        </p:nvSpPr>
+        <p:spPr>
+          <a:xfrm>
+            <a:off x="4594250" y="3951550"/>
+            <a:ext cx="3039770" cy="274320"/>
+          </a:xfrm>
+          <a:prstGeom prst="rect">
+            <a:avLst/>
+          </a:prstGeom>
+          <a:noFill/>
+        </p:spPr>
+        <p:txBody>
+          <a:bodyPr wrap="square" anchor="t" lIns="0" rIns="0" tIns="0" bIns="0">
+            <a:spAutoFit/>
+          </a:bodyPr>
+          <a:lstStyle/>
+          <a:p>
+            <a:pPr algn="l">
+              <a:lnSpc>
+                <a:spcPct val="102000"/>
+              </a:lnSpc>
+            </a:pPr>
+            <a:r>
+              <a:rPr sz="1200" b="1" i="0">
+                <a:solidFill>
+                  <a:srgbClr val="1E2430"/>
+                </a:solidFill>
+                <a:latin typeface="Arial"/>
+                <a:cs typeface="Arial"/>
+              </a:rPr>
+              <a:t>Adiabatic by physics, not assumption</a:t>
+            </a:r>
+          </a:p>
+        </p:txBody>
+      </p:sp>
+      <p:sp>
+        <p:nvSpPr>
+          <p:cNvPr id="14" name="TextBox 13"/>
+          <p:cNvSpPr txBox="1"/>
+          <p:nvPr/>
+        </p:nvSpPr>
+        <p:spPr>
+          <a:xfrm>
+            <a:off x="4594250" y="4271590"/>
+            <a:ext cx="3039770" cy="548640"/>
+          </a:xfrm>
+          <a:prstGeom prst="rect">
+            <a:avLst/>
+          </a:prstGeom>
+          <a:noFill/>
+        </p:spPr>
+        <p:txBody>
+          <a:bodyPr wrap="square" anchor="t" lIns="0" rIns="0" tIns="0" bIns="0">
+            <a:spAutoFit/>
+          </a:bodyPr>
+          <a:lstStyle/>
+          <a:p>
+            <a:pPr algn="l">
+              <a:lnSpc>
+                <a:spcPct val="106000"/>
+              </a:lnSpc>
+            </a:pPr>
+            <a:r>
+              <a:rPr sz="1000" b="0" i="0">
+                <a:solidFill>
+                  <a:srgbClr val="3A3F47"/>
+                </a:solidFill>
+                <a:latin typeface="Arial"/>
+                <a:cs typeface="Arial"/>
+              </a:rPr>
+              <a:t>diffusion length √(αt) ≈ 0.1 mm ≪ element size over the ~100 µs run. No heat-conduction PDE needed</a:t>
+            </a:r>
+          </a:p>
+        </p:txBody>
+      </p:sp>
+      <p:sp>
+        <p:nvSpPr>
+          <p:cNvPr id="15" name="Rounded Rectangle 14"/>
+          <p:cNvSpPr/>
+          <p:nvPr/>
+        </p:nvSpPr>
+        <p:spPr>
+          <a:xfrm>
+            <a:off x="8182660" y="3878398"/>
+            <a:ext cx="3442106" cy="960120"/>
+          </a:xfrm>
+          <a:prstGeom prst="roundRect">
+            <a:avLst>
+              <a:gd name="adj" fmla="val 5500"/>
+            </a:avLst>
+          </a:prstGeom>
+          <a:solidFill>
+            <a:srgbClr val="F4F5F7"/>
+          </a:solidFill>
+          <a:ln w="9525">
+            <a:solidFill>
+              <a:srgbClr val="DADDE2"/>
+            </a:solidFill>
+          </a:ln>
+          <a:effectLst/>
+        </p:spPr>
+        <p:style>
+          <a:lnRef idx="1">
+            <a:schemeClr val="accent1"/>
+          </a:lnRef>
+          <a:fillRef idx="3">
+            <a:schemeClr val="accent1"/>
+          </a:fillRef>
+          <a:effectRef idx="2">
+            <a:schemeClr val="accent1"/>
+          </a:effectRef>
+          <a:fontRef idx="minor">
+            <a:schemeClr val="lt1"/>
+          </a:fontRef>
+        </p:style>
+        <p:txBody>
+          <a:bodyPr rtlCol="0" anchor="ctr"/>
+          <a:lstStyle/>
+          <a:p>
+            <a:pPr algn="ctr"/>
+          </a:p>
+        </p:txBody>
+      </p:sp>
+      <p:sp>
+        <p:nvSpPr>
+          <p:cNvPr id="16" name="Rectangle 15"/>
+          <p:cNvSpPr/>
+          <p:nvPr/>
+        </p:nvSpPr>
+        <p:spPr>
+          <a:xfrm>
+            <a:off x="8182660" y="3960694"/>
+            <a:ext cx="50292" cy="795528"/>
+          </a:xfrm>
+          <a:prstGeom prst="rect">
+            <a:avLst/>
+          </a:prstGeom>
+          <a:solidFill>
+            <a:srgbClr val="5E8614"/>
+          </a:solidFill>
+          <a:ln>
+            <a:noFill/>
+          </a:ln>
+          <a:effectLst/>
+        </p:spPr>
+        <p:style>
+          <a:lnRef idx="1">
+            <a:schemeClr val="accent1"/>
+          </a:lnRef>
+          <a:fillRef idx="3">
+            <a:schemeClr val="accent1"/>
+          </a:fillRef>
+          <a:effectRef idx="2">
+            <a:schemeClr val="accent1"/>
+          </a:effectRef>
+          <a:fontRef idx="minor">
+            <a:schemeClr val="lt1"/>
+          </a:fontRef>
+        </p:style>
+        <p:txBody>
+          <a:bodyPr rtlCol="0" anchor="ctr"/>
+          <a:lstStyle/>
+          <a:p>
+            <a:pPr algn="ctr"/>
+          </a:p>
+        </p:txBody>
+      </p:sp>
+      <p:sp>
+        <p:nvSpPr>
+          <p:cNvPr id="17" name="TextBox 16"/>
+          <p:cNvSpPr txBox="1"/>
+          <p:nvPr/>
+        </p:nvSpPr>
+        <p:spPr>
+          <a:xfrm>
+            <a:off x="8402116" y="3951550"/>
+            <a:ext cx="3039770" cy="274320"/>
+          </a:xfrm>
+          <a:prstGeom prst="rect">
+            <a:avLst/>
+          </a:prstGeom>
+          <a:noFill/>
+        </p:spPr>
+        <p:txBody>
+          <a:bodyPr wrap="square" anchor="t" lIns="0" rIns="0" tIns="0" bIns="0">
+            <a:spAutoFit/>
+          </a:bodyPr>
+          <a:lstStyle/>
+          <a:p>
+            <a:pPr algn="l">
+              <a:lnSpc>
+                <a:spcPct val="102000"/>
+              </a:lnSpc>
+            </a:pPr>
+            <a:r>
+              <a:rPr sz="1200" b="1" i="0">
+                <a:solidFill>
+                  <a:srgbClr val="1E2430"/>
+                </a:solidFill>
+                <a:latin typeface="Arial"/>
+                <a:cs typeface="Arial"/>
+              </a:rPr>
+              <a:t>Three extra NEML2 model blocks</a:t>
+            </a:r>
+          </a:p>
+        </p:txBody>
+      </p:sp>
+      <p:sp>
+        <p:nvSpPr>
+          <p:cNvPr id="18" name="TextBox 17"/>
+          <p:cNvSpPr txBox="1"/>
+          <p:nvPr/>
+        </p:nvSpPr>
+        <p:spPr>
+          <a:xfrm>
+            <a:off x="8402116" y="4271590"/>
+            <a:ext cx="3039770" cy="548640"/>
+          </a:xfrm>
+          <a:prstGeom prst="rect">
+            <a:avLst/>
+          </a:prstGeom>
+          <a:noFill/>
+        </p:spPr>
+        <p:txBody>
+          <a:bodyPr wrap="square" anchor="t" lIns="0" rIns="0" tIns="0" bIns="0">
+            <a:spAutoFit/>
+          </a:bodyPr>
+          <a:lstStyle/>
+          <a:p>
+            <a:pPr algn="l">
+              <a:lnSpc>
+                <a:spcPct val="106000"/>
+              </a:lnSpc>
+            </a:pPr>
+            <a:r>
+              <a:rPr sz="1000" b="0" i="0">
+                <a:solidFill>
+                  <a:srgbClr val="3A3F47"/>
+                </a:solidFill>
+                <a:latin typeface="Arial"/>
+                <a:cs typeface="Arial"/>
+              </a:rPr>
+              <a:t>no new MOOSE modules, no new transfers. Temperature state lives on the device like everything else</a:t>
+            </a:r>
+          </a:p>
+        </p:txBody>
+      </p:sp>
+    </p:spTree>
+  </p:cSld>
+  <p:clrMapOvr>
+    <a:masterClrMapping/>
+  </p:clrMapOvr>
+</p:sld>
+</file>
+
+<file path=ppt/slides/slide18.xml><?xml version="1.0" encoding="utf-8"?>
+<p:sld xmlns:a="http://schemas.openxmlformats.org/drawingml/2006/main" xmlns:p="http://schemas.openxmlformats.org/presentationml/2006/main" xmlns:r="http://schemas.openxmlformats.org/officeDocument/2006/relationships">
+  <p:cSld>
+    <p:spTree>
+      <p:nvGrpSpPr>
+        <p:cNvPr id="1" name=""/>
+        <p:cNvGrpSpPr/>
+        <p:nvPr/>
+      </p:nvGrpSpPr>
+      <p:grpSpPr/>
+      <p:sp>
+        <p:nvSpPr>
+          <p:cNvPr id="2" name="Title 1"/>
+          <p:cNvSpPr>
+            <a:spLocks noGrp="1"/>
+          </p:cNvSpPr>
+          <p:nvPr>
+            <p:ph type="title"/>
+          </p:nvPr>
+        </p:nvSpPr>
+        <p:spPr/>
+        <p:txBody>
+          <a:bodyPr/>
+          <a:lstStyle/>
+          <a:p>
+            <a:r>
+              <a:rPr sz="2600"/>
+              <a:t>Bayesian calibration of the material parameters</a:t>
+            </a:r>
+          </a:p>
+        </p:txBody>
+      </p:sp>
+      <p:sp>
+        <p:nvSpPr>
+          <p:cNvPr id="3" name="TextBox 2"/>
+          <p:cNvSpPr txBox="1"/>
+          <p:nvPr/>
+        </p:nvSpPr>
+        <p:spPr>
+          <a:xfrm>
+            <a:off x="11231575" y="274320"/>
+            <a:ext cx="685800" cy="228600"/>
+          </a:xfrm>
+          <a:prstGeom prst="rect">
+            <a:avLst/>
+          </a:prstGeom>
+          <a:noFill/>
+        </p:spPr>
+        <p:txBody>
+          <a:bodyPr wrap="square" anchor="t" lIns="0" rIns="0" tIns="0" bIns="0">
+            <a:spAutoFit/>
+          </a:bodyPr>
+          <a:lstStyle/>
+          <a:p>
+            <a:pPr algn="r"/>
+            <a:r>
+              <a:rPr sz="900" b="0" i="0">
+                <a:solidFill>
+                  <a:srgbClr val="59595C"/>
+                </a:solidFill>
+                <a:latin typeface="Arial"/>
+                <a:cs typeface="Arial"/>
+              </a:rPr>
+              <a:t>18 / 19</a:t>
             </a:r>
           </a:p>
         </p:txBody>
@@ -15418,8 +16321,8 @@
         </p:blipFill>
         <p:spPr>
           <a:xfrm>
-            <a:off x="658368" y="3721608"/>
-            <a:ext cx="4584344" cy="298856"/>
+            <a:off x="658368" y="3675888"/>
+            <a:ext cx="4212640" cy="274624"/>
           </a:xfrm>
           <a:prstGeom prst="rect">
             <a:avLst/>
@@ -15434,8 +16337,8 @@
         </p:nvSpPr>
         <p:spPr>
           <a:xfrm>
-            <a:off x="7516368" y="3758184"/>
-            <a:ext cx="4108399" cy="548640"/>
+            <a:off x="694944" y="4224528"/>
+            <a:ext cx="6309360" cy="274320"/>
           </a:xfrm>
           <a:prstGeom prst="rect">
             <a:avLst/>
@@ -15450,7 +16353,7 @@
           <a:p>
             <a:pPr algn="l"/>
             <a:r>
-              <a:rPr sz="1150" b="0" i="1">
+              <a:rPr sz="1100" b="0" i="1">
                 <a:solidFill>
                   <a:srgbClr val="59595C"/>
                 </a:solidFill>
@@ -15478,8 +16381,8 @@
         </p:blipFill>
         <p:spPr>
           <a:xfrm>
-            <a:off x="658368" y="4590288"/>
-            <a:ext cx="4553331" cy="352425"/>
+            <a:off x="658368" y="4636008"/>
+            <a:ext cx="4184142" cy="323850"/>
           </a:xfrm>
           <a:prstGeom prst="rect">
             <a:avLst/>
@@ -15494,8 +16397,8 @@
         </p:nvSpPr>
         <p:spPr>
           <a:xfrm>
-            <a:off x="7516368" y="4626864"/>
-            <a:ext cx="4108399" cy="640080"/>
+            <a:off x="694944" y="5212080"/>
+            <a:ext cx="6309360" cy="320040"/>
           </a:xfrm>
           <a:prstGeom prst="rect">
             <a:avLst/>
@@ -15510,7 +16413,7 @@
           <a:p>
             <a:pPr algn="l"/>
             <a:r>
-              <a:rPr sz="1150" b="0" i="1">
+              <a:rPr sz="1100" b="0" i="1">
                 <a:solidFill>
                   <a:srgbClr val="59595C"/>
                 </a:solidFill>
@@ -15522,6 +16425,30 @@
           </a:p>
         </p:txBody>
       </p:sp>
+      <p:pic>
+        <p:nvPicPr>
+          <p:cNvPr id="28" name="Picture 27" descr="fig_priors.png"/>
+          <p:cNvPicPr>
+            <a:picLocks noChangeAspect="1"/>
+          </p:cNvPicPr>
+          <p:nvPr/>
+        </p:nvPicPr>
+        <p:blipFill>
+          <a:blip r:embed="rId4"/>
+          <a:stretch>
+            <a:fillRect/>
+          </a:stretch>
+        </p:blipFill>
+        <p:spPr>
+          <a:xfrm>
+            <a:off x="7327087" y="3447288"/>
+            <a:ext cx="4297680" cy="2609305"/>
+          </a:xfrm>
+          <a:prstGeom prst="rect">
+            <a:avLst/>
+          </a:prstGeom>
+        </p:spPr>
+      </p:pic>
     </p:spTree>
   </p:cSld>
   <p:clrMapOvr>
@@ -15530,7 +16457,7 @@
 </p:sld>
 </file>
 
-<file path=ppt/slides/slide18.xml><?xml version="1.0" encoding="utf-8"?>
+<file path=ppt/slides/slide19.xml><?xml version="1.0" encoding="utf-8"?>
 <p:sld xmlns:a="http://schemas.openxmlformats.org/drawingml/2006/main" xmlns:p="http://schemas.openxmlformats.org/presentationml/2006/main" xmlns:r="http://schemas.openxmlformats.org/officeDocument/2006/relationships">
   <p:cSld>
     <p:spTree>
@@ -15593,7 +16520,7 @@
                 <a:latin typeface="Arial"/>
                 <a:cs typeface="Arial"/>
               </a:rPr>
-              <a:t>18 / 18</a:t>
+              <a:t>19 / 19</a:t>
             </a:r>
           </a:p>
         </p:txBody>
@@ -16197,7 +17124,7 @@
                 <a:latin typeface="Arial"/>
                 <a:cs typeface="Arial"/>
               </a:rPr>
-              <a:t>2 / 18</a:t>
+              <a:t>2 / 19</a:t>
             </a:r>
           </a:p>
         </p:txBody>
@@ -17154,7 +18081,7 @@
                 <a:latin typeface="Arial"/>
                 <a:cs typeface="Arial"/>
               </a:rPr>
-              <a:t>3 / 18</a:t>
+              <a:t>3 / 19</a:t>
             </a:r>
           </a:p>
         </p:txBody>
@@ -17831,7 +18758,7 @@
                 <a:latin typeface="Arial"/>
                 <a:cs typeface="Arial"/>
               </a:rPr>
-              <a:t>4 / 18</a:t>
+              <a:t>4 / 19</a:t>
             </a:r>
           </a:p>
         </p:txBody>
@@ -18261,7 +19188,7 @@
                 <a:latin typeface="Arial"/>
                 <a:cs typeface="Arial"/>
               </a:rPr>
-              <a:t>5 / 18</a:t>
+              <a:t>5 / 19</a:t>
             </a:r>
           </a:p>
         </p:txBody>
@@ -18637,7 +19564,7 @@
                 <a:latin typeface="Arial"/>
                 <a:cs typeface="Arial"/>
               </a:rPr>
-              <a:t>6 / 18</a:t>
+              <a:t>6 / 19</a:t>
             </a:r>
           </a:p>
         </p:txBody>
@@ -19677,7 +20604,7 @@
                 <a:latin typeface="Arial"/>
                 <a:cs typeface="Arial"/>
               </a:rPr>
-              <a:t>7 / 18</a:t>
+              <a:t>7 / 19</a:t>
             </a:r>
           </a:p>
         </p:txBody>
@@ -20382,7 +21309,7 @@
                 <a:latin typeface="Arial"/>
                 <a:cs typeface="Arial"/>
               </a:rPr>
-              <a:t>8 / 18</a:t>
+              <a:t>8 / 19</a:t>
             </a:r>
           </a:p>
         </p:txBody>
@@ -21242,7 +22169,7 @@
                 <a:latin typeface="Arial"/>
                 <a:cs typeface="Arial"/>
               </a:rPr>
-              <a:t>9 / 18</a:t>
+              <a:t>9 / 19</a:t>
             </a:r>
           </a:p>
         </p:txBody>

</xml_diff>

<commit_message>
slides: simulation videos slide (both impact clips embedded)
</commit_message>
<xml_diff>
--- a/examples/impact/slide_assets/WCCM_NEML2_explicit_dynamics_v2.pptx
+++ b/examples/impact/slide_assets/WCCM_NEML2_explicit_dynamics_v2.pptx
@@ -27,6 +27,7 @@
     <p:sldId id="272" r:id="rId26"/>
     <p:sldId id="273" r:id="rId27"/>
     <p:sldId id="274" r:id="rId28"/>
+    <p:sldId id="275" r:id="rId29"/>
   </p:sldIdLst>
   <p:sldSz cx="12192000" cy="6858000"/>
   <p:notesSz cx="6858000" cy="9144000"/>
@@ -6363,7 +6364,7 @@
                 <a:latin typeface="Arial"/>
                 <a:cs typeface="Arial"/>
               </a:rPr>
-              <a:t>10 / 19</a:t>
+              <a:t>10 / 20</a:t>
             </a:r>
           </a:p>
         </p:txBody>
@@ -8751,7 +8752,7 @@
                 <a:latin typeface="Arial"/>
                 <a:cs typeface="Arial"/>
               </a:rPr>
-              <a:t>11 / 19</a:t>
+              <a:t>11 / 20</a:t>
             </a:r>
           </a:p>
         </p:txBody>
@@ -9596,7 +9597,7 @@
                 <a:latin typeface="Arial"/>
                 <a:cs typeface="Arial"/>
               </a:rPr>
-              <a:t>12 / 19</a:t>
+              <a:t>12 / 20</a:t>
             </a:r>
           </a:p>
         </p:txBody>
@@ -11191,7 +11192,7 @@
                 <a:latin typeface="Arial"/>
                 <a:cs typeface="Arial"/>
               </a:rPr>
-              <a:t>13 / 19</a:t>
+              <a:t>13 / 20</a:t>
             </a:r>
           </a:p>
         </p:txBody>
@@ -12471,7 +12472,7 @@
                 <a:latin typeface="Arial"/>
                 <a:cs typeface="Arial"/>
               </a:rPr>
-              <a:t>14 / 19</a:t>
+              <a:t>14 / 20</a:t>
             </a:r>
           </a:p>
         </p:txBody>
@@ -13345,7 +13346,7 @@
                 <a:latin typeface="Arial"/>
                 <a:cs typeface="Arial"/>
               </a:rPr>
-              <a:t>15 / 19</a:t>
+              <a:t>15 / 20</a:t>
             </a:r>
           </a:p>
         </p:txBody>
@@ -14247,7 +14248,7 @@
                 <a:latin typeface="Arial"/>
                 <a:cs typeface="Arial"/>
               </a:rPr>
-              <a:t>16 / 19</a:t>
+              <a:t>16 / 20</a:t>
             </a:r>
           </a:p>
         </p:txBody>
@@ -14570,7 +14571,7 @@
           <a:p>
             <a:r>
               <a:rPr sz="2600"/>
-              <a:t>Coupled thermo-mechanics: heating from plastic work</a:t>
+              <a:t>The simulated impact</a:t>
             </a:r>
           </a:p>
         </p:txBody>
@@ -14606,85 +14607,38 @@
                 <a:latin typeface="Arial"/>
                 <a:cs typeface="Arial"/>
               </a:rPr>
-              <a:t>17 / 19</a:t>
-            </a:r>
-          </a:p>
-        </p:txBody>
-      </p:sp>
-      <p:sp>
-        <p:nvSpPr>
-          <p:cNvPr id="4" name="TextBox 3"/>
-          <p:cNvSpPr txBox="1"/>
-          <p:nvPr/>
-        </p:nvSpPr>
-        <p:spPr>
-          <a:xfrm>
-            <a:off x="566928" y="1133856"/>
-            <a:ext cx="11057839" cy="320040"/>
-          </a:xfrm>
-          <a:prstGeom prst="rect">
-            <a:avLst/>
-          </a:prstGeom>
-          <a:noFill/>
-        </p:spPr>
-        <p:txBody>
-          <a:bodyPr wrap="square" anchor="t" lIns="0" rIns="0" tIns="0" bIns="0">
-            <a:spAutoFit/>
-          </a:bodyPr>
-          <a:lstStyle/>
-          <a:p>
-            <a:pPr algn="l"/>
-            <a:r>
-              <a:rPr sz="1450" b="0" i="0">
-                <a:solidFill>
-                  <a:srgbClr val="3A3F47"/>
-                </a:solidFill>
-                <a:latin typeface="Arial"/>
-                <a:cs typeface="Arial"/>
-              </a:rPr>
-              <a:t>The run you just saw is coupled. Temperature is integrated </a:t>
-            </a:r>
-            <a:r>
-              <a:rPr sz="1450" b="1" i="0">
-                <a:solidFill>
-                  <a:srgbClr val="1E2430"/>
-                </a:solidFill>
-                <a:latin typeface="Arial"/>
-                <a:cs typeface="Arial"/>
-              </a:rPr>
-              <a:t>inside the NEML2 model</a:t>
-            </a:r>
-            <a:r>
-              <a:rPr sz="1450" b="0" i="0">
-                <a:solidFill>
-                  <a:srgbClr val="3A3F47"/>
-                </a:solidFill>
-                <a:latin typeface="Arial"/>
-                <a:cs typeface="Arial"/>
-              </a:rPr>
-              <a:t> (adiabatic Taylor–Quinney heating, β = 0.9)</a:t>
+              <a:t>17 / 20</a:t>
             </a:r>
           </a:p>
         </p:txBody>
       </p:sp>
       <p:pic>
         <p:nvPicPr>
-          <p:cNvPr id="5" name="Picture 4" descr="fig_thermal.png"/>
+          <p:cNvPr id="4" name="slug_impact_horizontal.mp4">
+            <a:hlinkClick r:id="" action="ppaction://media"/>
+          </p:cNvPr>
           <p:cNvPicPr>
             <a:picLocks noChangeAspect="1"/>
           </p:cNvPicPr>
-          <p:nvPr/>
+          <p:nvPr>
+            <a:videoFile r:link="rId3"/>
+            <p:extLst>
+              <p:ext uri="{DAA4B4D4-6D71-4841-9C94-3DE7FCFB9230}">
+                <p14:media xmlns:p14="http://schemas.microsoft.com/office/powerpoint/2010/main" r:embed="rId2"/>
+              </p:ext>
+            </p:extLst>
+          </p:nvPr>
         </p:nvPicPr>
         <p:blipFill>
-          <a:blip r:embed="rId2"/>
+          <a:blip r:embed="rId4"/>
           <a:stretch>
             <a:fillRect/>
           </a:stretch>
         </p:blipFill>
         <p:spPr>
           <a:xfrm>
-            <a:off x="1755648" y="1609344"/>
-            <a:ext cx="7498079" cy="1921582"/>
+            <a:off x="566928" y="1709928"/>
+            <a:ext cx="5300319" cy="2981429"/>
           </a:xfrm>
           <a:prstGeom prst="rect">
             <a:avLst/>
@@ -14693,14 +14647,14 @@
       </p:pic>
       <p:sp>
         <p:nvSpPr>
-          <p:cNvPr id="6" name="TextBox 5"/>
+          <p:cNvPr id="5" name="TextBox 4"/>
           <p:cNvSpPr txBox="1"/>
           <p:nvPr/>
         </p:nvSpPr>
         <p:spPr>
           <a:xfrm>
-            <a:off x="1847088" y="3558358"/>
-            <a:ext cx="10058400" cy="256032"/>
+            <a:off x="612648" y="4764509"/>
+            <a:ext cx="5300319" cy="274320"/>
           </a:xfrm>
           <a:prstGeom prst="rect">
             <a:avLst/>
@@ -14722,113 +14676,54 @@
                 <a:latin typeface="Arial"/>
                 <a:cs typeface="Arial"/>
               </a:rPr>
-              <a:t>temperature rise above 300 K, cutaway views. Run to rebound at 96 µs with &gt;99% of the impact kinetic energy dissipated</a:t>
-            </a:r>
-          </a:p>
-        </p:txBody>
-      </p:sp>
-      <p:sp>
-        <p:nvSpPr>
-          <p:cNvPr id="7" name="Rounded Rectangle 6"/>
-          <p:cNvSpPr/>
-          <p:nvPr/>
-        </p:nvSpPr>
-        <p:spPr>
-          <a:xfrm>
-            <a:off x="566928" y="3878398"/>
-            <a:ext cx="3442106" cy="960120"/>
-          </a:xfrm>
-          <a:prstGeom prst="roundRect">
-            <a:avLst>
-              <a:gd name="adj" fmla="val 5500"/>
-            </a:avLst>
-          </a:prstGeom>
-          <a:solidFill>
-            <a:srgbClr val="F4F5F7"/>
-          </a:solidFill>
-          <a:ln w="9525">
-            <a:solidFill>
-              <a:srgbClr val="DADDE2"/>
-            </a:solidFill>
-          </a:ln>
-          <a:effectLst/>
-        </p:spPr>
-        <p:style>
-          <a:lnRef idx="1">
-            <a:schemeClr val="accent1"/>
-          </a:lnRef>
-          <a:fillRef idx="3">
-            <a:schemeClr val="accent1"/>
-          </a:fillRef>
-          <a:effectRef idx="2">
-            <a:schemeClr val="accent1"/>
-          </a:effectRef>
-          <a:fontRef idx="minor">
-            <a:schemeClr val="lt1"/>
-          </a:fontRef>
-        </p:style>
-        <p:txBody>
-          <a:bodyPr rtlCol="0" anchor="ctr"/>
-          <a:lstStyle/>
-          <a:p>
-            <a:pPr algn="ctr"/>
-          </a:p>
-        </p:txBody>
-      </p:sp>
-      <p:sp>
-        <p:nvSpPr>
-          <p:cNvPr id="8" name="Rectangle 7"/>
-          <p:cNvSpPr/>
-          <p:nvPr/>
-        </p:nvSpPr>
-        <p:spPr>
-          <a:xfrm>
-            <a:off x="566928" y="3960694"/>
-            <a:ext cx="50292" cy="795528"/>
-          </a:xfrm>
-          <a:prstGeom prst="rect">
-            <a:avLst/>
-          </a:prstGeom>
-          <a:solidFill>
-            <a:srgbClr val="CF1D4C"/>
-          </a:solidFill>
-          <a:ln>
-            <a:noFill/>
-          </a:ln>
-          <a:effectLst/>
-        </p:spPr>
-        <p:style>
-          <a:lnRef idx="1">
-            <a:schemeClr val="accent1"/>
-          </a:lnRef>
-          <a:fillRef idx="3">
-            <a:schemeClr val="accent1"/>
-          </a:fillRef>
-          <a:effectRef idx="2">
-            <a:schemeClr val="accent1"/>
-          </a:effectRef>
-          <a:fontRef idx="minor">
-            <a:schemeClr val="lt1"/>
-          </a:fontRef>
-        </p:style>
-        <p:txBody>
-          <a:bodyPr rtlCol="0" anchor="ctr"/>
-          <a:lstStyle/>
-          <a:p>
-            <a:pPr algn="ctr"/>
-          </a:p>
-        </p:txBody>
-      </p:sp>
-      <p:sp>
-        <p:nvSpPr>
-          <p:cNvPr id="9" name="TextBox 8"/>
+              <a:t>perspective view</a:t>
+            </a:r>
+          </a:p>
+        </p:txBody>
+      </p:sp>
+      <p:pic>
+        <p:nvPicPr>
+          <p:cNvPr id="6" name="slug_impact_side.mp4">
+            <a:hlinkClick r:id="" action="ppaction://media"/>
+          </p:cNvPr>
+          <p:cNvPicPr>
+            <a:picLocks noChangeAspect="1"/>
+          </p:cNvPicPr>
+          <p:nvPr>
+            <a:videoFile r:link="rId6"/>
+            <p:extLst>
+              <p:ext uri="{DAA4B4D4-6D71-4841-9C94-3DE7FCFB9230}">
+                <p14:media xmlns:p14="http://schemas.microsoft.com/office/powerpoint/2010/main" r:embed="rId5"/>
+              </p:ext>
+            </p:extLst>
+          </p:nvPr>
+        </p:nvPicPr>
+        <p:blipFill>
+          <a:blip r:embed="rId7"/>
+          <a:stretch>
+            <a:fillRect/>
+          </a:stretch>
+        </p:blipFill>
+        <p:spPr>
+          <a:xfrm>
+            <a:off x="6324447" y="1709928"/>
+            <a:ext cx="5300319" cy="2981429"/>
+          </a:xfrm>
+          <a:prstGeom prst="rect">
+            <a:avLst/>
+          </a:prstGeom>
+        </p:spPr>
+      </p:pic>
+      <p:sp>
+        <p:nvSpPr>
+          <p:cNvPr id="7" name="TextBox 6"/>
           <p:cNvSpPr txBox="1"/>
           <p:nvPr/>
         </p:nvSpPr>
         <p:spPr>
           <a:xfrm>
-            <a:off x="786384" y="3951550"/>
-            <a:ext cx="3039770" cy="274320"/>
+            <a:off x="6370167" y="4764509"/>
+            <a:ext cx="5300319" cy="274320"/>
           </a:xfrm>
           <a:prstGeom prst="rect">
             <a:avLst/>
@@ -14841,34 +14736,30 @@
           </a:bodyPr>
           <a:lstStyle/>
           <a:p>
-            <a:pPr algn="l">
-              <a:lnSpc>
-                <a:spcPct val="102000"/>
-              </a:lnSpc>
-            </a:pPr>
-            <a:r>
-              <a:rPr sz="1200" b="1" i="0">
-                <a:solidFill>
-                  <a:srgbClr val="1E2430"/>
-                </a:solidFill>
-                <a:latin typeface="Arial"/>
-                <a:cs typeface="Arial"/>
-              </a:rPr>
-              <a:t>Feeds back into the flow stress</a:t>
-            </a:r>
-          </a:p>
-        </p:txBody>
-      </p:sp>
-      <p:sp>
-        <p:nvSpPr>
-          <p:cNvPr id="10" name="TextBox 9"/>
+            <a:pPr algn="l"/>
+            <a:r>
+              <a:rPr sz="1100" b="0" i="1">
+                <a:solidFill>
+                  <a:srgbClr val="59595C"/>
+                </a:solidFill>
+                <a:latin typeface="Arial"/>
+                <a:cs typeface="Arial"/>
+              </a:rPr>
+              <a:t>side profile, the high-speed camera framing</a:t>
+            </a:r>
+          </a:p>
+        </p:txBody>
+      </p:sp>
+      <p:sp>
+        <p:nvSpPr>
+          <p:cNvPr id="8" name="TextBox 7"/>
           <p:cNvSpPr txBox="1"/>
           <p:nvPr/>
         </p:nvSpPr>
         <p:spPr>
           <a:xfrm>
-            <a:off x="786384" y="4271590"/>
-            <a:ext cx="3039770" cy="548640"/>
+            <a:off x="566928" y="5194277"/>
+            <a:ext cx="11057839" cy="320040"/>
           </a:xfrm>
           <a:prstGeom prst="rect">
             <a:avLst/>
@@ -14881,364 +14772,16 @@
           </a:bodyPr>
           <a:lstStyle/>
           <a:p>
-            <a:pPr algn="l">
-              <a:lnSpc>
-                <a:spcPct val="106000"/>
-              </a:lnSpc>
-            </a:pPr>
-            <a:r>
-              <a:rPr sz="1000" b="0" i="0">
+            <a:pPr algn="l"/>
+            <a:r>
+              <a:rPr sz="1300" b="0" i="0">
                 <a:solidFill>
                   <a:srgbClr val="3A3F47"/>
                 </a:solidFill>
                 <a:latin typeface="Arial"/>
                 <a:cs typeface="Arial"/>
               </a:rPr>
-              <a:t>the hot foot softens (Johnson–Cook Θ = 1 − T*ᵐ) and flows more easily</a:t>
-            </a:r>
-          </a:p>
-        </p:txBody>
-      </p:sp>
-      <p:sp>
-        <p:nvSpPr>
-          <p:cNvPr id="11" name="Rounded Rectangle 10"/>
-          <p:cNvSpPr/>
-          <p:nvPr/>
-        </p:nvSpPr>
-        <p:spPr>
-          <a:xfrm>
-            <a:off x="4374794" y="3878398"/>
-            <a:ext cx="3442106" cy="960120"/>
-          </a:xfrm>
-          <a:prstGeom prst="roundRect">
-            <a:avLst>
-              <a:gd name="adj" fmla="val 5500"/>
-            </a:avLst>
-          </a:prstGeom>
-          <a:solidFill>
-            <a:srgbClr val="F4F5F7"/>
-          </a:solidFill>
-          <a:ln w="9525">
-            <a:solidFill>
-              <a:srgbClr val="DADDE2"/>
-            </a:solidFill>
-          </a:ln>
-          <a:effectLst/>
-        </p:spPr>
-        <p:style>
-          <a:lnRef idx="1">
-            <a:schemeClr val="accent1"/>
-          </a:lnRef>
-          <a:fillRef idx="3">
-            <a:schemeClr val="accent1"/>
-          </a:fillRef>
-          <a:effectRef idx="2">
-            <a:schemeClr val="accent1"/>
-          </a:effectRef>
-          <a:fontRef idx="minor">
-            <a:schemeClr val="lt1"/>
-          </a:fontRef>
-        </p:style>
-        <p:txBody>
-          <a:bodyPr rtlCol="0" anchor="ctr"/>
-          <a:lstStyle/>
-          <a:p>
-            <a:pPr algn="ctr"/>
-          </a:p>
-        </p:txBody>
-      </p:sp>
-      <p:sp>
-        <p:nvSpPr>
-          <p:cNvPr id="12" name="Rectangle 11"/>
-          <p:cNvSpPr/>
-          <p:nvPr/>
-        </p:nvSpPr>
-        <p:spPr>
-          <a:xfrm>
-            <a:off x="4374794" y="3960694"/>
-            <a:ext cx="50292" cy="795528"/>
-          </a:xfrm>
-          <a:prstGeom prst="rect">
-            <a:avLst/>
-          </a:prstGeom>
-          <a:solidFill>
-            <a:srgbClr val="06509D"/>
-          </a:solidFill>
-          <a:ln>
-            <a:noFill/>
-          </a:ln>
-          <a:effectLst/>
-        </p:spPr>
-        <p:style>
-          <a:lnRef idx="1">
-            <a:schemeClr val="accent1"/>
-          </a:lnRef>
-          <a:fillRef idx="3">
-            <a:schemeClr val="accent1"/>
-          </a:fillRef>
-          <a:effectRef idx="2">
-            <a:schemeClr val="accent1"/>
-          </a:effectRef>
-          <a:fontRef idx="minor">
-            <a:schemeClr val="lt1"/>
-          </a:fontRef>
-        </p:style>
-        <p:txBody>
-          <a:bodyPr rtlCol="0" anchor="ctr"/>
-          <a:lstStyle/>
-          <a:p>
-            <a:pPr algn="ctr"/>
-          </a:p>
-        </p:txBody>
-      </p:sp>
-      <p:sp>
-        <p:nvSpPr>
-          <p:cNvPr id="13" name="TextBox 12"/>
-          <p:cNvSpPr txBox="1"/>
-          <p:nvPr/>
-        </p:nvSpPr>
-        <p:spPr>
-          <a:xfrm>
-            <a:off x="4594250" y="3951550"/>
-            <a:ext cx="3039770" cy="274320"/>
-          </a:xfrm>
-          <a:prstGeom prst="rect">
-            <a:avLst/>
-          </a:prstGeom>
-          <a:noFill/>
-        </p:spPr>
-        <p:txBody>
-          <a:bodyPr wrap="square" anchor="t" lIns="0" rIns="0" tIns="0" bIns="0">
-            <a:spAutoFit/>
-          </a:bodyPr>
-          <a:lstStyle/>
-          <a:p>
-            <a:pPr algn="l">
-              <a:lnSpc>
-                <a:spcPct val="102000"/>
-              </a:lnSpc>
-            </a:pPr>
-            <a:r>
-              <a:rPr sz="1200" b="1" i="0">
-                <a:solidFill>
-                  <a:srgbClr val="1E2430"/>
-                </a:solidFill>
-                <a:latin typeface="Arial"/>
-                <a:cs typeface="Arial"/>
-              </a:rPr>
-              <a:t>Adiabatic by physics, not assumption</a:t>
-            </a:r>
-          </a:p>
-        </p:txBody>
-      </p:sp>
-      <p:sp>
-        <p:nvSpPr>
-          <p:cNvPr id="14" name="TextBox 13"/>
-          <p:cNvSpPr txBox="1"/>
-          <p:nvPr/>
-        </p:nvSpPr>
-        <p:spPr>
-          <a:xfrm>
-            <a:off x="4594250" y="4271590"/>
-            <a:ext cx="3039770" cy="548640"/>
-          </a:xfrm>
-          <a:prstGeom prst="rect">
-            <a:avLst/>
-          </a:prstGeom>
-          <a:noFill/>
-        </p:spPr>
-        <p:txBody>
-          <a:bodyPr wrap="square" anchor="t" lIns="0" rIns="0" tIns="0" bIns="0">
-            <a:spAutoFit/>
-          </a:bodyPr>
-          <a:lstStyle/>
-          <a:p>
-            <a:pPr algn="l">
-              <a:lnSpc>
-                <a:spcPct val="106000"/>
-              </a:lnSpc>
-            </a:pPr>
-            <a:r>
-              <a:rPr sz="1000" b="0" i="0">
-                <a:solidFill>
-                  <a:srgbClr val="3A3F47"/>
-                </a:solidFill>
-                <a:latin typeface="Arial"/>
-                <a:cs typeface="Arial"/>
-              </a:rPr>
-              <a:t>diffusion length √(αt) ≈ 0.1 mm ≪ element size over the ~100 µs run. No heat-conduction PDE needed</a:t>
-            </a:r>
-          </a:p>
-        </p:txBody>
-      </p:sp>
-      <p:sp>
-        <p:nvSpPr>
-          <p:cNvPr id="15" name="Rounded Rectangle 14"/>
-          <p:cNvSpPr/>
-          <p:nvPr/>
-        </p:nvSpPr>
-        <p:spPr>
-          <a:xfrm>
-            <a:off x="8182660" y="3878398"/>
-            <a:ext cx="3442106" cy="960120"/>
-          </a:xfrm>
-          <a:prstGeom prst="roundRect">
-            <a:avLst>
-              <a:gd name="adj" fmla="val 5500"/>
-            </a:avLst>
-          </a:prstGeom>
-          <a:solidFill>
-            <a:srgbClr val="F4F5F7"/>
-          </a:solidFill>
-          <a:ln w="9525">
-            <a:solidFill>
-              <a:srgbClr val="DADDE2"/>
-            </a:solidFill>
-          </a:ln>
-          <a:effectLst/>
-        </p:spPr>
-        <p:style>
-          <a:lnRef idx="1">
-            <a:schemeClr val="accent1"/>
-          </a:lnRef>
-          <a:fillRef idx="3">
-            <a:schemeClr val="accent1"/>
-          </a:fillRef>
-          <a:effectRef idx="2">
-            <a:schemeClr val="accent1"/>
-          </a:effectRef>
-          <a:fontRef idx="minor">
-            <a:schemeClr val="lt1"/>
-          </a:fontRef>
-        </p:style>
-        <p:txBody>
-          <a:bodyPr rtlCol="0" anchor="ctr"/>
-          <a:lstStyle/>
-          <a:p>
-            <a:pPr algn="ctr"/>
-          </a:p>
-        </p:txBody>
-      </p:sp>
-      <p:sp>
-        <p:nvSpPr>
-          <p:cNvPr id="16" name="Rectangle 15"/>
-          <p:cNvSpPr/>
-          <p:nvPr/>
-        </p:nvSpPr>
-        <p:spPr>
-          <a:xfrm>
-            <a:off x="8182660" y="3960694"/>
-            <a:ext cx="50292" cy="795528"/>
-          </a:xfrm>
-          <a:prstGeom prst="rect">
-            <a:avLst/>
-          </a:prstGeom>
-          <a:solidFill>
-            <a:srgbClr val="5E8614"/>
-          </a:solidFill>
-          <a:ln>
-            <a:noFill/>
-          </a:ln>
-          <a:effectLst/>
-        </p:spPr>
-        <p:style>
-          <a:lnRef idx="1">
-            <a:schemeClr val="accent1"/>
-          </a:lnRef>
-          <a:fillRef idx="3">
-            <a:schemeClr val="accent1"/>
-          </a:fillRef>
-          <a:effectRef idx="2">
-            <a:schemeClr val="accent1"/>
-          </a:effectRef>
-          <a:fontRef idx="minor">
-            <a:schemeClr val="lt1"/>
-          </a:fontRef>
-        </p:style>
-        <p:txBody>
-          <a:bodyPr rtlCol="0" anchor="ctr"/>
-          <a:lstStyle/>
-          <a:p>
-            <a:pPr algn="ctr"/>
-          </a:p>
-        </p:txBody>
-      </p:sp>
-      <p:sp>
-        <p:nvSpPr>
-          <p:cNvPr id="17" name="TextBox 16"/>
-          <p:cNvSpPr txBox="1"/>
-          <p:nvPr/>
-        </p:nvSpPr>
-        <p:spPr>
-          <a:xfrm>
-            <a:off x="8402116" y="3951550"/>
-            <a:ext cx="3039770" cy="274320"/>
-          </a:xfrm>
-          <a:prstGeom prst="rect">
-            <a:avLst/>
-          </a:prstGeom>
-          <a:noFill/>
-        </p:spPr>
-        <p:txBody>
-          <a:bodyPr wrap="square" anchor="t" lIns="0" rIns="0" tIns="0" bIns="0">
-            <a:spAutoFit/>
-          </a:bodyPr>
-          <a:lstStyle/>
-          <a:p>
-            <a:pPr algn="l">
-              <a:lnSpc>
-                <a:spcPct val="102000"/>
-              </a:lnSpc>
-            </a:pPr>
-            <a:r>
-              <a:rPr sz="1200" b="1" i="0">
-                <a:solidFill>
-                  <a:srgbClr val="1E2430"/>
-                </a:solidFill>
-                <a:latin typeface="Arial"/>
-                <a:cs typeface="Arial"/>
-              </a:rPr>
-              <a:t>Three extra NEML2 model blocks</a:t>
-            </a:r>
-          </a:p>
-        </p:txBody>
-      </p:sp>
-      <p:sp>
-        <p:nvSpPr>
-          <p:cNvPr id="18" name="TextBox 17"/>
-          <p:cNvSpPr txBox="1"/>
-          <p:nvPr/>
-        </p:nvSpPr>
-        <p:spPr>
-          <a:xfrm>
-            <a:off x="8402116" y="4271590"/>
-            <a:ext cx="3039770" cy="548640"/>
-          </a:xfrm>
-          <a:prstGeom prst="rect">
-            <a:avLst/>
-          </a:prstGeom>
-          <a:noFill/>
-        </p:spPr>
-        <p:txBody>
-          <a:bodyPr wrap="square" anchor="t" lIns="0" rIns="0" tIns="0" bIns="0">
-            <a:spAutoFit/>
-          </a:bodyPr>
-          <a:lstStyle/>
-          <a:p>
-            <a:pPr algn="l">
-              <a:lnSpc>
-                <a:spcPct val="106000"/>
-              </a:lnSpc>
-            </a:pPr>
-            <a:r>
-              <a:rPr sz="1000" b="0" i="0">
-                <a:solidFill>
-                  <a:srgbClr val="3A3F47"/>
-                </a:solidFill>
-                <a:latin typeface="Arial"/>
-                <a:cs typeface="Arial"/>
-              </a:rPr>
-              <a:t>no new MOOSE modules, no new transfers. Temperature state lives on the device like everything else</a:t>
+              <a:t>Calibrated model, run to rebound at 96.9 µs. Color is effective plastic strain.</a:t>
             </a:r>
           </a:p>
         </p:txBody>
@@ -15248,6 +14791,40 @@
   <p:clrMapOvr>
     <a:masterClrMapping/>
   </p:clrMapOvr>
+  <p:timing>
+    <p:tnLst>
+      <p:par>
+        <p:cTn id="1" dur="indefinite" restart="never" nodeType="tmRoot">
+          <p:childTnLst>
+            <p:video>
+              <p:cMediaNode vol="80000">
+                <p:cTn id="2" fill="hold" display="0">
+                  <p:stCondLst>
+                    <p:cond delay="indefinite"/>
+                  </p:stCondLst>
+                </p:cTn>
+                <p:tgtEl>
+                  <p:spTgt spid="4"/>
+                </p:tgtEl>
+              </p:cMediaNode>
+            </p:video>
+            <p:video>
+              <p:cMediaNode vol="80000">
+                <p:cTn id="3" fill="hold" display="0">
+                  <p:stCondLst>
+                    <p:cond delay="indefinite"/>
+                  </p:stCondLst>
+                </p:cTn>
+                <p:tgtEl>
+                  <p:spTgt spid="6"/>
+                </p:tgtEl>
+              </p:cMediaNode>
+            </p:video>
+          </p:childTnLst>
+        </p:cTn>
+      </p:par>
+    </p:tnLst>
+  </p:timing>
 </p:sld>
 </file>
 
@@ -15278,7 +14855,7 @@
           <a:p>
             <a:r>
               <a:rPr sz="2600"/>
-              <a:t>Bayesian calibration of the material parameters</a:t>
+              <a:t>Coupled thermo-mechanics: heating from plastic work</a:t>
             </a:r>
           </a:p>
         </p:txBody>
@@ -15314,7 +14891,715 @@
                 <a:latin typeface="Arial"/>
                 <a:cs typeface="Arial"/>
               </a:rPr>
-              <a:t>18 / 19</a:t>
+              <a:t>18 / 20</a:t>
+            </a:r>
+          </a:p>
+        </p:txBody>
+      </p:sp>
+      <p:sp>
+        <p:nvSpPr>
+          <p:cNvPr id="4" name="TextBox 3"/>
+          <p:cNvSpPr txBox="1"/>
+          <p:nvPr/>
+        </p:nvSpPr>
+        <p:spPr>
+          <a:xfrm>
+            <a:off x="566928" y="1133856"/>
+            <a:ext cx="11057839" cy="320040"/>
+          </a:xfrm>
+          <a:prstGeom prst="rect">
+            <a:avLst/>
+          </a:prstGeom>
+          <a:noFill/>
+        </p:spPr>
+        <p:txBody>
+          <a:bodyPr wrap="square" anchor="t" lIns="0" rIns="0" tIns="0" bIns="0">
+            <a:spAutoFit/>
+          </a:bodyPr>
+          <a:lstStyle/>
+          <a:p>
+            <a:pPr algn="l"/>
+            <a:r>
+              <a:rPr sz="1450" b="0" i="0">
+                <a:solidFill>
+                  <a:srgbClr val="3A3F47"/>
+                </a:solidFill>
+                <a:latin typeface="Arial"/>
+                <a:cs typeface="Arial"/>
+              </a:rPr>
+              <a:t>The run you just saw is coupled. Temperature is integrated </a:t>
+            </a:r>
+            <a:r>
+              <a:rPr sz="1450" b="1" i="0">
+                <a:solidFill>
+                  <a:srgbClr val="1E2430"/>
+                </a:solidFill>
+                <a:latin typeface="Arial"/>
+                <a:cs typeface="Arial"/>
+              </a:rPr>
+              <a:t>inside the NEML2 model</a:t>
+            </a:r>
+            <a:r>
+              <a:rPr sz="1450" b="0" i="0">
+                <a:solidFill>
+                  <a:srgbClr val="3A3F47"/>
+                </a:solidFill>
+                <a:latin typeface="Arial"/>
+                <a:cs typeface="Arial"/>
+              </a:rPr>
+              <a:t> (adiabatic Taylor–Quinney heating, β = 0.9)</a:t>
+            </a:r>
+          </a:p>
+        </p:txBody>
+      </p:sp>
+      <p:pic>
+        <p:nvPicPr>
+          <p:cNvPr id="5" name="Picture 4" descr="fig_thermal.png"/>
+          <p:cNvPicPr>
+            <a:picLocks noChangeAspect="1"/>
+          </p:cNvPicPr>
+          <p:nvPr/>
+        </p:nvPicPr>
+        <p:blipFill>
+          <a:blip r:embed="rId2"/>
+          <a:stretch>
+            <a:fillRect/>
+          </a:stretch>
+        </p:blipFill>
+        <p:spPr>
+          <a:xfrm>
+            <a:off x="1755648" y="1609344"/>
+            <a:ext cx="7498079" cy="1921582"/>
+          </a:xfrm>
+          <a:prstGeom prst="rect">
+            <a:avLst/>
+          </a:prstGeom>
+        </p:spPr>
+      </p:pic>
+      <p:sp>
+        <p:nvSpPr>
+          <p:cNvPr id="6" name="TextBox 5"/>
+          <p:cNvSpPr txBox="1"/>
+          <p:nvPr/>
+        </p:nvSpPr>
+        <p:spPr>
+          <a:xfrm>
+            <a:off x="1847088" y="3558358"/>
+            <a:ext cx="10058400" cy="256032"/>
+          </a:xfrm>
+          <a:prstGeom prst="rect">
+            <a:avLst/>
+          </a:prstGeom>
+          <a:noFill/>
+        </p:spPr>
+        <p:txBody>
+          <a:bodyPr wrap="square" anchor="t" lIns="0" rIns="0" tIns="0" bIns="0">
+            <a:spAutoFit/>
+          </a:bodyPr>
+          <a:lstStyle/>
+          <a:p>
+            <a:pPr algn="l"/>
+            <a:r>
+              <a:rPr sz="1100" b="0" i="1">
+                <a:solidFill>
+                  <a:srgbClr val="59595C"/>
+                </a:solidFill>
+                <a:latin typeface="Arial"/>
+                <a:cs typeface="Arial"/>
+              </a:rPr>
+              <a:t>temperature rise above 300 K, cutaway views. Run to rebound at 96 µs with &gt;99% of the impact kinetic energy dissipated</a:t>
+            </a:r>
+          </a:p>
+        </p:txBody>
+      </p:sp>
+      <p:sp>
+        <p:nvSpPr>
+          <p:cNvPr id="7" name="Rounded Rectangle 6"/>
+          <p:cNvSpPr/>
+          <p:nvPr/>
+        </p:nvSpPr>
+        <p:spPr>
+          <a:xfrm>
+            <a:off x="566928" y="3878398"/>
+            <a:ext cx="3442106" cy="960120"/>
+          </a:xfrm>
+          <a:prstGeom prst="roundRect">
+            <a:avLst>
+              <a:gd name="adj" fmla="val 5500"/>
+            </a:avLst>
+          </a:prstGeom>
+          <a:solidFill>
+            <a:srgbClr val="F4F5F7"/>
+          </a:solidFill>
+          <a:ln w="9525">
+            <a:solidFill>
+              <a:srgbClr val="DADDE2"/>
+            </a:solidFill>
+          </a:ln>
+          <a:effectLst/>
+        </p:spPr>
+        <p:style>
+          <a:lnRef idx="1">
+            <a:schemeClr val="accent1"/>
+          </a:lnRef>
+          <a:fillRef idx="3">
+            <a:schemeClr val="accent1"/>
+          </a:fillRef>
+          <a:effectRef idx="2">
+            <a:schemeClr val="accent1"/>
+          </a:effectRef>
+          <a:fontRef idx="minor">
+            <a:schemeClr val="lt1"/>
+          </a:fontRef>
+        </p:style>
+        <p:txBody>
+          <a:bodyPr rtlCol="0" anchor="ctr"/>
+          <a:lstStyle/>
+          <a:p>
+            <a:pPr algn="ctr"/>
+          </a:p>
+        </p:txBody>
+      </p:sp>
+      <p:sp>
+        <p:nvSpPr>
+          <p:cNvPr id="8" name="Rectangle 7"/>
+          <p:cNvSpPr/>
+          <p:nvPr/>
+        </p:nvSpPr>
+        <p:spPr>
+          <a:xfrm>
+            <a:off x="566928" y="3960694"/>
+            <a:ext cx="50292" cy="795528"/>
+          </a:xfrm>
+          <a:prstGeom prst="rect">
+            <a:avLst/>
+          </a:prstGeom>
+          <a:solidFill>
+            <a:srgbClr val="CF1D4C"/>
+          </a:solidFill>
+          <a:ln>
+            <a:noFill/>
+          </a:ln>
+          <a:effectLst/>
+        </p:spPr>
+        <p:style>
+          <a:lnRef idx="1">
+            <a:schemeClr val="accent1"/>
+          </a:lnRef>
+          <a:fillRef idx="3">
+            <a:schemeClr val="accent1"/>
+          </a:fillRef>
+          <a:effectRef idx="2">
+            <a:schemeClr val="accent1"/>
+          </a:effectRef>
+          <a:fontRef idx="minor">
+            <a:schemeClr val="lt1"/>
+          </a:fontRef>
+        </p:style>
+        <p:txBody>
+          <a:bodyPr rtlCol="0" anchor="ctr"/>
+          <a:lstStyle/>
+          <a:p>
+            <a:pPr algn="ctr"/>
+          </a:p>
+        </p:txBody>
+      </p:sp>
+      <p:sp>
+        <p:nvSpPr>
+          <p:cNvPr id="9" name="TextBox 8"/>
+          <p:cNvSpPr txBox="1"/>
+          <p:nvPr/>
+        </p:nvSpPr>
+        <p:spPr>
+          <a:xfrm>
+            <a:off x="786384" y="3951550"/>
+            <a:ext cx="3039770" cy="274320"/>
+          </a:xfrm>
+          <a:prstGeom prst="rect">
+            <a:avLst/>
+          </a:prstGeom>
+          <a:noFill/>
+        </p:spPr>
+        <p:txBody>
+          <a:bodyPr wrap="square" anchor="t" lIns="0" rIns="0" tIns="0" bIns="0">
+            <a:spAutoFit/>
+          </a:bodyPr>
+          <a:lstStyle/>
+          <a:p>
+            <a:pPr algn="l">
+              <a:lnSpc>
+                <a:spcPct val="102000"/>
+              </a:lnSpc>
+            </a:pPr>
+            <a:r>
+              <a:rPr sz="1200" b="1" i="0">
+                <a:solidFill>
+                  <a:srgbClr val="1E2430"/>
+                </a:solidFill>
+                <a:latin typeface="Arial"/>
+                <a:cs typeface="Arial"/>
+              </a:rPr>
+              <a:t>Feeds back into the flow stress</a:t>
+            </a:r>
+          </a:p>
+        </p:txBody>
+      </p:sp>
+      <p:sp>
+        <p:nvSpPr>
+          <p:cNvPr id="10" name="TextBox 9"/>
+          <p:cNvSpPr txBox="1"/>
+          <p:nvPr/>
+        </p:nvSpPr>
+        <p:spPr>
+          <a:xfrm>
+            <a:off x="786384" y="4271590"/>
+            <a:ext cx="3039770" cy="548640"/>
+          </a:xfrm>
+          <a:prstGeom prst="rect">
+            <a:avLst/>
+          </a:prstGeom>
+          <a:noFill/>
+        </p:spPr>
+        <p:txBody>
+          <a:bodyPr wrap="square" anchor="t" lIns="0" rIns="0" tIns="0" bIns="0">
+            <a:spAutoFit/>
+          </a:bodyPr>
+          <a:lstStyle/>
+          <a:p>
+            <a:pPr algn="l">
+              <a:lnSpc>
+                <a:spcPct val="106000"/>
+              </a:lnSpc>
+            </a:pPr>
+            <a:r>
+              <a:rPr sz="1000" b="0" i="0">
+                <a:solidFill>
+                  <a:srgbClr val="3A3F47"/>
+                </a:solidFill>
+                <a:latin typeface="Arial"/>
+                <a:cs typeface="Arial"/>
+              </a:rPr>
+              <a:t>the hot foot softens (Johnson–Cook Θ = 1 − T*ᵐ) and flows more easily</a:t>
+            </a:r>
+          </a:p>
+        </p:txBody>
+      </p:sp>
+      <p:sp>
+        <p:nvSpPr>
+          <p:cNvPr id="11" name="Rounded Rectangle 10"/>
+          <p:cNvSpPr/>
+          <p:nvPr/>
+        </p:nvSpPr>
+        <p:spPr>
+          <a:xfrm>
+            <a:off x="4374794" y="3878398"/>
+            <a:ext cx="3442106" cy="960120"/>
+          </a:xfrm>
+          <a:prstGeom prst="roundRect">
+            <a:avLst>
+              <a:gd name="adj" fmla="val 5500"/>
+            </a:avLst>
+          </a:prstGeom>
+          <a:solidFill>
+            <a:srgbClr val="F4F5F7"/>
+          </a:solidFill>
+          <a:ln w="9525">
+            <a:solidFill>
+              <a:srgbClr val="DADDE2"/>
+            </a:solidFill>
+          </a:ln>
+          <a:effectLst/>
+        </p:spPr>
+        <p:style>
+          <a:lnRef idx="1">
+            <a:schemeClr val="accent1"/>
+          </a:lnRef>
+          <a:fillRef idx="3">
+            <a:schemeClr val="accent1"/>
+          </a:fillRef>
+          <a:effectRef idx="2">
+            <a:schemeClr val="accent1"/>
+          </a:effectRef>
+          <a:fontRef idx="minor">
+            <a:schemeClr val="lt1"/>
+          </a:fontRef>
+        </p:style>
+        <p:txBody>
+          <a:bodyPr rtlCol="0" anchor="ctr"/>
+          <a:lstStyle/>
+          <a:p>
+            <a:pPr algn="ctr"/>
+          </a:p>
+        </p:txBody>
+      </p:sp>
+      <p:sp>
+        <p:nvSpPr>
+          <p:cNvPr id="12" name="Rectangle 11"/>
+          <p:cNvSpPr/>
+          <p:nvPr/>
+        </p:nvSpPr>
+        <p:spPr>
+          <a:xfrm>
+            <a:off x="4374794" y="3960694"/>
+            <a:ext cx="50292" cy="795528"/>
+          </a:xfrm>
+          <a:prstGeom prst="rect">
+            <a:avLst/>
+          </a:prstGeom>
+          <a:solidFill>
+            <a:srgbClr val="06509D"/>
+          </a:solidFill>
+          <a:ln>
+            <a:noFill/>
+          </a:ln>
+          <a:effectLst/>
+        </p:spPr>
+        <p:style>
+          <a:lnRef idx="1">
+            <a:schemeClr val="accent1"/>
+          </a:lnRef>
+          <a:fillRef idx="3">
+            <a:schemeClr val="accent1"/>
+          </a:fillRef>
+          <a:effectRef idx="2">
+            <a:schemeClr val="accent1"/>
+          </a:effectRef>
+          <a:fontRef idx="minor">
+            <a:schemeClr val="lt1"/>
+          </a:fontRef>
+        </p:style>
+        <p:txBody>
+          <a:bodyPr rtlCol="0" anchor="ctr"/>
+          <a:lstStyle/>
+          <a:p>
+            <a:pPr algn="ctr"/>
+          </a:p>
+        </p:txBody>
+      </p:sp>
+      <p:sp>
+        <p:nvSpPr>
+          <p:cNvPr id="13" name="TextBox 12"/>
+          <p:cNvSpPr txBox="1"/>
+          <p:nvPr/>
+        </p:nvSpPr>
+        <p:spPr>
+          <a:xfrm>
+            <a:off x="4594250" y="3951550"/>
+            <a:ext cx="3039770" cy="274320"/>
+          </a:xfrm>
+          <a:prstGeom prst="rect">
+            <a:avLst/>
+          </a:prstGeom>
+          <a:noFill/>
+        </p:spPr>
+        <p:txBody>
+          <a:bodyPr wrap="square" anchor="t" lIns="0" rIns="0" tIns="0" bIns="0">
+            <a:spAutoFit/>
+          </a:bodyPr>
+          <a:lstStyle/>
+          <a:p>
+            <a:pPr algn="l">
+              <a:lnSpc>
+                <a:spcPct val="102000"/>
+              </a:lnSpc>
+            </a:pPr>
+            <a:r>
+              <a:rPr sz="1200" b="1" i="0">
+                <a:solidFill>
+                  <a:srgbClr val="1E2430"/>
+                </a:solidFill>
+                <a:latin typeface="Arial"/>
+                <a:cs typeface="Arial"/>
+              </a:rPr>
+              <a:t>Adiabatic by physics, not assumption</a:t>
+            </a:r>
+          </a:p>
+        </p:txBody>
+      </p:sp>
+      <p:sp>
+        <p:nvSpPr>
+          <p:cNvPr id="14" name="TextBox 13"/>
+          <p:cNvSpPr txBox="1"/>
+          <p:nvPr/>
+        </p:nvSpPr>
+        <p:spPr>
+          <a:xfrm>
+            <a:off x="4594250" y="4271590"/>
+            <a:ext cx="3039770" cy="548640"/>
+          </a:xfrm>
+          <a:prstGeom prst="rect">
+            <a:avLst/>
+          </a:prstGeom>
+          <a:noFill/>
+        </p:spPr>
+        <p:txBody>
+          <a:bodyPr wrap="square" anchor="t" lIns="0" rIns="0" tIns="0" bIns="0">
+            <a:spAutoFit/>
+          </a:bodyPr>
+          <a:lstStyle/>
+          <a:p>
+            <a:pPr algn="l">
+              <a:lnSpc>
+                <a:spcPct val="106000"/>
+              </a:lnSpc>
+            </a:pPr>
+            <a:r>
+              <a:rPr sz="1000" b="0" i="0">
+                <a:solidFill>
+                  <a:srgbClr val="3A3F47"/>
+                </a:solidFill>
+                <a:latin typeface="Arial"/>
+                <a:cs typeface="Arial"/>
+              </a:rPr>
+              <a:t>diffusion length √(αt) ≈ 0.1 mm ≪ element size over the ~100 µs run. No heat-conduction PDE needed</a:t>
+            </a:r>
+          </a:p>
+        </p:txBody>
+      </p:sp>
+      <p:sp>
+        <p:nvSpPr>
+          <p:cNvPr id="15" name="Rounded Rectangle 14"/>
+          <p:cNvSpPr/>
+          <p:nvPr/>
+        </p:nvSpPr>
+        <p:spPr>
+          <a:xfrm>
+            <a:off x="8182660" y="3878398"/>
+            <a:ext cx="3442106" cy="960120"/>
+          </a:xfrm>
+          <a:prstGeom prst="roundRect">
+            <a:avLst>
+              <a:gd name="adj" fmla="val 5500"/>
+            </a:avLst>
+          </a:prstGeom>
+          <a:solidFill>
+            <a:srgbClr val="F4F5F7"/>
+          </a:solidFill>
+          <a:ln w="9525">
+            <a:solidFill>
+              <a:srgbClr val="DADDE2"/>
+            </a:solidFill>
+          </a:ln>
+          <a:effectLst/>
+        </p:spPr>
+        <p:style>
+          <a:lnRef idx="1">
+            <a:schemeClr val="accent1"/>
+          </a:lnRef>
+          <a:fillRef idx="3">
+            <a:schemeClr val="accent1"/>
+          </a:fillRef>
+          <a:effectRef idx="2">
+            <a:schemeClr val="accent1"/>
+          </a:effectRef>
+          <a:fontRef idx="minor">
+            <a:schemeClr val="lt1"/>
+          </a:fontRef>
+        </p:style>
+        <p:txBody>
+          <a:bodyPr rtlCol="0" anchor="ctr"/>
+          <a:lstStyle/>
+          <a:p>
+            <a:pPr algn="ctr"/>
+          </a:p>
+        </p:txBody>
+      </p:sp>
+      <p:sp>
+        <p:nvSpPr>
+          <p:cNvPr id="16" name="Rectangle 15"/>
+          <p:cNvSpPr/>
+          <p:nvPr/>
+        </p:nvSpPr>
+        <p:spPr>
+          <a:xfrm>
+            <a:off x="8182660" y="3960694"/>
+            <a:ext cx="50292" cy="795528"/>
+          </a:xfrm>
+          <a:prstGeom prst="rect">
+            <a:avLst/>
+          </a:prstGeom>
+          <a:solidFill>
+            <a:srgbClr val="5E8614"/>
+          </a:solidFill>
+          <a:ln>
+            <a:noFill/>
+          </a:ln>
+          <a:effectLst/>
+        </p:spPr>
+        <p:style>
+          <a:lnRef idx="1">
+            <a:schemeClr val="accent1"/>
+          </a:lnRef>
+          <a:fillRef idx="3">
+            <a:schemeClr val="accent1"/>
+          </a:fillRef>
+          <a:effectRef idx="2">
+            <a:schemeClr val="accent1"/>
+          </a:effectRef>
+          <a:fontRef idx="minor">
+            <a:schemeClr val="lt1"/>
+          </a:fontRef>
+        </p:style>
+        <p:txBody>
+          <a:bodyPr rtlCol="0" anchor="ctr"/>
+          <a:lstStyle/>
+          <a:p>
+            <a:pPr algn="ctr"/>
+          </a:p>
+        </p:txBody>
+      </p:sp>
+      <p:sp>
+        <p:nvSpPr>
+          <p:cNvPr id="17" name="TextBox 16"/>
+          <p:cNvSpPr txBox="1"/>
+          <p:nvPr/>
+        </p:nvSpPr>
+        <p:spPr>
+          <a:xfrm>
+            <a:off x="8402116" y="3951550"/>
+            <a:ext cx="3039770" cy="274320"/>
+          </a:xfrm>
+          <a:prstGeom prst="rect">
+            <a:avLst/>
+          </a:prstGeom>
+          <a:noFill/>
+        </p:spPr>
+        <p:txBody>
+          <a:bodyPr wrap="square" anchor="t" lIns="0" rIns="0" tIns="0" bIns="0">
+            <a:spAutoFit/>
+          </a:bodyPr>
+          <a:lstStyle/>
+          <a:p>
+            <a:pPr algn="l">
+              <a:lnSpc>
+                <a:spcPct val="102000"/>
+              </a:lnSpc>
+            </a:pPr>
+            <a:r>
+              <a:rPr sz="1200" b="1" i="0">
+                <a:solidFill>
+                  <a:srgbClr val="1E2430"/>
+                </a:solidFill>
+                <a:latin typeface="Arial"/>
+                <a:cs typeface="Arial"/>
+              </a:rPr>
+              <a:t>Three extra NEML2 model blocks</a:t>
+            </a:r>
+          </a:p>
+        </p:txBody>
+      </p:sp>
+      <p:sp>
+        <p:nvSpPr>
+          <p:cNvPr id="18" name="TextBox 17"/>
+          <p:cNvSpPr txBox="1"/>
+          <p:nvPr/>
+        </p:nvSpPr>
+        <p:spPr>
+          <a:xfrm>
+            <a:off x="8402116" y="4271590"/>
+            <a:ext cx="3039770" cy="548640"/>
+          </a:xfrm>
+          <a:prstGeom prst="rect">
+            <a:avLst/>
+          </a:prstGeom>
+          <a:noFill/>
+        </p:spPr>
+        <p:txBody>
+          <a:bodyPr wrap="square" anchor="t" lIns="0" rIns="0" tIns="0" bIns="0">
+            <a:spAutoFit/>
+          </a:bodyPr>
+          <a:lstStyle/>
+          <a:p>
+            <a:pPr algn="l">
+              <a:lnSpc>
+                <a:spcPct val="106000"/>
+              </a:lnSpc>
+            </a:pPr>
+            <a:r>
+              <a:rPr sz="1000" b="0" i="0">
+                <a:solidFill>
+                  <a:srgbClr val="3A3F47"/>
+                </a:solidFill>
+                <a:latin typeface="Arial"/>
+                <a:cs typeface="Arial"/>
+              </a:rPr>
+              <a:t>no new MOOSE modules, no new transfers. Temperature state lives on the device like everything else</a:t>
+            </a:r>
+          </a:p>
+        </p:txBody>
+      </p:sp>
+    </p:spTree>
+  </p:cSld>
+  <p:clrMapOvr>
+    <a:masterClrMapping/>
+  </p:clrMapOvr>
+</p:sld>
+</file>
+
+<file path=ppt/slides/slide19.xml><?xml version="1.0" encoding="utf-8"?>
+<p:sld xmlns:a="http://schemas.openxmlformats.org/drawingml/2006/main" xmlns:p="http://schemas.openxmlformats.org/presentationml/2006/main" xmlns:r="http://schemas.openxmlformats.org/officeDocument/2006/relationships">
+  <p:cSld>
+    <p:spTree>
+      <p:nvGrpSpPr>
+        <p:cNvPr id="1" name=""/>
+        <p:cNvGrpSpPr/>
+        <p:nvPr/>
+      </p:nvGrpSpPr>
+      <p:grpSpPr/>
+      <p:sp>
+        <p:nvSpPr>
+          <p:cNvPr id="2" name="Title 1"/>
+          <p:cNvSpPr>
+            <a:spLocks noGrp="1"/>
+          </p:cNvSpPr>
+          <p:nvPr>
+            <p:ph type="title"/>
+          </p:nvPr>
+        </p:nvSpPr>
+        <p:spPr/>
+        <p:txBody>
+          <a:bodyPr/>
+          <a:lstStyle/>
+          <a:p>
+            <a:r>
+              <a:rPr sz="2600"/>
+              <a:t>Bayesian calibration of the material parameters</a:t>
+            </a:r>
+          </a:p>
+        </p:txBody>
+      </p:sp>
+      <p:sp>
+        <p:nvSpPr>
+          <p:cNvPr id="3" name="TextBox 2"/>
+          <p:cNvSpPr txBox="1"/>
+          <p:nvPr/>
+        </p:nvSpPr>
+        <p:spPr>
+          <a:xfrm>
+            <a:off x="11231575" y="274320"/>
+            <a:ext cx="685800" cy="228600"/>
+          </a:xfrm>
+          <a:prstGeom prst="rect">
+            <a:avLst/>
+          </a:prstGeom>
+          <a:noFill/>
+        </p:spPr>
+        <p:txBody>
+          <a:bodyPr wrap="square" anchor="t" lIns="0" rIns="0" tIns="0" bIns="0">
+            <a:spAutoFit/>
+          </a:bodyPr>
+          <a:lstStyle/>
+          <a:p>
+            <a:pPr algn="r"/>
+            <a:r>
+              <a:rPr sz="900" b="0" i="0">
+                <a:solidFill>
+                  <a:srgbClr val="59595C"/>
+                </a:solidFill>
+                <a:latin typeface="Arial"/>
+                <a:cs typeface="Arial"/>
+              </a:rPr>
+              <a:t>19 / 20</a:t>
             </a:r>
           </a:p>
         </p:txBody>
@@ -16457,7 +16742,7 @@
 </p:sld>
 </file>
 
-<file path=ppt/slides/slide19.xml><?xml version="1.0" encoding="utf-8"?>
+<file path=ppt/slides/slide2.xml><?xml version="1.0" encoding="utf-8"?>
 <p:sld xmlns:a="http://schemas.openxmlformats.org/drawingml/2006/main" xmlns:p="http://schemas.openxmlformats.org/presentationml/2006/main" xmlns:r="http://schemas.openxmlformats.org/officeDocument/2006/relationships">
   <p:cSld>
     <p:spTree>
@@ -16484,7 +16769,7 @@
           <a:p>
             <a:r>
               <a:rPr sz="2600"/>
-              <a:t>Validation: calibrated against a scanned specimen</a:t>
+              <a:t>Advanced reactors bring dynamic-loading questions</a:t>
             </a:r>
           </a:p>
         </p:txBody>
@@ -16520,7 +16805,964 @@
                 <a:latin typeface="Arial"/>
                 <a:cs typeface="Arial"/>
               </a:rPr>
-              <a:t>19 / 19</a:t>
+              <a:t>2 / 20</a:t>
+            </a:r>
+          </a:p>
+        </p:txBody>
+      </p:sp>
+      <p:sp>
+        <p:nvSpPr>
+          <p:cNvPr id="4" name="TextBox 3"/>
+          <p:cNvSpPr txBox="1"/>
+          <p:nvPr/>
+        </p:nvSpPr>
+        <p:spPr>
+          <a:xfrm>
+            <a:off x="566928" y="1554480"/>
+            <a:ext cx="6309360" cy="3840480"/>
+          </a:xfrm>
+          <a:prstGeom prst="rect">
+            <a:avLst/>
+          </a:prstGeom>
+          <a:noFill/>
+        </p:spPr>
+        <p:txBody>
+          <a:bodyPr wrap="square" lIns="0" rIns="0" tIns="0" bIns="0">
+            <a:spAutoFit/>
+          </a:bodyPr>
+          <a:lstStyle/>
+          <a:p>
+            <a:pPr marL="219456" indent="-219456">
+              <a:lnSpc>
+                <a:spcPct val="106000"/>
+              </a:lnSpc>
+              <a:spcAft>
+                <a:spcPts val="1800"/>
+              </a:spcAft>
+              <a:buClr>
+                <a:srgbClr val="06509D"/>
+              </a:buClr>
+              <a:buFont typeface="Arial"/>
+              <a:buChar char="•"/>
+            </a:pPr>
+            <a:r>
+              <a:rPr sz="1650" b="0" i="0">
+                <a:solidFill>
+                  <a:srgbClr val="3A3F47"/>
+                </a:solidFill>
+                <a:latin typeface="Arial"/>
+                <a:cs typeface="Arial"/>
+              </a:rPr>
+              <a:t>Transportable microreactors, pebble-bed cores, accident scenarios: components must be qualified under </a:t>
+            </a:r>
+            <a:r>
+              <a:rPr sz="1650" b="1" i="0">
+                <a:solidFill>
+                  <a:srgbClr val="3A3F47"/>
+                </a:solidFill>
+                <a:latin typeface="Arial"/>
+                <a:cs typeface="Arial"/>
+              </a:rPr>
+              <a:t>impact and other high-rate loads</a:t>
+            </a:r>
+          </a:p>
+          <a:p>
+            <a:pPr marL="219456" indent="-219456">
+              <a:lnSpc>
+                <a:spcPct val="106000"/>
+              </a:lnSpc>
+              <a:spcAft>
+                <a:spcPts val="1800"/>
+              </a:spcAft>
+              <a:buClr>
+                <a:srgbClr val="06509D"/>
+              </a:buClr>
+              <a:buFont typeface="Arial"/>
+              <a:buChar char="•"/>
+            </a:pPr>
+            <a:r>
+              <a:rPr sz="1650" b="0" i="0">
+                <a:solidFill>
+                  <a:srgbClr val="3A3F47"/>
+                </a:solidFill>
+                <a:latin typeface="Arial"/>
+                <a:cs typeface="Arial"/>
+              </a:rPr>
+              <a:t>These events are </a:t>
+            </a:r>
+            <a:r>
+              <a:rPr sz="1650" b="1" i="0">
+                <a:solidFill>
+                  <a:srgbClr val="3A3F47"/>
+                </a:solidFill>
+                <a:latin typeface="Arial"/>
+                <a:cs typeface="Arial"/>
+              </a:rPr>
+              <a:t>wave-dominated and fast</a:t>
+            </a:r>
+            <a:r>
+              <a:rPr sz="1650" b="0" i="0">
+                <a:solidFill>
+                  <a:srgbClr val="3A3F47"/>
+                </a:solidFill>
+                <a:latin typeface="Arial"/>
+                <a:cs typeface="Arial"/>
+              </a:rPr>
+              <a:t>. Stress waves traverse the part in microseconds, with severe, localized plasticity</a:t>
+            </a:r>
+          </a:p>
+          <a:p>
+            <a:pPr marL="219456" indent="-219456">
+              <a:lnSpc>
+                <a:spcPct val="106000"/>
+              </a:lnSpc>
+              <a:spcAft>
+                <a:spcPts val="1800"/>
+              </a:spcAft>
+              <a:buClr>
+                <a:srgbClr val="06509D"/>
+              </a:buClr>
+              <a:buFont typeface="Arial"/>
+              <a:buChar char="•"/>
+            </a:pPr>
+            <a:r>
+              <a:rPr sz="1650" b="0" i="0">
+                <a:solidFill>
+                  <a:srgbClr val="3A3F47"/>
+                </a:solidFill>
+                <a:latin typeface="Arial"/>
+                <a:cs typeface="Arial"/>
+              </a:rPr>
+              <a:t>Predictive fidelity requires </a:t>
+            </a:r>
+            <a:r>
+              <a:rPr sz="1650" b="1" i="0">
+                <a:solidFill>
+                  <a:srgbClr val="3A3F47"/>
+                </a:solidFill>
+                <a:latin typeface="Arial"/>
+                <a:cs typeface="Arial"/>
+              </a:rPr>
+              <a:t>modern constitutive models</a:t>
+            </a:r>
+            <a:r>
+              <a:rPr sz="1650" b="0" i="0">
+                <a:solidFill>
+                  <a:srgbClr val="3A3F47"/>
+                </a:solidFill>
+                <a:latin typeface="Arial"/>
+                <a:cs typeface="Arial"/>
+              </a:rPr>
+              <a:t>. Rate- and temperature-dependent, with evolving internal state</a:t>
+            </a:r>
+          </a:p>
+          <a:p>
+            <a:pPr marL="219456" indent="-219456">
+              <a:lnSpc>
+                <a:spcPct val="106000"/>
+              </a:lnSpc>
+              <a:spcAft>
+                <a:spcPts val="1800"/>
+              </a:spcAft>
+              <a:buClr>
+                <a:srgbClr val="06509D"/>
+              </a:buClr>
+              <a:buFont typeface="Arial"/>
+              <a:buChar char="•"/>
+            </a:pPr>
+            <a:r>
+              <a:rPr sz="1650" b="0" i="0">
+                <a:solidFill>
+                  <a:srgbClr val="3A3F47"/>
+                </a:solidFill>
+                <a:latin typeface="Arial"/>
+                <a:cs typeface="Arial"/>
+              </a:rPr>
+              <a:t>Simulating them means </a:t>
+            </a:r>
+            <a:r>
+              <a:rPr sz="1650" b="1" i="0">
+                <a:solidFill>
+                  <a:srgbClr val="3A3F47"/>
+                </a:solidFill>
+                <a:latin typeface="Arial"/>
+                <a:cs typeface="Arial"/>
+              </a:rPr>
+              <a:t>explicit time integration</a:t>
+            </a:r>
+            <a:r>
+              <a:rPr sz="1650" b="0" i="0">
+                <a:solidFill>
+                  <a:srgbClr val="3A3F47"/>
+                </a:solidFill>
+                <a:latin typeface="Arial"/>
+                <a:cs typeface="Arial"/>
+              </a:rPr>
+              <a:t> with a material-model evaluation at every quadrature point, every step</a:t>
+            </a:r>
+          </a:p>
+        </p:txBody>
+      </p:sp>
+      <p:sp>
+        <p:nvSpPr>
+          <p:cNvPr id="5" name="Rounded Rectangle 4"/>
+          <p:cNvSpPr/>
+          <p:nvPr/>
+        </p:nvSpPr>
+        <p:spPr>
+          <a:xfrm>
+            <a:off x="7333488" y="1207008"/>
+            <a:ext cx="4291279" cy="3977639"/>
+          </a:xfrm>
+          <a:prstGeom prst="roundRect">
+            <a:avLst>
+              <a:gd name="adj" fmla="val 5500"/>
+            </a:avLst>
+          </a:prstGeom>
+          <a:solidFill>
+            <a:srgbClr val="F4F5F7"/>
+          </a:solidFill>
+          <a:ln w="9525">
+            <a:solidFill>
+              <a:srgbClr val="DADDE2"/>
+            </a:solidFill>
+          </a:ln>
+          <a:effectLst/>
+        </p:spPr>
+        <p:style>
+          <a:lnRef idx="1">
+            <a:schemeClr val="accent1"/>
+          </a:lnRef>
+          <a:fillRef idx="3">
+            <a:schemeClr val="accent1"/>
+          </a:fillRef>
+          <a:effectRef idx="2">
+            <a:schemeClr val="accent1"/>
+          </a:effectRef>
+          <a:fontRef idx="minor">
+            <a:schemeClr val="lt1"/>
+          </a:fontRef>
+        </p:style>
+        <p:txBody>
+          <a:bodyPr rtlCol="0" anchor="ctr"/>
+          <a:lstStyle/>
+          <a:p>
+            <a:pPr algn="ctr"/>
+          </a:p>
+        </p:txBody>
+      </p:sp>
+      <p:sp>
+        <p:nvSpPr>
+          <p:cNvPr id="6" name="TextBox 5"/>
+          <p:cNvSpPr txBox="1"/>
+          <p:nvPr/>
+        </p:nvSpPr>
+        <p:spPr>
+          <a:xfrm>
+            <a:off x="7589520" y="1408176"/>
+            <a:ext cx="3779215" cy="274320"/>
+          </a:xfrm>
+          <a:prstGeom prst="rect">
+            <a:avLst/>
+          </a:prstGeom>
+          <a:noFill/>
+        </p:spPr>
+        <p:txBody>
+          <a:bodyPr wrap="square" anchor="t" lIns="0" rIns="0" tIns="0" bIns="0">
+            <a:spAutoFit/>
+          </a:bodyPr>
+          <a:lstStyle/>
+          <a:p>
+            <a:pPr algn="l"/>
+            <a:r>
+              <a:rPr sz="1050" b="1" i="0">
+                <a:solidFill>
+                  <a:srgbClr val="59595C"/>
+                </a:solidFill>
+                <a:latin typeface="Arial"/>
+                <a:cs typeface="Arial"/>
+              </a:rPr>
+              <a:t>TIMESCALES OF AN IMPACT EVENT</a:t>
+            </a:r>
+          </a:p>
+        </p:txBody>
+      </p:sp>
+      <p:sp>
+        <p:nvSpPr>
+          <p:cNvPr id="7" name="Rounded Rectangle 6"/>
+          <p:cNvSpPr/>
+          <p:nvPr/>
+        </p:nvSpPr>
+        <p:spPr>
+          <a:xfrm>
+            <a:off x="7589520" y="1865376"/>
+            <a:ext cx="3779215" cy="658368"/>
+          </a:xfrm>
+          <a:prstGeom prst="roundRect">
+            <a:avLst>
+              <a:gd name="adj" fmla="val 5500"/>
+            </a:avLst>
+          </a:prstGeom>
+          <a:solidFill>
+            <a:srgbClr val="FFFFFF"/>
+          </a:solidFill>
+          <a:ln w="9525">
+            <a:solidFill>
+              <a:srgbClr val="DADDE2"/>
+            </a:solidFill>
+          </a:ln>
+          <a:effectLst/>
+        </p:spPr>
+        <p:style>
+          <a:lnRef idx="1">
+            <a:schemeClr val="accent1"/>
+          </a:lnRef>
+          <a:fillRef idx="3">
+            <a:schemeClr val="accent1"/>
+          </a:fillRef>
+          <a:effectRef idx="2">
+            <a:schemeClr val="accent1"/>
+          </a:effectRef>
+          <a:fontRef idx="minor">
+            <a:schemeClr val="lt1"/>
+          </a:fontRef>
+        </p:style>
+        <p:txBody>
+          <a:bodyPr rtlCol="0" anchor="ctr"/>
+          <a:lstStyle/>
+          <a:p>
+            <a:pPr algn="ctr"/>
+          </a:p>
+        </p:txBody>
+      </p:sp>
+      <p:sp>
+        <p:nvSpPr>
+          <p:cNvPr id="8" name="TextBox 7"/>
+          <p:cNvSpPr txBox="1"/>
+          <p:nvPr/>
+        </p:nvSpPr>
+        <p:spPr>
+          <a:xfrm>
+            <a:off x="7808976" y="1865376"/>
+            <a:ext cx="2371039" cy="658368"/>
+          </a:xfrm>
+          <a:prstGeom prst="rect">
+            <a:avLst/>
+          </a:prstGeom>
+          <a:noFill/>
+        </p:spPr>
+        <p:txBody>
+          <a:bodyPr wrap="square" anchor="ctr" lIns="0" rIns="0" tIns="0" bIns="0">
+            <a:spAutoFit/>
+          </a:bodyPr>
+          <a:lstStyle/>
+          <a:p>
+            <a:pPr algn="l"/>
+            <a:r>
+              <a:rPr sz="1250" b="0" i="0">
+                <a:solidFill>
+                  <a:srgbClr val="3A3F47"/>
+                </a:solidFill>
+                <a:latin typeface="Arial"/>
+                <a:cs typeface="Arial"/>
+              </a:rPr>
+              <a:t>event duration</a:t>
+            </a:r>
+          </a:p>
+        </p:txBody>
+      </p:sp>
+      <p:sp>
+        <p:nvSpPr>
+          <p:cNvPr id="9" name="TextBox 8"/>
+          <p:cNvSpPr txBox="1"/>
+          <p:nvPr/>
+        </p:nvSpPr>
+        <p:spPr>
+          <a:xfrm>
+            <a:off x="9841687" y="1865376"/>
+            <a:ext cx="1417320" cy="658368"/>
+          </a:xfrm>
+          <a:prstGeom prst="rect">
+            <a:avLst/>
+          </a:prstGeom>
+          <a:noFill/>
+        </p:spPr>
+        <p:txBody>
+          <a:bodyPr wrap="square" anchor="ctr" lIns="0" rIns="0" tIns="0" bIns="0">
+            <a:spAutoFit/>
+          </a:bodyPr>
+          <a:lstStyle/>
+          <a:p>
+            <a:pPr algn="r"/>
+            <a:r>
+              <a:rPr sz="1500" b="1" i="0">
+                <a:solidFill>
+                  <a:srgbClr val="06509D"/>
+                </a:solidFill>
+                <a:latin typeface="Arial"/>
+                <a:cs typeface="Arial"/>
+              </a:rPr>
+              <a:t>~100 µs</a:t>
+            </a:r>
+          </a:p>
+        </p:txBody>
+      </p:sp>
+      <p:sp>
+        <p:nvSpPr>
+          <p:cNvPr id="10" name="Rounded Rectangle 9"/>
+          <p:cNvSpPr/>
+          <p:nvPr/>
+        </p:nvSpPr>
+        <p:spPr>
+          <a:xfrm>
+            <a:off x="7589520" y="2660904"/>
+            <a:ext cx="3779215" cy="658368"/>
+          </a:xfrm>
+          <a:prstGeom prst="roundRect">
+            <a:avLst>
+              <a:gd name="adj" fmla="val 5500"/>
+            </a:avLst>
+          </a:prstGeom>
+          <a:solidFill>
+            <a:srgbClr val="FFFFFF"/>
+          </a:solidFill>
+          <a:ln w="9525">
+            <a:solidFill>
+              <a:srgbClr val="DADDE2"/>
+            </a:solidFill>
+          </a:ln>
+          <a:effectLst/>
+        </p:spPr>
+        <p:style>
+          <a:lnRef idx="1">
+            <a:schemeClr val="accent1"/>
+          </a:lnRef>
+          <a:fillRef idx="3">
+            <a:schemeClr val="accent1"/>
+          </a:fillRef>
+          <a:effectRef idx="2">
+            <a:schemeClr val="accent1"/>
+          </a:effectRef>
+          <a:fontRef idx="minor">
+            <a:schemeClr val="lt1"/>
+          </a:fontRef>
+        </p:style>
+        <p:txBody>
+          <a:bodyPr rtlCol="0" anchor="ctr"/>
+          <a:lstStyle/>
+          <a:p>
+            <a:pPr algn="ctr"/>
+          </a:p>
+        </p:txBody>
+      </p:sp>
+      <p:sp>
+        <p:nvSpPr>
+          <p:cNvPr id="11" name="TextBox 10"/>
+          <p:cNvSpPr txBox="1"/>
+          <p:nvPr/>
+        </p:nvSpPr>
+        <p:spPr>
+          <a:xfrm>
+            <a:off x="7808976" y="2660904"/>
+            <a:ext cx="2371039" cy="658368"/>
+          </a:xfrm>
+          <a:prstGeom prst="rect">
+            <a:avLst/>
+          </a:prstGeom>
+          <a:noFill/>
+        </p:spPr>
+        <p:txBody>
+          <a:bodyPr wrap="square" anchor="ctr" lIns="0" rIns="0" tIns="0" bIns="0">
+            <a:spAutoFit/>
+          </a:bodyPr>
+          <a:lstStyle/>
+          <a:p>
+            <a:pPr algn="l"/>
+            <a:r>
+              <a:rPr sz="1250" b="0" i="0">
+                <a:solidFill>
+                  <a:srgbClr val="3A3F47"/>
+                </a:solidFill>
+                <a:latin typeface="Arial"/>
+                <a:cs typeface="Arial"/>
+              </a:rPr>
+              <a:t>wave transit through part</a:t>
+            </a:r>
+          </a:p>
+        </p:txBody>
+      </p:sp>
+      <p:sp>
+        <p:nvSpPr>
+          <p:cNvPr id="12" name="TextBox 11"/>
+          <p:cNvSpPr txBox="1"/>
+          <p:nvPr/>
+        </p:nvSpPr>
+        <p:spPr>
+          <a:xfrm>
+            <a:off x="9841687" y="2660904"/>
+            <a:ext cx="1417320" cy="658368"/>
+          </a:xfrm>
+          <a:prstGeom prst="rect">
+            <a:avLst/>
+          </a:prstGeom>
+          <a:noFill/>
+        </p:spPr>
+        <p:txBody>
+          <a:bodyPr wrap="square" anchor="ctr" lIns="0" rIns="0" tIns="0" bIns="0">
+            <a:spAutoFit/>
+          </a:bodyPr>
+          <a:lstStyle/>
+          <a:p>
+            <a:pPr algn="r"/>
+            <a:r>
+              <a:rPr sz="1500" b="1" i="0">
+                <a:solidFill>
+                  <a:srgbClr val="06509D"/>
+                </a:solidFill>
+                <a:latin typeface="Arial"/>
+                <a:cs typeface="Arial"/>
+              </a:rPr>
+              <a:t>~1–10 µs</a:t>
+            </a:r>
+          </a:p>
+        </p:txBody>
+      </p:sp>
+      <p:sp>
+        <p:nvSpPr>
+          <p:cNvPr id="13" name="Rounded Rectangle 12"/>
+          <p:cNvSpPr/>
+          <p:nvPr/>
+        </p:nvSpPr>
+        <p:spPr>
+          <a:xfrm>
+            <a:off x="7589520" y="3456432"/>
+            <a:ext cx="3779215" cy="658368"/>
+          </a:xfrm>
+          <a:prstGeom prst="roundRect">
+            <a:avLst>
+              <a:gd name="adj" fmla="val 5500"/>
+            </a:avLst>
+          </a:prstGeom>
+          <a:solidFill>
+            <a:srgbClr val="FFFFFF"/>
+          </a:solidFill>
+          <a:ln w="9525">
+            <a:solidFill>
+              <a:srgbClr val="DADDE2"/>
+            </a:solidFill>
+          </a:ln>
+          <a:effectLst/>
+        </p:spPr>
+        <p:style>
+          <a:lnRef idx="1">
+            <a:schemeClr val="accent1"/>
+          </a:lnRef>
+          <a:fillRef idx="3">
+            <a:schemeClr val="accent1"/>
+          </a:fillRef>
+          <a:effectRef idx="2">
+            <a:schemeClr val="accent1"/>
+          </a:effectRef>
+          <a:fontRef idx="minor">
+            <a:schemeClr val="lt1"/>
+          </a:fontRef>
+        </p:style>
+        <p:txBody>
+          <a:bodyPr rtlCol="0" anchor="ctr"/>
+          <a:lstStyle/>
+          <a:p>
+            <a:pPr algn="ctr"/>
+          </a:p>
+        </p:txBody>
+      </p:sp>
+      <p:sp>
+        <p:nvSpPr>
+          <p:cNvPr id="14" name="TextBox 13"/>
+          <p:cNvSpPr txBox="1"/>
+          <p:nvPr/>
+        </p:nvSpPr>
+        <p:spPr>
+          <a:xfrm>
+            <a:off x="7808976" y="3456432"/>
+            <a:ext cx="2371039" cy="658368"/>
+          </a:xfrm>
+          <a:prstGeom prst="rect">
+            <a:avLst/>
+          </a:prstGeom>
+          <a:noFill/>
+        </p:spPr>
+        <p:txBody>
+          <a:bodyPr wrap="square" anchor="ctr" lIns="0" rIns="0" tIns="0" bIns="0">
+            <a:spAutoFit/>
+          </a:bodyPr>
+          <a:lstStyle/>
+          <a:p>
+            <a:pPr algn="l"/>
+            <a:r>
+              <a:rPr sz="1250" b="0" i="0">
+                <a:solidFill>
+                  <a:srgbClr val="3A3F47"/>
+                </a:solidFill>
+                <a:latin typeface="Arial"/>
+                <a:cs typeface="Arial"/>
+              </a:rPr>
+              <a:t>stable explicit step</a:t>
+            </a:r>
+          </a:p>
+        </p:txBody>
+      </p:sp>
+      <p:sp>
+        <p:nvSpPr>
+          <p:cNvPr id="15" name="TextBox 14"/>
+          <p:cNvSpPr txBox="1"/>
+          <p:nvPr/>
+        </p:nvSpPr>
+        <p:spPr>
+          <a:xfrm>
+            <a:off x="9841687" y="3456432"/>
+            <a:ext cx="1417320" cy="658368"/>
+          </a:xfrm>
+          <a:prstGeom prst="rect">
+            <a:avLst/>
+          </a:prstGeom>
+          <a:noFill/>
+        </p:spPr>
+        <p:txBody>
+          <a:bodyPr wrap="square" anchor="ctr" lIns="0" rIns="0" tIns="0" bIns="0">
+            <a:spAutoFit/>
+          </a:bodyPr>
+          <a:lstStyle/>
+          <a:p>
+            <a:pPr algn="r"/>
+            <a:r>
+              <a:rPr sz="1500" b="1" i="0">
+                <a:solidFill>
+                  <a:srgbClr val="CF1D4C"/>
+                </a:solidFill>
+                <a:latin typeface="Arial"/>
+                <a:cs typeface="Arial"/>
+              </a:rPr>
+              <a:t>~10 ns</a:t>
+            </a:r>
+          </a:p>
+        </p:txBody>
+      </p:sp>
+      <p:sp>
+        <p:nvSpPr>
+          <p:cNvPr id="16" name="Rounded Rectangle 15"/>
+          <p:cNvSpPr/>
+          <p:nvPr/>
+        </p:nvSpPr>
+        <p:spPr>
+          <a:xfrm>
+            <a:off x="7589520" y="4251960"/>
+            <a:ext cx="3779215" cy="658368"/>
+          </a:xfrm>
+          <a:prstGeom prst="roundRect">
+            <a:avLst>
+              <a:gd name="adj" fmla="val 5500"/>
+            </a:avLst>
+          </a:prstGeom>
+          <a:solidFill>
+            <a:srgbClr val="FFFFFF"/>
+          </a:solidFill>
+          <a:ln w="9525">
+            <a:solidFill>
+              <a:srgbClr val="DADDE2"/>
+            </a:solidFill>
+          </a:ln>
+          <a:effectLst/>
+        </p:spPr>
+        <p:style>
+          <a:lnRef idx="1">
+            <a:schemeClr val="accent1"/>
+          </a:lnRef>
+          <a:fillRef idx="3">
+            <a:schemeClr val="accent1"/>
+          </a:fillRef>
+          <a:effectRef idx="2">
+            <a:schemeClr val="accent1"/>
+          </a:effectRef>
+          <a:fontRef idx="minor">
+            <a:schemeClr val="lt1"/>
+          </a:fontRef>
+        </p:style>
+        <p:txBody>
+          <a:bodyPr rtlCol="0" anchor="ctr"/>
+          <a:lstStyle/>
+          <a:p>
+            <a:pPr algn="ctr"/>
+          </a:p>
+        </p:txBody>
+      </p:sp>
+      <p:sp>
+        <p:nvSpPr>
+          <p:cNvPr id="17" name="TextBox 16"/>
+          <p:cNvSpPr txBox="1"/>
+          <p:nvPr/>
+        </p:nvSpPr>
+        <p:spPr>
+          <a:xfrm>
+            <a:off x="7808976" y="4251960"/>
+            <a:ext cx="2371039" cy="658368"/>
+          </a:xfrm>
+          <a:prstGeom prst="rect">
+            <a:avLst/>
+          </a:prstGeom>
+          <a:noFill/>
+        </p:spPr>
+        <p:txBody>
+          <a:bodyPr wrap="square" anchor="ctr" lIns="0" rIns="0" tIns="0" bIns="0">
+            <a:spAutoFit/>
+          </a:bodyPr>
+          <a:lstStyle/>
+          <a:p>
+            <a:pPr algn="l"/>
+            <a:r>
+              <a:rPr sz="1250" b="0" i="0">
+                <a:solidFill>
+                  <a:srgbClr val="3A3F47"/>
+                </a:solidFill>
+                <a:latin typeface="Arial"/>
+                <a:cs typeface="Arial"/>
+              </a:rPr>
+              <a:t>⇒  steps to simulate</a:t>
+            </a:r>
+          </a:p>
+        </p:txBody>
+      </p:sp>
+      <p:sp>
+        <p:nvSpPr>
+          <p:cNvPr id="18" name="TextBox 17"/>
+          <p:cNvSpPr txBox="1"/>
+          <p:nvPr/>
+        </p:nvSpPr>
+        <p:spPr>
+          <a:xfrm>
+            <a:off x="9841687" y="4251960"/>
+            <a:ext cx="1417320" cy="658368"/>
+          </a:xfrm>
+          <a:prstGeom prst="rect">
+            <a:avLst/>
+          </a:prstGeom>
+          <a:noFill/>
+        </p:spPr>
+        <p:txBody>
+          <a:bodyPr wrap="square" anchor="ctr" lIns="0" rIns="0" tIns="0" bIns="0">
+            <a:spAutoFit/>
+          </a:bodyPr>
+          <a:lstStyle/>
+          <a:p>
+            <a:pPr algn="r"/>
+            <a:r>
+              <a:rPr sz="1500" b="1" i="0">
+                <a:solidFill>
+                  <a:srgbClr val="1E2430"/>
+                </a:solidFill>
+                <a:latin typeface="Arial"/>
+                <a:cs typeface="Arial"/>
+              </a:rPr>
+              <a:t>10</a:t>
+            </a:r>
+            <a:r>
+              <a:rPr sz="1500" b="1" i="0" baseline="30000">
+                <a:solidFill>
+                  <a:srgbClr val="1E2430"/>
+                </a:solidFill>
+                <a:latin typeface="Arial"/>
+                <a:cs typeface="Arial"/>
+              </a:rPr>
+              <a:t>4</a:t>
+            </a:r>
+            <a:r>
+              <a:rPr sz="1500" b="1" i="0">
+                <a:solidFill>
+                  <a:srgbClr val="1E2430"/>
+                </a:solidFill>
+                <a:latin typeface="Arial"/>
+                <a:cs typeface="Arial"/>
+              </a:rPr>
+              <a:t>–10</a:t>
+            </a:r>
+            <a:r>
+              <a:rPr sz="1500" b="1" i="0" baseline="30000">
+                <a:solidFill>
+                  <a:srgbClr val="1E2430"/>
+                </a:solidFill>
+                <a:latin typeface="Arial"/>
+                <a:cs typeface="Arial"/>
+              </a:rPr>
+              <a:t>5</a:t>
+            </a:r>
+          </a:p>
+        </p:txBody>
+      </p:sp>
+      <p:sp>
+        <p:nvSpPr>
+          <p:cNvPr id="19" name="Rounded Rectangle 18"/>
+          <p:cNvSpPr/>
+          <p:nvPr/>
+        </p:nvSpPr>
+        <p:spPr>
+          <a:xfrm>
+            <a:off x="566928" y="5376672"/>
+            <a:ext cx="11057839" cy="658368"/>
+          </a:xfrm>
+          <a:prstGeom prst="roundRect">
+            <a:avLst>
+              <a:gd name="adj" fmla="val 5500"/>
+            </a:avLst>
+          </a:prstGeom>
+          <a:solidFill>
+            <a:srgbClr val="FDF0DF"/>
+          </a:solidFill>
+          <a:ln w="12700">
+            <a:solidFill>
+              <a:srgbClr val="B4620B"/>
+            </a:solidFill>
+          </a:ln>
+          <a:effectLst/>
+        </p:spPr>
+        <p:style>
+          <a:lnRef idx="1">
+            <a:schemeClr val="accent1"/>
+          </a:lnRef>
+          <a:fillRef idx="3">
+            <a:schemeClr val="accent1"/>
+          </a:fillRef>
+          <a:effectRef idx="2">
+            <a:schemeClr val="accent1"/>
+          </a:effectRef>
+          <a:fontRef idx="minor">
+            <a:schemeClr val="lt1"/>
+          </a:fontRef>
+        </p:style>
+        <p:txBody>
+          <a:bodyPr rtlCol="0" anchor="ctr"/>
+          <a:lstStyle/>
+          <a:p>
+            <a:pPr algn="ctr"/>
+          </a:p>
+        </p:txBody>
+      </p:sp>
+      <p:sp>
+        <p:nvSpPr>
+          <p:cNvPr id="20" name="TextBox 19"/>
+          <p:cNvSpPr txBox="1"/>
+          <p:nvPr/>
+        </p:nvSpPr>
+        <p:spPr>
+          <a:xfrm>
+            <a:off x="841248" y="5376672"/>
+            <a:ext cx="10509199" cy="658368"/>
+          </a:xfrm>
+          <a:prstGeom prst="rect">
+            <a:avLst/>
+          </a:prstGeom>
+          <a:noFill/>
+        </p:spPr>
+        <p:txBody>
+          <a:bodyPr wrap="square" anchor="ctr" lIns="0" rIns="0" tIns="0" bIns="0">
+            <a:spAutoFit/>
+          </a:bodyPr>
+          <a:lstStyle/>
+          <a:p>
+            <a:pPr algn="l"/>
+            <a:r>
+              <a:rPr sz="1500" b="1" i="0">
+                <a:solidFill>
+                  <a:srgbClr val="1E2430"/>
+                </a:solidFill>
+                <a:latin typeface="Arial"/>
+                <a:cs typeface="Arial"/>
+              </a:rPr>
+              <a:t>Many steps × expensive material updates:</a:t>
+            </a:r>
+            <a:r>
+              <a:rPr sz="1500" b="0" i="0">
+                <a:solidFill>
+                  <a:srgbClr val="3A3F47"/>
+                </a:solidFill>
+                <a:latin typeface="Arial"/>
+                <a:cs typeface="Arial"/>
+              </a:rPr>
+              <a:t> high-rate simulation is compute-hungry in a very particular way.</a:t>
+            </a:r>
+          </a:p>
+        </p:txBody>
+      </p:sp>
+    </p:spTree>
+  </p:cSld>
+  <p:clrMapOvr>
+    <a:masterClrMapping/>
+  </p:clrMapOvr>
+</p:sld>
+</file>
+
+<file path=ppt/slides/slide20.xml><?xml version="1.0" encoding="utf-8"?>
+<p:sld xmlns:a="http://schemas.openxmlformats.org/drawingml/2006/main" xmlns:p="http://schemas.openxmlformats.org/presentationml/2006/main" xmlns:r="http://schemas.openxmlformats.org/officeDocument/2006/relationships">
+  <p:cSld>
+    <p:spTree>
+      <p:nvGrpSpPr>
+        <p:cNvPr id="1" name=""/>
+        <p:cNvGrpSpPr/>
+        <p:nvPr/>
+      </p:nvGrpSpPr>
+      <p:grpSpPr/>
+      <p:sp>
+        <p:nvSpPr>
+          <p:cNvPr id="2" name="Title 1"/>
+          <p:cNvSpPr>
+            <a:spLocks noGrp="1"/>
+          </p:cNvSpPr>
+          <p:nvPr>
+            <p:ph type="title"/>
+          </p:nvPr>
+        </p:nvSpPr>
+        <p:spPr/>
+        <p:txBody>
+          <a:bodyPr/>
+          <a:lstStyle/>
+          <a:p>
+            <a:r>
+              <a:rPr sz="2600"/>
+              <a:t>Validation: calibrated against a scanned specimen</a:t>
+            </a:r>
+          </a:p>
+        </p:txBody>
+      </p:sp>
+      <p:sp>
+        <p:nvSpPr>
+          <p:cNvPr id="3" name="TextBox 2"/>
+          <p:cNvSpPr txBox="1"/>
+          <p:nvPr/>
+        </p:nvSpPr>
+        <p:spPr>
+          <a:xfrm>
+            <a:off x="11231575" y="274320"/>
+            <a:ext cx="685800" cy="228600"/>
+          </a:xfrm>
+          <a:prstGeom prst="rect">
+            <a:avLst/>
+          </a:prstGeom>
+          <a:noFill/>
+        </p:spPr>
+        <p:txBody>
+          <a:bodyPr wrap="square" anchor="t" lIns="0" rIns="0" tIns="0" bIns="0">
+            <a:spAutoFit/>
+          </a:bodyPr>
+          <a:lstStyle/>
+          <a:p>
+            <a:pPr algn="r"/>
+            <a:r>
+              <a:rPr sz="900" b="0" i="0">
+                <a:solidFill>
+                  <a:srgbClr val="59595C"/>
+                </a:solidFill>
+                <a:latin typeface="Arial"/>
+                <a:cs typeface="Arial"/>
+              </a:rPr>
+              <a:t>20 / 20</a:t>
             </a:r>
           </a:p>
         </p:txBody>
@@ -17061,963 +18303,6 @@
 </p:sld>
 </file>
 
-<file path=ppt/slides/slide2.xml><?xml version="1.0" encoding="utf-8"?>
-<p:sld xmlns:a="http://schemas.openxmlformats.org/drawingml/2006/main" xmlns:p="http://schemas.openxmlformats.org/presentationml/2006/main" xmlns:r="http://schemas.openxmlformats.org/officeDocument/2006/relationships">
-  <p:cSld>
-    <p:spTree>
-      <p:nvGrpSpPr>
-        <p:cNvPr id="1" name=""/>
-        <p:cNvGrpSpPr/>
-        <p:nvPr/>
-      </p:nvGrpSpPr>
-      <p:grpSpPr/>
-      <p:sp>
-        <p:nvSpPr>
-          <p:cNvPr id="2" name="Title 1"/>
-          <p:cNvSpPr>
-            <a:spLocks noGrp="1"/>
-          </p:cNvSpPr>
-          <p:nvPr>
-            <p:ph type="title"/>
-          </p:nvPr>
-        </p:nvSpPr>
-        <p:spPr/>
-        <p:txBody>
-          <a:bodyPr/>
-          <a:lstStyle/>
-          <a:p>
-            <a:r>
-              <a:rPr sz="2600"/>
-              <a:t>Advanced reactors bring dynamic-loading questions</a:t>
-            </a:r>
-          </a:p>
-        </p:txBody>
-      </p:sp>
-      <p:sp>
-        <p:nvSpPr>
-          <p:cNvPr id="3" name="TextBox 2"/>
-          <p:cNvSpPr txBox="1"/>
-          <p:nvPr/>
-        </p:nvSpPr>
-        <p:spPr>
-          <a:xfrm>
-            <a:off x="11231575" y="274320"/>
-            <a:ext cx="685800" cy="228600"/>
-          </a:xfrm>
-          <a:prstGeom prst="rect">
-            <a:avLst/>
-          </a:prstGeom>
-          <a:noFill/>
-        </p:spPr>
-        <p:txBody>
-          <a:bodyPr wrap="square" anchor="t" lIns="0" rIns="0" tIns="0" bIns="0">
-            <a:spAutoFit/>
-          </a:bodyPr>
-          <a:lstStyle/>
-          <a:p>
-            <a:pPr algn="r"/>
-            <a:r>
-              <a:rPr sz="900" b="0" i="0">
-                <a:solidFill>
-                  <a:srgbClr val="59595C"/>
-                </a:solidFill>
-                <a:latin typeface="Arial"/>
-                <a:cs typeface="Arial"/>
-              </a:rPr>
-              <a:t>2 / 19</a:t>
-            </a:r>
-          </a:p>
-        </p:txBody>
-      </p:sp>
-      <p:sp>
-        <p:nvSpPr>
-          <p:cNvPr id="4" name="TextBox 3"/>
-          <p:cNvSpPr txBox="1"/>
-          <p:nvPr/>
-        </p:nvSpPr>
-        <p:spPr>
-          <a:xfrm>
-            <a:off x="566928" y="1554480"/>
-            <a:ext cx="6309360" cy="3840480"/>
-          </a:xfrm>
-          <a:prstGeom prst="rect">
-            <a:avLst/>
-          </a:prstGeom>
-          <a:noFill/>
-        </p:spPr>
-        <p:txBody>
-          <a:bodyPr wrap="square" lIns="0" rIns="0" tIns="0" bIns="0">
-            <a:spAutoFit/>
-          </a:bodyPr>
-          <a:lstStyle/>
-          <a:p>
-            <a:pPr marL="219456" indent="-219456">
-              <a:lnSpc>
-                <a:spcPct val="106000"/>
-              </a:lnSpc>
-              <a:spcAft>
-                <a:spcPts val="1800"/>
-              </a:spcAft>
-              <a:buClr>
-                <a:srgbClr val="06509D"/>
-              </a:buClr>
-              <a:buFont typeface="Arial"/>
-              <a:buChar char="•"/>
-            </a:pPr>
-            <a:r>
-              <a:rPr sz="1650" b="0" i="0">
-                <a:solidFill>
-                  <a:srgbClr val="3A3F47"/>
-                </a:solidFill>
-                <a:latin typeface="Arial"/>
-                <a:cs typeface="Arial"/>
-              </a:rPr>
-              <a:t>Transportable microreactors, pebble-bed cores, accident scenarios: components must be qualified under </a:t>
-            </a:r>
-            <a:r>
-              <a:rPr sz="1650" b="1" i="0">
-                <a:solidFill>
-                  <a:srgbClr val="3A3F47"/>
-                </a:solidFill>
-                <a:latin typeface="Arial"/>
-                <a:cs typeface="Arial"/>
-              </a:rPr>
-              <a:t>impact and other high-rate loads</a:t>
-            </a:r>
-          </a:p>
-          <a:p>
-            <a:pPr marL="219456" indent="-219456">
-              <a:lnSpc>
-                <a:spcPct val="106000"/>
-              </a:lnSpc>
-              <a:spcAft>
-                <a:spcPts val="1800"/>
-              </a:spcAft>
-              <a:buClr>
-                <a:srgbClr val="06509D"/>
-              </a:buClr>
-              <a:buFont typeface="Arial"/>
-              <a:buChar char="•"/>
-            </a:pPr>
-            <a:r>
-              <a:rPr sz="1650" b="0" i="0">
-                <a:solidFill>
-                  <a:srgbClr val="3A3F47"/>
-                </a:solidFill>
-                <a:latin typeface="Arial"/>
-                <a:cs typeface="Arial"/>
-              </a:rPr>
-              <a:t>These events are </a:t>
-            </a:r>
-            <a:r>
-              <a:rPr sz="1650" b="1" i="0">
-                <a:solidFill>
-                  <a:srgbClr val="3A3F47"/>
-                </a:solidFill>
-                <a:latin typeface="Arial"/>
-                <a:cs typeface="Arial"/>
-              </a:rPr>
-              <a:t>wave-dominated and fast</a:t>
-            </a:r>
-            <a:r>
-              <a:rPr sz="1650" b="0" i="0">
-                <a:solidFill>
-                  <a:srgbClr val="3A3F47"/>
-                </a:solidFill>
-                <a:latin typeface="Arial"/>
-                <a:cs typeface="Arial"/>
-              </a:rPr>
-              <a:t>. Stress waves traverse the part in microseconds, with severe, localized plasticity</a:t>
-            </a:r>
-          </a:p>
-          <a:p>
-            <a:pPr marL="219456" indent="-219456">
-              <a:lnSpc>
-                <a:spcPct val="106000"/>
-              </a:lnSpc>
-              <a:spcAft>
-                <a:spcPts val="1800"/>
-              </a:spcAft>
-              <a:buClr>
-                <a:srgbClr val="06509D"/>
-              </a:buClr>
-              <a:buFont typeface="Arial"/>
-              <a:buChar char="•"/>
-            </a:pPr>
-            <a:r>
-              <a:rPr sz="1650" b="0" i="0">
-                <a:solidFill>
-                  <a:srgbClr val="3A3F47"/>
-                </a:solidFill>
-                <a:latin typeface="Arial"/>
-                <a:cs typeface="Arial"/>
-              </a:rPr>
-              <a:t>Predictive fidelity requires </a:t>
-            </a:r>
-            <a:r>
-              <a:rPr sz="1650" b="1" i="0">
-                <a:solidFill>
-                  <a:srgbClr val="3A3F47"/>
-                </a:solidFill>
-                <a:latin typeface="Arial"/>
-                <a:cs typeface="Arial"/>
-              </a:rPr>
-              <a:t>modern constitutive models</a:t>
-            </a:r>
-            <a:r>
-              <a:rPr sz="1650" b="0" i="0">
-                <a:solidFill>
-                  <a:srgbClr val="3A3F47"/>
-                </a:solidFill>
-                <a:latin typeface="Arial"/>
-                <a:cs typeface="Arial"/>
-              </a:rPr>
-              <a:t>. Rate- and temperature-dependent, with evolving internal state</a:t>
-            </a:r>
-          </a:p>
-          <a:p>
-            <a:pPr marL="219456" indent="-219456">
-              <a:lnSpc>
-                <a:spcPct val="106000"/>
-              </a:lnSpc>
-              <a:spcAft>
-                <a:spcPts val="1800"/>
-              </a:spcAft>
-              <a:buClr>
-                <a:srgbClr val="06509D"/>
-              </a:buClr>
-              <a:buFont typeface="Arial"/>
-              <a:buChar char="•"/>
-            </a:pPr>
-            <a:r>
-              <a:rPr sz="1650" b="0" i="0">
-                <a:solidFill>
-                  <a:srgbClr val="3A3F47"/>
-                </a:solidFill>
-                <a:latin typeface="Arial"/>
-                <a:cs typeface="Arial"/>
-              </a:rPr>
-              <a:t>Simulating them means </a:t>
-            </a:r>
-            <a:r>
-              <a:rPr sz="1650" b="1" i="0">
-                <a:solidFill>
-                  <a:srgbClr val="3A3F47"/>
-                </a:solidFill>
-                <a:latin typeface="Arial"/>
-                <a:cs typeface="Arial"/>
-              </a:rPr>
-              <a:t>explicit time integration</a:t>
-            </a:r>
-            <a:r>
-              <a:rPr sz="1650" b="0" i="0">
-                <a:solidFill>
-                  <a:srgbClr val="3A3F47"/>
-                </a:solidFill>
-                <a:latin typeface="Arial"/>
-                <a:cs typeface="Arial"/>
-              </a:rPr>
-              <a:t> with a material-model evaluation at every quadrature point, every step</a:t>
-            </a:r>
-          </a:p>
-        </p:txBody>
-      </p:sp>
-      <p:sp>
-        <p:nvSpPr>
-          <p:cNvPr id="5" name="Rounded Rectangle 4"/>
-          <p:cNvSpPr/>
-          <p:nvPr/>
-        </p:nvSpPr>
-        <p:spPr>
-          <a:xfrm>
-            <a:off x="7333488" y="1207008"/>
-            <a:ext cx="4291279" cy="3977639"/>
-          </a:xfrm>
-          <a:prstGeom prst="roundRect">
-            <a:avLst>
-              <a:gd name="adj" fmla="val 5500"/>
-            </a:avLst>
-          </a:prstGeom>
-          <a:solidFill>
-            <a:srgbClr val="F4F5F7"/>
-          </a:solidFill>
-          <a:ln w="9525">
-            <a:solidFill>
-              <a:srgbClr val="DADDE2"/>
-            </a:solidFill>
-          </a:ln>
-          <a:effectLst/>
-        </p:spPr>
-        <p:style>
-          <a:lnRef idx="1">
-            <a:schemeClr val="accent1"/>
-          </a:lnRef>
-          <a:fillRef idx="3">
-            <a:schemeClr val="accent1"/>
-          </a:fillRef>
-          <a:effectRef idx="2">
-            <a:schemeClr val="accent1"/>
-          </a:effectRef>
-          <a:fontRef idx="minor">
-            <a:schemeClr val="lt1"/>
-          </a:fontRef>
-        </p:style>
-        <p:txBody>
-          <a:bodyPr rtlCol="0" anchor="ctr"/>
-          <a:lstStyle/>
-          <a:p>
-            <a:pPr algn="ctr"/>
-          </a:p>
-        </p:txBody>
-      </p:sp>
-      <p:sp>
-        <p:nvSpPr>
-          <p:cNvPr id="6" name="TextBox 5"/>
-          <p:cNvSpPr txBox="1"/>
-          <p:nvPr/>
-        </p:nvSpPr>
-        <p:spPr>
-          <a:xfrm>
-            <a:off x="7589520" y="1408176"/>
-            <a:ext cx="3779215" cy="274320"/>
-          </a:xfrm>
-          <a:prstGeom prst="rect">
-            <a:avLst/>
-          </a:prstGeom>
-          <a:noFill/>
-        </p:spPr>
-        <p:txBody>
-          <a:bodyPr wrap="square" anchor="t" lIns="0" rIns="0" tIns="0" bIns="0">
-            <a:spAutoFit/>
-          </a:bodyPr>
-          <a:lstStyle/>
-          <a:p>
-            <a:pPr algn="l"/>
-            <a:r>
-              <a:rPr sz="1050" b="1" i="0">
-                <a:solidFill>
-                  <a:srgbClr val="59595C"/>
-                </a:solidFill>
-                <a:latin typeface="Arial"/>
-                <a:cs typeface="Arial"/>
-              </a:rPr>
-              <a:t>TIMESCALES OF AN IMPACT EVENT</a:t>
-            </a:r>
-          </a:p>
-        </p:txBody>
-      </p:sp>
-      <p:sp>
-        <p:nvSpPr>
-          <p:cNvPr id="7" name="Rounded Rectangle 6"/>
-          <p:cNvSpPr/>
-          <p:nvPr/>
-        </p:nvSpPr>
-        <p:spPr>
-          <a:xfrm>
-            <a:off x="7589520" y="1865376"/>
-            <a:ext cx="3779215" cy="658368"/>
-          </a:xfrm>
-          <a:prstGeom prst="roundRect">
-            <a:avLst>
-              <a:gd name="adj" fmla="val 5500"/>
-            </a:avLst>
-          </a:prstGeom>
-          <a:solidFill>
-            <a:srgbClr val="FFFFFF"/>
-          </a:solidFill>
-          <a:ln w="9525">
-            <a:solidFill>
-              <a:srgbClr val="DADDE2"/>
-            </a:solidFill>
-          </a:ln>
-          <a:effectLst/>
-        </p:spPr>
-        <p:style>
-          <a:lnRef idx="1">
-            <a:schemeClr val="accent1"/>
-          </a:lnRef>
-          <a:fillRef idx="3">
-            <a:schemeClr val="accent1"/>
-          </a:fillRef>
-          <a:effectRef idx="2">
-            <a:schemeClr val="accent1"/>
-          </a:effectRef>
-          <a:fontRef idx="minor">
-            <a:schemeClr val="lt1"/>
-          </a:fontRef>
-        </p:style>
-        <p:txBody>
-          <a:bodyPr rtlCol="0" anchor="ctr"/>
-          <a:lstStyle/>
-          <a:p>
-            <a:pPr algn="ctr"/>
-          </a:p>
-        </p:txBody>
-      </p:sp>
-      <p:sp>
-        <p:nvSpPr>
-          <p:cNvPr id="8" name="TextBox 7"/>
-          <p:cNvSpPr txBox="1"/>
-          <p:nvPr/>
-        </p:nvSpPr>
-        <p:spPr>
-          <a:xfrm>
-            <a:off x="7808976" y="1865376"/>
-            <a:ext cx="2371039" cy="658368"/>
-          </a:xfrm>
-          <a:prstGeom prst="rect">
-            <a:avLst/>
-          </a:prstGeom>
-          <a:noFill/>
-        </p:spPr>
-        <p:txBody>
-          <a:bodyPr wrap="square" anchor="ctr" lIns="0" rIns="0" tIns="0" bIns="0">
-            <a:spAutoFit/>
-          </a:bodyPr>
-          <a:lstStyle/>
-          <a:p>
-            <a:pPr algn="l"/>
-            <a:r>
-              <a:rPr sz="1250" b="0" i="0">
-                <a:solidFill>
-                  <a:srgbClr val="3A3F47"/>
-                </a:solidFill>
-                <a:latin typeface="Arial"/>
-                <a:cs typeface="Arial"/>
-              </a:rPr>
-              <a:t>event duration</a:t>
-            </a:r>
-          </a:p>
-        </p:txBody>
-      </p:sp>
-      <p:sp>
-        <p:nvSpPr>
-          <p:cNvPr id="9" name="TextBox 8"/>
-          <p:cNvSpPr txBox="1"/>
-          <p:nvPr/>
-        </p:nvSpPr>
-        <p:spPr>
-          <a:xfrm>
-            <a:off x="9841687" y="1865376"/>
-            <a:ext cx="1417320" cy="658368"/>
-          </a:xfrm>
-          <a:prstGeom prst="rect">
-            <a:avLst/>
-          </a:prstGeom>
-          <a:noFill/>
-        </p:spPr>
-        <p:txBody>
-          <a:bodyPr wrap="square" anchor="ctr" lIns="0" rIns="0" tIns="0" bIns="0">
-            <a:spAutoFit/>
-          </a:bodyPr>
-          <a:lstStyle/>
-          <a:p>
-            <a:pPr algn="r"/>
-            <a:r>
-              <a:rPr sz="1500" b="1" i="0">
-                <a:solidFill>
-                  <a:srgbClr val="06509D"/>
-                </a:solidFill>
-                <a:latin typeface="Arial"/>
-                <a:cs typeface="Arial"/>
-              </a:rPr>
-              <a:t>~100 µs</a:t>
-            </a:r>
-          </a:p>
-        </p:txBody>
-      </p:sp>
-      <p:sp>
-        <p:nvSpPr>
-          <p:cNvPr id="10" name="Rounded Rectangle 9"/>
-          <p:cNvSpPr/>
-          <p:nvPr/>
-        </p:nvSpPr>
-        <p:spPr>
-          <a:xfrm>
-            <a:off x="7589520" y="2660904"/>
-            <a:ext cx="3779215" cy="658368"/>
-          </a:xfrm>
-          <a:prstGeom prst="roundRect">
-            <a:avLst>
-              <a:gd name="adj" fmla="val 5500"/>
-            </a:avLst>
-          </a:prstGeom>
-          <a:solidFill>
-            <a:srgbClr val="FFFFFF"/>
-          </a:solidFill>
-          <a:ln w="9525">
-            <a:solidFill>
-              <a:srgbClr val="DADDE2"/>
-            </a:solidFill>
-          </a:ln>
-          <a:effectLst/>
-        </p:spPr>
-        <p:style>
-          <a:lnRef idx="1">
-            <a:schemeClr val="accent1"/>
-          </a:lnRef>
-          <a:fillRef idx="3">
-            <a:schemeClr val="accent1"/>
-          </a:fillRef>
-          <a:effectRef idx="2">
-            <a:schemeClr val="accent1"/>
-          </a:effectRef>
-          <a:fontRef idx="minor">
-            <a:schemeClr val="lt1"/>
-          </a:fontRef>
-        </p:style>
-        <p:txBody>
-          <a:bodyPr rtlCol="0" anchor="ctr"/>
-          <a:lstStyle/>
-          <a:p>
-            <a:pPr algn="ctr"/>
-          </a:p>
-        </p:txBody>
-      </p:sp>
-      <p:sp>
-        <p:nvSpPr>
-          <p:cNvPr id="11" name="TextBox 10"/>
-          <p:cNvSpPr txBox="1"/>
-          <p:nvPr/>
-        </p:nvSpPr>
-        <p:spPr>
-          <a:xfrm>
-            <a:off x="7808976" y="2660904"/>
-            <a:ext cx="2371039" cy="658368"/>
-          </a:xfrm>
-          <a:prstGeom prst="rect">
-            <a:avLst/>
-          </a:prstGeom>
-          <a:noFill/>
-        </p:spPr>
-        <p:txBody>
-          <a:bodyPr wrap="square" anchor="ctr" lIns="0" rIns="0" tIns="0" bIns="0">
-            <a:spAutoFit/>
-          </a:bodyPr>
-          <a:lstStyle/>
-          <a:p>
-            <a:pPr algn="l"/>
-            <a:r>
-              <a:rPr sz="1250" b="0" i="0">
-                <a:solidFill>
-                  <a:srgbClr val="3A3F47"/>
-                </a:solidFill>
-                <a:latin typeface="Arial"/>
-                <a:cs typeface="Arial"/>
-              </a:rPr>
-              <a:t>wave transit through part</a:t>
-            </a:r>
-          </a:p>
-        </p:txBody>
-      </p:sp>
-      <p:sp>
-        <p:nvSpPr>
-          <p:cNvPr id="12" name="TextBox 11"/>
-          <p:cNvSpPr txBox="1"/>
-          <p:nvPr/>
-        </p:nvSpPr>
-        <p:spPr>
-          <a:xfrm>
-            <a:off x="9841687" y="2660904"/>
-            <a:ext cx="1417320" cy="658368"/>
-          </a:xfrm>
-          <a:prstGeom prst="rect">
-            <a:avLst/>
-          </a:prstGeom>
-          <a:noFill/>
-        </p:spPr>
-        <p:txBody>
-          <a:bodyPr wrap="square" anchor="ctr" lIns="0" rIns="0" tIns="0" bIns="0">
-            <a:spAutoFit/>
-          </a:bodyPr>
-          <a:lstStyle/>
-          <a:p>
-            <a:pPr algn="r"/>
-            <a:r>
-              <a:rPr sz="1500" b="1" i="0">
-                <a:solidFill>
-                  <a:srgbClr val="06509D"/>
-                </a:solidFill>
-                <a:latin typeface="Arial"/>
-                <a:cs typeface="Arial"/>
-              </a:rPr>
-              <a:t>~1–10 µs</a:t>
-            </a:r>
-          </a:p>
-        </p:txBody>
-      </p:sp>
-      <p:sp>
-        <p:nvSpPr>
-          <p:cNvPr id="13" name="Rounded Rectangle 12"/>
-          <p:cNvSpPr/>
-          <p:nvPr/>
-        </p:nvSpPr>
-        <p:spPr>
-          <a:xfrm>
-            <a:off x="7589520" y="3456432"/>
-            <a:ext cx="3779215" cy="658368"/>
-          </a:xfrm>
-          <a:prstGeom prst="roundRect">
-            <a:avLst>
-              <a:gd name="adj" fmla="val 5500"/>
-            </a:avLst>
-          </a:prstGeom>
-          <a:solidFill>
-            <a:srgbClr val="FFFFFF"/>
-          </a:solidFill>
-          <a:ln w="9525">
-            <a:solidFill>
-              <a:srgbClr val="DADDE2"/>
-            </a:solidFill>
-          </a:ln>
-          <a:effectLst/>
-        </p:spPr>
-        <p:style>
-          <a:lnRef idx="1">
-            <a:schemeClr val="accent1"/>
-          </a:lnRef>
-          <a:fillRef idx="3">
-            <a:schemeClr val="accent1"/>
-          </a:fillRef>
-          <a:effectRef idx="2">
-            <a:schemeClr val="accent1"/>
-          </a:effectRef>
-          <a:fontRef idx="minor">
-            <a:schemeClr val="lt1"/>
-          </a:fontRef>
-        </p:style>
-        <p:txBody>
-          <a:bodyPr rtlCol="0" anchor="ctr"/>
-          <a:lstStyle/>
-          <a:p>
-            <a:pPr algn="ctr"/>
-          </a:p>
-        </p:txBody>
-      </p:sp>
-      <p:sp>
-        <p:nvSpPr>
-          <p:cNvPr id="14" name="TextBox 13"/>
-          <p:cNvSpPr txBox="1"/>
-          <p:nvPr/>
-        </p:nvSpPr>
-        <p:spPr>
-          <a:xfrm>
-            <a:off x="7808976" y="3456432"/>
-            <a:ext cx="2371039" cy="658368"/>
-          </a:xfrm>
-          <a:prstGeom prst="rect">
-            <a:avLst/>
-          </a:prstGeom>
-          <a:noFill/>
-        </p:spPr>
-        <p:txBody>
-          <a:bodyPr wrap="square" anchor="ctr" lIns="0" rIns="0" tIns="0" bIns="0">
-            <a:spAutoFit/>
-          </a:bodyPr>
-          <a:lstStyle/>
-          <a:p>
-            <a:pPr algn="l"/>
-            <a:r>
-              <a:rPr sz="1250" b="0" i="0">
-                <a:solidFill>
-                  <a:srgbClr val="3A3F47"/>
-                </a:solidFill>
-                <a:latin typeface="Arial"/>
-                <a:cs typeface="Arial"/>
-              </a:rPr>
-              <a:t>stable explicit step</a:t>
-            </a:r>
-          </a:p>
-        </p:txBody>
-      </p:sp>
-      <p:sp>
-        <p:nvSpPr>
-          <p:cNvPr id="15" name="TextBox 14"/>
-          <p:cNvSpPr txBox="1"/>
-          <p:nvPr/>
-        </p:nvSpPr>
-        <p:spPr>
-          <a:xfrm>
-            <a:off x="9841687" y="3456432"/>
-            <a:ext cx="1417320" cy="658368"/>
-          </a:xfrm>
-          <a:prstGeom prst="rect">
-            <a:avLst/>
-          </a:prstGeom>
-          <a:noFill/>
-        </p:spPr>
-        <p:txBody>
-          <a:bodyPr wrap="square" anchor="ctr" lIns="0" rIns="0" tIns="0" bIns="0">
-            <a:spAutoFit/>
-          </a:bodyPr>
-          <a:lstStyle/>
-          <a:p>
-            <a:pPr algn="r"/>
-            <a:r>
-              <a:rPr sz="1500" b="1" i="0">
-                <a:solidFill>
-                  <a:srgbClr val="CF1D4C"/>
-                </a:solidFill>
-                <a:latin typeface="Arial"/>
-                <a:cs typeface="Arial"/>
-              </a:rPr>
-              <a:t>~10 ns</a:t>
-            </a:r>
-          </a:p>
-        </p:txBody>
-      </p:sp>
-      <p:sp>
-        <p:nvSpPr>
-          <p:cNvPr id="16" name="Rounded Rectangle 15"/>
-          <p:cNvSpPr/>
-          <p:nvPr/>
-        </p:nvSpPr>
-        <p:spPr>
-          <a:xfrm>
-            <a:off x="7589520" y="4251960"/>
-            <a:ext cx="3779215" cy="658368"/>
-          </a:xfrm>
-          <a:prstGeom prst="roundRect">
-            <a:avLst>
-              <a:gd name="adj" fmla="val 5500"/>
-            </a:avLst>
-          </a:prstGeom>
-          <a:solidFill>
-            <a:srgbClr val="FFFFFF"/>
-          </a:solidFill>
-          <a:ln w="9525">
-            <a:solidFill>
-              <a:srgbClr val="DADDE2"/>
-            </a:solidFill>
-          </a:ln>
-          <a:effectLst/>
-        </p:spPr>
-        <p:style>
-          <a:lnRef idx="1">
-            <a:schemeClr val="accent1"/>
-          </a:lnRef>
-          <a:fillRef idx="3">
-            <a:schemeClr val="accent1"/>
-          </a:fillRef>
-          <a:effectRef idx="2">
-            <a:schemeClr val="accent1"/>
-          </a:effectRef>
-          <a:fontRef idx="minor">
-            <a:schemeClr val="lt1"/>
-          </a:fontRef>
-        </p:style>
-        <p:txBody>
-          <a:bodyPr rtlCol="0" anchor="ctr"/>
-          <a:lstStyle/>
-          <a:p>
-            <a:pPr algn="ctr"/>
-          </a:p>
-        </p:txBody>
-      </p:sp>
-      <p:sp>
-        <p:nvSpPr>
-          <p:cNvPr id="17" name="TextBox 16"/>
-          <p:cNvSpPr txBox="1"/>
-          <p:nvPr/>
-        </p:nvSpPr>
-        <p:spPr>
-          <a:xfrm>
-            <a:off x="7808976" y="4251960"/>
-            <a:ext cx="2371039" cy="658368"/>
-          </a:xfrm>
-          <a:prstGeom prst="rect">
-            <a:avLst/>
-          </a:prstGeom>
-          <a:noFill/>
-        </p:spPr>
-        <p:txBody>
-          <a:bodyPr wrap="square" anchor="ctr" lIns="0" rIns="0" tIns="0" bIns="0">
-            <a:spAutoFit/>
-          </a:bodyPr>
-          <a:lstStyle/>
-          <a:p>
-            <a:pPr algn="l"/>
-            <a:r>
-              <a:rPr sz="1250" b="0" i="0">
-                <a:solidFill>
-                  <a:srgbClr val="3A3F47"/>
-                </a:solidFill>
-                <a:latin typeface="Arial"/>
-                <a:cs typeface="Arial"/>
-              </a:rPr>
-              <a:t>⇒  steps to simulate</a:t>
-            </a:r>
-          </a:p>
-        </p:txBody>
-      </p:sp>
-      <p:sp>
-        <p:nvSpPr>
-          <p:cNvPr id="18" name="TextBox 17"/>
-          <p:cNvSpPr txBox="1"/>
-          <p:nvPr/>
-        </p:nvSpPr>
-        <p:spPr>
-          <a:xfrm>
-            <a:off x="9841687" y="4251960"/>
-            <a:ext cx="1417320" cy="658368"/>
-          </a:xfrm>
-          <a:prstGeom prst="rect">
-            <a:avLst/>
-          </a:prstGeom>
-          <a:noFill/>
-        </p:spPr>
-        <p:txBody>
-          <a:bodyPr wrap="square" anchor="ctr" lIns="0" rIns="0" tIns="0" bIns="0">
-            <a:spAutoFit/>
-          </a:bodyPr>
-          <a:lstStyle/>
-          <a:p>
-            <a:pPr algn="r"/>
-            <a:r>
-              <a:rPr sz="1500" b="1" i="0">
-                <a:solidFill>
-                  <a:srgbClr val="1E2430"/>
-                </a:solidFill>
-                <a:latin typeface="Arial"/>
-                <a:cs typeface="Arial"/>
-              </a:rPr>
-              <a:t>10</a:t>
-            </a:r>
-            <a:r>
-              <a:rPr sz="1500" b="1" i="0" baseline="30000">
-                <a:solidFill>
-                  <a:srgbClr val="1E2430"/>
-                </a:solidFill>
-                <a:latin typeface="Arial"/>
-                <a:cs typeface="Arial"/>
-              </a:rPr>
-              <a:t>4</a:t>
-            </a:r>
-            <a:r>
-              <a:rPr sz="1500" b="1" i="0">
-                <a:solidFill>
-                  <a:srgbClr val="1E2430"/>
-                </a:solidFill>
-                <a:latin typeface="Arial"/>
-                <a:cs typeface="Arial"/>
-              </a:rPr>
-              <a:t>–10</a:t>
-            </a:r>
-            <a:r>
-              <a:rPr sz="1500" b="1" i="0" baseline="30000">
-                <a:solidFill>
-                  <a:srgbClr val="1E2430"/>
-                </a:solidFill>
-                <a:latin typeface="Arial"/>
-                <a:cs typeface="Arial"/>
-              </a:rPr>
-              <a:t>5</a:t>
-            </a:r>
-          </a:p>
-        </p:txBody>
-      </p:sp>
-      <p:sp>
-        <p:nvSpPr>
-          <p:cNvPr id="19" name="Rounded Rectangle 18"/>
-          <p:cNvSpPr/>
-          <p:nvPr/>
-        </p:nvSpPr>
-        <p:spPr>
-          <a:xfrm>
-            <a:off x="566928" y="5376672"/>
-            <a:ext cx="11057839" cy="658368"/>
-          </a:xfrm>
-          <a:prstGeom prst="roundRect">
-            <a:avLst>
-              <a:gd name="adj" fmla="val 5500"/>
-            </a:avLst>
-          </a:prstGeom>
-          <a:solidFill>
-            <a:srgbClr val="FDF0DF"/>
-          </a:solidFill>
-          <a:ln w="12700">
-            <a:solidFill>
-              <a:srgbClr val="B4620B"/>
-            </a:solidFill>
-          </a:ln>
-          <a:effectLst/>
-        </p:spPr>
-        <p:style>
-          <a:lnRef idx="1">
-            <a:schemeClr val="accent1"/>
-          </a:lnRef>
-          <a:fillRef idx="3">
-            <a:schemeClr val="accent1"/>
-          </a:fillRef>
-          <a:effectRef idx="2">
-            <a:schemeClr val="accent1"/>
-          </a:effectRef>
-          <a:fontRef idx="minor">
-            <a:schemeClr val="lt1"/>
-          </a:fontRef>
-        </p:style>
-        <p:txBody>
-          <a:bodyPr rtlCol="0" anchor="ctr"/>
-          <a:lstStyle/>
-          <a:p>
-            <a:pPr algn="ctr"/>
-          </a:p>
-        </p:txBody>
-      </p:sp>
-      <p:sp>
-        <p:nvSpPr>
-          <p:cNvPr id="20" name="TextBox 19"/>
-          <p:cNvSpPr txBox="1"/>
-          <p:nvPr/>
-        </p:nvSpPr>
-        <p:spPr>
-          <a:xfrm>
-            <a:off x="841248" y="5376672"/>
-            <a:ext cx="10509199" cy="658368"/>
-          </a:xfrm>
-          <a:prstGeom prst="rect">
-            <a:avLst/>
-          </a:prstGeom>
-          <a:noFill/>
-        </p:spPr>
-        <p:txBody>
-          <a:bodyPr wrap="square" anchor="ctr" lIns="0" rIns="0" tIns="0" bIns="0">
-            <a:spAutoFit/>
-          </a:bodyPr>
-          <a:lstStyle/>
-          <a:p>
-            <a:pPr algn="l"/>
-            <a:r>
-              <a:rPr sz="1500" b="1" i="0">
-                <a:solidFill>
-                  <a:srgbClr val="1E2430"/>
-                </a:solidFill>
-                <a:latin typeface="Arial"/>
-                <a:cs typeface="Arial"/>
-              </a:rPr>
-              <a:t>Many steps × expensive material updates:</a:t>
-            </a:r>
-            <a:r>
-              <a:rPr sz="1500" b="0" i="0">
-                <a:solidFill>
-                  <a:srgbClr val="3A3F47"/>
-                </a:solidFill>
-                <a:latin typeface="Arial"/>
-                <a:cs typeface="Arial"/>
-              </a:rPr>
-              <a:t> high-rate simulation is compute-hungry in a very particular way.</a:t>
-            </a:r>
-          </a:p>
-        </p:txBody>
-      </p:sp>
-    </p:spTree>
-  </p:cSld>
-  <p:clrMapOvr>
-    <a:masterClrMapping/>
-  </p:clrMapOvr>
-</p:sld>
-</file>
-
 <file path=ppt/slides/slide3.xml><?xml version="1.0" encoding="utf-8"?>
 <p:sld xmlns:a="http://schemas.openxmlformats.org/drawingml/2006/main" xmlns:p="http://schemas.openxmlformats.org/presentationml/2006/main" xmlns:r="http://schemas.openxmlformats.org/officeDocument/2006/relationships">
   <p:cSld>
@@ -18081,7 +18366,7 @@
                 <a:latin typeface="Arial"/>
                 <a:cs typeface="Arial"/>
               </a:rPr>
-              <a:t>3 / 19</a:t>
+              <a:t>3 / 20</a:t>
             </a:r>
           </a:p>
         </p:txBody>
@@ -18758,7 +19043,7 @@
                 <a:latin typeface="Arial"/>
                 <a:cs typeface="Arial"/>
               </a:rPr>
-              <a:t>4 / 19</a:t>
+              <a:t>4 / 20</a:t>
             </a:r>
           </a:p>
         </p:txBody>
@@ -19188,7 +19473,7 @@
                 <a:latin typeface="Arial"/>
                 <a:cs typeface="Arial"/>
               </a:rPr>
-              <a:t>5 / 19</a:t>
+              <a:t>5 / 20</a:t>
             </a:r>
           </a:p>
         </p:txBody>
@@ -19564,7 +19849,7 @@
                 <a:latin typeface="Arial"/>
                 <a:cs typeface="Arial"/>
               </a:rPr>
-              <a:t>6 / 19</a:t>
+              <a:t>6 / 20</a:t>
             </a:r>
           </a:p>
         </p:txBody>
@@ -20604,7 +20889,7 @@
                 <a:latin typeface="Arial"/>
                 <a:cs typeface="Arial"/>
               </a:rPr>
-              <a:t>7 / 19</a:t>
+              <a:t>7 / 20</a:t>
             </a:r>
           </a:p>
         </p:txBody>
@@ -21309,7 +21594,7 @@
                 <a:latin typeface="Arial"/>
                 <a:cs typeface="Arial"/>
               </a:rPr>
-              <a:t>8 / 19</a:t>
+              <a:t>8 / 20</a:t>
             </a:r>
           </a:p>
         </p:txBody>
@@ -22169,7 +22454,7 @@
                 <a:latin typeface="Arial"/>
                 <a:cs typeface="Arial"/>
               </a:rPr>
-              <a:t>9 / 19</a:t>
+              <a:t>9 / 20</a:t>
             </a:r>
           </a:p>
         </p:txBody>

</xml_diff>

<commit_message>
slides: blind prediction at 132.3 m/s (slide 21)
</commit_message>
<xml_diff>
--- a/examples/impact/slide_assets/WCCM_NEML2_explicit_dynamics_v2.pptx
+++ b/examples/impact/slide_assets/WCCM_NEML2_explicit_dynamics_v2.pptx
@@ -28,6 +28,7 @@
     <p:sldId id="273" r:id="rId27"/>
     <p:sldId id="274" r:id="rId28"/>
     <p:sldId id="275" r:id="rId29"/>
+    <p:sldId id="276" r:id="rId30"/>
   </p:sldIdLst>
   <p:sldSz cx="12192000" cy="6858000"/>
   <p:notesSz cx="6858000" cy="9144000"/>
@@ -6364,7 +6365,7 @@
                 <a:latin typeface="Arial"/>
                 <a:cs typeface="Arial"/>
               </a:rPr>
-              <a:t>10 / 20</a:t>
+              <a:t>10 / 21</a:t>
             </a:r>
           </a:p>
         </p:txBody>
@@ -8752,7 +8753,7 @@
                 <a:latin typeface="Arial"/>
                 <a:cs typeface="Arial"/>
               </a:rPr>
-              <a:t>11 / 20</a:t>
+              <a:t>11 / 21</a:t>
             </a:r>
           </a:p>
         </p:txBody>
@@ -9597,7 +9598,7 @@
                 <a:latin typeface="Arial"/>
                 <a:cs typeface="Arial"/>
               </a:rPr>
-              <a:t>12 / 20</a:t>
+              <a:t>12 / 21</a:t>
             </a:r>
           </a:p>
         </p:txBody>
@@ -11192,7 +11193,7 @@
                 <a:latin typeface="Arial"/>
                 <a:cs typeface="Arial"/>
               </a:rPr>
-              <a:t>13 / 20</a:t>
+              <a:t>13 / 21</a:t>
             </a:r>
           </a:p>
         </p:txBody>
@@ -12472,7 +12473,7 @@
                 <a:latin typeface="Arial"/>
                 <a:cs typeface="Arial"/>
               </a:rPr>
-              <a:t>14 / 20</a:t>
+              <a:t>14 / 21</a:t>
             </a:r>
           </a:p>
         </p:txBody>
@@ -13346,7 +13347,7 @@
                 <a:latin typeface="Arial"/>
                 <a:cs typeface="Arial"/>
               </a:rPr>
-              <a:t>15 / 20</a:t>
+              <a:t>15 / 21</a:t>
             </a:r>
           </a:p>
         </p:txBody>
@@ -14248,7 +14249,7 @@
                 <a:latin typeface="Arial"/>
                 <a:cs typeface="Arial"/>
               </a:rPr>
-              <a:t>16 / 20</a:t>
+              <a:t>16 / 21</a:t>
             </a:r>
           </a:p>
         </p:txBody>
@@ -14607,7 +14608,7 @@
                 <a:latin typeface="Arial"/>
                 <a:cs typeface="Arial"/>
               </a:rPr>
-              <a:t>17 / 20</a:t>
+              <a:t>17 / 21</a:t>
             </a:r>
           </a:p>
         </p:txBody>
@@ -14891,7 +14892,7 @@
                 <a:latin typeface="Arial"/>
                 <a:cs typeface="Arial"/>
               </a:rPr>
-              <a:t>18 / 20</a:t>
+              <a:t>18 / 21</a:t>
             </a:r>
           </a:p>
         </p:txBody>
@@ -15599,7 +15600,7 @@
                 <a:latin typeface="Arial"/>
                 <a:cs typeface="Arial"/>
               </a:rPr>
-              <a:t>19 / 20</a:t>
+              <a:t>19 / 21</a:t>
             </a:r>
           </a:p>
         </p:txBody>
@@ -16805,7 +16806,7 @@
                 <a:latin typeface="Arial"/>
                 <a:cs typeface="Arial"/>
               </a:rPr>
-              <a:t>2 / 20</a:t>
+              <a:t>2 / 21</a:t>
             </a:r>
           </a:p>
         </p:txBody>
@@ -17762,7 +17763,7 @@
                 <a:latin typeface="Arial"/>
                 <a:cs typeface="Arial"/>
               </a:rPr>
-              <a:t>20 / 20</a:t>
+              <a:t>20 / 21</a:t>
             </a:r>
           </a:p>
         </p:txBody>
@@ -18303,6 +18304,564 @@
 </p:sld>
 </file>
 
+<file path=ppt/slides/slide21.xml><?xml version="1.0" encoding="utf-8"?>
+<p:sld xmlns:a="http://schemas.openxmlformats.org/drawingml/2006/main" xmlns:p="http://schemas.openxmlformats.org/presentationml/2006/main" xmlns:r="http://schemas.openxmlformats.org/officeDocument/2006/relationships">
+  <p:cSld>
+    <p:spTree>
+      <p:nvGrpSpPr>
+        <p:cNvPr id="1" name=""/>
+        <p:cNvGrpSpPr/>
+        <p:nvPr/>
+      </p:nvGrpSpPr>
+      <p:grpSpPr/>
+      <p:sp>
+        <p:nvSpPr>
+          <p:cNvPr id="2" name="Title 1"/>
+          <p:cNvSpPr>
+            <a:spLocks noGrp="1"/>
+          </p:cNvSpPr>
+          <p:nvPr>
+            <p:ph type="title"/>
+          </p:nvPr>
+        </p:nvSpPr>
+        <p:spPr/>
+        <p:txBody>
+          <a:bodyPr/>
+          <a:lstStyle/>
+          <a:p>
+            <a:r>
+              <a:rPr sz="2600"/>
+              <a:t>Prediction at a second velocity</a:t>
+            </a:r>
+          </a:p>
+        </p:txBody>
+      </p:sp>
+      <p:sp>
+        <p:nvSpPr>
+          <p:cNvPr id="3" name="TextBox 2"/>
+          <p:cNvSpPr txBox="1"/>
+          <p:nvPr/>
+        </p:nvSpPr>
+        <p:spPr>
+          <a:xfrm>
+            <a:off x="11231575" y="274320"/>
+            <a:ext cx="685800" cy="228600"/>
+          </a:xfrm>
+          <a:prstGeom prst="rect">
+            <a:avLst/>
+          </a:prstGeom>
+          <a:noFill/>
+        </p:spPr>
+        <p:txBody>
+          <a:bodyPr wrap="square" anchor="t" lIns="0" rIns="0" tIns="0" bIns="0">
+            <a:spAutoFit/>
+          </a:bodyPr>
+          <a:lstStyle/>
+          <a:p>
+            <a:pPr algn="r"/>
+            <a:r>
+              <a:rPr sz="900" b="0" i="0">
+                <a:solidFill>
+                  <a:srgbClr val="59595C"/>
+                </a:solidFill>
+                <a:latin typeface="Arial"/>
+                <a:cs typeface="Arial"/>
+              </a:rPr>
+              <a:t>21 / 21</a:t>
+            </a:r>
+          </a:p>
+        </p:txBody>
+      </p:sp>
+      <p:sp>
+        <p:nvSpPr>
+          <p:cNvPr id="4" name="TextBox 3"/>
+          <p:cNvSpPr txBox="1"/>
+          <p:nvPr/>
+        </p:nvSpPr>
+        <p:spPr>
+          <a:xfrm>
+            <a:off x="566928" y="1133856"/>
+            <a:ext cx="11057839" cy="320040"/>
+          </a:xfrm>
+          <a:prstGeom prst="rect">
+            <a:avLst/>
+          </a:prstGeom>
+          <a:noFill/>
+        </p:spPr>
+        <p:txBody>
+          <a:bodyPr wrap="square" anchor="t" lIns="0" rIns="0" tIns="0" bIns="0">
+            <a:spAutoFit/>
+          </a:bodyPr>
+          <a:lstStyle/>
+          <a:p>
+            <a:pPr algn="l"/>
+            <a:r>
+              <a:rPr sz="1450" b="0" i="0">
+                <a:solidFill>
+                  <a:srgbClr val="3A3F47"/>
+                </a:solidFill>
+                <a:latin typeface="Arial"/>
+                <a:cs typeface="Arial"/>
+              </a:rPr>
+              <a:t>A second specimen was shot at </a:t>
+            </a:r>
+            <a:r>
+              <a:rPr sz="1450" b="1" i="0">
+                <a:solidFill>
+                  <a:srgbClr val="1E2430"/>
+                </a:solidFill>
+                <a:latin typeface="Arial"/>
+                <a:cs typeface="Arial"/>
+              </a:rPr>
+              <a:t>132.3 m/s</a:t>
+            </a:r>
+            <a:r>
+              <a:rPr sz="1450" b="0" i="0">
+                <a:solidFill>
+                  <a:srgbClr val="3A3F47"/>
+                </a:solidFill>
+                <a:latin typeface="Arial"/>
+                <a:cs typeface="Arial"/>
+              </a:rPr>
+              <a:t> and scanned. The calibrated model was run at that velocity with </a:t>
+            </a:r>
+            <a:r>
+              <a:rPr sz="1450" b="1" i="0">
+                <a:solidFill>
+                  <a:srgbClr val="1E2430"/>
+                </a:solidFill>
+                <a:latin typeface="Arial"/>
+                <a:cs typeface="Arial"/>
+              </a:rPr>
+              <a:t>no refitting</a:t>
+            </a:r>
+            <a:r>
+              <a:rPr sz="1450" b="0" i="0">
+                <a:solidFill>
+                  <a:srgbClr val="3A3F47"/>
+                </a:solidFill>
+                <a:latin typeface="Arial"/>
+                <a:cs typeface="Arial"/>
+              </a:rPr>
+              <a:t>.</a:t>
+            </a:r>
+          </a:p>
+        </p:txBody>
+      </p:sp>
+      <p:pic>
+        <p:nvPicPr>
+          <p:cNvPr id="5" name="Picture 4" descr="fig_predict132.png"/>
+          <p:cNvPicPr>
+            <a:picLocks noChangeAspect="1"/>
+          </p:cNvPicPr>
+          <p:nvPr/>
+        </p:nvPicPr>
+        <p:blipFill>
+          <a:blip r:embed="rId2"/>
+          <a:stretch>
+            <a:fillRect/>
+          </a:stretch>
+        </p:blipFill>
+        <p:spPr>
+          <a:xfrm>
+            <a:off x="658368" y="1709928"/>
+            <a:ext cx="6949440" cy="2918764"/>
+          </a:xfrm>
+          <a:prstGeom prst="rect">
+            <a:avLst/>
+          </a:prstGeom>
+        </p:spPr>
+      </p:pic>
+      <p:sp>
+        <p:nvSpPr>
+          <p:cNvPr id="6" name="TextBox 5"/>
+          <p:cNvSpPr txBox="1"/>
+          <p:nvPr/>
+        </p:nvSpPr>
+        <p:spPr>
+          <a:xfrm>
+            <a:off x="749808" y="4683556"/>
+            <a:ext cx="6949440" cy="219456"/>
+          </a:xfrm>
+          <a:prstGeom prst="rect">
+            <a:avLst/>
+          </a:prstGeom>
+          <a:noFill/>
+        </p:spPr>
+        <p:txBody>
+          <a:bodyPr wrap="square" anchor="t" lIns="0" rIns="0" tIns="0" bIns="0">
+            <a:spAutoFit/>
+          </a:bodyPr>
+          <a:lstStyle/>
+          <a:p>
+            <a:pPr algn="l"/>
+            <a:r>
+              <a:rPr sz="1050" b="0" i="1">
+                <a:solidFill>
+                  <a:srgbClr val="59595C"/>
+                </a:solidFill>
+                <a:latin typeface="Arial"/>
+                <a:cs typeface="Arial"/>
+              </a:rPr>
+              <a:t>final deformed profile, production model at the calibrated posterior median</a:t>
+            </a:r>
+          </a:p>
+        </p:txBody>
+      </p:sp>
+      <p:sp>
+        <p:nvSpPr>
+          <p:cNvPr id="7" name="Rounded Rectangle 6"/>
+          <p:cNvSpPr/>
+          <p:nvPr/>
+        </p:nvSpPr>
+        <p:spPr>
+          <a:xfrm>
+            <a:off x="8065008" y="1755648"/>
+            <a:ext cx="3559759" cy="1371600"/>
+          </a:xfrm>
+          <a:prstGeom prst="roundRect">
+            <a:avLst>
+              <a:gd name="adj" fmla="val 5500"/>
+            </a:avLst>
+          </a:prstGeom>
+          <a:solidFill>
+            <a:srgbClr val="FFFFFF"/>
+          </a:solidFill>
+          <a:ln w="9525">
+            <a:solidFill>
+              <a:srgbClr val="DADDE2"/>
+            </a:solidFill>
+          </a:ln>
+          <a:effectLst/>
+        </p:spPr>
+        <p:style>
+          <a:lnRef idx="1">
+            <a:schemeClr val="accent1"/>
+          </a:lnRef>
+          <a:fillRef idx="3">
+            <a:schemeClr val="accent1"/>
+          </a:fillRef>
+          <a:effectRef idx="2">
+            <a:schemeClr val="accent1"/>
+          </a:effectRef>
+          <a:fontRef idx="minor">
+            <a:schemeClr val="lt1"/>
+          </a:fontRef>
+        </p:style>
+        <p:txBody>
+          <a:bodyPr rtlCol="0" anchor="ctr"/>
+          <a:lstStyle/>
+          <a:p>
+            <a:pPr algn="ctr"/>
+          </a:p>
+        </p:txBody>
+      </p:sp>
+      <p:sp>
+        <p:nvSpPr>
+          <p:cNvPr id="8" name="Rectangle 7"/>
+          <p:cNvSpPr/>
+          <p:nvPr/>
+        </p:nvSpPr>
+        <p:spPr>
+          <a:xfrm>
+            <a:off x="8065008" y="1865376"/>
+            <a:ext cx="50292" cy="1152144"/>
+          </a:xfrm>
+          <a:prstGeom prst="rect">
+            <a:avLst/>
+          </a:prstGeom>
+          <a:solidFill>
+            <a:srgbClr val="5E8614"/>
+          </a:solidFill>
+          <a:ln>
+            <a:noFill/>
+          </a:ln>
+          <a:effectLst/>
+        </p:spPr>
+        <p:style>
+          <a:lnRef idx="1">
+            <a:schemeClr val="accent1"/>
+          </a:lnRef>
+          <a:fillRef idx="3">
+            <a:schemeClr val="accent1"/>
+          </a:fillRef>
+          <a:effectRef idx="2">
+            <a:schemeClr val="accent1"/>
+          </a:effectRef>
+          <a:fontRef idx="minor">
+            <a:schemeClr val="lt1"/>
+          </a:fontRef>
+        </p:style>
+        <p:txBody>
+          <a:bodyPr rtlCol="0" anchor="ctr"/>
+          <a:lstStyle/>
+          <a:p>
+            <a:pPr algn="ctr"/>
+          </a:p>
+        </p:txBody>
+      </p:sp>
+      <p:sp>
+        <p:nvSpPr>
+          <p:cNvPr id="9" name="TextBox 8"/>
+          <p:cNvSpPr txBox="1"/>
+          <p:nvPr/>
+        </p:nvSpPr>
+        <p:spPr>
+          <a:xfrm>
+            <a:off x="8302752" y="1883664"/>
+            <a:ext cx="3102559" cy="457200"/>
+          </a:xfrm>
+          <a:prstGeom prst="rect">
+            <a:avLst/>
+          </a:prstGeom>
+          <a:noFill/>
+        </p:spPr>
+        <p:txBody>
+          <a:bodyPr wrap="square" anchor="t" lIns="0" rIns="0" tIns="0" bIns="0">
+            <a:spAutoFit/>
+          </a:bodyPr>
+          <a:lstStyle/>
+          <a:p>
+            <a:pPr algn="l"/>
+            <a:r>
+              <a:rPr sz="2600" b="1" i="0">
+                <a:solidFill>
+                  <a:srgbClr val="5E8614"/>
+                </a:solidFill>
+                <a:latin typeface="Arial"/>
+                <a:cs typeface="Arial"/>
+              </a:rPr>
+              <a:t>81 µm</a:t>
+            </a:r>
+            <a:r>
+              <a:rPr sz="1100" b="0" i="0">
+                <a:solidFill>
+                  <a:srgbClr val="59595C"/>
+                </a:solidFill>
+                <a:latin typeface="Arial"/>
+                <a:cs typeface="Arial"/>
+              </a:rPr>
+              <a:t>  profile RMS</a:t>
+            </a:r>
+          </a:p>
+        </p:txBody>
+      </p:sp>
+      <p:sp>
+        <p:nvSpPr>
+          <p:cNvPr id="10" name="TextBox 9"/>
+          <p:cNvSpPr txBox="1"/>
+          <p:nvPr/>
+        </p:nvSpPr>
+        <p:spPr>
+          <a:xfrm>
+            <a:off x="8302752" y="2414016"/>
+            <a:ext cx="3102559" cy="640080"/>
+          </a:xfrm>
+          <a:prstGeom prst="rect">
+            <a:avLst/>
+          </a:prstGeom>
+          <a:noFill/>
+        </p:spPr>
+        <p:txBody>
+          <a:bodyPr wrap="square" anchor="t" lIns="0" rIns="0" tIns="0" bIns="0">
+            <a:spAutoFit/>
+          </a:bodyPr>
+          <a:lstStyle/>
+          <a:p>
+            <a:pPr algn="l">
+              <a:lnSpc>
+                <a:spcPct val="115000"/>
+              </a:lnSpc>
+            </a:pPr>
+            <a:r>
+              <a:rPr sz="1150" b="0" i="0">
+                <a:solidFill>
+                  <a:srgbClr val="3A3F47"/>
+                </a:solidFill>
+                <a:latin typeface="Arial"/>
+                <a:cs typeface="Arial"/>
+              </a:rPr>
+              <a:t>blind, at a velocity 44% below the calibration shot</a:t>
+            </a:r>
+          </a:p>
+        </p:txBody>
+      </p:sp>
+      <p:sp>
+        <p:nvSpPr>
+          <p:cNvPr id="11" name="Rounded Rectangle 10"/>
+          <p:cNvSpPr/>
+          <p:nvPr/>
+        </p:nvSpPr>
+        <p:spPr>
+          <a:xfrm>
+            <a:off x="8065008" y="3328416"/>
+            <a:ext cx="3559759" cy="1463040"/>
+          </a:xfrm>
+          <a:prstGeom prst="roundRect">
+            <a:avLst>
+              <a:gd name="adj" fmla="val 5500"/>
+            </a:avLst>
+          </a:prstGeom>
+          <a:solidFill>
+            <a:srgbClr val="FFFFFF"/>
+          </a:solidFill>
+          <a:ln w="9525">
+            <a:solidFill>
+              <a:srgbClr val="DADDE2"/>
+            </a:solidFill>
+          </a:ln>
+          <a:effectLst/>
+        </p:spPr>
+        <p:style>
+          <a:lnRef idx="1">
+            <a:schemeClr val="accent1"/>
+          </a:lnRef>
+          <a:fillRef idx="3">
+            <a:schemeClr val="accent1"/>
+          </a:fillRef>
+          <a:effectRef idx="2">
+            <a:schemeClr val="accent1"/>
+          </a:effectRef>
+          <a:fontRef idx="minor">
+            <a:schemeClr val="lt1"/>
+          </a:fontRef>
+        </p:style>
+        <p:txBody>
+          <a:bodyPr rtlCol="0" anchor="ctr"/>
+          <a:lstStyle/>
+          <a:p>
+            <a:pPr algn="ctr"/>
+          </a:p>
+        </p:txBody>
+      </p:sp>
+      <p:sp>
+        <p:nvSpPr>
+          <p:cNvPr id="12" name="Rectangle 11"/>
+          <p:cNvSpPr/>
+          <p:nvPr/>
+        </p:nvSpPr>
+        <p:spPr>
+          <a:xfrm>
+            <a:off x="8065008" y="3438144"/>
+            <a:ext cx="50292" cy="1243584"/>
+          </a:xfrm>
+          <a:prstGeom prst="rect">
+            <a:avLst/>
+          </a:prstGeom>
+          <a:solidFill>
+            <a:srgbClr val="06509D"/>
+          </a:solidFill>
+          <a:ln>
+            <a:noFill/>
+          </a:ln>
+          <a:effectLst/>
+        </p:spPr>
+        <p:style>
+          <a:lnRef idx="1">
+            <a:schemeClr val="accent1"/>
+          </a:lnRef>
+          <a:fillRef idx="3">
+            <a:schemeClr val="accent1"/>
+          </a:fillRef>
+          <a:effectRef idx="2">
+            <a:schemeClr val="accent1"/>
+          </a:effectRef>
+          <a:fontRef idx="minor">
+            <a:schemeClr val="lt1"/>
+          </a:fontRef>
+        </p:style>
+        <p:txBody>
+          <a:bodyPr rtlCol="0" anchor="ctr"/>
+          <a:lstStyle/>
+          <a:p>
+            <a:pPr algn="ctr"/>
+          </a:p>
+        </p:txBody>
+      </p:sp>
+      <p:sp>
+        <p:nvSpPr>
+          <p:cNvPr id="13" name="TextBox 12"/>
+          <p:cNvSpPr txBox="1"/>
+          <p:nvPr/>
+        </p:nvSpPr>
+        <p:spPr>
+          <a:xfrm>
+            <a:off x="8302752" y="3438144"/>
+            <a:ext cx="3102559" cy="320040"/>
+          </a:xfrm>
+          <a:prstGeom prst="rect">
+            <a:avLst/>
+          </a:prstGeom>
+          <a:noFill/>
+        </p:spPr>
+        <p:txBody>
+          <a:bodyPr wrap="square" anchor="t" lIns="0" rIns="0" tIns="0" bIns="0">
+            <a:spAutoFit/>
+          </a:bodyPr>
+          <a:lstStyle/>
+          <a:p>
+            <a:pPr algn="l"/>
+            <a:r>
+              <a:rPr sz="1250" b="1" i="0">
+                <a:solidFill>
+                  <a:srgbClr val="1E2430"/>
+                </a:solidFill>
+                <a:latin typeface="Arial"/>
+                <a:cs typeface="Arial"/>
+              </a:rPr>
+              <a:t>Joint two-shot calibration</a:t>
+            </a:r>
+          </a:p>
+        </p:txBody>
+      </p:sp>
+      <p:sp>
+        <p:nvSpPr>
+          <p:cNvPr id="14" name="TextBox 13"/>
+          <p:cNvSpPr txBox="1"/>
+          <p:nvPr/>
+        </p:nvSpPr>
+        <p:spPr>
+          <a:xfrm>
+            <a:off x="8302752" y="3785616"/>
+            <a:ext cx="3102559" cy="914400"/>
+          </a:xfrm>
+          <a:prstGeom prst="rect">
+            <a:avLst/>
+          </a:prstGeom>
+          <a:noFill/>
+        </p:spPr>
+        <p:txBody>
+          <a:bodyPr wrap="square" anchor="t" lIns="0" rIns="0" tIns="0" bIns="0">
+            <a:spAutoFit/>
+          </a:bodyPr>
+          <a:lstStyle/>
+          <a:p>
+            <a:pPr algn="l">
+              <a:lnSpc>
+                <a:spcPct val="115000"/>
+              </a:lnSpc>
+            </a:pPr>
+            <a:r>
+              <a:rPr sz="1150" b="0" i="0">
+                <a:solidFill>
+                  <a:srgbClr val="3A3F47"/>
+                </a:solidFill>
+                <a:latin typeface="Arial"/>
+                <a:cs typeface="Arial"/>
+              </a:rPr>
+              <a:t>Recalibrating against both scans lands each shot near 75 µm and resolves the hardening exponent away from its prior bound.</a:t>
+            </a:r>
+          </a:p>
+        </p:txBody>
+      </p:sp>
+    </p:spTree>
+  </p:cSld>
+  <p:clrMapOvr>
+    <a:masterClrMapping/>
+  </p:clrMapOvr>
+</p:sld>
+</file>
+
 <file path=ppt/slides/slide3.xml><?xml version="1.0" encoding="utf-8"?>
 <p:sld xmlns:a="http://schemas.openxmlformats.org/drawingml/2006/main" xmlns:p="http://schemas.openxmlformats.org/presentationml/2006/main" xmlns:r="http://schemas.openxmlformats.org/officeDocument/2006/relationships">
   <p:cSld>
@@ -18366,7 +18925,7 @@
                 <a:latin typeface="Arial"/>
                 <a:cs typeface="Arial"/>
               </a:rPr>
-              <a:t>3 / 20</a:t>
+              <a:t>3 / 21</a:t>
             </a:r>
           </a:p>
         </p:txBody>
@@ -19043,7 +19602,7 @@
                 <a:latin typeface="Arial"/>
                 <a:cs typeface="Arial"/>
               </a:rPr>
-              <a:t>4 / 20</a:t>
+              <a:t>4 / 21</a:t>
             </a:r>
           </a:p>
         </p:txBody>
@@ -19473,7 +20032,7 @@
                 <a:latin typeface="Arial"/>
                 <a:cs typeface="Arial"/>
               </a:rPr>
-              <a:t>5 / 20</a:t>
+              <a:t>5 / 21</a:t>
             </a:r>
           </a:p>
         </p:txBody>
@@ -19849,7 +20408,7 @@
                 <a:latin typeface="Arial"/>
                 <a:cs typeface="Arial"/>
               </a:rPr>
-              <a:t>6 / 20</a:t>
+              <a:t>6 / 21</a:t>
             </a:r>
           </a:p>
         </p:txBody>
@@ -20889,7 +21448,7 @@
                 <a:latin typeface="Arial"/>
                 <a:cs typeface="Arial"/>
               </a:rPr>
-              <a:t>7 / 20</a:t>
+              <a:t>7 / 21</a:t>
             </a:r>
           </a:p>
         </p:txBody>
@@ -21594,7 +22153,7 @@
                 <a:latin typeface="Arial"/>
                 <a:cs typeface="Arial"/>
               </a:rPr>
-              <a:t>8 / 20</a:t>
+              <a:t>8 / 21</a:t>
             </a:r>
           </a:p>
         </p:txBody>
@@ -22454,7 +23013,7 @@
                 <a:latin typeface="Arial"/>
                 <a:cs typeface="Arial"/>
               </a:rPr>
-              <a:t>9 / 20</a:t>
+              <a:t>9 / 21</a:t>
             </a:r>
           </a:p>
         </p:txBody>

</xml_diff>

<commit_message>
adopt joint two-shot calibration: model files from g3 median, deck slides reworked
</commit_message>
<xml_diff>
--- a/examples/impact/slide_assets/WCCM_NEML2_explicit_dynamics_v2.pptx
+++ b/examples/impact/slide_assets/WCCM_NEML2_explicit_dynamics_v2.pptx
@@ -15676,7 +15676,7 @@
                 <a:latin typeface="Arial"/>
                 <a:cs typeface="Arial"/>
               </a:rPr>
-              <a:t>. The forward model in the loop is the production simulation itself.</a:t>
+              <a:t>. Two shots, 235.9 and 132.3 m/s, are fit jointly. The forward model in the loop is the production simulation itself.</a:t>
             </a:r>
           </a:p>
         </p:txBody>
@@ -16054,7 +16054,7 @@
                 <a:latin typeface="Arial"/>
                 <a:cs typeface="Arial"/>
               </a:rPr>
-              <a:t>96-run Sobol design</a:t>
+              <a:t>96-run Sobol design per shot</a:t>
             </a:r>
           </a:p>
         </p:txBody>
@@ -16094,7 +16094,7 @@
                 <a:latin typeface="Arial"/>
                 <a:cs typeface="Arial"/>
               </a:rPr>
-              <a:t>one production simulation per point (~21 min each)</a:t>
+              <a:t>one production simulation per point and velocity (~21 min each)</a:t>
             </a:r>
           </a:p>
         </p:txBody>
@@ -16706,7 +16706,7 @@
                 <a:latin typeface="Arial"/>
                 <a:cs typeface="Arial"/>
               </a:rPr>
-              <a:t>Gaussian over ~40 profile stations, final length, and foot radius</a:t>
+              <a:t>Gaussian over ~40 profile stations, final length, and foot radius, per shot</a:t>
             </a:r>
           </a:p>
         </p:txBody>
@@ -17727,7 +17727,7 @@
           <a:p>
             <a:r>
               <a:rPr sz="2600"/>
-              <a:t>Validation: calibrated against a scanned specimen</a:t>
+              <a:t>Validation: the first shot</a:t>
             </a:r>
           </a:p>
         </p:txBody>
@@ -17799,7 +17799,7 @@
                 <a:latin typeface="Arial"/>
                 <a:cs typeface="Arial"/>
               </a:rPr>
-              <a:t>Laser-scanned recovered specimen (OFHC copper, 235.9 m/s) → axis-corrected profile target → </a:t>
+              <a:t>The jointly calibrated model at the first shot velocity of </a:t>
             </a:r>
             <a:r>
               <a:rPr sz="1450" b="1" i="0">
@@ -17809,7 +17809,17 @@
                 <a:latin typeface="Arial"/>
                 <a:cs typeface="Arial"/>
               </a:rPr>
-              <a:t>Bayesian calibration of the Johnson–Cook parameters</a:t>
+              <a:t>235.9 m/s</a:t>
+            </a:r>
+            <a:r>
+              <a:rPr sz="1450" b="0" i="0">
+                <a:solidFill>
+                  <a:srgbClr val="3A3F47"/>
+                </a:solidFill>
+                <a:latin typeface="Arial"/>
+                <a:cs typeface="Arial"/>
+              </a:rPr>
+              <a:t>.</a:t>
             </a:r>
           </a:p>
         </p:txBody>
@@ -17883,7 +17893,7 @@
         <p:spPr>
           <a:xfrm>
             <a:off x="8065008" y="1755648"/>
-            <a:ext cx="3559759" cy="786384"/>
+            <a:ext cx="3559759" cy="1371600"/>
           </a:xfrm>
           <a:prstGeom prst="roundRect">
             <a:avLst>
@@ -17930,256 +17940,8 @@
         </p:nvSpPr>
         <p:spPr>
           <a:xfrm>
-            <a:off x="8065008" y="1847088"/>
-            <a:ext cx="50292" cy="603504"/>
-          </a:xfrm>
-          <a:prstGeom prst="rect">
-            <a:avLst/>
-          </a:prstGeom>
-          <a:solidFill>
-            <a:srgbClr val="06509D"/>
-          </a:solidFill>
-          <a:ln>
-            <a:noFill/>
-          </a:ln>
-          <a:effectLst/>
-        </p:spPr>
-        <p:style>
-          <a:lnRef idx="1">
-            <a:schemeClr val="accent1"/>
-          </a:lnRef>
-          <a:fillRef idx="3">
-            <a:schemeClr val="accent1"/>
-          </a:fillRef>
-          <a:effectRef idx="2">
-            <a:schemeClr val="accent1"/>
-          </a:effectRef>
-          <a:fontRef idx="minor">
-            <a:schemeClr val="lt1"/>
-          </a:fontRef>
-        </p:style>
-        <p:txBody>
-          <a:bodyPr rtlCol="0" anchor="ctr"/>
-          <a:lstStyle/>
-          <a:p>
-            <a:pPr algn="ctr"/>
-          </a:p>
-        </p:txBody>
-      </p:sp>
-      <p:sp>
-        <p:nvSpPr>
-          <p:cNvPr id="9" name="TextBox 8"/>
-          <p:cNvSpPr txBox="1"/>
-          <p:nvPr/>
-        </p:nvSpPr>
-        <p:spPr>
-          <a:xfrm>
-            <a:off x="8302752" y="1828800"/>
-            <a:ext cx="3102559" cy="384048"/>
-          </a:xfrm>
-          <a:prstGeom prst="rect">
-            <a:avLst/>
-          </a:prstGeom>
-          <a:noFill/>
-        </p:spPr>
-        <p:txBody>
-          <a:bodyPr wrap="square" anchor="t" lIns="0" rIns="0" tIns="0" bIns="0">
-            <a:spAutoFit/>
-          </a:bodyPr>
-          <a:lstStyle/>
-          <a:p>
-            <a:pPr algn="l"/>
-            <a:r>
-              <a:rPr sz="2200" b="1" i="0">
-                <a:solidFill>
-                  <a:srgbClr val="06509D"/>
-                </a:solidFill>
-                <a:latin typeface="Arial"/>
-                <a:cs typeface="Arial"/>
-              </a:rPr>
-              <a:t>81 µm</a:t>
-            </a:r>
-            <a:r>
-              <a:rPr sz="1050" b="0" i="0">
-                <a:solidFill>
-                  <a:srgbClr val="59595C"/>
-                </a:solidFill>
-                <a:latin typeface="Arial"/>
-                <a:cs typeface="Arial"/>
-              </a:rPr>
-              <a:t>  profile RMS</a:t>
-            </a:r>
-          </a:p>
-        </p:txBody>
-      </p:sp>
-      <p:sp>
-        <p:nvSpPr>
-          <p:cNvPr id="10" name="TextBox 9"/>
-          <p:cNvSpPr txBox="1"/>
-          <p:nvPr/>
-        </p:nvSpPr>
-        <p:spPr>
-          <a:xfrm>
-            <a:off x="8302752" y="2231136"/>
-            <a:ext cx="3102559" cy="237744"/>
-          </a:xfrm>
-          <a:prstGeom prst="rect">
-            <a:avLst/>
-          </a:prstGeom>
-          <a:noFill/>
-        </p:spPr>
-        <p:txBody>
-          <a:bodyPr wrap="square" anchor="t" lIns="0" rIns="0" tIns="0" bIns="0">
-            <a:spAutoFit/>
-          </a:bodyPr>
-          <a:lstStyle/>
-          <a:p>
-            <a:pPr algn="l"/>
-            <a:r>
-              <a:rPr sz="1050" b="0" i="0">
-                <a:solidFill>
-                  <a:srgbClr val="3A3F47"/>
-                </a:solidFill>
-                <a:latin typeface="Arial"/>
-                <a:cs typeface="Arial"/>
-              </a:rPr>
-              <a:t>Bayesian posterior median</a:t>
-            </a:r>
-          </a:p>
-        </p:txBody>
-      </p:sp>
-      <p:sp>
-        <p:nvSpPr>
-          <p:cNvPr id="11" name="Freeform 10"/>
-          <p:cNvSpPr/>
-          <p:nvPr/>
-        </p:nvSpPr>
-        <p:spPr>
-          <a:xfrm>
-            <a:off x="9783768" y="2560320"/>
-            <a:ext cx="122237" cy="256032"/>
-          </a:xfrm>
-          <a:custGeom>
-            <a:avLst/>
-            <a:gdLst/>
-            <a:ahLst/>
-            <a:cxnLst/>
-            <a:rect l="l" t="t" r="r" b="b"/>
-            <a:pathLst>
-              <a:path w="122237" h="256032">
-                <a:moveTo>
-                  <a:pt x="50006" y="0"/>
-                </a:moveTo>
-                <a:lnTo>
-                  <a:pt x="50006" y="144907"/>
-                </a:lnTo>
-                <a:lnTo>
-                  <a:pt x="0" y="144907"/>
-                </a:lnTo>
-                <a:lnTo>
-                  <a:pt x="61119" y="256032"/>
-                </a:lnTo>
-                <a:lnTo>
-                  <a:pt x="122237" y="144907"/>
-                </a:lnTo>
-                <a:lnTo>
-                  <a:pt x="72231" y="144907"/>
-                </a:lnTo>
-                <a:lnTo>
-                  <a:pt x="72231" y="0"/>
-                </a:lnTo>
-                <a:close/>
-              </a:path>
-            </a:pathLst>
-          </a:custGeom>
-          <a:solidFill>
-            <a:srgbClr val="1E2430"/>
-          </a:solidFill>
-          <a:ln>
-            <a:noFill/>
-          </a:ln>
-          <a:effectLst/>
-        </p:spPr>
-        <p:style>
-          <a:lnRef idx="1">
-            <a:schemeClr val="accent1"/>
-          </a:lnRef>
-          <a:fillRef idx="3">
-            <a:schemeClr val="accent1"/>
-          </a:fillRef>
-          <a:effectRef idx="2">
-            <a:schemeClr val="accent1"/>
-          </a:effectRef>
-          <a:fontRef idx="minor">
-            <a:schemeClr val="lt1"/>
-          </a:fontRef>
-        </p:style>
-        <p:txBody>
-          <a:bodyPr rtlCol="0" anchor="ctr"/>
-          <a:lstStyle/>
-          <a:p>
-            <a:pPr algn="ctr"/>
-          </a:p>
-        </p:txBody>
-      </p:sp>
-      <p:sp>
-        <p:nvSpPr>
-          <p:cNvPr id="12" name="Rounded Rectangle 11"/>
-          <p:cNvSpPr/>
-          <p:nvPr/>
-        </p:nvSpPr>
-        <p:spPr>
-          <a:xfrm>
-            <a:off x="8065008" y="2871216"/>
-            <a:ext cx="3559759" cy="786384"/>
-          </a:xfrm>
-          <a:prstGeom prst="roundRect">
-            <a:avLst>
-              <a:gd name="adj" fmla="val 5500"/>
-            </a:avLst>
-          </a:prstGeom>
-          <a:solidFill>
-            <a:srgbClr val="FFFFFF"/>
-          </a:solidFill>
-          <a:ln w="9525">
-            <a:solidFill>
-              <a:srgbClr val="DADDE2"/>
-            </a:solidFill>
-          </a:ln>
-          <a:effectLst/>
-        </p:spPr>
-        <p:style>
-          <a:lnRef idx="1">
-            <a:schemeClr val="accent1"/>
-          </a:lnRef>
-          <a:fillRef idx="3">
-            <a:schemeClr val="accent1"/>
-          </a:fillRef>
-          <a:effectRef idx="2">
-            <a:schemeClr val="accent1"/>
-          </a:effectRef>
-          <a:fontRef idx="minor">
-            <a:schemeClr val="lt1"/>
-          </a:fontRef>
-        </p:style>
-        <p:txBody>
-          <a:bodyPr rtlCol="0" anchor="ctr"/>
-          <a:lstStyle/>
-          <a:p>
-            <a:pPr algn="ctr"/>
-          </a:p>
-        </p:txBody>
-      </p:sp>
-      <p:sp>
-        <p:nvSpPr>
-          <p:cNvPr id="13" name="Rectangle 12"/>
-          <p:cNvSpPr/>
-          <p:nvPr/>
-        </p:nvSpPr>
-        <p:spPr>
-          <a:xfrm>
-            <a:off x="8065008" y="2962656"/>
-            <a:ext cx="50292" cy="603504"/>
+            <a:off x="8065008" y="1865376"/>
+            <a:ext cx="50292" cy="1152144"/>
           </a:xfrm>
           <a:prstGeom prst="rect">
             <a:avLst/>
@@ -18216,14 +17978,14 @@
       </p:sp>
       <p:sp>
         <p:nvSpPr>
-          <p:cNvPr id="14" name="TextBox 13"/>
+          <p:cNvPr id="9" name="TextBox 8"/>
           <p:cNvSpPr txBox="1"/>
           <p:nvPr/>
         </p:nvSpPr>
         <p:spPr>
           <a:xfrm>
-            <a:off x="8302752" y="2944368"/>
-            <a:ext cx="3102559" cy="384048"/>
+            <a:off x="8302752" y="1883664"/>
+            <a:ext cx="3102559" cy="457200"/>
           </a:xfrm>
           <a:prstGeom prst="rect">
             <a:avLst/>
@@ -18238,17 +18000,17 @@
           <a:p>
             <a:pPr algn="l"/>
             <a:r>
-              <a:rPr sz="2200" b="1" i="0">
+              <a:rPr sz="2600" b="1" i="0">
                 <a:solidFill>
                   <a:srgbClr val="5E8614"/>
                 </a:solidFill>
                 <a:latin typeface="Arial"/>
                 <a:cs typeface="Arial"/>
               </a:rPr>
-              <a:t>69 µm</a:t>
-            </a:r>
-            <a:r>
-              <a:rPr sz="1050" b="0" i="0">
+              <a:t>77 µm</a:t>
+            </a:r>
+            <a:r>
+              <a:rPr sz="1100" b="0" i="0">
                 <a:solidFill>
                   <a:srgbClr val="59595C"/>
                 </a:solidFill>
@@ -18262,14 +18024,14 @@
       </p:sp>
       <p:sp>
         <p:nvSpPr>
-          <p:cNvPr id="15" name="TextBox 14"/>
+          <p:cNvPr id="10" name="TextBox 9"/>
           <p:cNvSpPr txBox="1"/>
           <p:nvPr/>
         </p:nvSpPr>
         <p:spPr>
           <a:xfrm>
-            <a:off x="8302752" y="3346704"/>
-            <a:ext cx="3102559" cy="237744"/>
+            <a:off x="8302752" y="2432304"/>
+            <a:ext cx="3102559" cy="548640"/>
           </a:xfrm>
           <a:prstGeom prst="rect">
             <a:avLst/>
@@ -18282,16 +18044,20 @@
           </a:bodyPr>
           <a:lstStyle/>
           <a:p>
-            <a:pPr algn="l"/>
-            <a:r>
-              <a:rPr sz="1050" b="0" i="0">
+            <a:pPr algn="l">
+              <a:lnSpc>
+                <a:spcPct val="115000"/>
+              </a:lnSpc>
+            </a:pPr>
+            <a:r>
+              <a:rPr sz="1150" b="0" i="0">
                 <a:solidFill>
                   <a:srgbClr val="3A3F47"/>
                 </a:solidFill>
                 <a:latin typeface="Arial"/>
                 <a:cs typeface="Arial"/>
               </a:rPr>
-              <a:t>+ frictionless anvil</a:t>
+              <a:t>final length 22.96 mm vs 22.41 ± 0.44 scanned</a:t>
             </a:r>
           </a:p>
         </p:txBody>
@@ -18331,7 +18097,7 @@
           <a:p>
             <a:r>
               <a:rPr sz="2600"/>
-              <a:t>Prediction at a second velocity</a:t>
+              <a:t>The second shot</a:t>
             </a:r>
           </a:p>
         </p:txBody>
@@ -18403,7 +18169,7 @@
                 <a:latin typeface="Arial"/>
                 <a:cs typeface="Arial"/>
               </a:rPr>
-              <a:t>A second specimen was shot at </a:t>
+              <a:t>The same parameter set, run at the second shot velocity of </a:t>
             </a:r>
             <a:r>
               <a:rPr sz="1450" b="1" i="0">
@@ -18414,26 +18180,6 @@
                 <a:cs typeface="Arial"/>
               </a:rPr>
               <a:t>132.3 m/s</a:t>
-            </a:r>
-            <a:r>
-              <a:rPr sz="1450" b="0" i="0">
-                <a:solidFill>
-                  <a:srgbClr val="3A3F47"/>
-                </a:solidFill>
-                <a:latin typeface="Arial"/>
-                <a:cs typeface="Arial"/>
-              </a:rPr>
-              <a:t> and scanned. The calibrated model was run at that velocity with </a:t>
-            </a:r>
-            <a:r>
-              <a:rPr sz="1450" b="1" i="0">
-                <a:solidFill>
-                  <a:srgbClr val="1E2430"/>
-                </a:solidFill>
-                <a:latin typeface="Arial"/>
-                <a:cs typeface="Arial"/>
-              </a:rPr>
-              <a:t>no refitting</a:t>
             </a:r>
             <a:r>
               <a:rPr sz="1450" b="0" i="0">
@@ -18631,7 +18377,7 @@
                 <a:latin typeface="Arial"/>
                 <a:cs typeface="Arial"/>
               </a:rPr>
-              <a:t>81 µm</a:t>
+              <a:t>74 µm</a:t>
             </a:r>
             <a:r>
               <a:rPr sz="1100" b="0" i="0">
@@ -18681,7 +18427,7 @@
                 <a:latin typeface="Arial"/>
                 <a:cs typeface="Arial"/>
               </a:rPr>
-              <a:t>blind, at a velocity 44% below the calibration shot</a:t>
+              <a:t>at a velocity 44% below the first shot, and a much lower strain range</a:t>
             </a:r>
           </a:p>
         </p:txBody>
@@ -18809,7 +18555,7 @@
                 <a:latin typeface="Arial"/>
                 <a:cs typeface="Arial"/>
               </a:rPr>
-              <a:t>Joint two-shot calibration</a:t>
+              <a:t>Why two velocities matter</a:t>
             </a:r>
           </a:p>
         </p:txBody>
@@ -18849,7 +18595,7 @@
                 <a:latin typeface="Arial"/>
                 <a:cs typeface="Arial"/>
               </a:rPr>
-              <a:t>Recalibrating against both scans lands each shot near 75 µm and resolves the hardening exponent away from its prior bound.</a:t>
+              <a:t>One shot cannot separate rate sensitivity from strain hardening. The second velocity resolves the trade-off and pulls every parameter to the interior of its prior.</a:t>
             </a:r>
           </a:p>
         </p:txBody>
@@ -20960,7 +20706,7 @@
                 <a:latin typeface="Arial"/>
                 <a:cs typeface="Arial"/>
               </a:rPr>
-              <a:t>129 MPa</a:t>
+              <a:t>104 MPa</a:t>
             </a:r>
           </a:p>
         </p:txBody>
@@ -21032,7 +20778,7 @@
                 <a:latin typeface="Arial"/>
                 <a:cs typeface="Arial"/>
               </a:rPr>
-              <a:t>308 MPa</a:t>
+              <a:t>329 MPa</a:t>
             </a:r>
           </a:p>
         </p:txBody>
@@ -21104,7 +20850,7 @@
                 <a:latin typeface="Arial"/>
                 <a:cs typeface="Arial"/>
               </a:rPr>
-              <a:t>0.47</a:t>
+              <a:t>0.43</a:t>
             </a:r>
           </a:p>
         </p:txBody>
@@ -21176,7 +20922,7 @@
                 <a:latin typeface="Arial"/>
                 <a:cs typeface="Arial"/>
               </a:rPr>
-              <a:t>0.022</a:t>
+              <a:t>0.025</a:t>
             </a:r>
           </a:p>
         </p:txBody>
@@ -21248,7 +20994,7 @@
                 <a:latin typeface="Arial"/>
                 <a:cs typeface="Arial"/>
               </a:rPr>
-              <a:t>0.14  (H04 temper)</a:t>
+              <a:t>0.12  (H04 temper)</a:t>
             </a:r>
           </a:p>
         </p:txBody>
@@ -21288,7 +21034,7 @@
                 <a:latin typeface="Arial"/>
                 <a:cs typeface="Arial"/>
               </a:rPr>
-              <a:t>green = Bayesian-calibrated against the recovered specimen (later in this talk)</a:t>
+              <a:t>green = Bayesian-calibrated against two recovered specimens (later in this talk)</a:t>
             </a:r>
           </a:p>
         </p:txBody>

</xml_diff>

<commit_message>
slides: speed slide from cluster results - implicit 32 ranks vs explicit on one GPU, 45x
</commit_message>
<xml_diff>
--- a/examples/impact/slide_assets/WCCM_NEML2_explicit_dynamics_v2.pptx
+++ b/examples/impact/slide_assets/WCCM_NEML2_explicit_dynamics_v2.pptx
@@ -12488,7 +12488,7 @@
         <p:spPr>
           <a:xfrm>
             <a:off x="566928" y="1161288"/>
-            <a:ext cx="11057839" cy="640080"/>
+            <a:ext cx="11057839" cy="320040"/>
           </a:xfrm>
           <a:prstGeom prst="rect">
             <a:avLst/>
@@ -12501,11 +12501,7 @@
           </a:bodyPr>
           <a:lstStyle/>
           <a:p>
-            <a:pPr algn="l">
-              <a:lnSpc>
-                <a:spcPct val="115000"/>
-              </a:lnSpc>
-            </a:pPr>
+            <a:pPr algn="l"/>
             <a:r>
               <a:rPr sz="1450" b="0" i="0">
                 <a:solidFill>
@@ -12514,7 +12510,7 @@
                 <a:latin typeface="Arial"/>
                 <a:cs typeface="Arial"/>
               </a:rPr>
-              <a:t>Same mesh, material, and timestep, serial, run to rebound. The implicit twin uses Newmark-beta with the exact NEML2 tangent and full integration with F-bar. The explicit path uses reduced integration with hourglass control.</a:t>
+              <a:t>The same impact problem, about one million degrees of freedom, run for the same number of steps at the same timestep.</a:t>
             </a:r>
           </a:p>
         </p:txBody>
@@ -12527,8 +12523,8 @@
         </p:nvSpPr>
         <p:spPr>
           <a:xfrm>
-            <a:off x="566928" y="1984248"/>
-            <a:ext cx="5300319" cy="1828800"/>
+            <a:off x="566928" y="1709928"/>
+            <a:ext cx="5300319" cy="1783080"/>
           </a:xfrm>
           <a:prstGeom prst="roundRect">
             <a:avLst>
@@ -12575,14 +12571,14 @@
         </p:nvSpPr>
         <p:spPr>
           <a:xfrm>
-            <a:off x="566928" y="2148840"/>
-            <a:ext cx="64008" cy="1499616"/>
+            <a:off x="566928" y="1837944"/>
+            <a:ext cx="54864" cy="1527048"/>
           </a:xfrm>
           <a:prstGeom prst="rect">
             <a:avLst/>
           </a:prstGeom>
           <a:solidFill>
-            <a:srgbClr val="06509D"/>
+            <a:srgbClr val="CF1D4C"/>
           </a:solidFill>
           <a:ln>
             <a:noFill/>
@@ -12619,8 +12615,8 @@
         </p:nvSpPr>
         <p:spPr>
           <a:xfrm>
-            <a:off x="978408" y="2240280"/>
-            <a:ext cx="4660239" cy="914400"/>
+            <a:off x="841248" y="1856232"/>
+            <a:ext cx="4797399" cy="274320"/>
           </a:xfrm>
           <a:prstGeom prst="rect">
             <a:avLst/>
@@ -12635,14 +12631,14 @@
           <a:p>
             <a:pPr algn="l"/>
             <a:r>
-              <a:rPr sz="5400" b="1" i="0">
-                <a:solidFill>
-                  <a:srgbClr val="06509D"/>
-                </a:solidFill>
-                <a:latin typeface="Arial"/>
-                <a:cs typeface="Arial"/>
-              </a:rPr>
-              <a:t>9.5×</a:t>
+              <a:rPr sz="1100" b="1" i="0">
+                <a:solidFill>
+                  <a:srgbClr val="CF1D4C"/>
+                </a:solidFill>
+                <a:latin typeface="Arial"/>
+                <a:cs typeface="Arial"/>
+              </a:rPr>
+              <a:t>IMPLICIT TWIN</a:t>
             </a:r>
           </a:p>
         </p:txBody>
@@ -12655,8 +12651,8 @@
         </p:nvSpPr>
         <p:spPr>
           <a:xfrm>
-            <a:off x="996696" y="3264408"/>
-            <a:ext cx="4614519" cy="411480"/>
+            <a:off x="859536" y="2185416"/>
+            <a:ext cx="4751679" cy="1143000"/>
           </a:xfrm>
           <a:prstGeom prst="rect">
             <a:avLst/>
@@ -12664,21 +12660,83 @@
           <a:noFill/>
         </p:spPr>
         <p:txBody>
-          <a:bodyPr wrap="square" anchor="t" lIns="0" rIns="0" tIns="0" bIns="0">
+          <a:bodyPr wrap="square" lIns="0" rIns="0" tIns="0" bIns="0">
             <a:spAutoFit/>
           </a:bodyPr>
           <a:lstStyle/>
           <a:p>
-            <a:pPr algn="l"/>
-            <a:r>
-              <a:rPr sz="1450" b="0" i="0">
+            <a:pPr marL="219456" indent="-219456">
+              <a:lnSpc>
+                <a:spcPct val="106000"/>
+              </a:lnSpc>
+              <a:spcAft>
+                <a:spcPts val="600"/>
+              </a:spcAft>
+              <a:buClr>
+                <a:srgbClr val="CF1D4C"/>
+              </a:buClr>
+              <a:buFont typeface="Arial"/>
+              <a:buChar char="•"/>
+            </a:pPr>
+            <a:r>
+              <a:rPr sz="1250" b="0" i="0">
                 <a:solidFill>
                   <a:srgbClr val="3A3F47"/>
                 </a:solidFill>
                 <a:latin typeface="Arial"/>
                 <a:cs typeface="Arial"/>
               </a:rPr>
-              <a:t>faster in 2D</a:t>
+              <a:t>Newmark-beta with the exact NEML2 tangent</a:t>
+            </a:r>
+          </a:p>
+          <a:p>
+            <a:pPr marL="219456" indent="-219456">
+              <a:lnSpc>
+                <a:spcPct val="106000"/>
+              </a:lnSpc>
+              <a:spcAft>
+                <a:spcPts val="600"/>
+              </a:spcAft>
+              <a:buClr>
+                <a:srgbClr val="CF1D4C"/>
+              </a:buClr>
+              <a:buFont typeface="Arial"/>
+              <a:buChar char="•"/>
+            </a:pPr>
+            <a:r>
+              <a:rPr sz="1250" b="0" i="0">
+                <a:solidFill>
+                  <a:srgbClr val="3A3F47"/>
+                </a:solidFill>
+                <a:latin typeface="Arial"/>
+                <a:cs typeface="Arial"/>
+              </a:rPr>
+              <a:t>Full integration with F-bar</a:t>
+            </a:r>
+          </a:p>
+          <a:p>
+            <a:pPr marL="219456" indent="-219456">
+              <a:lnSpc>
+                <a:spcPct val="106000"/>
+              </a:lnSpc>
+              <a:spcAft>
+                <a:spcPts val="600"/>
+              </a:spcAft>
+              <a:buClr>
+                <a:srgbClr val="CF1D4C"/>
+              </a:buClr>
+              <a:buFont typeface="Arial"/>
+              <a:buChar char="•"/>
+            </a:pPr>
+            <a:r>
+              <a:rPr sz="1250" b="0" i="0">
+                <a:solidFill>
+                  <a:srgbClr val="3A3F47"/>
+                </a:solidFill>
+                <a:latin typeface="Arial"/>
+                <a:cs typeface="Arial"/>
+              </a:rPr>
+              <a:t>MUMPS direct solve on 32 MPI ranks</a:t>
             </a:r>
           </a:p>
         </p:txBody>
@@ -12691,8 +12749,8 @@
         </p:nvSpPr>
         <p:spPr>
           <a:xfrm>
-            <a:off x="6324447" y="1984248"/>
-            <a:ext cx="5300319" cy="1828800"/>
+            <a:off x="6324447" y="1709928"/>
+            <a:ext cx="5300319" cy="1783080"/>
           </a:xfrm>
           <a:prstGeom prst="roundRect">
             <a:avLst>
@@ -12739,8 +12797,8 @@
         </p:nvSpPr>
         <p:spPr>
           <a:xfrm>
-            <a:off x="6324447" y="2148840"/>
-            <a:ext cx="64008" cy="1499616"/>
+            <a:off x="6324447" y="1837944"/>
+            <a:ext cx="54864" cy="1527048"/>
           </a:xfrm>
           <a:prstGeom prst="rect">
             <a:avLst/>
@@ -12783,8 +12841,8 @@
         </p:nvSpPr>
         <p:spPr>
           <a:xfrm>
-            <a:off x="6735927" y="2240280"/>
-            <a:ext cx="4660239" cy="914400"/>
+            <a:off x="6598767" y="1856232"/>
+            <a:ext cx="4797399" cy="274320"/>
           </a:xfrm>
           <a:prstGeom prst="rect">
             <a:avLst/>
@@ -12799,14 +12857,14 @@
           <a:p>
             <a:pPr algn="l"/>
             <a:r>
-              <a:rPr sz="5400" b="1" i="0">
+              <a:rPr sz="1100" b="1" i="0">
                 <a:solidFill>
                   <a:srgbClr val="5E8614"/>
                 </a:solidFill>
                 <a:latin typeface="Arial"/>
                 <a:cs typeface="Arial"/>
               </a:rPr>
-              <a:t>25×</a:t>
+              <a:t>EXPLICIT PATH</a:t>
             </a:r>
           </a:p>
         </p:txBody>
@@ -12819,8 +12877,8 @@
         </p:nvSpPr>
         <p:spPr>
           <a:xfrm>
-            <a:off x="6754215" y="3264408"/>
-            <a:ext cx="4614519" cy="411480"/>
+            <a:off x="6617055" y="2185416"/>
+            <a:ext cx="4751679" cy="1143000"/>
           </a:xfrm>
           <a:prstGeom prst="rect">
             <a:avLst/>
@@ -12828,21 +12886,83 @@
           <a:noFill/>
         </p:spPr>
         <p:txBody>
-          <a:bodyPr wrap="square" anchor="t" lIns="0" rIns="0" tIns="0" bIns="0">
+          <a:bodyPr wrap="square" lIns="0" rIns="0" tIns="0" bIns="0">
             <a:spAutoFit/>
           </a:bodyPr>
           <a:lstStyle/>
           <a:p>
-            <a:pPr algn="l"/>
-            <a:r>
-              <a:rPr sz="1450" b="0" i="0">
+            <a:pPr marL="219456" indent="-219456">
+              <a:lnSpc>
+                <a:spcPct val="106000"/>
+              </a:lnSpc>
+              <a:spcAft>
+                <a:spcPts val="600"/>
+              </a:spcAft>
+              <a:buClr>
+                <a:srgbClr val="5E8614"/>
+              </a:buClr>
+              <a:buFont typeface="Arial"/>
+              <a:buChar char="•"/>
+            </a:pPr>
+            <a:r>
+              <a:rPr sz="1250" b="0" i="0">
                 <a:solidFill>
                   <a:srgbClr val="3A3F47"/>
                 </a:solidFill>
                 <a:latin typeface="Arial"/>
                 <a:cs typeface="Arial"/>
               </a:rPr>
-              <a:t>faster in 3D</a:t>
+              <a:t>Central difference, batched NEML2 force assembly</a:t>
+            </a:r>
+          </a:p>
+          <a:p>
+            <a:pPr marL="219456" indent="-219456">
+              <a:lnSpc>
+                <a:spcPct val="106000"/>
+              </a:lnSpc>
+              <a:spcAft>
+                <a:spcPts val="600"/>
+              </a:spcAft>
+              <a:buClr>
+                <a:srgbClr val="5E8614"/>
+              </a:buClr>
+              <a:buFont typeface="Arial"/>
+              <a:buChar char="•"/>
+            </a:pPr>
+            <a:r>
+              <a:rPr sz="1250" b="0" i="0">
+                <a:solidFill>
+                  <a:srgbClr val="3A3F47"/>
+                </a:solidFill>
+                <a:latin typeface="Arial"/>
+                <a:cs typeface="Arial"/>
+              </a:rPr>
+              <a:t>Reduced integration with hourglass control</a:t>
+            </a:r>
+          </a:p>
+          <a:p>
+            <a:pPr marL="219456" indent="-219456">
+              <a:lnSpc>
+                <a:spcPct val="106000"/>
+              </a:lnSpc>
+              <a:spcAft>
+                <a:spcPts val="600"/>
+              </a:spcAft>
+              <a:buClr>
+                <a:srgbClr val="5E8614"/>
+              </a:buClr>
+              <a:buFont typeface="Arial"/>
+              <a:buChar char="•"/>
+            </a:pPr>
+            <a:r>
+              <a:rPr sz="1250" b="0" i="0">
+                <a:solidFill>
+                  <a:srgbClr val="3A3F47"/>
+                </a:solidFill>
+                <a:latin typeface="Arial"/>
+                <a:cs typeface="Arial"/>
+              </a:rPr>
+              <a:t>One CPU core and one GPU</a:t>
             </a:r>
           </a:p>
         </p:txBody>
@@ -12855,8 +12975,8 @@
         </p:nvSpPr>
         <p:spPr>
           <a:xfrm>
-            <a:off x="566928" y="4133088"/>
-            <a:ext cx="11057839" cy="1051560"/>
+            <a:off x="566928" y="3767328"/>
+            <a:ext cx="11057839" cy="1234440"/>
           </a:xfrm>
           <a:prstGeom prst="roundRect">
             <a:avLst>
@@ -12866,7 +12986,7 @@
           <a:solidFill>
             <a:srgbClr val="FFFFFF"/>
           </a:solidFill>
-          <a:ln w="9525">
+          <a:ln w="12700">
             <a:solidFill>
               <a:srgbClr val="DADDE2"/>
             </a:solidFill>
@@ -12903,8 +13023,8 @@
         </p:nvSpPr>
         <p:spPr>
           <a:xfrm>
-            <a:off x="822960" y="4242816"/>
-            <a:ext cx="10545775" cy="274320"/>
+            <a:off x="1024128" y="3767328"/>
+            <a:ext cx="2926080" cy="1234440"/>
           </a:xfrm>
           <a:prstGeom prst="rect">
             <a:avLst/>
@@ -12912,21 +13032,21 @@
           <a:noFill/>
         </p:spPr>
         <p:txBody>
-          <a:bodyPr wrap="square" anchor="t" lIns="0" rIns="0" tIns="0" bIns="0">
+          <a:bodyPr wrap="square" anchor="ctr" lIns="0" rIns="0" tIns="0" bIns="0">
             <a:spAutoFit/>
           </a:bodyPr>
           <a:lstStyle/>
           <a:p>
             <a:pPr algn="l"/>
             <a:r>
-              <a:rPr sz="1050" b="1" i="0">
-                <a:solidFill>
-                  <a:srgbClr val="59595C"/>
-                </a:solidFill>
-                <a:latin typeface="Arial"/>
-                <a:cs typeface="Arial"/>
-              </a:rPr>
-              <a:t>WHERE THE GAP COMES FROM</a:t>
+              <a:rPr sz="5200" b="1" i="0">
+                <a:solidFill>
+                  <a:srgbClr val="5E8614"/>
+                </a:solidFill>
+                <a:latin typeface="Arial"/>
+                <a:cs typeface="Arial"/>
+              </a:rPr>
+              <a:t>45×</a:t>
             </a:r>
           </a:p>
         </p:txBody>
@@ -12939,8 +13059,8 @@
         </p:nvSpPr>
         <p:spPr>
           <a:xfrm>
-            <a:off x="822960" y="4544568"/>
-            <a:ext cx="10545775" cy="548640"/>
+            <a:off x="3858768" y="3767328"/>
+            <a:ext cx="7400239" cy="1234440"/>
           </a:xfrm>
           <a:prstGeom prst="rect">
             <a:avLst/>
@@ -12948,7 +13068,7 @@
           <a:noFill/>
         </p:spPr>
         <p:txBody>
-          <a:bodyPr wrap="square" anchor="t" lIns="0" rIns="0" tIns="0" bIns="0">
+          <a:bodyPr wrap="square" anchor="ctr" lIns="0" rIns="0" tIns="0" bIns="0">
             <a:spAutoFit/>
           </a:bodyPr>
           <a:lstStyle/>
@@ -12959,21 +13079,57 @@
               </a:lnSpc>
             </a:pPr>
             <a:r>
-              <a:rPr sz="1300" b="0" i="0">
-                <a:solidFill>
-                  <a:srgbClr val="3A3F47"/>
-                </a:solidFill>
-                <a:latin typeface="Arial"/>
-                <a:cs typeface="Arial"/>
-              </a:rPr>
-              <a:t>Each implicit step pays Newton iterations, a global Jacobian assembly, and a direct solve, with four times the constitutive evaluations per element. The explicit step is one batched residual and vector updates.</a:t>
-            </a:r>
-          </a:p>
-        </p:txBody>
-      </p:sp>
-      <p:sp>
-        <p:nvSpPr>
-          <p:cNvPr id="16" name="Rounded Rectangle 15"/>
+              <a:rPr sz="1600" b="0" i="0">
+                <a:solidFill>
+                  <a:srgbClr val="1E2430"/>
+                </a:solidFill>
+                <a:latin typeface="Arial"/>
+                <a:cs typeface="Arial"/>
+              </a:rPr>
+              <a:t>faster with the explicit path on one CPU core and one GPU than the implicit twin on 32 CPU cores</a:t>
+            </a:r>
+          </a:p>
+        </p:txBody>
+      </p:sp>
+      <p:sp>
+        <p:nvSpPr>
+          <p:cNvPr id="16" name="TextBox 15"/>
+          <p:cNvSpPr txBox="1"/>
+          <p:nvPr/>
+        </p:nvSpPr>
+        <p:spPr>
+          <a:xfrm>
+            <a:off x="658368" y="5065776"/>
+            <a:ext cx="10874959" cy="256032"/>
+          </a:xfrm>
+          <a:prstGeom prst="rect">
+            <a:avLst/>
+          </a:prstGeom>
+          <a:noFill/>
+        </p:spPr>
+        <p:txBody>
+          <a:bodyPr wrap="square" anchor="t" lIns="0" rIns="0" tIns="0" bIns="0">
+            <a:spAutoFit/>
+          </a:bodyPr>
+          <a:lstStyle/>
+          <a:p>
+            <a:pPr algn="l"/>
+            <a:r>
+              <a:rPr sz="1050" b="0" i="1">
+                <a:solidFill>
+                  <a:srgbClr val="59595C"/>
+                </a:solidFill>
+                <a:latin typeface="Arial"/>
+                <a:cs typeface="Arial"/>
+              </a:rPr>
+              <a:t>hardware: Intel Xeon Platinum 8592+ CPU cores, NVIDIA L4 GPU</a:t>
+            </a:r>
+          </a:p>
+        </p:txBody>
+      </p:sp>
+      <p:sp>
+        <p:nvSpPr>
+          <p:cNvPr id="17" name="Rounded Rectangle 16"/>
           <p:cNvSpPr/>
           <p:nvPr/>
         </p:nvSpPr>
@@ -13021,7 +13177,7 @@
       </p:sp>
       <p:sp>
         <p:nvSpPr>
-          <p:cNvPr id="17" name="TextBox 16"/>
+          <p:cNvPr id="18" name="TextBox 17"/>
           <p:cNvSpPr txBox="1"/>
           <p:nvPr/>
         </p:nvSpPr>
@@ -13050,7 +13206,7 @@
                 <a:latin typeface="Arial"/>
                 <a:cs typeface="Arial"/>
               </a:rPr>
-              <a:t>The gap grows with problem size.</a:t>
+              <a:t>Each implicit step pays Newton iterations, a global Jacobian, and a distributed direct solve.</a:t>
             </a:r>
             <a:r>
               <a:rPr sz="1500" b="0" i="0">
@@ -13060,7 +13216,7 @@
                 <a:latin typeface="Arial"/>
                 <a:cs typeface="Arial"/>
               </a:rPr>
-              <a:t> The direct solve scales superlinearly; the batched residual scales linearly.</a:t>
+              <a:t> The explicit step is one batched residual.</a:t>
             </a:r>
           </a:p>
         </p:txBody>

</xml_diff>